<commit_message>
Add blue-flower AI deep dives for stocks and mutual funds
</commit_message>
<xml_diff>
--- a/deliverables/Ionic-Exclusives-Final.pptx
+++ b/deliverables/Ionic-Exclusives-Final.pptx
@@ -2,16 +2,16 @@
 <file path=ppt/presentation.xml><?xml version="1.0" encoding="utf-8"?>
 <p:presentation xmlns:p="http://schemas.openxmlformats.org/presentationml/2006/main">
   <p:sldMasterIdLst>
-    <p:sldMasterId xmlns:r="http://schemas.openxmlformats.org/officeDocument/2006/relationships" id="2147483648" r:id="Rce66caf59d164dc1"/>
+    <p:sldMasterId xmlns:r="http://schemas.openxmlformats.org/officeDocument/2006/relationships" id="2147483648" r:id="R30420a2338ed45c6"/>
   </p:sldMasterIdLst>
   <p:notesMasterIdLst>
-    <p:notesMasterId xmlns:r="http://schemas.openxmlformats.org/officeDocument/2006/relationships" r:id="Rb6c91cf540294cfa"/>
+    <p:notesMasterId xmlns:r="http://schemas.openxmlformats.org/officeDocument/2006/relationships" r:id="R08ffd88fe7a44e4a"/>
   </p:notesMasterIdLst>
   <p:sldIdLst>
-    <p:sldId xmlns:r="http://schemas.openxmlformats.org/officeDocument/2006/relationships" id="256" r:id="R45db3520b3ba4ae0"/>
-    <p:sldId xmlns:r="http://schemas.openxmlformats.org/officeDocument/2006/relationships" id="257" r:id="R0d6954570f8b40cc"/>
-    <p:sldId xmlns:r="http://schemas.openxmlformats.org/officeDocument/2006/relationships" id="258" r:id="R33a7004421fb4d72"/>
-    <p:sldId xmlns:r="http://schemas.openxmlformats.org/officeDocument/2006/relationships" id="259" r:id="Re23279844126488c"/>
+    <p:sldId xmlns:r="http://schemas.openxmlformats.org/officeDocument/2006/relationships" id="256" r:id="Rd8d17d65160f4a27"/>
+    <p:sldId xmlns:r="http://schemas.openxmlformats.org/officeDocument/2006/relationships" id="257" r:id="Rc0fc51c547244dca"/>
+    <p:sldId xmlns:r="http://schemas.openxmlformats.org/officeDocument/2006/relationships" id="258" r:id="R1cb5b1c3653c4ef8"/>
+    <p:sldId xmlns:r="http://schemas.openxmlformats.org/officeDocument/2006/relationships" id="259" r:id="R42a1e97608404265"/>
   </p:sldIdLst>
   <p:sldSz cx="12192000" cy="6858000"/>
   <p:notesSz cx="6858000" cy="9144000"/>
@@ -515,7 +515,7 @@
           <a:lstStyle xmlns:a="http://schemas.openxmlformats.org/drawingml/2006/main"/>
           <a:p xmlns:a="http://schemas.openxmlformats.org/drawingml/2006/main">
             <a:r>
-              <a:t>All screenshots are from the working proposal. The category tabs and horizontal hero swipe update each other. Private Wealth has a Flagship badge outside and above its tab, with a slow pulse and reduced-motion support. It contains 9 PMS, 3 AIF and 6 SIF offerings. Each product has a working detail link. Stock rows move at 4 CSS pixels per second in opposite directions, with pause, mouse drag and stationary search/filter results. The 392px frame, header and navigation are shared with Portfolio. Product figures are captured fixtures, not live quotes.</a:t>
+              <a:t>All screenshots are from the working proposal. The category tabs and horizontal hero swipe update each other. Private Wealth has a Flagship badge outside and above its tab, with a slow pulse and reduced-motion support. It contains 9 PMS, 3 AIF and 6 SIF offerings. Each product has a working detail link. Stock rows move at 4 CSS pixels per second in opposite directions, with pause, mouse drag and stationary search/filter results. The 392px frame, header and navigation are shared with Portfolio. Product figures are captured fixtures, not live quotes. The stock footer and mutual fund metadata slot now include a blue-flower AI deep dive action. Their heights are unchanged from the previous version.</a:t>
             </a:r>
           </a:p>
         </p:txBody>
@@ -585,7 +585,7 @@
           <a:lstStyle xmlns:a="http://schemas.openxmlformats.org/drawingml/2006/main"/>
           <a:p xmlns:a="http://schemas.openxmlformats.org/drawingml/2006/main">
             <a:r>
-              <a:t>The prototype demonstrates discovery and decision support. It does not connect real account verification, funding or orders. The $1 figure is a captured fractional order minimum and does not describe total funding costs. Fund and strategy details use supplied facts and identify missing terms. Lower entry cost is not a suitability recommendation. The proposed flow should be tested with eligible first-time users before claiming a conversion improvement.</a:t>
+              <a:t>The blue flower uses the existing Ionic assistant mark. Actions are available on all ten stock cards and all three mutual fund rows, and again inside product details. The existing card and row heights are unchanged. The deep dive explains the appeal, risks and management direction for companies, or the mandate and approach for funds. Topic buttons let the user focus on one question. Each explanation has a company filing or official fund source. These are prepared prototype explanations, not live model responses, personalised suitability checks or return forecasts. A live implementation would need approved source retrieval, source timestamps, factual evaluation and explicit handling of missing information. Test whether the explanations improve understanding and first unassisted investments. Do not infer success from AI opens alone. Product facts and costs should remain visible outside AI as well. AI source links are in ai-research-data.js in the shared GitHub repository.</a:t>
             </a:r>
           </a:p>
         </p:txBody>
@@ -655,7 +655,7 @@
           <a:lstStyle xmlns:a="http://schemas.openxmlformats.org/drawingml/2006/main"/>
           <a:p xmlns:a="http://schemas.openxmlformats.org/drawingml/2006/main">
             <a:r>
-              <a:t>Android research: Haverkamp et al., Reading and Writing 36 (2023), 1589-1608, published online in 2022. DOI: 10.1007/s11145-022-10328-9. Participants: 145 Norwegian university students. Samsung Galaxy A02s phone and Lenovo Tab M10 tablet, both Android 10. Text: 1492 words. Paging led to more strategic backtracking; better integrated understanding was a tendency. This was a reading study, with no investing task or iOS scroll-depth measure. Choice research: Iyengar and Kamenica (2010), Journal of Public Economics 94, 530-539, DOI 10.1016/j.jpubeco.2010.03.006. Laboratory experiments and records of over 500,000 employees at 638 institutions. Evidence of simplicity seeking, not proof of Ionic conversion uplift. W3C carousel guidance supports user controls to pause moving content. Experiment: first unassisted completed investment within seven days divided by all eligible importers with no prior transaction assigned to each version. Record assistance consistently, and monitor costs, risk understanding, funding failures, cancellations and complaints. Set sample size from the measured baseline. Test static layout first, then motion.</a:t>
+              <a:t>Android research: Haverkamp et al., Reading and Writing 36 (2023), 1589-1608, published online in 2022. DOI: 10.1007/s11145-022-10328-9. Participants: 145 Norwegian university students. Samsung Galaxy A02s phone and Lenovo Tab M10 tablet, both Android 10. Text: 1492 words. Paging led to more strategic backtracking; better integrated understanding was a tendency. This was a reading study, with no investing task or iOS scroll-depth measure. Choice research: Iyengar and Kamenica (2010), Journal of Public Economics 94, 530-539, DOI 10.1016/j.jpubeco.2010.03.006. Laboratory experiments and records of over 500,000 employees at 638 institutions. Evidence of simplicity seeking, not proof of Ionic conversion uplift. W3C carousel guidance supports user controls to pause moving content. Experiment: first unassisted completed investment within seven days divided by all eligible importers with no prior transaction assigned to each version. Record assistance consistently, and monitor costs, risk understanding, funding failures, cancellations and complaints. Set sample size from the measured baseline. Test static layout first, then motion. The AI feature is an additional hypothesis. Source-linked explanations could help users make sense of products, but no conversion uplift is claimed. Evaluate accuracy, source freshness and whether users understand both the appeal and downside.</a:t>
             </a:r>
           </a:p>
         </p:txBody>
@@ -702,7 +702,7 @@
           <p:cNvPr id="3" name="Title">
             <a:extLst xmlns:a="http://schemas.openxmlformats.org/drawingml/2006/main">
               <a:ext uri="{FF2B5EF4-FFF2-40B4-BE49-F238E27FC236}">
-                <a16:creationId xmlns:a16="http://schemas.microsoft.com/office/drawing/2014/main" id="{64B42641-C88F-41B5-9782-3A5AA1179FCD}"/>
+                <a16:creationId xmlns:a16="http://schemas.microsoft.com/office/drawing/2014/main" id="{1BCD04AD-8B83-40B6-A030-4CDA2A3A245F}"/>
               </a:ext>
             </a:extLst>
           </p:cNvPr>
@@ -931,7 +931,7 @@
           <p:cNvPr id="2" name="Subtitle">
             <a:extLst xmlns:a="http://schemas.openxmlformats.org/drawingml/2006/main">
               <a:ext uri="{FF2B5EF4-FFF2-40B4-BE49-F238E27FC236}">
-                <a16:creationId xmlns:a16="http://schemas.microsoft.com/office/drawing/2014/main" id="{8D86878F-89E8-4A77-BE75-CAA5C15A611C}"/>
+                <a16:creationId xmlns:a16="http://schemas.microsoft.com/office/drawing/2014/main" id="{805E3343-54EC-46C6-ABF5-1F876D3E2877}"/>
               </a:ext>
             </a:extLst>
           </p:cNvPr>
@@ -1177,7 +1177,7 @@
           <p:cNvPr id="2" name="Section title">
             <a:extLst xmlns:a="http://schemas.openxmlformats.org/drawingml/2006/main">
               <a:ext uri="{FF2B5EF4-FFF2-40B4-BE49-F238E27FC236}">
-                <a16:creationId xmlns:a16="http://schemas.microsoft.com/office/drawing/2014/main" id="{44308D8E-618D-4D09-BBA6-D1B6C1130F10}"/>
+                <a16:creationId xmlns:a16="http://schemas.microsoft.com/office/drawing/2014/main" id="{63DEFE71-A9E2-40CC-AD28-FA0589767C5C}"/>
               </a:ext>
             </a:extLst>
           </p:cNvPr>
@@ -1423,7 +1423,7 @@
           <p:cNvPr id="3" name="Title">
             <a:extLst xmlns:a="http://schemas.openxmlformats.org/drawingml/2006/main">
               <a:ext uri="{FF2B5EF4-FFF2-40B4-BE49-F238E27FC236}">
-                <a16:creationId xmlns:a16="http://schemas.microsoft.com/office/drawing/2014/main" id="{4A5B8DCD-0E2F-4A98-A59D-4D633D0A2FE3}"/>
+                <a16:creationId xmlns:a16="http://schemas.microsoft.com/office/drawing/2014/main" id="{F4735274-7AEB-4D74-8625-C4824D45AFF6}"/>
               </a:ext>
             </a:extLst>
           </p:cNvPr>
@@ -1652,7 +1652,7 @@
           <p:cNvPr id="2" name="Body">
             <a:extLst xmlns:a="http://schemas.openxmlformats.org/drawingml/2006/main">
               <a:ext uri="{FF2B5EF4-FFF2-40B4-BE49-F238E27FC236}">
-                <a16:creationId xmlns:a16="http://schemas.microsoft.com/office/drawing/2014/main" id="{8469AC1F-B900-4AA9-A2F7-9C155B6699FE}"/>
+                <a16:creationId xmlns:a16="http://schemas.microsoft.com/office/drawing/2014/main" id="{979862DD-16D1-4EB7-A180-B7F9780507BF}"/>
               </a:ext>
             </a:extLst>
           </p:cNvPr>
@@ -1898,7 +1898,7 @@
           <p:cNvPr id="4" name="Title">
             <a:extLst xmlns:a="http://schemas.openxmlformats.org/drawingml/2006/main">
               <a:ext uri="{FF2B5EF4-FFF2-40B4-BE49-F238E27FC236}">
-                <a16:creationId xmlns:a16="http://schemas.microsoft.com/office/drawing/2014/main" id="{8197F0D7-5C01-472A-90A5-E2D6CCC39575}"/>
+                <a16:creationId xmlns:a16="http://schemas.microsoft.com/office/drawing/2014/main" id="{F5DF940F-A140-4A91-BFE3-43833CD13A61}"/>
               </a:ext>
             </a:extLst>
           </p:cNvPr>
@@ -2127,7 +2127,7 @@
           <p:cNvPr id="2" name="Left column">
             <a:extLst xmlns:a="http://schemas.openxmlformats.org/drawingml/2006/main">
               <a:ext uri="{FF2B5EF4-FFF2-40B4-BE49-F238E27FC236}">
-                <a16:creationId xmlns:a16="http://schemas.microsoft.com/office/drawing/2014/main" id="{2E0F6820-2DA9-4EE1-9116-337EEF238A3F}"/>
+                <a16:creationId xmlns:a16="http://schemas.microsoft.com/office/drawing/2014/main" id="{049365DF-41BB-4D52-810C-5D601DDFB884}"/>
               </a:ext>
             </a:extLst>
           </p:cNvPr>
@@ -2356,7 +2356,7 @@
           <p:cNvPr id="3" name="Right column">
             <a:extLst xmlns:a="http://schemas.openxmlformats.org/drawingml/2006/main">
               <a:ext uri="{FF2B5EF4-FFF2-40B4-BE49-F238E27FC236}">
-                <a16:creationId xmlns:a16="http://schemas.microsoft.com/office/drawing/2014/main" id="{C6019FBA-ADC5-476A-9DAE-E7D354E2254C}"/>
+                <a16:creationId xmlns:a16="http://schemas.microsoft.com/office/drawing/2014/main" id="{642C6C3D-C238-4D08-98C2-52A31332261A}"/>
               </a:ext>
             </a:extLst>
           </p:cNvPr>
@@ -2602,7 +2602,7 @@
           <p:cNvPr id="3" name="Title">
             <a:extLst xmlns:a="http://schemas.openxmlformats.org/drawingml/2006/main">
               <a:ext uri="{FF2B5EF4-FFF2-40B4-BE49-F238E27FC236}">
-                <a16:creationId xmlns:a16="http://schemas.microsoft.com/office/drawing/2014/main" id="{8F037667-514A-408F-A30B-6D704F248D5E}"/>
+                <a16:creationId xmlns:a16="http://schemas.microsoft.com/office/drawing/2014/main" id="{99553C17-F2F5-465C-BDA8-383278D5B81B}"/>
               </a:ext>
             </a:extLst>
           </p:cNvPr>
@@ -2831,7 +2831,7 @@
           <p:cNvPr id="2" name="Left column">
             <a:extLst xmlns:a="http://schemas.openxmlformats.org/drawingml/2006/main">
               <a:ext uri="{FF2B5EF4-FFF2-40B4-BE49-F238E27FC236}">
-                <a16:creationId xmlns:a16="http://schemas.microsoft.com/office/drawing/2014/main" id="{7877AA57-B3FF-48CD-988B-1E5A6AC0E4BA}"/>
+                <a16:creationId xmlns:a16="http://schemas.microsoft.com/office/drawing/2014/main" id="{5404E471-D584-4F7A-9ADE-EE82EDBB45F1}"/>
               </a:ext>
             </a:extLst>
           </p:cNvPr>
@@ -3098,12 +3098,12 @@
   </p:cSld>
   <p:clrMap bg1="lt1" tx1="dk1" bg2="lt2" tx2="dk2" accent1="accent1" accent2="accent2" accent3="accent3" accent4="accent4" accent5="accent5" accent6="accent6" hlink="hlink" folHlink="folHlink"/>
   <p:sldLayoutIdLst>
-    <p:sldLayoutId xmlns:r="http://schemas.openxmlformats.org/officeDocument/2006/relationships" id="2147483649" r:id="R0c951b8e29f5497e"/>
-    <p:sldLayoutId xmlns:r="http://schemas.openxmlformats.org/officeDocument/2006/relationships" id="2147483650" r:id="Ra93dd469523c427c"/>
-    <p:sldLayoutId xmlns:r="http://schemas.openxmlformats.org/officeDocument/2006/relationships" id="2147483651" r:id="Re3774386547340c2"/>
-    <p:sldLayoutId xmlns:r="http://schemas.openxmlformats.org/officeDocument/2006/relationships" id="2147483652" r:id="R68f8a1d1b77e473b"/>
-    <p:sldLayoutId xmlns:r="http://schemas.openxmlformats.org/officeDocument/2006/relationships" id="2147483653" r:id="Ra7ce76c607134cef"/>
-    <p:sldLayoutId xmlns:r="http://schemas.openxmlformats.org/officeDocument/2006/relationships" id="2147483654" r:id="Rdef86e0a415044d4"/>
+    <p:sldLayoutId xmlns:r="http://schemas.openxmlformats.org/officeDocument/2006/relationships" id="2147483649" r:id="R7d6bc5b25c4d4562"/>
+    <p:sldLayoutId xmlns:r="http://schemas.openxmlformats.org/officeDocument/2006/relationships" id="2147483650" r:id="R97bcd52412d140e0"/>
+    <p:sldLayoutId xmlns:r="http://schemas.openxmlformats.org/officeDocument/2006/relationships" id="2147483651" r:id="Refd60a9a84b14810"/>
+    <p:sldLayoutId xmlns:r="http://schemas.openxmlformats.org/officeDocument/2006/relationships" id="2147483652" r:id="R7b8917c7037a4d7e"/>
+    <p:sldLayoutId xmlns:r="http://schemas.openxmlformats.org/officeDocument/2006/relationships" id="2147483653" r:id="Re48d72dbb4294ead"/>
+    <p:sldLayoutId xmlns:r="http://schemas.openxmlformats.org/officeDocument/2006/relationships" id="2147483654" r:id="R086ed705161a43ad"/>
   </p:sldLayoutIdLst>
   <p:txStyles>
     <p:titleStyle>
@@ -3654,7 +3654,7 @@
           <p:cNvPr id="9" name="">
             <a:extLst xmlns:a="http://schemas.openxmlformats.org/drawingml/2006/main">
               <a:ext uri="{FF2B5EF4-FFF2-40B4-BE49-F238E27FC236}">
-                <a16:creationId xmlns:a16="http://schemas.microsoft.com/office/drawing/2014/main" id="{DD67F971-74E5-472B-96CF-A9F8B43000D7}"/>
+                <a16:creationId xmlns:a16="http://schemas.microsoft.com/office/drawing/2014/main" id="{8A2B23D5-34CF-4195-8B8E-6F97D75463FC}"/>
               </a:ext>
             </a:extLst>
           </p:cNvPr>
@@ -3810,7 +3810,7 @@
           <p:cNvPr id="2" name="">
             <a:extLst xmlns:a="http://schemas.openxmlformats.org/drawingml/2006/main">
               <a:ext uri="{FF2B5EF4-FFF2-40B4-BE49-F238E27FC236}">
-                <a16:creationId xmlns:a16="http://schemas.microsoft.com/office/drawing/2014/main" id="{1C426BEE-9C79-41E2-9A7C-27024FB65EB7}"/>
+                <a16:creationId xmlns:a16="http://schemas.microsoft.com/office/drawing/2014/main" id="{522DAF92-FD80-4B54-A2BE-FE66A271EFA9}"/>
               </a:ext>
             </a:extLst>
           </p:cNvPr>
@@ -3989,7 +3989,7 @@
           <p:cNvPr id="3" name="">
             <a:extLst xmlns:a="http://schemas.openxmlformats.org/drawingml/2006/main">
               <a:ext uri="{FF2B5EF4-FFF2-40B4-BE49-F238E27FC236}">
-                <a16:creationId xmlns:a16="http://schemas.microsoft.com/office/drawing/2014/main" id="{AD930A36-F557-4A78-9CD9-B1BD1BCE1237}"/>
+                <a16:creationId xmlns:a16="http://schemas.microsoft.com/office/drawing/2014/main" id="{31DCFFCB-E096-4E32-81BD-BFDD6B7FC92F}"/>
               </a:ext>
             </a:extLst>
           </p:cNvPr>
@@ -4145,7 +4145,7 @@
           <p:cNvPr id="4" name="">
             <a:extLst xmlns:a="http://schemas.openxmlformats.org/drawingml/2006/main">
               <a:ext uri="{FF2B5EF4-FFF2-40B4-BE49-F238E27FC236}">
-                <a16:creationId xmlns:a16="http://schemas.microsoft.com/office/drawing/2014/main" id="{30AB0FF3-8832-46C5-8AE9-A4C82C935A11}"/>
+                <a16:creationId xmlns:a16="http://schemas.microsoft.com/office/drawing/2014/main" id="{064F0F10-C5F7-441B-9D09-4C99CB428B38}"/>
               </a:ext>
             </a:extLst>
           </p:cNvPr>
@@ -4301,7 +4301,7 @@
           <p:cNvPr id="5" name="">
             <a:extLst xmlns:a="http://schemas.openxmlformats.org/drawingml/2006/main">
               <a:ext uri="{FF2B5EF4-FFF2-40B4-BE49-F238E27FC236}">
-                <a16:creationId xmlns:a16="http://schemas.microsoft.com/office/drawing/2014/main" id="{70CF7155-2787-47DC-9C1D-07635C5CCFD4}"/>
+                <a16:creationId xmlns:a16="http://schemas.microsoft.com/office/drawing/2014/main" id="{623E2439-158B-400A-BF5A-0F60A41059E3}"/>
               </a:ext>
             </a:extLst>
           </p:cNvPr>
@@ -4457,7 +4457,7 @@
           <p:cNvPr id="6" name="">
             <a:extLst xmlns:a="http://schemas.openxmlformats.org/drawingml/2006/main">
               <a:ext uri="{FF2B5EF4-FFF2-40B4-BE49-F238E27FC236}">
-                <a16:creationId xmlns:a16="http://schemas.microsoft.com/office/drawing/2014/main" id="{AAADF7AD-23B1-40B0-8C7B-A3B0CE29E24A}"/>
+                <a16:creationId xmlns:a16="http://schemas.microsoft.com/office/drawing/2014/main" id="{3F67FF73-FDD1-48F3-A3E8-3D445C6BC216}"/>
               </a:ext>
             </a:extLst>
           </p:cNvPr>
@@ -4613,7 +4613,7 @@
           <p:cNvPr id="7" name="">
             <a:extLst xmlns:a="http://schemas.openxmlformats.org/drawingml/2006/main">
               <a:ext uri="{FF2B5EF4-FFF2-40B4-BE49-F238E27FC236}">
-                <a16:creationId xmlns:a16="http://schemas.microsoft.com/office/drawing/2014/main" id="{AC1FEEA6-C0AB-41E6-965B-360E2F8A66BC}"/>
+                <a16:creationId xmlns:a16="http://schemas.microsoft.com/office/drawing/2014/main" id="{9BB745B9-8BCF-4AA2-ABD4-49D294B39068}"/>
               </a:ext>
             </a:extLst>
           </p:cNvPr>
@@ -4769,7 +4769,7 @@
           <p:cNvPr id="8" name="">
             <a:extLst xmlns:a="http://schemas.openxmlformats.org/drawingml/2006/main">
               <a:ext uri="{FF2B5EF4-FFF2-40B4-BE49-F238E27FC236}">
-                <a16:creationId xmlns:a16="http://schemas.microsoft.com/office/drawing/2014/main" id="{0C758800-E133-4E7C-A714-821B2D10DE82}"/>
+                <a16:creationId xmlns:a16="http://schemas.microsoft.com/office/drawing/2014/main" id="{7E48E64F-7760-4F8A-8AB5-C6EC7F6C63E1}"/>
               </a:ext>
             </a:extLst>
           </p:cNvPr>
@@ -4779,7 +4779,7 @@
           <p:nvPr/>
         </p:nvPicPr>
         <p:blipFill>
-          <a:blip xmlns:r="http://schemas.openxmlformats.org/officeDocument/2006/relationships" xmlns:a="http://schemas.openxmlformats.org/drawingml/2006/main" r:embed="R5a0b8cba0a014fd0"/>
+          <a:blip xmlns:r="http://schemas.openxmlformats.org/officeDocument/2006/relationships" xmlns:a="http://schemas.openxmlformats.org/drawingml/2006/main" r:embed="Ra9c5112416844d2d"/>
           <a:stretch xmlns:a="http://schemas.openxmlformats.org/drawingml/2006/main"/>
         </p:blipFill>
         <p:spPr>
@@ -4795,7 +4795,7 @@
     </p:spTree>
     <p:extLst>
       <p:ext uri="{BB962C8B-B14F-4D97-AF65-F5344CB8AC3E}">
-        <p14:creationId xmlns:p14="http://schemas.microsoft.com/office/powerpoint/2010/main" val="1618733976"/>
+        <p14:creationId xmlns:p14="http://schemas.microsoft.com/office/powerpoint/2010/main" val="853908249"/>
       </p:ext>
     </p:extLst>
   </p:cSld>
@@ -4826,7 +4826,7 @@
           <p:cNvPr id="12" name="">
             <a:extLst xmlns:a="http://schemas.openxmlformats.org/drawingml/2006/main">
               <a:ext uri="{FF2B5EF4-FFF2-40B4-BE49-F238E27FC236}">
-                <a16:creationId xmlns:a16="http://schemas.microsoft.com/office/drawing/2014/main" id="{9D02C14B-7291-48FA-BE3E-A1E168AF0C3D}"/>
+                <a16:creationId xmlns:a16="http://schemas.microsoft.com/office/drawing/2014/main" id="{21AFD41B-87CA-4C87-A17F-763958275AA0}"/>
               </a:ext>
             </a:extLst>
           </p:cNvPr>
@@ -4982,7 +4982,7 @@
           <p:cNvPr id="2" name="">
             <a:extLst xmlns:a="http://schemas.openxmlformats.org/drawingml/2006/main">
               <a:ext uri="{FF2B5EF4-FFF2-40B4-BE49-F238E27FC236}">
-                <a16:creationId xmlns:a16="http://schemas.microsoft.com/office/drawing/2014/main" id="{80F0E088-8572-4D86-9190-4B2DA16EDE64}"/>
+                <a16:creationId xmlns:a16="http://schemas.microsoft.com/office/drawing/2014/main" id="{CF07B2EE-DE3C-4E15-AB05-A9C8332013A7}"/>
               </a:ext>
             </a:extLst>
           </p:cNvPr>
@@ -5138,7 +5138,7 @@
           <p:cNvPr id="3" name="">
             <a:extLst xmlns:a="http://schemas.openxmlformats.org/drawingml/2006/main">
               <a:ext uri="{FF2B5EF4-FFF2-40B4-BE49-F238E27FC236}">
-                <a16:creationId xmlns:a16="http://schemas.microsoft.com/office/drawing/2014/main" id="{177F9A1C-8D7E-4E96-A4F4-3748BD8D16F9}"/>
+                <a16:creationId xmlns:a16="http://schemas.microsoft.com/office/drawing/2014/main" id="{A9C4EEDE-4E09-47D0-A0A2-9321B6723A5F}"/>
               </a:ext>
             </a:extLst>
           </p:cNvPr>
@@ -5148,7 +5148,7 @@
           <p:nvPr/>
         </p:nvPicPr>
         <p:blipFill>
-          <a:blip xmlns:r="http://schemas.openxmlformats.org/officeDocument/2006/relationships" xmlns:a="http://schemas.openxmlformats.org/drawingml/2006/main" r:embed="Rbcd0b3e35543471e"/>
+          <a:blip xmlns:r="http://schemas.openxmlformats.org/officeDocument/2006/relationships" xmlns:a="http://schemas.openxmlformats.org/drawingml/2006/main" r:embed="R62b2693484404634"/>
           <a:stretch xmlns:a="http://schemas.openxmlformats.org/drawingml/2006/main"/>
         </p:blipFill>
         <p:spPr>
@@ -5166,7 +5166,7 @@
           <p:cNvPr id="4" name="">
             <a:extLst xmlns:a="http://schemas.openxmlformats.org/drawingml/2006/main">
               <a:ext uri="{FF2B5EF4-FFF2-40B4-BE49-F238E27FC236}">
-                <a16:creationId xmlns:a16="http://schemas.microsoft.com/office/drawing/2014/main" id="{6B02AF58-4C79-43FB-9F27-B9FA040C38F3}"/>
+                <a16:creationId xmlns:a16="http://schemas.microsoft.com/office/drawing/2014/main" id="{A8E03962-12EB-42F3-B3EB-F12C792CCF65}"/>
               </a:ext>
             </a:extLst>
           </p:cNvPr>
@@ -5176,7 +5176,7 @@
           <p:nvPr/>
         </p:nvPicPr>
         <p:blipFill>
-          <a:blip xmlns:r="http://schemas.openxmlformats.org/officeDocument/2006/relationships" xmlns:a="http://schemas.openxmlformats.org/drawingml/2006/main" r:embed="R9b009a87770e4c0a"/>
+          <a:blip xmlns:r="http://schemas.openxmlformats.org/officeDocument/2006/relationships" xmlns:a="http://schemas.openxmlformats.org/drawingml/2006/main" r:embed="R74e03e7f65e14f89"/>
           <a:stretch xmlns:a="http://schemas.openxmlformats.org/drawingml/2006/main"/>
         </p:blipFill>
         <p:spPr>
@@ -5194,7 +5194,7 @@
           <p:cNvPr id="5" name="">
             <a:extLst xmlns:a="http://schemas.openxmlformats.org/drawingml/2006/main">
               <a:ext uri="{FF2B5EF4-FFF2-40B4-BE49-F238E27FC236}">
-                <a16:creationId xmlns:a16="http://schemas.microsoft.com/office/drawing/2014/main" id="{5B7DCA62-6E65-4F55-A10C-80B1F6E746B4}"/>
+                <a16:creationId xmlns:a16="http://schemas.microsoft.com/office/drawing/2014/main" id="{0144BE32-E6FE-4B8D-B6D7-0F653EAF1CD9}"/>
               </a:ext>
             </a:extLst>
           </p:cNvPr>
@@ -5204,7 +5204,7 @@
           <p:nvPr/>
         </p:nvPicPr>
         <p:blipFill>
-          <a:blip xmlns:r="http://schemas.openxmlformats.org/officeDocument/2006/relationships" xmlns:a="http://schemas.openxmlformats.org/drawingml/2006/main" r:embed="R6ab59f9af3054840"/>
+          <a:blip xmlns:r="http://schemas.openxmlformats.org/officeDocument/2006/relationships" xmlns:a="http://schemas.openxmlformats.org/drawingml/2006/main" r:embed="Rb654a00c5d7146e7"/>
           <a:stretch xmlns:a="http://schemas.openxmlformats.org/drawingml/2006/main"/>
         </p:blipFill>
         <p:spPr>
@@ -5222,7 +5222,7 @@
           <p:cNvPr id="6" name="">
             <a:extLst xmlns:a="http://schemas.openxmlformats.org/drawingml/2006/main">
               <a:ext uri="{FF2B5EF4-FFF2-40B4-BE49-F238E27FC236}">
-                <a16:creationId xmlns:a16="http://schemas.microsoft.com/office/drawing/2014/main" id="{ACA371F6-93E8-4C81-979A-0E4307C599B5}"/>
+                <a16:creationId xmlns:a16="http://schemas.microsoft.com/office/drawing/2014/main" id="{CFBCCBFB-52FB-4793-975A-DE35C97D5F93}"/>
               </a:ext>
             </a:extLst>
           </p:cNvPr>
@@ -5378,7 +5378,7 @@
           <p:cNvPr id="7" name="">
             <a:extLst xmlns:a="http://schemas.openxmlformats.org/drawingml/2006/main">
               <a:ext uri="{FF2B5EF4-FFF2-40B4-BE49-F238E27FC236}">
-                <a16:creationId xmlns:a16="http://schemas.microsoft.com/office/drawing/2014/main" id="{FD451ACB-D5E0-442E-AF8C-99E495FE466E}"/>
+                <a16:creationId xmlns:a16="http://schemas.microsoft.com/office/drawing/2014/main" id="{1C637EBA-AD16-4B4B-A2DB-629CAA0AE3EA}"/>
               </a:ext>
             </a:extLst>
           </p:cNvPr>
@@ -5524,7 +5524,7 @@
                 <a:ea typeface="Arial"/>
                 <a:cs typeface="Arial"/>
               </a:rPr>
-              <a:t>Search familiar companies. See the share price and daily change before opening a product.</a:t>
+              <a:t>See the share price, compare companies, or open the blue flower for a deeper explanation.</a:t>
             </a:r>
           </a:p>
         </p:txBody>
@@ -5534,7 +5534,7 @@
           <p:cNvPr id="8" name="">
             <a:extLst xmlns:a="http://schemas.openxmlformats.org/drawingml/2006/main">
               <a:ext uri="{FF2B5EF4-FFF2-40B4-BE49-F238E27FC236}">
-                <a16:creationId xmlns:a16="http://schemas.microsoft.com/office/drawing/2014/main" id="{55B10A19-1988-43F5-AD55-A0B70C23E92C}"/>
+                <a16:creationId xmlns:a16="http://schemas.microsoft.com/office/drawing/2014/main" id="{146B7978-8B10-4B25-9451-3740CCCA1EA5}"/>
               </a:ext>
             </a:extLst>
           </p:cNvPr>
@@ -5690,7 +5690,7 @@
           <p:cNvPr id="9" name="">
             <a:extLst xmlns:a="http://schemas.openxmlformats.org/drawingml/2006/main">
               <a:ext uri="{FF2B5EF4-FFF2-40B4-BE49-F238E27FC236}">
-                <a16:creationId xmlns:a16="http://schemas.microsoft.com/office/drawing/2014/main" id="{9668BFFB-9330-4954-83BE-51CA7155EF62}"/>
+                <a16:creationId xmlns:a16="http://schemas.microsoft.com/office/drawing/2014/main" id="{B2A9A298-698C-42C3-A357-AD857C6833CA}"/>
               </a:ext>
             </a:extLst>
           </p:cNvPr>
@@ -5836,7 +5836,7 @@
                 <a:ea typeface="Arial"/>
                 <a:cs typeface="Arial"/>
               </a:rPr>
-              <a:t>Keep mutual funds, managed US portfolios and the Ionic stock basket together, with their key facts.</a:t>
+              <a:t>Browse funds and baskets. Open the blue flower for the fund’s appeal, risks and approach.</a:t>
             </a:r>
           </a:p>
         </p:txBody>
@@ -5846,7 +5846,7 @@
           <p:cNvPr id="10" name="">
             <a:extLst xmlns:a="http://schemas.openxmlformats.org/drawingml/2006/main">
               <a:ext uri="{FF2B5EF4-FFF2-40B4-BE49-F238E27FC236}">
-                <a16:creationId xmlns:a16="http://schemas.microsoft.com/office/drawing/2014/main" id="{5423101C-66E2-49AC-9835-EB45EA38288D}"/>
+                <a16:creationId xmlns:a16="http://schemas.microsoft.com/office/drawing/2014/main" id="{E33273D2-E356-4039-97F9-411C67ACD369}"/>
               </a:ext>
             </a:extLst>
           </p:cNvPr>
@@ -6002,7 +6002,7 @@
           <p:cNvPr id="11" name="">
             <a:extLst xmlns:a="http://schemas.openxmlformats.org/drawingml/2006/main">
               <a:ext uri="{FF2B5EF4-FFF2-40B4-BE49-F238E27FC236}">
-                <a16:creationId xmlns:a16="http://schemas.microsoft.com/office/drawing/2014/main" id="{D5F3E8A4-1825-4DE7-A85D-423AA0E5539A}"/>
+                <a16:creationId xmlns:a16="http://schemas.microsoft.com/office/drawing/2014/main" id="{14A17156-1FA1-490C-9736-342B64CB18C2}"/>
               </a:ext>
             </a:extLst>
           </p:cNvPr>
@@ -6156,7 +6156,7 @@
     </p:spTree>
     <p:extLst>
       <p:ext uri="{BB962C8B-B14F-4D97-AF65-F5344CB8AC3E}">
-        <p14:creationId xmlns:p14="http://schemas.microsoft.com/office/powerpoint/2010/main" val="1727795398"/>
+        <p14:creationId xmlns:p14="http://schemas.microsoft.com/office/powerpoint/2010/main" val="790603576"/>
       </p:ext>
     </p:extLst>
   </p:cSld>
@@ -6184,10 +6184,10 @@
       </p:grpSpPr>
       <p:sp>
         <p:nvSpPr>
-          <p:cNvPr id="10" name="">
+          <p:cNvPr id="14" name="">
             <a:extLst xmlns:a="http://schemas.openxmlformats.org/drawingml/2006/main">
               <a:ext uri="{FF2B5EF4-FFF2-40B4-BE49-F238E27FC236}">
-                <a16:creationId xmlns:a16="http://schemas.microsoft.com/office/drawing/2014/main" id="{4F47BEF7-DA6F-45B4-A134-CA08AC1B3BC9}"/>
+                <a16:creationId xmlns:a16="http://schemas.microsoft.com/office/drawing/2014/main" id="{0AA73E33-786E-4B3E-A502-6536D9C02F13}"/>
               </a:ext>
             </a:extLst>
           </p:cNvPr>
@@ -6333,7 +6333,7 @@
                 <a:ea typeface="Arial"/>
                 <a:cs typeface="Arial"/>
               </a:rPr>
-              <a:t>3 / How does someone get closer to buying?</a:t>
+              <a:t>3 / AI support, at the point of doubt</a:t>
             </a:r>
           </a:p>
         </p:txBody>
@@ -6343,7 +6343,7 @@
           <p:cNvPr id="2" name="">
             <a:extLst xmlns:a="http://schemas.openxmlformats.org/drawingml/2006/main">
               <a:ext uri="{FF2B5EF4-FFF2-40B4-BE49-F238E27FC236}">
-                <a16:creationId xmlns:a16="http://schemas.microsoft.com/office/drawing/2014/main" id="{15614EEF-DE6A-402F-B363-B84357F8637B}"/>
+                <a16:creationId xmlns:a16="http://schemas.microsoft.com/office/drawing/2014/main" id="{40FA741A-3DF5-4E9B-AB49-9A72198E6647}"/>
               </a:ext>
             </a:extLst>
           </p:cNvPr>
@@ -6489,7 +6489,7 @@
                 <a:ea typeface="Arial"/>
                 <a:cs typeface="Arial"/>
               </a:rPr>
-              <a:t>Answer the questions that hold up the first purchase.</a:t>
+              <a:t>Help users understand the investment.</a:t>
             </a:r>
           </a:p>
         </p:txBody>
@@ -6499,7 +6499,7 @@
           <p:cNvPr id="3" name="">
             <a:extLst xmlns:a="http://schemas.openxmlformats.org/drawingml/2006/main">
               <a:ext uri="{FF2B5EF4-FFF2-40B4-BE49-F238E27FC236}">
-                <a16:creationId xmlns:a16="http://schemas.microsoft.com/office/drawing/2014/main" id="{067A72EF-33CA-4320-8207-DCF09C7A48C7}"/>
+                <a16:creationId xmlns:a16="http://schemas.microsoft.com/office/drawing/2014/main" id="{913FD728-D5F4-447A-A910-A98DA58304FC}"/>
               </a:ext>
             </a:extLst>
           </p:cNvPr>
@@ -6510,8 +6510,8 @@
         </p:nvSpPr>
         <p:spPr>
           <a:xfrm xmlns:a="http://schemas.openxmlformats.org/drawingml/2006/main">
-            <a:off x="590550" y="2009775"/>
-            <a:ext cx="6143625" cy="285750"/>
+            <a:off x="590550" y="2000250"/>
+            <a:ext cx="5715000" cy="285750"/>
           </a:xfrm>
           <a:prstGeom xmlns:a="http://schemas.openxmlformats.org/drawingml/2006/main" prst="rect">
             <a:avLst/>
@@ -6645,7 +6645,7 @@
                 <a:ea typeface="Arial"/>
                 <a:cs typeface="Arial"/>
               </a:rPr>
-              <a:t>What am I buying?</a:t>
+              <a:t>Explain the upside and downside</a:t>
             </a:r>
           </a:p>
         </p:txBody>
@@ -6655,7 +6655,7 @@
           <p:cNvPr id="4" name="">
             <a:extLst xmlns:a="http://schemas.openxmlformats.org/drawingml/2006/main">
               <a:ext uri="{FF2B5EF4-FFF2-40B4-BE49-F238E27FC236}">
-                <a16:creationId xmlns:a16="http://schemas.microsoft.com/office/drawing/2014/main" id="{5E578874-52BC-473D-886F-7579B9D26C74}"/>
+                <a16:creationId xmlns:a16="http://schemas.microsoft.com/office/drawing/2014/main" id="{CD40BB90-8761-44B3-A789-2EC74DE1F995}"/>
               </a:ext>
             </a:extLst>
           </p:cNvPr>
@@ -6666,8 +6666,8 @@
         </p:nvSpPr>
         <p:spPr>
           <a:xfrm xmlns:a="http://schemas.openxmlformats.org/drawingml/2006/main">
-            <a:off x="590550" y="2419350"/>
-            <a:ext cx="6143625" cy="923925"/>
+            <a:off x="590550" y="2409825"/>
+            <a:ext cx="5715000" cy="933450"/>
           </a:xfrm>
           <a:prstGeom xmlns:a="http://schemas.openxmlformats.org/drawingml/2006/main" prst="rect">
             <a:avLst/>
@@ -6801,7 +6801,7 @@
                 <a:ea typeface="Arial"/>
                 <a:cs typeface="Arial"/>
               </a:rPr>
-              <a:t>A stock card shows the full share price. The detail sheet explains that someone can buy a fraction from $1. Account funding and FX charges are separate.</a:t>
+              <a:t>Explain the business, what makes it interesting and what could go wrong. Let users switch between Overview, Strengths, Risks and Vision.</a:t>
             </a:r>
           </a:p>
         </p:txBody>
@@ -6811,7 +6811,7 @@
           <p:cNvPr id="5" name="">
             <a:extLst xmlns:a="http://schemas.openxmlformats.org/drawingml/2006/main">
               <a:ext uri="{FF2B5EF4-FFF2-40B4-BE49-F238E27FC236}">
-                <a16:creationId xmlns:a16="http://schemas.microsoft.com/office/drawing/2014/main" id="{62F11148-F20B-4BB1-9D81-0F39D5FD9B3B}"/>
+                <a16:creationId xmlns:a16="http://schemas.microsoft.com/office/drawing/2014/main" id="{8F0D7ECC-81BC-4AD9-9545-9091DEED23B7}"/>
               </a:ext>
             </a:extLst>
           </p:cNvPr>
@@ -6822,8 +6822,8 @@
         </p:nvSpPr>
         <p:spPr>
           <a:xfrm xmlns:a="http://schemas.openxmlformats.org/drawingml/2006/main">
-            <a:off x="590550" y="3619500"/>
-            <a:ext cx="6143625" cy="285750"/>
+            <a:off x="590550" y="3562350"/>
+            <a:ext cx="5715000" cy="285750"/>
           </a:xfrm>
           <a:prstGeom xmlns:a="http://schemas.openxmlformats.org/drawingml/2006/main" prst="rect">
             <a:avLst/>
@@ -6957,7 +6957,7 @@
                 <a:ea typeface="Arial"/>
                 <a:cs typeface="Arial"/>
               </a:rPr>
-              <a:t>What will it cost, and what could go wrong?</a:t>
+              <a:t>Make the company’s direction clear</a:t>
             </a:r>
           </a:p>
         </p:txBody>
@@ -6967,7 +6967,7 @@
           <p:cNvPr id="6" name="">
             <a:extLst xmlns:a="http://schemas.openxmlformats.org/drawingml/2006/main">
               <a:ext uri="{FF2B5EF4-FFF2-40B4-BE49-F238E27FC236}">
-                <a16:creationId xmlns:a16="http://schemas.microsoft.com/office/drawing/2014/main" id="{C253DC77-FA70-46FE-A2BF-6FD610DFBC79}"/>
+                <a16:creationId xmlns:a16="http://schemas.microsoft.com/office/drawing/2014/main" id="{37DEE84D-0047-4D3A-B18D-3D3CD3E685D0}"/>
               </a:ext>
             </a:extLst>
           </p:cNvPr>
@@ -6978,8 +6978,8 @@
         </p:nvSpPr>
         <p:spPr>
           <a:xfrm xmlns:a="http://schemas.openxmlformats.org/drawingml/2006/main">
-            <a:off x="590550" y="4029075"/>
-            <a:ext cx="6143625" cy="923925"/>
+            <a:off x="590550" y="3971925"/>
+            <a:ext cx="5715000" cy="933450"/>
           </a:xfrm>
           <a:prstGeom xmlns:a="http://schemas.openxmlformats.org/drawingml/2006/main" prst="rect">
             <a:avLst/>
@@ -7113,7 +7113,7 @@
                 <a:ea typeface="Arial"/>
                 <a:cs typeface="Arial"/>
               </a:rPr>
-              <a:t>Keep ownership, fees and key risks together. If a fee or minimum is missing from the source screen, say what still needs to be checked with the provider.</a:t>
+              <a:t>Summarise the company’s stated direction and link to its filing. Separate those plans from any claim about the future share price.</a:t>
             </a:r>
           </a:p>
         </p:txBody>
@@ -7123,7 +7123,7 @@
           <p:cNvPr id="7" name="">
             <a:extLst xmlns:a="http://schemas.openxmlformats.org/drawingml/2006/main">
               <a:ext uri="{FF2B5EF4-FFF2-40B4-BE49-F238E27FC236}">
-                <a16:creationId xmlns:a16="http://schemas.microsoft.com/office/drawing/2014/main" id="{EA08F9F6-7545-4B17-BAE1-CC55F5D5C81D}"/>
+                <a16:creationId xmlns:a16="http://schemas.microsoft.com/office/drawing/2014/main" id="{7ADB5C1F-9761-4501-BF8B-92182F9F8999}"/>
               </a:ext>
             </a:extLst>
           </p:cNvPr>
@@ -7134,8 +7134,8 @@
         </p:nvSpPr>
         <p:spPr>
           <a:xfrm xmlns:a="http://schemas.openxmlformats.org/drawingml/2006/main">
-            <a:off x="590550" y="5219700"/>
-            <a:ext cx="6143625" cy="285750"/>
+            <a:off x="590550" y="5124450"/>
+            <a:ext cx="5715000" cy="285750"/>
           </a:xfrm>
           <a:prstGeom xmlns:a="http://schemas.openxmlformats.org/drawingml/2006/main" prst="rect">
             <a:avLst/>
@@ -7269,7 +7269,7 @@
                 <a:ea typeface="Arial"/>
                 <a:cs typeface="Arial"/>
               </a:rPr>
-              <a:t>What happens next?</a:t>
+              <a:t>Help the user decide what to check next</a:t>
             </a:r>
           </a:p>
         </p:txBody>
@@ -7279,7 +7279,7 @@
           <p:cNvPr id="8" name="">
             <a:extLst xmlns:a="http://schemas.openxmlformats.org/drawingml/2006/main">
               <a:ext uri="{FF2B5EF4-FFF2-40B4-BE49-F238E27FC236}">
-                <a16:creationId xmlns:a16="http://schemas.microsoft.com/office/drawing/2014/main" id="{9456A95F-DC06-41B3-B7AA-34ECCA7341C4}"/>
+                <a16:creationId xmlns:a16="http://schemas.microsoft.com/office/drawing/2014/main" id="{ED8F6A72-BA24-4E32-8A2B-AA615149DC63}"/>
               </a:ext>
             </a:extLst>
           </p:cNvPr>
@@ -7290,8 +7290,8 @@
         </p:nvSpPr>
         <p:spPr>
           <a:xfrm xmlns:a="http://schemas.openxmlformats.org/drawingml/2006/main">
-            <a:off x="590550" y="5629275"/>
-            <a:ext cx="6143625" cy="895350"/>
+            <a:off x="590550" y="5534025"/>
+            <a:ext cx="5715000" cy="933450"/>
           </a:xfrm>
           <a:prstGeom xmlns:a="http://schemas.openxmlformats.org/drawingml/2006/main" prst="rect">
             <a:avLst/>
@@ -7425,7 +7425,7 @@
                 <a:ea typeface="Arial"/>
                 <a:cs typeface="Arial"/>
               </a:rPr>
-              <a:t>Explain verification, funding and order review before the handoff. This gives the user a concrete next step and makes the setup requirements visible.</a:t>
+              <a:t>Fund deep dives explain the mandate, exposure and costs. For US stocks, call out funding and FX needs. Link back to the product details before the next step.</a:t>
             </a:r>
           </a:p>
         </p:txBody>
@@ -7435,7 +7435,7 @@
           <p:cNvPr id="9" name="">
             <a:extLst xmlns:a="http://schemas.openxmlformats.org/drawingml/2006/main">
               <a:ext uri="{FF2B5EF4-FFF2-40B4-BE49-F238E27FC236}">
-                <a16:creationId xmlns:a16="http://schemas.microsoft.com/office/drawing/2014/main" id="{1B1578D8-42CD-4BEE-8436-B5C3B877EEC8}"/>
+                <a16:creationId xmlns:a16="http://schemas.microsoft.com/office/drawing/2014/main" id="{C7C2AB23-423F-479E-BA22-D051B94D6958}"/>
               </a:ext>
             </a:extLst>
           </p:cNvPr>
@@ -7445,23 +7445,519 @@
           <p:nvPr/>
         </p:nvPicPr>
         <p:blipFill>
-          <a:blip xmlns:r="http://schemas.openxmlformats.org/officeDocument/2006/relationships" xmlns:a="http://schemas.openxmlformats.org/drawingml/2006/main" r:embed="Rfa54769571b343e2"/>
+          <a:blip xmlns:r="http://schemas.openxmlformats.org/officeDocument/2006/relationships" xmlns:a="http://schemas.openxmlformats.org/drawingml/2006/main" r:embed="Re54e3cd163c34dd1"/>
           <a:stretch xmlns:a="http://schemas.openxmlformats.org/drawingml/2006/main"/>
         </p:blipFill>
         <p:spPr>
           <a:xfrm xmlns:a="http://schemas.openxmlformats.org/drawingml/2006/main">
-            <a:off x="8343900" y="1735479"/>
-            <a:ext cx="2124075" cy="4596716"/>
+            <a:off x="7163195" y="1876425"/>
+            <a:ext cx="1808960" cy="3914775"/>
           </a:xfrm>
           <a:prstGeom xmlns:a="http://schemas.openxmlformats.org/drawingml/2006/main" prst="rect">
             <a:avLst/>
           </a:prstGeom>
         </p:spPr>
       </p:pic>
+      <p:pic>
+        <p:nvPicPr>
+          <p:cNvPr id="10" name="">
+            <a:extLst xmlns:a="http://schemas.openxmlformats.org/drawingml/2006/main">
+              <a:ext uri="{FF2B5EF4-FFF2-40B4-BE49-F238E27FC236}">
+                <a16:creationId xmlns:a16="http://schemas.microsoft.com/office/drawing/2014/main" id="{B70806EE-6BAD-4060-8081-ACF08C927B39}"/>
+              </a:ext>
+            </a:extLst>
+          </p:cNvPr>
+          <p:cNvPicPr>
+            <a:picLocks xmlns:a="http://schemas.openxmlformats.org/drawingml/2006/main" noChangeAspect="1"/>
+          </p:cNvPicPr>
+          <p:nvPr/>
+        </p:nvPicPr>
+        <p:blipFill>
+          <a:blip xmlns:r="http://schemas.openxmlformats.org/officeDocument/2006/relationships" xmlns:a="http://schemas.openxmlformats.org/drawingml/2006/main" r:embed="R44fcff8036984218"/>
+          <a:stretch xmlns:a="http://schemas.openxmlformats.org/drawingml/2006/main"/>
+        </p:blipFill>
+        <p:spPr>
+          <a:xfrm xmlns:a="http://schemas.openxmlformats.org/drawingml/2006/main">
+            <a:off x="9525395" y="1876425"/>
+            <a:ext cx="1808960" cy="3914775"/>
+          </a:xfrm>
+          <a:prstGeom xmlns:a="http://schemas.openxmlformats.org/drawingml/2006/main" prst="rect">
+            <a:avLst/>
+          </a:prstGeom>
+        </p:spPr>
+      </p:pic>
+      <p:sp>
+        <p:nvSpPr>
+          <p:cNvPr id="11" name="">
+            <a:extLst xmlns:a="http://schemas.openxmlformats.org/drawingml/2006/main">
+              <a:ext uri="{FF2B5EF4-FFF2-40B4-BE49-F238E27FC236}">
+                <a16:creationId xmlns:a16="http://schemas.microsoft.com/office/drawing/2014/main" id="{F9195FC9-420F-4F23-BCB2-A48810C2978B}"/>
+              </a:ext>
+            </a:extLst>
+          </p:cNvPr>
+          <p:cNvSpPr>
+            <a:spLocks xmlns:a="http://schemas.openxmlformats.org/drawingml/2006/main" noGrp="1"/>
+          </p:cNvSpPr>
+          <p:nvPr/>
+        </p:nvSpPr>
+        <p:spPr>
+          <a:xfrm xmlns:a="http://schemas.openxmlformats.org/drawingml/2006/main">
+            <a:off x="7162800" y="5981700"/>
+            <a:ext cx="2286000" cy="247650"/>
+          </a:xfrm>
+          <a:prstGeom xmlns:a="http://schemas.openxmlformats.org/drawingml/2006/main" prst="rect">
+            <a:avLst/>
+          </a:prstGeom>
+          <a:noFill xmlns:a="http://schemas.openxmlformats.org/drawingml/2006/main"/>
+          <a:ln xmlns:a="http://schemas.openxmlformats.org/drawingml/2006/main" w="0">
+            <a:noFill/>
+          </a:ln>
+        </p:spPr>
+        <p:txBody>
+          <a:bodyPr xmlns:a="http://schemas.openxmlformats.org/drawingml/2006/main"/>
+          <a:lstStyle xmlns:a="http://schemas.openxmlformats.org/drawingml/2006/main">
+            <a:defPPr>
+              <a:defRPr sz="1275" b="1">
+                <a:solidFill>
+                  <a:srgbClr val="28369F"/>
+                </a:solidFill>
+                <a:latin typeface="Arial"/>
+                <a:ea typeface="Arial"/>
+                <a:cs typeface="Arial"/>
+              </a:defRPr>
+            </a:defPPr>
+            <a:lvl1pPr>
+              <a:defRPr sz="1275" b="1">
+                <a:solidFill>
+                  <a:srgbClr val="28369F"/>
+                </a:solidFill>
+                <a:latin typeface="Arial"/>
+                <a:ea typeface="Arial"/>
+                <a:cs typeface="Arial"/>
+              </a:defRPr>
+            </a:lvl1pPr>
+            <a:lvl2pPr>
+              <a:defRPr sz="1275" b="1">
+                <a:solidFill>
+                  <a:srgbClr val="28369F"/>
+                </a:solidFill>
+                <a:latin typeface="Arial"/>
+                <a:ea typeface="Arial"/>
+                <a:cs typeface="Arial"/>
+              </a:defRPr>
+            </a:lvl2pPr>
+            <a:lvl3pPr>
+              <a:defRPr sz="1275" b="1">
+                <a:solidFill>
+                  <a:srgbClr val="28369F"/>
+                </a:solidFill>
+                <a:latin typeface="Arial"/>
+                <a:ea typeface="Arial"/>
+                <a:cs typeface="Arial"/>
+              </a:defRPr>
+            </a:lvl3pPr>
+            <a:lvl4pPr>
+              <a:defRPr sz="1275" b="1">
+                <a:solidFill>
+                  <a:srgbClr val="28369F"/>
+                </a:solidFill>
+                <a:latin typeface="Arial"/>
+                <a:ea typeface="Arial"/>
+                <a:cs typeface="Arial"/>
+              </a:defRPr>
+            </a:lvl4pPr>
+            <a:lvl5pPr>
+              <a:defRPr sz="1275" b="1">
+                <a:solidFill>
+                  <a:srgbClr val="28369F"/>
+                </a:solidFill>
+                <a:latin typeface="Arial"/>
+                <a:ea typeface="Arial"/>
+                <a:cs typeface="Arial"/>
+              </a:defRPr>
+            </a:lvl5pPr>
+            <a:lvl6pPr>
+              <a:defRPr sz="1275" b="1">
+                <a:solidFill>
+                  <a:srgbClr val="28369F"/>
+                </a:solidFill>
+                <a:latin typeface="Arial"/>
+                <a:ea typeface="Arial"/>
+                <a:cs typeface="Arial"/>
+              </a:defRPr>
+            </a:lvl6pPr>
+            <a:lvl7pPr>
+              <a:defRPr sz="1275" b="1">
+                <a:solidFill>
+                  <a:srgbClr val="28369F"/>
+                </a:solidFill>
+                <a:latin typeface="Arial"/>
+                <a:ea typeface="Arial"/>
+                <a:cs typeface="Arial"/>
+              </a:defRPr>
+            </a:lvl7pPr>
+            <a:lvl8pPr>
+              <a:defRPr sz="1275" b="1">
+                <a:solidFill>
+                  <a:srgbClr val="28369F"/>
+                </a:solidFill>
+                <a:latin typeface="Arial"/>
+                <a:ea typeface="Arial"/>
+                <a:cs typeface="Arial"/>
+              </a:defRPr>
+            </a:lvl8pPr>
+            <a:lvl9pPr>
+              <a:defRPr sz="1275" b="1">
+                <a:solidFill>
+                  <a:srgbClr val="28369F"/>
+                </a:solidFill>
+                <a:latin typeface="Arial"/>
+                <a:ea typeface="Arial"/>
+                <a:cs typeface="Arial"/>
+              </a:defRPr>
+            </a:lvl9pPr>
+          </a:lstStyle>
+          <a:p xmlns:a="http://schemas.openxmlformats.org/drawingml/2006/main">
+            <a:pPr>
+              <a:defRPr sz="1275" b="1">
+                <a:solidFill>
+                  <a:srgbClr val="28369F"/>
+                </a:solidFill>
+                <a:latin typeface="Arial"/>
+                <a:ea typeface="Arial"/>
+                <a:cs typeface="Arial"/>
+              </a:defRPr>
+            </a:pPr>
+            <a:r>
+              <a:rPr sz="1275" b="1">
+                <a:solidFill>
+                  <a:srgbClr val="28369F"/>
+                </a:solidFill>
+                <a:latin typeface="Arial"/>
+                <a:ea typeface="Arial"/>
+                <a:cs typeface="Arial"/>
+              </a:rPr>
+              <a:t>Stock deep dive</a:t>
+            </a:r>
+          </a:p>
+        </p:txBody>
+      </p:sp>
+      <p:sp>
+        <p:nvSpPr>
+          <p:cNvPr id="12" name="">
+            <a:extLst xmlns:a="http://schemas.openxmlformats.org/drawingml/2006/main">
+              <a:ext uri="{FF2B5EF4-FFF2-40B4-BE49-F238E27FC236}">
+                <a16:creationId xmlns:a16="http://schemas.microsoft.com/office/drawing/2014/main" id="{FB2B35F9-1161-4F10-862B-D78F3FE16574}"/>
+              </a:ext>
+            </a:extLst>
+          </p:cNvPr>
+          <p:cNvSpPr>
+            <a:spLocks xmlns:a="http://schemas.openxmlformats.org/drawingml/2006/main" noGrp="1"/>
+          </p:cNvSpPr>
+          <p:nvPr/>
+        </p:nvSpPr>
+        <p:spPr>
+          <a:xfrm xmlns:a="http://schemas.openxmlformats.org/drawingml/2006/main">
+            <a:off x="9525000" y="5981700"/>
+            <a:ext cx="2286000" cy="247650"/>
+          </a:xfrm>
+          <a:prstGeom xmlns:a="http://schemas.openxmlformats.org/drawingml/2006/main" prst="rect">
+            <a:avLst/>
+          </a:prstGeom>
+          <a:noFill xmlns:a="http://schemas.openxmlformats.org/drawingml/2006/main"/>
+          <a:ln xmlns:a="http://schemas.openxmlformats.org/drawingml/2006/main" w="0">
+            <a:noFill/>
+          </a:ln>
+        </p:spPr>
+        <p:txBody>
+          <a:bodyPr xmlns:a="http://schemas.openxmlformats.org/drawingml/2006/main"/>
+          <a:lstStyle xmlns:a="http://schemas.openxmlformats.org/drawingml/2006/main">
+            <a:defPPr>
+              <a:defRPr sz="1275" b="1">
+                <a:solidFill>
+                  <a:srgbClr val="28369F"/>
+                </a:solidFill>
+                <a:latin typeface="Arial"/>
+                <a:ea typeface="Arial"/>
+                <a:cs typeface="Arial"/>
+              </a:defRPr>
+            </a:defPPr>
+            <a:lvl1pPr>
+              <a:defRPr sz="1275" b="1">
+                <a:solidFill>
+                  <a:srgbClr val="28369F"/>
+                </a:solidFill>
+                <a:latin typeface="Arial"/>
+                <a:ea typeface="Arial"/>
+                <a:cs typeface="Arial"/>
+              </a:defRPr>
+            </a:lvl1pPr>
+            <a:lvl2pPr>
+              <a:defRPr sz="1275" b="1">
+                <a:solidFill>
+                  <a:srgbClr val="28369F"/>
+                </a:solidFill>
+                <a:latin typeface="Arial"/>
+                <a:ea typeface="Arial"/>
+                <a:cs typeface="Arial"/>
+              </a:defRPr>
+            </a:lvl2pPr>
+            <a:lvl3pPr>
+              <a:defRPr sz="1275" b="1">
+                <a:solidFill>
+                  <a:srgbClr val="28369F"/>
+                </a:solidFill>
+                <a:latin typeface="Arial"/>
+                <a:ea typeface="Arial"/>
+                <a:cs typeface="Arial"/>
+              </a:defRPr>
+            </a:lvl3pPr>
+            <a:lvl4pPr>
+              <a:defRPr sz="1275" b="1">
+                <a:solidFill>
+                  <a:srgbClr val="28369F"/>
+                </a:solidFill>
+                <a:latin typeface="Arial"/>
+                <a:ea typeface="Arial"/>
+                <a:cs typeface="Arial"/>
+              </a:defRPr>
+            </a:lvl4pPr>
+            <a:lvl5pPr>
+              <a:defRPr sz="1275" b="1">
+                <a:solidFill>
+                  <a:srgbClr val="28369F"/>
+                </a:solidFill>
+                <a:latin typeface="Arial"/>
+                <a:ea typeface="Arial"/>
+                <a:cs typeface="Arial"/>
+              </a:defRPr>
+            </a:lvl5pPr>
+            <a:lvl6pPr>
+              <a:defRPr sz="1275" b="1">
+                <a:solidFill>
+                  <a:srgbClr val="28369F"/>
+                </a:solidFill>
+                <a:latin typeface="Arial"/>
+                <a:ea typeface="Arial"/>
+                <a:cs typeface="Arial"/>
+              </a:defRPr>
+            </a:lvl6pPr>
+            <a:lvl7pPr>
+              <a:defRPr sz="1275" b="1">
+                <a:solidFill>
+                  <a:srgbClr val="28369F"/>
+                </a:solidFill>
+                <a:latin typeface="Arial"/>
+                <a:ea typeface="Arial"/>
+                <a:cs typeface="Arial"/>
+              </a:defRPr>
+            </a:lvl7pPr>
+            <a:lvl8pPr>
+              <a:defRPr sz="1275" b="1">
+                <a:solidFill>
+                  <a:srgbClr val="28369F"/>
+                </a:solidFill>
+                <a:latin typeface="Arial"/>
+                <a:ea typeface="Arial"/>
+                <a:cs typeface="Arial"/>
+              </a:defRPr>
+            </a:lvl8pPr>
+            <a:lvl9pPr>
+              <a:defRPr sz="1275" b="1">
+                <a:solidFill>
+                  <a:srgbClr val="28369F"/>
+                </a:solidFill>
+                <a:latin typeface="Arial"/>
+                <a:ea typeface="Arial"/>
+                <a:cs typeface="Arial"/>
+              </a:defRPr>
+            </a:lvl9pPr>
+          </a:lstStyle>
+          <a:p xmlns:a="http://schemas.openxmlformats.org/drawingml/2006/main">
+            <a:pPr>
+              <a:defRPr sz="1275" b="1">
+                <a:solidFill>
+                  <a:srgbClr val="28369F"/>
+                </a:solidFill>
+                <a:latin typeface="Arial"/>
+                <a:ea typeface="Arial"/>
+                <a:cs typeface="Arial"/>
+              </a:defRPr>
+            </a:pPr>
+            <a:r>
+              <a:rPr sz="1275" b="1">
+                <a:solidFill>
+                  <a:srgbClr val="28369F"/>
+                </a:solidFill>
+                <a:latin typeface="Arial"/>
+                <a:ea typeface="Arial"/>
+                <a:cs typeface="Arial"/>
+              </a:rPr>
+              <a:t>Mutual fund deep dive</a:t>
+            </a:r>
+          </a:p>
+        </p:txBody>
+      </p:sp>
+      <p:sp>
+        <p:nvSpPr>
+          <p:cNvPr id="13" name="">
+            <a:extLst xmlns:a="http://schemas.openxmlformats.org/drawingml/2006/main">
+              <a:ext uri="{FF2B5EF4-FFF2-40B4-BE49-F238E27FC236}">
+                <a16:creationId xmlns:a16="http://schemas.microsoft.com/office/drawing/2014/main" id="{DA8393FF-4842-4813-B8E7-CF3C8E552099}"/>
+              </a:ext>
+            </a:extLst>
+          </p:cNvPr>
+          <p:cNvSpPr>
+            <a:spLocks xmlns:a="http://schemas.openxmlformats.org/drawingml/2006/main" noGrp="1"/>
+          </p:cNvSpPr>
+          <p:nvPr/>
+        </p:nvSpPr>
+        <p:spPr>
+          <a:xfrm xmlns:a="http://schemas.openxmlformats.org/drawingml/2006/main">
+            <a:off x="590550" y="6600825"/>
+            <a:ext cx="10953750" cy="171450"/>
+          </a:xfrm>
+          <a:prstGeom xmlns:a="http://schemas.openxmlformats.org/drawingml/2006/main" prst="rect">
+            <a:avLst/>
+          </a:prstGeom>
+          <a:noFill xmlns:a="http://schemas.openxmlformats.org/drawingml/2006/main"/>
+          <a:ln xmlns:a="http://schemas.openxmlformats.org/drawingml/2006/main" w="0">
+            <a:noFill/>
+          </a:ln>
+        </p:spPr>
+        <p:txBody>
+          <a:bodyPr xmlns:a="http://schemas.openxmlformats.org/drawingml/2006/main"/>
+          <a:lstStyle xmlns:a="http://schemas.openxmlformats.org/drawingml/2006/main">
+            <a:defPPr>
+              <a:defRPr sz="825" b="0">
+                <a:solidFill>
+                  <a:srgbClr val="58677E"/>
+                </a:solidFill>
+                <a:latin typeface="Arial"/>
+                <a:ea typeface="Arial"/>
+                <a:cs typeface="Arial"/>
+              </a:defRPr>
+            </a:defPPr>
+            <a:lvl1pPr>
+              <a:defRPr sz="825" b="0">
+                <a:solidFill>
+                  <a:srgbClr val="58677E"/>
+                </a:solidFill>
+                <a:latin typeface="Arial"/>
+                <a:ea typeface="Arial"/>
+                <a:cs typeface="Arial"/>
+              </a:defRPr>
+            </a:lvl1pPr>
+            <a:lvl2pPr>
+              <a:defRPr sz="825" b="0">
+                <a:solidFill>
+                  <a:srgbClr val="58677E"/>
+                </a:solidFill>
+                <a:latin typeface="Arial"/>
+                <a:ea typeface="Arial"/>
+                <a:cs typeface="Arial"/>
+              </a:defRPr>
+            </a:lvl2pPr>
+            <a:lvl3pPr>
+              <a:defRPr sz="825" b="0">
+                <a:solidFill>
+                  <a:srgbClr val="58677E"/>
+                </a:solidFill>
+                <a:latin typeface="Arial"/>
+                <a:ea typeface="Arial"/>
+                <a:cs typeface="Arial"/>
+              </a:defRPr>
+            </a:lvl3pPr>
+            <a:lvl4pPr>
+              <a:defRPr sz="825" b="0">
+                <a:solidFill>
+                  <a:srgbClr val="58677E"/>
+                </a:solidFill>
+                <a:latin typeface="Arial"/>
+                <a:ea typeface="Arial"/>
+                <a:cs typeface="Arial"/>
+              </a:defRPr>
+            </a:lvl4pPr>
+            <a:lvl5pPr>
+              <a:defRPr sz="825" b="0">
+                <a:solidFill>
+                  <a:srgbClr val="58677E"/>
+                </a:solidFill>
+                <a:latin typeface="Arial"/>
+                <a:ea typeface="Arial"/>
+                <a:cs typeface="Arial"/>
+              </a:defRPr>
+            </a:lvl5pPr>
+            <a:lvl6pPr>
+              <a:defRPr sz="825" b="0">
+                <a:solidFill>
+                  <a:srgbClr val="58677E"/>
+                </a:solidFill>
+                <a:latin typeface="Arial"/>
+                <a:ea typeface="Arial"/>
+                <a:cs typeface="Arial"/>
+              </a:defRPr>
+            </a:lvl6pPr>
+            <a:lvl7pPr>
+              <a:defRPr sz="825" b="0">
+                <a:solidFill>
+                  <a:srgbClr val="58677E"/>
+                </a:solidFill>
+                <a:latin typeface="Arial"/>
+                <a:ea typeface="Arial"/>
+                <a:cs typeface="Arial"/>
+              </a:defRPr>
+            </a:lvl7pPr>
+            <a:lvl8pPr>
+              <a:defRPr sz="825" b="0">
+                <a:solidFill>
+                  <a:srgbClr val="58677E"/>
+                </a:solidFill>
+                <a:latin typeface="Arial"/>
+                <a:ea typeface="Arial"/>
+                <a:cs typeface="Arial"/>
+              </a:defRPr>
+            </a:lvl8pPr>
+            <a:lvl9pPr>
+              <a:defRPr sz="825" b="0">
+                <a:solidFill>
+                  <a:srgbClr val="58677E"/>
+                </a:solidFill>
+                <a:latin typeface="Arial"/>
+                <a:ea typeface="Arial"/>
+                <a:cs typeface="Arial"/>
+              </a:defRPr>
+            </a:lvl9pPr>
+          </a:lstStyle>
+          <a:p xmlns:a="http://schemas.openxmlformats.org/drawingml/2006/main">
+            <a:pPr>
+              <a:defRPr sz="825" b="0">
+                <a:solidFill>
+                  <a:srgbClr val="58677E"/>
+                </a:solidFill>
+                <a:latin typeface="Arial"/>
+                <a:ea typeface="Arial"/>
+                <a:cs typeface="Arial"/>
+              </a:defRPr>
+            </a:pPr>
+            <a:r>
+              <a:rPr sz="825" b="0">
+                <a:solidFill>
+                  <a:srgbClr val="58677E"/>
+                </a:solidFill>
+                <a:latin typeface="Arial"/>
+                <a:ea typeface="Arial"/>
+                <a:cs typeface="Arial"/>
+              </a:rPr>
+              <a:t>Prototype: prepared explanations with linked sources. Live AI generation and portfolio analysis are not connected.</a:t>
+            </a:r>
+          </a:p>
+        </p:txBody>
+      </p:sp>
     </p:spTree>
     <p:extLst>
       <p:ext uri="{BB962C8B-B14F-4D97-AF65-F5344CB8AC3E}">
-        <p14:creationId xmlns:p14="http://schemas.microsoft.com/office/powerpoint/2010/main" val="1644915656"/>
+        <p14:creationId xmlns:p14="http://schemas.microsoft.com/office/powerpoint/2010/main" val="1106648503"/>
       </p:ext>
     </p:extLst>
   </p:cSld>
@@ -7492,7 +7988,7 @@
           <p:cNvPr id="15" name="">
             <a:extLst xmlns:a="http://schemas.openxmlformats.org/drawingml/2006/main">
               <a:ext uri="{FF2B5EF4-FFF2-40B4-BE49-F238E27FC236}">
-                <a16:creationId xmlns:a16="http://schemas.microsoft.com/office/drawing/2014/main" id="{F949BAA0-374D-4099-AD42-471236112F48}"/>
+                <a16:creationId xmlns:a16="http://schemas.microsoft.com/office/drawing/2014/main" id="{7299AFEB-4DCC-4872-AAB4-0985EB6F63D6}"/>
               </a:ext>
             </a:extLst>
           </p:cNvPr>
@@ -7648,7 +8144,7 @@
           <p:cNvPr id="2" name="">
             <a:extLst xmlns:a="http://schemas.openxmlformats.org/drawingml/2006/main">
               <a:ext uri="{FF2B5EF4-FFF2-40B4-BE49-F238E27FC236}">
-                <a16:creationId xmlns:a16="http://schemas.microsoft.com/office/drawing/2014/main" id="{83FD46A2-3483-48DA-8CCE-7D3871B7D847}"/>
+                <a16:creationId xmlns:a16="http://schemas.microsoft.com/office/drawing/2014/main" id="{1E7C9E7D-C3D7-4DE3-A0AC-AA2CE5327DC1}"/>
               </a:ext>
             </a:extLst>
           </p:cNvPr>
@@ -7804,7 +8300,7 @@
           <p:cNvPr id="3" name="">
             <a:extLst xmlns:a="http://schemas.openxmlformats.org/drawingml/2006/main">
               <a:ext uri="{FF2B5EF4-FFF2-40B4-BE49-F238E27FC236}">
-                <a16:creationId xmlns:a16="http://schemas.microsoft.com/office/drawing/2014/main" id="{88D942F8-1146-4623-B754-CAA6D5E07477}"/>
+                <a16:creationId xmlns:a16="http://schemas.microsoft.com/office/drawing/2014/main" id="{3022941F-F6C1-45FE-A35F-D50900AF3AC0}"/>
               </a:ext>
             </a:extLst>
           </p:cNvPr>
@@ -7960,7 +8456,7 @@
           <p:cNvPr id="4" name="">
             <a:extLst xmlns:a="http://schemas.openxmlformats.org/drawingml/2006/main">
               <a:ext uri="{FF2B5EF4-FFF2-40B4-BE49-F238E27FC236}">
-                <a16:creationId xmlns:a16="http://schemas.microsoft.com/office/drawing/2014/main" id="{4DF790BB-7FDF-414C-B0D0-A436736DDED1}"/>
+                <a16:creationId xmlns:a16="http://schemas.microsoft.com/office/drawing/2014/main" id="{A196E53C-CD49-47EB-AE5B-ADC4A7EC9670}"/>
               </a:ext>
             </a:extLst>
           </p:cNvPr>
@@ -8116,7 +8612,7 @@
           <p:cNvPr id="5" name="">
             <a:extLst xmlns:a="http://schemas.openxmlformats.org/drawingml/2006/main">
               <a:ext uri="{FF2B5EF4-FFF2-40B4-BE49-F238E27FC236}">
-                <a16:creationId xmlns:a16="http://schemas.microsoft.com/office/drawing/2014/main" id="{95917513-9E5C-4A36-83FF-2C672009E2A2}"/>
+                <a16:creationId xmlns:a16="http://schemas.microsoft.com/office/drawing/2014/main" id="{A4A51BD2-3DB3-4218-ACF6-D342B3FA2305}"/>
               </a:ext>
             </a:extLst>
           </p:cNvPr>
@@ -8272,7 +8768,7 @@
           <p:cNvPr id="6" name="">
             <a:extLst xmlns:a="http://schemas.openxmlformats.org/drawingml/2006/main">
               <a:ext uri="{FF2B5EF4-FFF2-40B4-BE49-F238E27FC236}">
-                <a16:creationId xmlns:a16="http://schemas.microsoft.com/office/drawing/2014/main" id="{5E1D704B-9827-4061-B2BA-05EBCA732AFE}"/>
+                <a16:creationId xmlns:a16="http://schemas.microsoft.com/office/drawing/2014/main" id="{3AA0A61D-AE9E-4858-89C3-01368BDE8CFC}"/>
               </a:ext>
             </a:extLst>
           </p:cNvPr>
@@ -8428,7 +8924,7 @@
           <p:cNvPr id="7" name="">
             <a:extLst xmlns:a="http://schemas.openxmlformats.org/drawingml/2006/main">
               <a:ext uri="{FF2B5EF4-FFF2-40B4-BE49-F238E27FC236}">
-                <a16:creationId xmlns:a16="http://schemas.microsoft.com/office/drawing/2014/main" id="{006F2F7D-5F2A-42D9-AFAF-178948B6673E}"/>
+                <a16:creationId xmlns:a16="http://schemas.microsoft.com/office/drawing/2014/main" id="{A92DEE29-8499-41B8-A330-892E3E65A5BA}"/>
               </a:ext>
             </a:extLst>
           </p:cNvPr>
@@ -8584,7 +9080,7 @@
           <p:cNvPr id="8" name="">
             <a:extLst xmlns:a="http://schemas.openxmlformats.org/drawingml/2006/main">
               <a:ext uri="{FF2B5EF4-FFF2-40B4-BE49-F238E27FC236}">
-                <a16:creationId xmlns:a16="http://schemas.microsoft.com/office/drawing/2014/main" id="{AE5920A2-A112-4A25-B068-26A1352012F4}"/>
+                <a16:creationId xmlns:a16="http://schemas.microsoft.com/office/drawing/2014/main" id="{D4D62256-6D71-4420-AD72-B18C013719F4}"/>
               </a:ext>
             </a:extLst>
           </p:cNvPr>
@@ -8740,7 +9236,7 @@
           <p:cNvPr id="9" name="">
             <a:extLst xmlns:a="http://schemas.openxmlformats.org/drawingml/2006/main">
               <a:ext uri="{FF2B5EF4-FFF2-40B4-BE49-F238E27FC236}">
-                <a16:creationId xmlns:a16="http://schemas.microsoft.com/office/drawing/2014/main" id="{EBB27846-2AD4-40CE-9891-77D6501430A5}"/>
+                <a16:creationId xmlns:a16="http://schemas.microsoft.com/office/drawing/2014/main" id="{EE8E3983-B0FA-4E32-8BA9-0EF6EA2F4497}"/>
               </a:ext>
             </a:extLst>
           </p:cNvPr>
@@ -8896,7 +9392,7 @@
           <p:cNvPr id="10" name="">
             <a:extLst xmlns:a="http://schemas.openxmlformats.org/drawingml/2006/main">
               <a:ext uri="{FF2B5EF4-FFF2-40B4-BE49-F238E27FC236}">
-                <a16:creationId xmlns:a16="http://schemas.microsoft.com/office/drawing/2014/main" id="{0FD4926A-2035-43F2-8D37-894A42261216}"/>
+                <a16:creationId xmlns:a16="http://schemas.microsoft.com/office/drawing/2014/main" id="{7BC0BB51-1F97-4309-913A-0B77DF230B53}"/>
               </a:ext>
             </a:extLst>
           </p:cNvPr>
@@ -9052,7 +9548,7 @@
           <p:cNvPr id="11" name="">
             <a:extLst xmlns:a="http://schemas.openxmlformats.org/drawingml/2006/main">
               <a:ext uri="{FF2B5EF4-FFF2-40B4-BE49-F238E27FC236}">
-                <a16:creationId xmlns:a16="http://schemas.microsoft.com/office/drawing/2014/main" id="{85AA821C-5C28-43EE-90C7-F1C04FF27B0C}"/>
+                <a16:creationId xmlns:a16="http://schemas.microsoft.com/office/drawing/2014/main" id="{0B5B5A2F-8EA9-47B3-B3C7-AFCE0F41BE6E}"/>
               </a:ext>
             </a:extLst>
           </p:cNvPr>
@@ -9198,7 +9694,7 @@
                 <a:ea typeface="Arial"/>
                 <a:cs typeface="Arial"/>
               </a:rPr>
-              <a:t>Track first funded investments without assistance within seven days, alongside fee and risk understanding. Establish a baseline, split results by Android and iOS, and test card motion separately.</a:t>
+              <a:t>Track first funded investments without assistance and check fee and risk understanding. Establish a baseline, split by Android and iOS, and test AI explanations separately from layout and motion.</a:t>
             </a:r>
           </a:p>
         </p:txBody>
@@ -9208,7 +9704,7 @@
           <p:cNvPr id="12" name="">
             <a:extLst xmlns:a="http://schemas.openxmlformats.org/drawingml/2006/main">
               <a:ext uri="{FF2B5EF4-FFF2-40B4-BE49-F238E27FC236}">
-                <a16:creationId xmlns:a16="http://schemas.microsoft.com/office/drawing/2014/main" id="{B1A0FDF4-B614-4452-9B3C-7C7BFADDD51A}"/>
+                <a16:creationId xmlns:a16="http://schemas.microsoft.com/office/drawing/2014/main" id="{5CCF0FBD-E75A-4BB5-8B78-DFDFC24A877C}"/>
               </a:ext>
             </a:extLst>
           </p:cNvPr>
@@ -9353,7 +9849,7 @@
                 <a:latin typeface="Arial"/>
                 <a:ea typeface="Arial"/>
                 <a:cs typeface="Arial"/>
-                <a:hlinkClick xmlns:r="http://schemas.openxmlformats.org/officeDocument/2006/relationships" r:id="Rc75e4736badc434b"/>
+                <a:hlinkClick xmlns:r="http://schemas.openxmlformats.org/officeDocument/2006/relationships" r:id="R831c53a808ee4f92"/>
               </a:rPr>
               <a:t>Android study: Haverkamp et al.</a:t>
             </a:r>
@@ -9365,7 +9861,7 @@
           <p:cNvPr id="13" name="">
             <a:extLst xmlns:a="http://schemas.openxmlformats.org/drawingml/2006/main">
               <a:ext uri="{FF2B5EF4-FFF2-40B4-BE49-F238E27FC236}">
-                <a16:creationId xmlns:a16="http://schemas.microsoft.com/office/drawing/2014/main" id="{064388F5-C184-4E59-A453-C6F1B221FAE5}"/>
+                <a16:creationId xmlns:a16="http://schemas.microsoft.com/office/drawing/2014/main" id="{78CD19CD-3071-4240-9E46-18A462DDEFBE}"/>
               </a:ext>
             </a:extLst>
           </p:cNvPr>
@@ -9510,7 +10006,7 @@
                 <a:latin typeface="Arial"/>
                 <a:ea typeface="Arial"/>
                 <a:cs typeface="Arial"/>
-                <a:hlinkClick xmlns:r="http://schemas.openxmlformats.org/officeDocument/2006/relationships" r:id="R0bc8162fe41a4d50"/>
+                <a:hlinkClick xmlns:r="http://schemas.openxmlformats.org/officeDocument/2006/relationships" r:id="Rad4347a2614b4fbe"/>
               </a:rPr>
               <a:t>Choice study: Iyengar &amp; Kamenica</a:t>
             </a:r>
@@ -9522,7 +10018,7 @@
           <p:cNvPr id="14" name="">
             <a:extLst xmlns:a="http://schemas.openxmlformats.org/drawingml/2006/main">
               <a:ext uri="{FF2B5EF4-FFF2-40B4-BE49-F238E27FC236}">
-                <a16:creationId xmlns:a16="http://schemas.microsoft.com/office/drawing/2014/main" id="{0E210B3A-DFC0-496D-80F9-D602F9688170}"/>
+                <a16:creationId xmlns:a16="http://schemas.microsoft.com/office/drawing/2014/main" id="{01C6D3C8-E9F9-4073-ACF6-9B8CD123EBE3}"/>
               </a:ext>
             </a:extLst>
           </p:cNvPr>
@@ -9667,7 +10163,7 @@
                 <a:latin typeface="Arial"/>
                 <a:ea typeface="Arial"/>
                 <a:cs typeface="Arial"/>
-                <a:hlinkClick xmlns:r="http://schemas.openxmlformats.org/officeDocument/2006/relationships" r:id="Rcb5db6eb4315428f"/>
+                <a:hlinkClick xmlns:r="http://schemas.openxmlformats.org/officeDocument/2006/relationships" r:id="R3994cae8499d4ada"/>
               </a:rPr>
               <a:t>Motion controls: W3C guidance</a:t>
             </a:r>
@@ -9677,7 +10173,7 @@
     </p:spTree>
     <p:extLst>
       <p:ext uri="{BB962C8B-B14F-4D97-AF65-F5344CB8AC3E}">
-        <p14:creationId xmlns:p14="http://schemas.microsoft.com/office/powerpoint/2010/main" val="1125478287"/>
+        <p14:creationId xmlns:p14="http://schemas.microsoft.com/office/powerpoint/2010/main" val="698385038"/>
       </p:ext>
     </p:extLst>
   </p:cSld>

</xml_diff>

<commit_message>
Refresh final proposal with welcome and AI experience
</commit_message>
<xml_diff>
--- a/deliverables/Ionic-Exclusives-Final.pptx
+++ b/deliverables/Ionic-Exclusives-Final.pptx
@@ -2,16 +2,16 @@
 <file path=ppt/presentation.xml><?xml version="1.0" encoding="utf-8"?>
 <p:presentation xmlns:p="http://schemas.openxmlformats.org/presentationml/2006/main">
   <p:sldMasterIdLst>
-    <p:sldMasterId xmlns:r="http://schemas.openxmlformats.org/officeDocument/2006/relationships" id="2147483648" r:id="R30420a2338ed45c6"/>
+    <p:sldMasterId xmlns:r="http://schemas.openxmlformats.org/officeDocument/2006/relationships" id="2147483648" r:id="R68ed006880be4073"/>
   </p:sldMasterIdLst>
   <p:notesMasterIdLst>
-    <p:notesMasterId xmlns:r="http://schemas.openxmlformats.org/officeDocument/2006/relationships" r:id="R08ffd88fe7a44e4a"/>
+    <p:notesMasterId xmlns:r="http://schemas.openxmlformats.org/officeDocument/2006/relationships" r:id="R8a0c28599ab74cf0"/>
   </p:notesMasterIdLst>
   <p:sldIdLst>
-    <p:sldId xmlns:r="http://schemas.openxmlformats.org/officeDocument/2006/relationships" id="256" r:id="Rd8d17d65160f4a27"/>
-    <p:sldId xmlns:r="http://schemas.openxmlformats.org/officeDocument/2006/relationships" id="257" r:id="Rc0fc51c547244dca"/>
-    <p:sldId xmlns:r="http://schemas.openxmlformats.org/officeDocument/2006/relationships" id="258" r:id="R1cb5b1c3653c4ef8"/>
-    <p:sldId xmlns:r="http://schemas.openxmlformats.org/officeDocument/2006/relationships" id="259" r:id="R42a1e97608404265"/>
+    <p:sldId xmlns:r="http://schemas.openxmlformats.org/officeDocument/2006/relationships" id="256" r:id="Rbdc2e3d159644332"/>
+    <p:sldId xmlns:r="http://schemas.openxmlformats.org/officeDocument/2006/relationships" id="257" r:id="R5710bbe65e604fd3"/>
+    <p:sldId xmlns:r="http://schemas.openxmlformats.org/officeDocument/2006/relationships" id="258" r:id="R642bc80659a7425b"/>
+    <p:sldId xmlns:r="http://schemas.openxmlformats.org/officeDocument/2006/relationships" id="259" r:id="R604cd2318b5f4327"/>
   </p:sldIdLst>
   <p:sldSz cx="12192000" cy="6858000"/>
   <p:notesSz cx="6858000" cy="9144000"/>
@@ -515,7 +515,7 @@
           <a:lstStyle xmlns:a="http://schemas.openxmlformats.org/drawingml/2006/main"/>
           <a:p xmlns:a="http://schemas.openxmlformats.org/drawingml/2006/main">
             <a:r>
-              <a:t>All screenshots are from the working proposal. The category tabs and horizontal hero swipe update each other. Private Wealth has a Flagship badge outside and above its tab, with a slow pulse and reduced-motion support. It contains 9 PMS, 3 AIF and 6 SIF offerings. Each product has a working detail link. Stock rows move at 4 CSS pixels per second in opposite directions, with pause, mouse drag and stationary search/filter results. The 392px frame, header and navigation are shared with Portfolio. Product figures are captured fixtures, not live quotes. The stock footer and mutual fund metadata slot now include a blue-flower AI deep dive action. Their heights are unchanged from the previous version.</a:t>
+              <a:t>All screenshots are from the working proposal. The category tabs and horizontal hero swipe update each other. Private Wealth has a Flagship badge outside and above its tab, with a slow pulse and reduced-motion support. It contains 9 PMS, 3 AIF and 6 SIF offerings. Each product has a working detail link. Stock rows move at 4 CSS pixels per second in opposite directions, with pause, mouse drag and stationary search/filter results. The 392px frame, header and navigation are shared with Portfolio. Product figures are captured fixtures, not live quotes. The stock footer and mutual fund metadata slot now include a blue-flower AI deep dive action. Their heights are unchanged from the previous version. The Private Wealth screenshot now shows the opening welcome. It automatically continues after 3.2 seconds, with immediate Skip and Explore actions. Interaction stops the timer. Keyboard focus is contained during the introduction and restored on exit. Reduced-motion mode is static. The welcome gives a premium visual treatment; it does not grant eligibility or membership. The underlying catalogue still contains all 18 captured offerings.</a:t>
             </a:r>
           </a:p>
         </p:txBody>
@@ -655,7 +655,7 @@
           <a:lstStyle xmlns:a="http://schemas.openxmlformats.org/drawingml/2006/main"/>
           <a:p xmlns:a="http://schemas.openxmlformats.org/drawingml/2006/main">
             <a:r>
-              <a:t>Android research: Haverkamp et al., Reading and Writing 36 (2023), 1589-1608, published online in 2022. DOI: 10.1007/s11145-022-10328-9. Participants: 145 Norwegian university students. Samsung Galaxy A02s phone and Lenovo Tab M10 tablet, both Android 10. Text: 1492 words. Paging led to more strategic backtracking; better integrated understanding was a tendency. This was a reading study, with no investing task or iOS scroll-depth measure. Choice research: Iyengar and Kamenica (2010), Journal of Public Economics 94, 530-539, DOI 10.1016/j.jpubeco.2010.03.006. Laboratory experiments and records of over 500,000 employees at 638 institutions. Evidence of simplicity seeking, not proof of Ionic conversion uplift. W3C carousel guidance supports user controls to pause moving content. Experiment: first unassisted completed investment within seven days divided by all eligible importers with no prior transaction assigned to each version. Record assistance consistently, and monitor costs, risk understanding, funding failures, cancellations and complaints. Set sample size from the measured baseline. Test static layout first, then motion. The AI feature is an additional hypothesis. Source-linked explanations could help users make sense of products, but no conversion uplift is claimed. Evaluate accuracy, source freshness and whether users understand both the appeal and downside.</a:t>
+              <a:t>Android research: Haverkamp et al., Reading and Writing 36 (2023), 1589-1608, published online in 2022. DOI: 10.1007/s11145-022-10328-9. Participants: 145 Norwegian university students. Samsung Galaxy A02s phone and Lenovo Tab M10 tablet, both Android 10. Text: 1492 words. Paging led to more strategic backtracking; better integrated understanding was a tendency. This was a reading study, with no investing task or iOS scroll-depth measure. Choice research: Iyengar and Kamenica (2010), Journal of Public Economics 94, 530-539, DOI 10.1016/j.jpubeco.2010.03.006. Laboratory experiments and records of over 500,000 employees at 638 institutions. Evidence of simplicity seeking, not proof of Ionic conversion uplift. W3C carousel guidance supports user controls to pause moving content. Experiment: first unassisted completed investment within seven days divided by all eligible importers with no prior transaction assigned to each version. Record assistance consistently, and monitor costs, risk understanding, funding failures, cancellations and complaints. Set sample size from the measured baseline. Test static layout first, then motion. The AI feature is an additional hypothesis. Source-linked explanations could help users make sense of products, but no conversion uplift is claimed. Evaluate accuracy, source freshness and whether users understand both the appeal and downside. Test the welcome independently and monitor skips, exits and time to reach products. Retain it only if it helps orientation without harming the purchase flow.</a:t>
             </a:r>
           </a:p>
         </p:txBody>
@@ -702,7 +702,7 @@
           <p:cNvPr id="3" name="Title">
             <a:extLst xmlns:a="http://schemas.openxmlformats.org/drawingml/2006/main">
               <a:ext uri="{FF2B5EF4-FFF2-40B4-BE49-F238E27FC236}">
-                <a16:creationId xmlns:a16="http://schemas.microsoft.com/office/drawing/2014/main" id="{1BCD04AD-8B83-40B6-A030-4CDA2A3A245F}"/>
+                <a16:creationId xmlns:a16="http://schemas.microsoft.com/office/drawing/2014/main" id="{C4030177-A12D-4217-B958-EFCFB3B567B8}"/>
               </a:ext>
             </a:extLst>
           </p:cNvPr>
@@ -931,7 +931,7 @@
           <p:cNvPr id="2" name="Subtitle">
             <a:extLst xmlns:a="http://schemas.openxmlformats.org/drawingml/2006/main">
               <a:ext uri="{FF2B5EF4-FFF2-40B4-BE49-F238E27FC236}">
-                <a16:creationId xmlns:a16="http://schemas.microsoft.com/office/drawing/2014/main" id="{805E3343-54EC-46C6-ABF5-1F876D3E2877}"/>
+                <a16:creationId xmlns:a16="http://schemas.microsoft.com/office/drawing/2014/main" id="{A829C897-0B09-4977-8570-8962F1B9169D}"/>
               </a:ext>
             </a:extLst>
           </p:cNvPr>
@@ -1177,7 +1177,7 @@
           <p:cNvPr id="2" name="Section title">
             <a:extLst xmlns:a="http://schemas.openxmlformats.org/drawingml/2006/main">
               <a:ext uri="{FF2B5EF4-FFF2-40B4-BE49-F238E27FC236}">
-                <a16:creationId xmlns:a16="http://schemas.microsoft.com/office/drawing/2014/main" id="{63DEFE71-A9E2-40CC-AD28-FA0589767C5C}"/>
+                <a16:creationId xmlns:a16="http://schemas.microsoft.com/office/drawing/2014/main" id="{8A26963E-607C-44DC-AB9B-54B16C0553E7}"/>
               </a:ext>
             </a:extLst>
           </p:cNvPr>
@@ -1423,7 +1423,7 @@
           <p:cNvPr id="3" name="Title">
             <a:extLst xmlns:a="http://schemas.openxmlformats.org/drawingml/2006/main">
               <a:ext uri="{FF2B5EF4-FFF2-40B4-BE49-F238E27FC236}">
-                <a16:creationId xmlns:a16="http://schemas.microsoft.com/office/drawing/2014/main" id="{F4735274-7AEB-4D74-8625-C4824D45AFF6}"/>
+                <a16:creationId xmlns:a16="http://schemas.microsoft.com/office/drawing/2014/main" id="{C4B1DAC6-6D3D-4A72-B53C-EB7BEFD4D3D7}"/>
               </a:ext>
             </a:extLst>
           </p:cNvPr>
@@ -1652,7 +1652,7 @@
           <p:cNvPr id="2" name="Body">
             <a:extLst xmlns:a="http://schemas.openxmlformats.org/drawingml/2006/main">
               <a:ext uri="{FF2B5EF4-FFF2-40B4-BE49-F238E27FC236}">
-                <a16:creationId xmlns:a16="http://schemas.microsoft.com/office/drawing/2014/main" id="{979862DD-16D1-4EB7-A180-B7F9780507BF}"/>
+                <a16:creationId xmlns:a16="http://schemas.microsoft.com/office/drawing/2014/main" id="{AC17B363-DC06-44F3-8942-2998694D6A69}"/>
               </a:ext>
             </a:extLst>
           </p:cNvPr>
@@ -1898,7 +1898,7 @@
           <p:cNvPr id="4" name="Title">
             <a:extLst xmlns:a="http://schemas.openxmlformats.org/drawingml/2006/main">
               <a:ext uri="{FF2B5EF4-FFF2-40B4-BE49-F238E27FC236}">
-                <a16:creationId xmlns:a16="http://schemas.microsoft.com/office/drawing/2014/main" id="{F5DF940F-A140-4A91-BFE3-43833CD13A61}"/>
+                <a16:creationId xmlns:a16="http://schemas.microsoft.com/office/drawing/2014/main" id="{C37F6F6F-2FB2-4360-B11E-A1B7D81E1E06}"/>
               </a:ext>
             </a:extLst>
           </p:cNvPr>
@@ -2127,7 +2127,7 @@
           <p:cNvPr id="2" name="Left column">
             <a:extLst xmlns:a="http://schemas.openxmlformats.org/drawingml/2006/main">
               <a:ext uri="{FF2B5EF4-FFF2-40B4-BE49-F238E27FC236}">
-                <a16:creationId xmlns:a16="http://schemas.microsoft.com/office/drawing/2014/main" id="{049365DF-41BB-4D52-810C-5D601DDFB884}"/>
+                <a16:creationId xmlns:a16="http://schemas.microsoft.com/office/drawing/2014/main" id="{1B63E573-8A8A-45E1-BB87-EDDE0E732B24}"/>
               </a:ext>
             </a:extLst>
           </p:cNvPr>
@@ -2356,7 +2356,7 @@
           <p:cNvPr id="3" name="Right column">
             <a:extLst xmlns:a="http://schemas.openxmlformats.org/drawingml/2006/main">
               <a:ext uri="{FF2B5EF4-FFF2-40B4-BE49-F238E27FC236}">
-                <a16:creationId xmlns:a16="http://schemas.microsoft.com/office/drawing/2014/main" id="{642C6C3D-C238-4D08-98C2-52A31332261A}"/>
+                <a16:creationId xmlns:a16="http://schemas.microsoft.com/office/drawing/2014/main" id="{8C6A2318-211F-4C02-9B04-482CB63D219B}"/>
               </a:ext>
             </a:extLst>
           </p:cNvPr>
@@ -2602,7 +2602,7 @@
           <p:cNvPr id="3" name="Title">
             <a:extLst xmlns:a="http://schemas.openxmlformats.org/drawingml/2006/main">
               <a:ext uri="{FF2B5EF4-FFF2-40B4-BE49-F238E27FC236}">
-                <a16:creationId xmlns:a16="http://schemas.microsoft.com/office/drawing/2014/main" id="{99553C17-F2F5-465C-BDA8-383278D5B81B}"/>
+                <a16:creationId xmlns:a16="http://schemas.microsoft.com/office/drawing/2014/main" id="{1FF9D47B-212B-48A0-9639-9B01263A353E}"/>
               </a:ext>
             </a:extLst>
           </p:cNvPr>
@@ -2831,7 +2831,7 @@
           <p:cNvPr id="2" name="Left column">
             <a:extLst xmlns:a="http://schemas.openxmlformats.org/drawingml/2006/main">
               <a:ext uri="{FF2B5EF4-FFF2-40B4-BE49-F238E27FC236}">
-                <a16:creationId xmlns:a16="http://schemas.microsoft.com/office/drawing/2014/main" id="{5404E471-D584-4F7A-9ADE-EE82EDBB45F1}"/>
+                <a16:creationId xmlns:a16="http://schemas.microsoft.com/office/drawing/2014/main" id="{7B807D7D-1CED-474F-B889-9A7A27E3CE6F}"/>
               </a:ext>
             </a:extLst>
           </p:cNvPr>
@@ -3098,12 +3098,12 @@
   </p:cSld>
   <p:clrMap bg1="lt1" tx1="dk1" bg2="lt2" tx2="dk2" accent1="accent1" accent2="accent2" accent3="accent3" accent4="accent4" accent5="accent5" accent6="accent6" hlink="hlink" folHlink="folHlink"/>
   <p:sldLayoutIdLst>
-    <p:sldLayoutId xmlns:r="http://schemas.openxmlformats.org/officeDocument/2006/relationships" id="2147483649" r:id="R7d6bc5b25c4d4562"/>
-    <p:sldLayoutId xmlns:r="http://schemas.openxmlformats.org/officeDocument/2006/relationships" id="2147483650" r:id="R97bcd52412d140e0"/>
-    <p:sldLayoutId xmlns:r="http://schemas.openxmlformats.org/officeDocument/2006/relationships" id="2147483651" r:id="Refd60a9a84b14810"/>
-    <p:sldLayoutId xmlns:r="http://schemas.openxmlformats.org/officeDocument/2006/relationships" id="2147483652" r:id="R7b8917c7037a4d7e"/>
-    <p:sldLayoutId xmlns:r="http://schemas.openxmlformats.org/officeDocument/2006/relationships" id="2147483653" r:id="Re48d72dbb4294ead"/>
-    <p:sldLayoutId xmlns:r="http://schemas.openxmlformats.org/officeDocument/2006/relationships" id="2147483654" r:id="R086ed705161a43ad"/>
+    <p:sldLayoutId xmlns:r="http://schemas.openxmlformats.org/officeDocument/2006/relationships" id="2147483649" r:id="Ra582d71aba144fcb"/>
+    <p:sldLayoutId xmlns:r="http://schemas.openxmlformats.org/officeDocument/2006/relationships" id="2147483650" r:id="Rabd84782a1f24132"/>
+    <p:sldLayoutId xmlns:r="http://schemas.openxmlformats.org/officeDocument/2006/relationships" id="2147483651" r:id="Rcf60860ed0b84e0c"/>
+    <p:sldLayoutId xmlns:r="http://schemas.openxmlformats.org/officeDocument/2006/relationships" id="2147483652" r:id="Ra05080989d9a414c"/>
+    <p:sldLayoutId xmlns:r="http://schemas.openxmlformats.org/officeDocument/2006/relationships" id="2147483653" r:id="Rc403fbc62ea843b6"/>
+    <p:sldLayoutId xmlns:r="http://schemas.openxmlformats.org/officeDocument/2006/relationships" id="2147483654" r:id="R67c1c556949245fe"/>
   </p:sldLayoutIdLst>
   <p:txStyles>
     <p:titleStyle>
@@ -3654,7 +3654,7 @@
           <p:cNvPr id="9" name="">
             <a:extLst xmlns:a="http://schemas.openxmlformats.org/drawingml/2006/main">
               <a:ext uri="{FF2B5EF4-FFF2-40B4-BE49-F238E27FC236}">
-                <a16:creationId xmlns:a16="http://schemas.microsoft.com/office/drawing/2014/main" id="{8A2B23D5-34CF-4195-8B8E-6F97D75463FC}"/>
+                <a16:creationId xmlns:a16="http://schemas.microsoft.com/office/drawing/2014/main" id="{B5527C18-79A6-49A5-8C11-220CBA60E6D5}"/>
               </a:ext>
             </a:extLst>
           </p:cNvPr>
@@ -3810,7 +3810,7 @@
           <p:cNvPr id="2" name="">
             <a:extLst xmlns:a="http://schemas.openxmlformats.org/drawingml/2006/main">
               <a:ext uri="{FF2B5EF4-FFF2-40B4-BE49-F238E27FC236}">
-                <a16:creationId xmlns:a16="http://schemas.microsoft.com/office/drawing/2014/main" id="{522DAF92-FD80-4B54-A2BE-FE66A271EFA9}"/>
+                <a16:creationId xmlns:a16="http://schemas.microsoft.com/office/drawing/2014/main" id="{75951965-648A-4E12-97CA-C2A2161AE10C}"/>
               </a:ext>
             </a:extLst>
           </p:cNvPr>
@@ -3989,7 +3989,7 @@
           <p:cNvPr id="3" name="">
             <a:extLst xmlns:a="http://schemas.openxmlformats.org/drawingml/2006/main">
               <a:ext uri="{FF2B5EF4-FFF2-40B4-BE49-F238E27FC236}">
-                <a16:creationId xmlns:a16="http://schemas.microsoft.com/office/drawing/2014/main" id="{31DCFFCB-E096-4E32-81BD-BFDD6B7FC92F}"/>
+                <a16:creationId xmlns:a16="http://schemas.microsoft.com/office/drawing/2014/main" id="{DFA85032-C5D5-4344-B88E-35A3EDA2FB05}"/>
               </a:ext>
             </a:extLst>
           </p:cNvPr>
@@ -4145,7 +4145,7 @@
           <p:cNvPr id="4" name="">
             <a:extLst xmlns:a="http://schemas.openxmlformats.org/drawingml/2006/main">
               <a:ext uri="{FF2B5EF4-FFF2-40B4-BE49-F238E27FC236}">
-                <a16:creationId xmlns:a16="http://schemas.microsoft.com/office/drawing/2014/main" id="{064F0F10-C5F7-441B-9D09-4C99CB428B38}"/>
+                <a16:creationId xmlns:a16="http://schemas.microsoft.com/office/drawing/2014/main" id="{679C3850-8A03-4981-AE9D-F9792AB350FF}"/>
               </a:ext>
             </a:extLst>
           </p:cNvPr>
@@ -4301,7 +4301,7 @@
           <p:cNvPr id="5" name="">
             <a:extLst xmlns:a="http://schemas.openxmlformats.org/drawingml/2006/main">
               <a:ext uri="{FF2B5EF4-FFF2-40B4-BE49-F238E27FC236}">
-                <a16:creationId xmlns:a16="http://schemas.microsoft.com/office/drawing/2014/main" id="{623E2439-158B-400A-BF5A-0F60A41059E3}"/>
+                <a16:creationId xmlns:a16="http://schemas.microsoft.com/office/drawing/2014/main" id="{9129846A-1486-4A60-A386-206600C40B6B}"/>
               </a:ext>
             </a:extLst>
           </p:cNvPr>
@@ -4457,7 +4457,7 @@
           <p:cNvPr id="6" name="">
             <a:extLst xmlns:a="http://schemas.openxmlformats.org/drawingml/2006/main">
               <a:ext uri="{FF2B5EF4-FFF2-40B4-BE49-F238E27FC236}">
-                <a16:creationId xmlns:a16="http://schemas.microsoft.com/office/drawing/2014/main" id="{3F67FF73-FDD1-48F3-A3E8-3D445C6BC216}"/>
+                <a16:creationId xmlns:a16="http://schemas.microsoft.com/office/drawing/2014/main" id="{AE9DA23E-BAE4-4B77-ACB8-B0B7DC083E5C}"/>
               </a:ext>
             </a:extLst>
           </p:cNvPr>
@@ -4613,7 +4613,7 @@
           <p:cNvPr id="7" name="">
             <a:extLst xmlns:a="http://schemas.openxmlformats.org/drawingml/2006/main">
               <a:ext uri="{FF2B5EF4-FFF2-40B4-BE49-F238E27FC236}">
-                <a16:creationId xmlns:a16="http://schemas.microsoft.com/office/drawing/2014/main" id="{9BB745B9-8BCF-4AA2-ABD4-49D294B39068}"/>
+                <a16:creationId xmlns:a16="http://schemas.microsoft.com/office/drawing/2014/main" id="{6453A883-9E26-44CE-BA80-9F7A15AE1EAB}"/>
               </a:ext>
             </a:extLst>
           </p:cNvPr>
@@ -4769,7 +4769,7 @@
           <p:cNvPr id="8" name="">
             <a:extLst xmlns:a="http://schemas.openxmlformats.org/drawingml/2006/main">
               <a:ext uri="{FF2B5EF4-FFF2-40B4-BE49-F238E27FC236}">
-                <a16:creationId xmlns:a16="http://schemas.microsoft.com/office/drawing/2014/main" id="{7E48E64F-7760-4F8A-8AB5-C6EC7F6C63E1}"/>
+                <a16:creationId xmlns:a16="http://schemas.microsoft.com/office/drawing/2014/main" id="{58DE404C-F305-42F7-8A2C-9345601789F1}"/>
               </a:ext>
             </a:extLst>
           </p:cNvPr>
@@ -4779,7 +4779,7 @@
           <p:nvPr/>
         </p:nvPicPr>
         <p:blipFill>
-          <a:blip xmlns:r="http://schemas.openxmlformats.org/officeDocument/2006/relationships" xmlns:a="http://schemas.openxmlformats.org/drawingml/2006/main" r:embed="Ra9c5112416844d2d"/>
+          <a:blip xmlns:r="http://schemas.openxmlformats.org/officeDocument/2006/relationships" xmlns:a="http://schemas.openxmlformats.org/drawingml/2006/main" r:embed="R01a9771a362f4b36"/>
           <a:stretch xmlns:a="http://schemas.openxmlformats.org/drawingml/2006/main"/>
         </p:blipFill>
         <p:spPr>
@@ -4795,7 +4795,7 @@
     </p:spTree>
     <p:extLst>
       <p:ext uri="{BB962C8B-B14F-4D97-AF65-F5344CB8AC3E}">
-        <p14:creationId xmlns:p14="http://schemas.microsoft.com/office/powerpoint/2010/main" val="853908249"/>
+        <p14:creationId xmlns:p14="http://schemas.microsoft.com/office/powerpoint/2010/main" val="1833769585"/>
       </p:ext>
     </p:extLst>
   </p:cSld>
@@ -4826,7 +4826,7 @@
           <p:cNvPr id="12" name="">
             <a:extLst xmlns:a="http://schemas.openxmlformats.org/drawingml/2006/main">
               <a:ext uri="{FF2B5EF4-FFF2-40B4-BE49-F238E27FC236}">
-                <a16:creationId xmlns:a16="http://schemas.microsoft.com/office/drawing/2014/main" id="{21AFD41B-87CA-4C87-A17F-763958275AA0}"/>
+                <a16:creationId xmlns:a16="http://schemas.microsoft.com/office/drawing/2014/main" id="{86E09541-FA27-4E26-8561-932CAF3317A0}"/>
               </a:ext>
             </a:extLst>
           </p:cNvPr>
@@ -4982,7 +4982,7 @@
           <p:cNvPr id="2" name="">
             <a:extLst xmlns:a="http://schemas.openxmlformats.org/drawingml/2006/main">
               <a:ext uri="{FF2B5EF4-FFF2-40B4-BE49-F238E27FC236}">
-                <a16:creationId xmlns:a16="http://schemas.microsoft.com/office/drawing/2014/main" id="{CF07B2EE-DE3C-4E15-AB05-A9C8332013A7}"/>
+                <a16:creationId xmlns:a16="http://schemas.microsoft.com/office/drawing/2014/main" id="{CB0AD907-209E-4E93-B676-1776D6738A12}"/>
               </a:ext>
             </a:extLst>
           </p:cNvPr>
@@ -5138,7 +5138,7 @@
           <p:cNvPr id="3" name="">
             <a:extLst xmlns:a="http://schemas.openxmlformats.org/drawingml/2006/main">
               <a:ext uri="{FF2B5EF4-FFF2-40B4-BE49-F238E27FC236}">
-                <a16:creationId xmlns:a16="http://schemas.microsoft.com/office/drawing/2014/main" id="{A9C4EEDE-4E09-47D0-A0A2-9321B6723A5F}"/>
+                <a16:creationId xmlns:a16="http://schemas.microsoft.com/office/drawing/2014/main" id="{BCD25FBC-1CD1-46FE-9F7A-D7117FBE0411}"/>
               </a:ext>
             </a:extLst>
           </p:cNvPr>
@@ -5148,7 +5148,7 @@
           <p:nvPr/>
         </p:nvPicPr>
         <p:blipFill>
-          <a:blip xmlns:r="http://schemas.openxmlformats.org/officeDocument/2006/relationships" xmlns:a="http://schemas.openxmlformats.org/drawingml/2006/main" r:embed="R62b2693484404634"/>
+          <a:blip xmlns:r="http://schemas.openxmlformats.org/officeDocument/2006/relationships" xmlns:a="http://schemas.openxmlformats.org/drawingml/2006/main" r:embed="R6bf1c4f363094407"/>
           <a:stretch xmlns:a="http://schemas.openxmlformats.org/drawingml/2006/main"/>
         </p:blipFill>
         <p:spPr>
@@ -5166,7 +5166,7 @@
           <p:cNvPr id="4" name="">
             <a:extLst xmlns:a="http://schemas.openxmlformats.org/drawingml/2006/main">
               <a:ext uri="{FF2B5EF4-FFF2-40B4-BE49-F238E27FC236}">
-                <a16:creationId xmlns:a16="http://schemas.microsoft.com/office/drawing/2014/main" id="{A8E03962-12EB-42F3-B3EB-F12C792CCF65}"/>
+                <a16:creationId xmlns:a16="http://schemas.microsoft.com/office/drawing/2014/main" id="{18C2D555-082C-45CC-80DA-6DE33364239B}"/>
               </a:ext>
             </a:extLst>
           </p:cNvPr>
@@ -5176,7 +5176,7 @@
           <p:nvPr/>
         </p:nvPicPr>
         <p:blipFill>
-          <a:blip xmlns:r="http://schemas.openxmlformats.org/officeDocument/2006/relationships" xmlns:a="http://schemas.openxmlformats.org/drawingml/2006/main" r:embed="R74e03e7f65e14f89"/>
+          <a:blip xmlns:r="http://schemas.openxmlformats.org/officeDocument/2006/relationships" xmlns:a="http://schemas.openxmlformats.org/drawingml/2006/main" r:embed="R3b078bd13e9c4330"/>
           <a:stretch xmlns:a="http://schemas.openxmlformats.org/drawingml/2006/main"/>
         </p:blipFill>
         <p:spPr>
@@ -5194,7 +5194,7 @@
           <p:cNvPr id="5" name="">
             <a:extLst xmlns:a="http://schemas.openxmlformats.org/drawingml/2006/main">
               <a:ext uri="{FF2B5EF4-FFF2-40B4-BE49-F238E27FC236}">
-                <a16:creationId xmlns:a16="http://schemas.microsoft.com/office/drawing/2014/main" id="{0144BE32-E6FE-4B8D-B6D7-0F653EAF1CD9}"/>
+                <a16:creationId xmlns:a16="http://schemas.microsoft.com/office/drawing/2014/main" id="{C361484C-1193-492B-92A1-E9CBDD5BF63B}"/>
               </a:ext>
             </a:extLst>
           </p:cNvPr>
@@ -5204,13 +5204,13 @@
           <p:nvPr/>
         </p:nvPicPr>
         <p:blipFill>
-          <a:blip xmlns:r="http://schemas.openxmlformats.org/officeDocument/2006/relationships" xmlns:a="http://schemas.openxmlformats.org/drawingml/2006/main" r:embed="Rb654a00c5d7146e7"/>
+          <a:blip xmlns:r="http://schemas.openxmlformats.org/officeDocument/2006/relationships" xmlns:a="http://schemas.openxmlformats.org/drawingml/2006/main" r:embed="R544a1d28fbd64677"/>
           <a:stretch xmlns:a="http://schemas.openxmlformats.org/drawingml/2006/main"/>
         </p:blipFill>
         <p:spPr>
           <a:xfrm xmlns:a="http://schemas.openxmlformats.org/drawingml/2006/main">
-            <a:off x="9220335" y="1685925"/>
-            <a:ext cx="1628504" cy="3524250"/>
+            <a:off x="9238652" y="1685925"/>
+            <a:ext cx="1591871" cy="3524250"/>
           </a:xfrm>
           <a:prstGeom xmlns:a="http://schemas.openxmlformats.org/drawingml/2006/main" prst="rect">
             <a:avLst/>
@@ -5222,7 +5222,7 @@
           <p:cNvPr id="6" name="">
             <a:extLst xmlns:a="http://schemas.openxmlformats.org/drawingml/2006/main">
               <a:ext uri="{FF2B5EF4-FFF2-40B4-BE49-F238E27FC236}">
-                <a16:creationId xmlns:a16="http://schemas.microsoft.com/office/drawing/2014/main" id="{CFBCCBFB-52FB-4793-975A-DE35C97D5F93}"/>
+                <a16:creationId xmlns:a16="http://schemas.microsoft.com/office/drawing/2014/main" id="{16CC2243-25C5-48B5-A68F-2666423431D7}"/>
               </a:ext>
             </a:extLst>
           </p:cNvPr>
@@ -5378,7 +5378,7 @@
           <p:cNvPr id="7" name="">
             <a:extLst xmlns:a="http://schemas.openxmlformats.org/drawingml/2006/main">
               <a:ext uri="{FF2B5EF4-FFF2-40B4-BE49-F238E27FC236}">
-                <a16:creationId xmlns:a16="http://schemas.microsoft.com/office/drawing/2014/main" id="{1C637EBA-AD16-4B4B-A2DB-629CAA0AE3EA}"/>
+                <a16:creationId xmlns:a16="http://schemas.microsoft.com/office/drawing/2014/main" id="{1D17FA09-C95A-4BF5-B1FB-E3102D3BA545}"/>
               </a:ext>
             </a:extLst>
           </p:cNvPr>
@@ -5534,7 +5534,7 @@
           <p:cNvPr id="8" name="">
             <a:extLst xmlns:a="http://schemas.openxmlformats.org/drawingml/2006/main">
               <a:ext uri="{FF2B5EF4-FFF2-40B4-BE49-F238E27FC236}">
-                <a16:creationId xmlns:a16="http://schemas.microsoft.com/office/drawing/2014/main" id="{146B7978-8B10-4B25-9451-3740CCCA1EA5}"/>
+                <a16:creationId xmlns:a16="http://schemas.microsoft.com/office/drawing/2014/main" id="{DBEBE876-C89B-43B9-9B78-A3A93ADC5C77}"/>
               </a:ext>
             </a:extLst>
           </p:cNvPr>
@@ -5690,7 +5690,7 @@
           <p:cNvPr id="9" name="">
             <a:extLst xmlns:a="http://schemas.openxmlformats.org/drawingml/2006/main">
               <a:ext uri="{FF2B5EF4-FFF2-40B4-BE49-F238E27FC236}">
-                <a16:creationId xmlns:a16="http://schemas.microsoft.com/office/drawing/2014/main" id="{B2A9A298-698C-42C3-A357-AD857C6833CA}"/>
+                <a16:creationId xmlns:a16="http://schemas.microsoft.com/office/drawing/2014/main" id="{0A206C36-33A9-4DD3-88C5-CEA5C68F7DD4}"/>
               </a:ext>
             </a:extLst>
           </p:cNvPr>
@@ -5846,7 +5846,7 @@
           <p:cNvPr id="10" name="">
             <a:extLst xmlns:a="http://schemas.openxmlformats.org/drawingml/2006/main">
               <a:ext uri="{FF2B5EF4-FFF2-40B4-BE49-F238E27FC236}">
-                <a16:creationId xmlns:a16="http://schemas.microsoft.com/office/drawing/2014/main" id="{E33273D2-E356-4039-97F9-411C67ACD369}"/>
+                <a16:creationId xmlns:a16="http://schemas.microsoft.com/office/drawing/2014/main" id="{3894D845-C84F-4845-B424-23D6BC7A18EF}"/>
               </a:ext>
             </a:extLst>
           </p:cNvPr>
@@ -6002,7 +6002,7 @@
           <p:cNvPr id="11" name="">
             <a:extLst xmlns:a="http://schemas.openxmlformats.org/drawingml/2006/main">
               <a:ext uri="{FF2B5EF4-FFF2-40B4-BE49-F238E27FC236}">
-                <a16:creationId xmlns:a16="http://schemas.microsoft.com/office/drawing/2014/main" id="{14A17156-1FA1-490C-9736-342B64CB18C2}"/>
+                <a16:creationId xmlns:a16="http://schemas.microsoft.com/office/drawing/2014/main" id="{C17FF858-B010-4603-9DD8-3A16275EB48A}"/>
               </a:ext>
             </a:extLst>
           </p:cNvPr>
@@ -6148,7 +6148,7 @@
                 <a:ea typeface="Arial"/>
                 <a:cs typeface="Arial"/>
               </a:rPr>
-              <a:t>Give PMS, AIF and SIF a visible place. One scroll shows all 18 offerings, with shortcuts to each section.</a:t>
+              <a:t>Private Wealth opens with a short, skippable welcome. The catalogue then shows all 18 PMS, AIF and SIF offerings.</a:t>
             </a:r>
           </a:p>
         </p:txBody>
@@ -6156,7 +6156,7 @@
     </p:spTree>
     <p:extLst>
       <p:ext uri="{BB962C8B-B14F-4D97-AF65-F5344CB8AC3E}">
-        <p14:creationId xmlns:p14="http://schemas.microsoft.com/office/powerpoint/2010/main" val="790603576"/>
+        <p14:creationId xmlns:p14="http://schemas.microsoft.com/office/powerpoint/2010/main" val="50753927"/>
       </p:ext>
     </p:extLst>
   </p:cSld>
@@ -6187,7 +6187,7 @@
           <p:cNvPr id="14" name="">
             <a:extLst xmlns:a="http://schemas.openxmlformats.org/drawingml/2006/main">
               <a:ext uri="{FF2B5EF4-FFF2-40B4-BE49-F238E27FC236}">
-                <a16:creationId xmlns:a16="http://schemas.microsoft.com/office/drawing/2014/main" id="{0AA73E33-786E-4B3E-A502-6536D9C02F13}"/>
+                <a16:creationId xmlns:a16="http://schemas.microsoft.com/office/drawing/2014/main" id="{7851105B-3F02-435F-993D-43DBE0A56E69}"/>
               </a:ext>
             </a:extLst>
           </p:cNvPr>
@@ -6343,7 +6343,7 @@
           <p:cNvPr id="2" name="">
             <a:extLst xmlns:a="http://schemas.openxmlformats.org/drawingml/2006/main">
               <a:ext uri="{FF2B5EF4-FFF2-40B4-BE49-F238E27FC236}">
-                <a16:creationId xmlns:a16="http://schemas.microsoft.com/office/drawing/2014/main" id="{40FA741A-3DF5-4E9B-AB49-9A72198E6647}"/>
+                <a16:creationId xmlns:a16="http://schemas.microsoft.com/office/drawing/2014/main" id="{9F4E866B-AC22-413D-9DCB-64061CBD8912}"/>
               </a:ext>
             </a:extLst>
           </p:cNvPr>
@@ -6499,7 +6499,7 @@
           <p:cNvPr id="3" name="">
             <a:extLst xmlns:a="http://schemas.openxmlformats.org/drawingml/2006/main">
               <a:ext uri="{FF2B5EF4-FFF2-40B4-BE49-F238E27FC236}">
-                <a16:creationId xmlns:a16="http://schemas.microsoft.com/office/drawing/2014/main" id="{913FD728-D5F4-447A-A910-A98DA58304FC}"/>
+                <a16:creationId xmlns:a16="http://schemas.microsoft.com/office/drawing/2014/main" id="{26D0206C-44FD-4BE3-AAE3-4D17685B68D2}"/>
               </a:ext>
             </a:extLst>
           </p:cNvPr>
@@ -6655,7 +6655,7 @@
           <p:cNvPr id="4" name="">
             <a:extLst xmlns:a="http://schemas.openxmlformats.org/drawingml/2006/main">
               <a:ext uri="{FF2B5EF4-FFF2-40B4-BE49-F238E27FC236}">
-                <a16:creationId xmlns:a16="http://schemas.microsoft.com/office/drawing/2014/main" id="{CD40BB90-8761-44B3-A789-2EC74DE1F995}"/>
+                <a16:creationId xmlns:a16="http://schemas.microsoft.com/office/drawing/2014/main" id="{5E49EABE-27CB-478A-A853-71C8DB7A2C7A}"/>
               </a:ext>
             </a:extLst>
           </p:cNvPr>
@@ -6811,7 +6811,7 @@
           <p:cNvPr id="5" name="">
             <a:extLst xmlns:a="http://schemas.openxmlformats.org/drawingml/2006/main">
               <a:ext uri="{FF2B5EF4-FFF2-40B4-BE49-F238E27FC236}">
-                <a16:creationId xmlns:a16="http://schemas.microsoft.com/office/drawing/2014/main" id="{8F0D7ECC-81BC-4AD9-9545-9091DEED23B7}"/>
+                <a16:creationId xmlns:a16="http://schemas.microsoft.com/office/drawing/2014/main" id="{0417C228-FEE6-4668-ACB8-AB7EB97B70AA}"/>
               </a:ext>
             </a:extLst>
           </p:cNvPr>
@@ -6967,7 +6967,7 @@
           <p:cNvPr id="6" name="">
             <a:extLst xmlns:a="http://schemas.openxmlformats.org/drawingml/2006/main">
               <a:ext uri="{FF2B5EF4-FFF2-40B4-BE49-F238E27FC236}">
-                <a16:creationId xmlns:a16="http://schemas.microsoft.com/office/drawing/2014/main" id="{37DEE84D-0047-4D3A-B18D-3D3CD3E685D0}"/>
+                <a16:creationId xmlns:a16="http://schemas.microsoft.com/office/drawing/2014/main" id="{EDB2968A-F67C-4DF3-91DB-F3D2A13454DB}"/>
               </a:ext>
             </a:extLst>
           </p:cNvPr>
@@ -7123,7 +7123,7 @@
           <p:cNvPr id="7" name="">
             <a:extLst xmlns:a="http://schemas.openxmlformats.org/drawingml/2006/main">
               <a:ext uri="{FF2B5EF4-FFF2-40B4-BE49-F238E27FC236}">
-                <a16:creationId xmlns:a16="http://schemas.microsoft.com/office/drawing/2014/main" id="{7ADB5C1F-9761-4501-BF8B-92182F9F8999}"/>
+                <a16:creationId xmlns:a16="http://schemas.microsoft.com/office/drawing/2014/main" id="{0FB50FA1-E8B4-4916-88E5-7336127C1D94}"/>
               </a:ext>
             </a:extLst>
           </p:cNvPr>
@@ -7279,7 +7279,7 @@
           <p:cNvPr id="8" name="">
             <a:extLst xmlns:a="http://schemas.openxmlformats.org/drawingml/2006/main">
               <a:ext uri="{FF2B5EF4-FFF2-40B4-BE49-F238E27FC236}">
-                <a16:creationId xmlns:a16="http://schemas.microsoft.com/office/drawing/2014/main" id="{ED8F6A72-BA24-4E32-8A2B-AA615149DC63}"/>
+                <a16:creationId xmlns:a16="http://schemas.microsoft.com/office/drawing/2014/main" id="{780BDDD2-7346-4765-BFAC-7F7384528329}"/>
               </a:ext>
             </a:extLst>
           </p:cNvPr>
@@ -7435,7 +7435,7 @@
           <p:cNvPr id="9" name="">
             <a:extLst xmlns:a="http://schemas.openxmlformats.org/drawingml/2006/main">
               <a:ext uri="{FF2B5EF4-FFF2-40B4-BE49-F238E27FC236}">
-                <a16:creationId xmlns:a16="http://schemas.microsoft.com/office/drawing/2014/main" id="{C7C2AB23-423F-479E-BA22-D051B94D6958}"/>
+                <a16:creationId xmlns:a16="http://schemas.microsoft.com/office/drawing/2014/main" id="{175FDECE-1DEB-4F8B-83B5-1518E6733C6C}"/>
               </a:ext>
             </a:extLst>
           </p:cNvPr>
@@ -7445,7 +7445,7 @@
           <p:nvPr/>
         </p:nvPicPr>
         <p:blipFill>
-          <a:blip xmlns:r="http://schemas.openxmlformats.org/officeDocument/2006/relationships" xmlns:a="http://schemas.openxmlformats.org/drawingml/2006/main" r:embed="Re54e3cd163c34dd1"/>
+          <a:blip xmlns:r="http://schemas.openxmlformats.org/officeDocument/2006/relationships" xmlns:a="http://schemas.openxmlformats.org/drawingml/2006/main" r:embed="R2e2ee73f71304653"/>
           <a:stretch xmlns:a="http://schemas.openxmlformats.org/drawingml/2006/main"/>
         </p:blipFill>
         <p:spPr>
@@ -7463,7 +7463,7 @@
           <p:cNvPr id="10" name="">
             <a:extLst xmlns:a="http://schemas.openxmlformats.org/drawingml/2006/main">
               <a:ext uri="{FF2B5EF4-FFF2-40B4-BE49-F238E27FC236}">
-                <a16:creationId xmlns:a16="http://schemas.microsoft.com/office/drawing/2014/main" id="{B70806EE-6BAD-4060-8081-ACF08C927B39}"/>
+                <a16:creationId xmlns:a16="http://schemas.microsoft.com/office/drawing/2014/main" id="{31F7F3C5-11AD-4741-94FE-5CF87F436C8E}"/>
               </a:ext>
             </a:extLst>
           </p:cNvPr>
@@ -7473,7 +7473,7 @@
           <p:nvPr/>
         </p:nvPicPr>
         <p:blipFill>
-          <a:blip xmlns:r="http://schemas.openxmlformats.org/officeDocument/2006/relationships" xmlns:a="http://schemas.openxmlformats.org/drawingml/2006/main" r:embed="R44fcff8036984218"/>
+          <a:blip xmlns:r="http://schemas.openxmlformats.org/officeDocument/2006/relationships" xmlns:a="http://schemas.openxmlformats.org/drawingml/2006/main" r:embed="R3033347cc16d4fca"/>
           <a:stretch xmlns:a="http://schemas.openxmlformats.org/drawingml/2006/main"/>
         </p:blipFill>
         <p:spPr>
@@ -7491,7 +7491,7 @@
           <p:cNvPr id="11" name="">
             <a:extLst xmlns:a="http://schemas.openxmlformats.org/drawingml/2006/main">
               <a:ext uri="{FF2B5EF4-FFF2-40B4-BE49-F238E27FC236}">
-                <a16:creationId xmlns:a16="http://schemas.microsoft.com/office/drawing/2014/main" id="{F9195FC9-420F-4F23-BCB2-A48810C2978B}"/>
+                <a16:creationId xmlns:a16="http://schemas.microsoft.com/office/drawing/2014/main" id="{BF343894-5BBC-4E16-8ED0-E3CA4FF5A25A}"/>
               </a:ext>
             </a:extLst>
           </p:cNvPr>
@@ -7647,7 +7647,7 @@
           <p:cNvPr id="12" name="">
             <a:extLst xmlns:a="http://schemas.openxmlformats.org/drawingml/2006/main">
               <a:ext uri="{FF2B5EF4-FFF2-40B4-BE49-F238E27FC236}">
-                <a16:creationId xmlns:a16="http://schemas.microsoft.com/office/drawing/2014/main" id="{FB2B35F9-1161-4F10-862B-D78F3FE16574}"/>
+                <a16:creationId xmlns:a16="http://schemas.microsoft.com/office/drawing/2014/main" id="{B8A0FD78-9153-4821-8001-B239EABB5171}"/>
               </a:ext>
             </a:extLst>
           </p:cNvPr>
@@ -7803,7 +7803,7 @@
           <p:cNvPr id="13" name="">
             <a:extLst xmlns:a="http://schemas.openxmlformats.org/drawingml/2006/main">
               <a:ext uri="{FF2B5EF4-FFF2-40B4-BE49-F238E27FC236}">
-                <a16:creationId xmlns:a16="http://schemas.microsoft.com/office/drawing/2014/main" id="{DA8393FF-4842-4813-B8E7-CF3C8E552099}"/>
+                <a16:creationId xmlns:a16="http://schemas.microsoft.com/office/drawing/2014/main" id="{D85C4245-FDB3-4ABA-A5AE-A9D7854B967F}"/>
               </a:ext>
             </a:extLst>
           </p:cNvPr>
@@ -7957,7 +7957,7 @@
     </p:spTree>
     <p:extLst>
       <p:ext uri="{BB962C8B-B14F-4D97-AF65-F5344CB8AC3E}">
-        <p14:creationId xmlns:p14="http://schemas.microsoft.com/office/powerpoint/2010/main" val="1106648503"/>
+        <p14:creationId xmlns:p14="http://schemas.microsoft.com/office/powerpoint/2010/main" val="504698080"/>
       </p:ext>
     </p:extLst>
   </p:cSld>
@@ -7988,7 +7988,7 @@
           <p:cNvPr id="15" name="">
             <a:extLst xmlns:a="http://schemas.openxmlformats.org/drawingml/2006/main">
               <a:ext uri="{FF2B5EF4-FFF2-40B4-BE49-F238E27FC236}">
-                <a16:creationId xmlns:a16="http://schemas.microsoft.com/office/drawing/2014/main" id="{7299AFEB-4DCC-4872-AAB4-0985EB6F63D6}"/>
+                <a16:creationId xmlns:a16="http://schemas.microsoft.com/office/drawing/2014/main" id="{DC0D66E1-2894-4163-A2CF-07D7481DE4A1}"/>
               </a:ext>
             </a:extLst>
           </p:cNvPr>
@@ -8144,7 +8144,7 @@
           <p:cNvPr id="2" name="">
             <a:extLst xmlns:a="http://schemas.openxmlformats.org/drawingml/2006/main">
               <a:ext uri="{FF2B5EF4-FFF2-40B4-BE49-F238E27FC236}">
-                <a16:creationId xmlns:a16="http://schemas.microsoft.com/office/drawing/2014/main" id="{1E7C9E7D-C3D7-4DE3-A0AC-AA2CE5327DC1}"/>
+                <a16:creationId xmlns:a16="http://schemas.microsoft.com/office/drawing/2014/main" id="{903560ED-3898-4CD6-B97A-0AB0B165ACE9}"/>
               </a:ext>
             </a:extLst>
           </p:cNvPr>
@@ -8300,7 +8300,7 @@
           <p:cNvPr id="3" name="">
             <a:extLst xmlns:a="http://schemas.openxmlformats.org/drawingml/2006/main">
               <a:ext uri="{FF2B5EF4-FFF2-40B4-BE49-F238E27FC236}">
-                <a16:creationId xmlns:a16="http://schemas.microsoft.com/office/drawing/2014/main" id="{3022941F-F6C1-45FE-A35F-D50900AF3AC0}"/>
+                <a16:creationId xmlns:a16="http://schemas.microsoft.com/office/drawing/2014/main" id="{954B3CC2-6E2A-4117-A03F-3E121467B388}"/>
               </a:ext>
             </a:extLst>
           </p:cNvPr>
@@ -8456,7 +8456,7 @@
           <p:cNvPr id="4" name="">
             <a:extLst xmlns:a="http://schemas.openxmlformats.org/drawingml/2006/main">
               <a:ext uri="{FF2B5EF4-FFF2-40B4-BE49-F238E27FC236}">
-                <a16:creationId xmlns:a16="http://schemas.microsoft.com/office/drawing/2014/main" id="{A196E53C-CD49-47EB-AE5B-ADC4A7EC9670}"/>
+                <a16:creationId xmlns:a16="http://schemas.microsoft.com/office/drawing/2014/main" id="{EB1AE06C-95BD-4DDE-A836-027426BC65E7}"/>
               </a:ext>
             </a:extLst>
           </p:cNvPr>
@@ -8612,7 +8612,7 @@
           <p:cNvPr id="5" name="">
             <a:extLst xmlns:a="http://schemas.openxmlformats.org/drawingml/2006/main">
               <a:ext uri="{FF2B5EF4-FFF2-40B4-BE49-F238E27FC236}">
-                <a16:creationId xmlns:a16="http://schemas.microsoft.com/office/drawing/2014/main" id="{A4A51BD2-3DB3-4218-ACF6-D342B3FA2305}"/>
+                <a16:creationId xmlns:a16="http://schemas.microsoft.com/office/drawing/2014/main" id="{8971008B-31B6-404E-B52E-57A351C126E7}"/>
               </a:ext>
             </a:extLst>
           </p:cNvPr>
@@ -8768,7 +8768,7 @@
           <p:cNvPr id="6" name="">
             <a:extLst xmlns:a="http://schemas.openxmlformats.org/drawingml/2006/main">
               <a:ext uri="{FF2B5EF4-FFF2-40B4-BE49-F238E27FC236}">
-                <a16:creationId xmlns:a16="http://schemas.microsoft.com/office/drawing/2014/main" id="{3AA0A61D-AE9E-4858-89C3-01368BDE8CFC}"/>
+                <a16:creationId xmlns:a16="http://schemas.microsoft.com/office/drawing/2014/main" id="{20E1E8FB-E915-4D73-B146-15AC10F1BD40}"/>
               </a:ext>
             </a:extLst>
           </p:cNvPr>
@@ -8924,7 +8924,7 @@
           <p:cNvPr id="7" name="">
             <a:extLst xmlns:a="http://schemas.openxmlformats.org/drawingml/2006/main">
               <a:ext uri="{FF2B5EF4-FFF2-40B4-BE49-F238E27FC236}">
-                <a16:creationId xmlns:a16="http://schemas.microsoft.com/office/drawing/2014/main" id="{A92DEE29-8499-41B8-A330-892E3E65A5BA}"/>
+                <a16:creationId xmlns:a16="http://schemas.microsoft.com/office/drawing/2014/main" id="{09398D95-6266-44AB-8F62-477CF2573020}"/>
               </a:ext>
             </a:extLst>
           </p:cNvPr>
@@ -9080,7 +9080,7 @@
           <p:cNvPr id="8" name="">
             <a:extLst xmlns:a="http://schemas.openxmlformats.org/drawingml/2006/main">
               <a:ext uri="{FF2B5EF4-FFF2-40B4-BE49-F238E27FC236}">
-                <a16:creationId xmlns:a16="http://schemas.microsoft.com/office/drawing/2014/main" id="{D4D62256-6D71-4420-AD72-B18C013719F4}"/>
+                <a16:creationId xmlns:a16="http://schemas.microsoft.com/office/drawing/2014/main" id="{E778822A-400B-481D-BD0F-7DE0A0FD98EF}"/>
               </a:ext>
             </a:extLst>
           </p:cNvPr>
@@ -9236,7 +9236,7 @@
           <p:cNvPr id="9" name="">
             <a:extLst xmlns:a="http://schemas.openxmlformats.org/drawingml/2006/main">
               <a:ext uri="{FF2B5EF4-FFF2-40B4-BE49-F238E27FC236}">
-                <a16:creationId xmlns:a16="http://schemas.microsoft.com/office/drawing/2014/main" id="{EE8E3983-B0FA-4E32-8BA9-0EF6EA2F4497}"/>
+                <a16:creationId xmlns:a16="http://schemas.microsoft.com/office/drawing/2014/main" id="{3D24B493-D1E9-43DB-BFB6-C79E7D23DEBB}"/>
               </a:ext>
             </a:extLst>
           </p:cNvPr>
@@ -9392,7 +9392,7 @@
           <p:cNvPr id="10" name="">
             <a:extLst xmlns:a="http://schemas.openxmlformats.org/drawingml/2006/main">
               <a:ext uri="{FF2B5EF4-FFF2-40B4-BE49-F238E27FC236}">
-                <a16:creationId xmlns:a16="http://schemas.microsoft.com/office/drawing/2014/main" id="{7BC0BB51-1F97-4309-913A-0B77DF230B53}"/>
+                <a16:creationId xmlns:a16="http://schemas.microsoft.com/office/drawing/2014/main" id="{BD770A91-9C86-4091-98D1-852EAC147F63}"/>
               </a:ext>
             </a:extLst>
           </p:cNvPr>
@@ -9548,7 +9548,7 @@
           <p:cNvPr id="11" name="">
             <a:extLst xmlns:a="http://schemas.openxmlformats.org/drawingml/2006/main">
               <a:ext uri="{FF2B5EF4-FFF2-40B4-BE49-F238E27FC236}">
-                <a16:creationId xmlns:a16="http://schemas.microsoft.com/office/drawing/2014/main" id="{0B5B5A2F-8EA9-47B3-B3C7-AFCE0F41BE6E}"/>
+                <a16:creationId xmlns:a16="http://schemas.microsoft.com/office/drawing/2014/main" id="{C93C81E8-0E2A-4BFB-8089-C899F5B84420}"/>
               </a:ext>
             </a:extLst>
           </p:cNvPr>
@@ -9704,7 +9704,7 @@
           <p:cNvPr id="12" name="">
             <a:extLst xmlns:a="http://schemas.openxmlformats.org/drawingml/2006/main">
               <a:ext uri="{FF2B5EF4-FFF2-40B4-BE49-F238E27FC236}">
-                <a16:creationId xmlns:a16="http://schemas.microsoft.com/office/drawing/2014/main" id="{5CCF0FBD-E75A-4BB5-8B78-DFDFC24A877C}"/>
+                <a16:creationId xmlns:a16="http://schemas.microsoft.com/office/drawing/2014/main" id="{C12F5217-13E9-4FDF-8C77-353288EA0BD5}"/>
               </a:ext>
             </a:extLst>
           </p:cNvPr>
@@ -9849,7 +9849,7 @@
                 <a:latin typeface="Arial"/>
                 <a:ea typeface="Arial"/>
                 <a:cs typeface="Arial"/>
-                <a:hlinkClick xmlns:r="http://schemas.openxmlformats.org/officeDocument/2006/relationships" r:id="R831c53a808ee4f92"/>
+                <a:hlinkClick xmlns:r="http://schemas.openxmlformats.org/officeDocument/2006/relationships" r:id="Rd1404d81be3042db"/>
               </a:rPr>
               <a:t>Android study: Haverkamp et al.</a:t>
             </a:r>
@@ -9861,7 +9861,7 @@
           <p:cNvPr id="13" name="">
             <a:extLst xmlns:a="http://schemas.openxmlformats.org/drawingml/2006/main">
               <a:ext uri="{FF2B5EF4-FFF2-40B4-BE49-F238E27FC236}">
-                <a16:creationId xmlns:a16="http://schemas.microsoft.com/office/drawing/2014/main" id="{78CD19CD-3071-4240-9E46-18A462DDEFBE}"/>
+                <a16:creationId xmlns:a16="http://schemas.microsoft.com/office/drawing/2014/main" id="{8A27ADA4-D8C7-4AE9-B4FC-9AB56B9FA123}"/>
               </a:ext>
             </a:extLst>
           </p:cNvPr>
@@ -10006,7 +10006,7 @@
                 <a:latin typeface="Arial"/>
                 <a:ea typeface="Arial"/>
                 <a:cs typeface="Arial"/>
-                <a:hlinkClick xmlns:r="http://schemas.openxmlformats.org/officeDocument/2006/relationships" r:id="Rad4347a2614b4fbe"/>
+                <a:hlinkClick xmlns:r="http://schemas.openxmlformats.org/officeDocument/2006/relationships" r:id="R6a443726235e4512"/>
               </a:rPr>
               <a:t>Choice study: Iyengar &amp; Kamenica</a:t>
             </a:r>
@@ -10018,7 +10018,7 @@
           <p:cNvPr id="14" name="">
             <a:extLst xmlns:a="http://schemas.openxmlformats.org/drawingml/2006/main">
               <a:ext uri="{FF2B5EF4-FFF2-40B4-BE49-F238E27FC236}">
-                <a16:creationId xmlns:a16="http://schemas.microsoft.com/office/drawing/2014/main" id="{01C6D3C8-E9F9-4073-ACF6-9B8CD123EBE3}"/>
+                <a16:creationId xmlns:a16="http://schemas.microsoft.com/office/drawing/2014/main" id="{49DB28A7-BA35-4EEE-A861-4A2D7B55F88F}"/>
               </a:ext>
             </a:extLst>
           </p:cNvPr>
@@ -10163,7 +10163,7 @@
                 <a:latin typeface="Arial"/>
                 <a:ea typeface="Arial"/>
                 <a:cs typeface="Arial"/>
-                <a:hlinkClick xmlns:r="http://schemas.openxmlformats.org/officeDocument/2006/relationships" r:id="R3994cae8499d4ada"/>
+                <a:hlinkClick xmlns:r="http://schemas.openxmlformats.org/officeDocument/2006/relationships" r:id="R9abb59e398e94d12"/>
               </a:rPr>
               <a:t>Motion controls: W3C guidance</a:t>
             </a:r>
@@ -10173,7 +10173,7 @@
     </p:spTree>
     <p:extLst>
       <p:ext uri="{BB962C8B-B14F-4D97-AF65-F5344CB8AC3E}">
-        <p14:creationId xmlns:p14="http://schemas.microsoft.com/office/powerpoint/2010/main" val="698385038"/>
+        <p14:creationId xmlns:p14="http://schemas.microsoft.com/office/powerpoint/2010/main" val="1874902756"/>
       </p:ext>
     </p:extLst>
   </p:cSld>

</xml_diff>

<commit_message>
Finalize focused wealth navigation and motion appendix
</commit_message>
<xml_diff>
--- a/deliverables/Ionic-Exclusives-Final.pptx
+++ b/deliverables/Ionic-Exclusives-Final.pptx
@@ -2,16 +2,17 @@
 <file path=ppt/presentation.xml><?xml version="1.0" encoding="utf-8"?>
 <p:presentation xmlns:p="http://schemas.openxmlformats.org/presentationml/2006/main">
   <p:sldMasterIdLst>
-    <p:sldMasterId xmlns:r="http://schemas.openxmlformats.org/officeDocument/2006/relationships" id="2147483648" r:id="R68ed006880be4073"/>
+    <p:sldMasterId xmlns:r="http://schemas.openxmlformats.org/officeDocument/2006/relationships" id="2147483648" r:id="Rcfce73f1ac3346e1"/>
   </p:sldMasterIdLst>
   <p:notesMasterIdLst>
-    <p:notesMasterId xmlns:r="http://schemas.openxmlformats.org/officeDocument/2006/relationships" r:id="R8a0c28599ab74cf0"/>
+    <p:notesMasterId xmlns:r="http://schemas.openxmlformats.org/officeDocument/2006/relationships" r:id="R3f87a73d6512434b"/>
   </p:notesMasterIdLst>
   <p:sldIdLst>
-    <p:sldId xmlns:r="http://schemas.openxmlformats.org/officeDocument/2006/relationships" id="256" r:id="Rbdc2e3d159644332"/>
-    <p:sldId xmlns:r="http://schemas.openxmlformats.org/officeDocument/2006/relationships" id="257" r:id="R5710bbe65e604fd3"/>
-    <p:sldId xmlns:r="http://schemas.openxmlformats.org/officeDocument/2006/relationships" id="258" r:id="R642bc80659a7425b"/>
-    <p:sldId xmlns:r="http://schemas.openxmlformats.org/officeDocument/2006/relationships" id="259" r:id="R604cd2318b5f4327"/>
+    <p:sldId xmlns:r="http://schemas.openxmlformats.org/officeDocument/2006/relationships" id="256" r:id="R13b39066e4fe4009"/>
+    <p:sldId xmlns:r="http://schemas.openxmlformats.org/officeDocument/2006/relationships" id="257" r:id="Rf2a3b787ec814b99"/>
+    <p:sldId xmlns:r="http://schemas.openxmlformats.org/officeDocument/2006/relationships" id="258" r:id="Rcd463cabe6b24633"/>
+    <p:sldId xmlns:r="http://schemas.openxmlformats.org/officeDocument/2006/relationships" id="259" r:id="R314384c3eb114824"/>
+    <p:sldId xmlns:r="http://schemas.openxmlformats.org/officeDocument/2006/relationships" id="260" r:id="R6930afd21cfe4b52"/>
   </p:sldIdLst>
   <p:sldSz cx="12192000" cy="6858000"/>
   <p:notesSz cx="6858000" cy="9144000"/>
@@ -685,6 +686,76 @@
 </p:notes>
 </file>
 
+<file path=ppt/notesSlides/notesSlide5.xml><?xml version="1.0" encoding="utf-8"?>
+<p:notes xmlns:p="http://schemas.openxmlformats.org/presentationml/2006/main">
+  <p:cSld>
+    <p:spTree>
+      <p:nvGrpSpPr>
+        <p:cNvPr id="1" name=""/>
+        <p:cNvGrpSpPr/>
+        <p:nvPr/>
+      </p:nvGrpSpPr>
+      <p:grpSpPr>
+        <a:xfrm xmlns:a="http://schemas.openxmlformats.org/drawingml/2006/main"/>
+      </p:grpSpPr>
+      <p:sp>
+        <p:nvSpPr>
+          <p:cNvPr id="2" name="Slide Image Placeholder 1"/>
+          <p:cNvSpPr>
+            <a:spLocks xmlns:a="http://schemas.openxmlformats.org/drawingml/2006/main" noGrp="1"/>
+          </p:cNvSpPr>
+          <p:nvPr>
+            <p:ph type="sldImg" idx="0"/>
+          </p:nvPr>
+        </p:nvSpPr>
+        <p:spPr/>
+      </p:sp>
+      <p:sp>
+        <p:nvSpPr>
+          <p:cNvPr id="3" name="Notes Placeholder 2"/>
+          <p:cNvSpPr>
+            <a:spLocks xmlns:a="http://schemas.openxmlformats.org/drawingml/2006/main" noGrp="1"/>
+          </p:cNvSpPr>
+          <p:nvPr>
+            <p:ph type="body" idx="1"/>
+          </p:nvPr>
+        </p:nvSpPr>
+        <p:spPr/>
+        <p:txBody>
+          <a:bodyPr xmlns:a="http://schemas.openxmlformats.org/drawingml/2006/main"/>
+          <a:lstStyle xmlns:a="http://schemas.openxmlformats.org/drawingml/2006/main"/>
+          <a:p xmlns:a="http://schemas.openxmlformats.org/drawingml/2006/main">
+            <a:r>
+              <a:t>The intent is to signal a change of context and give Private Wealth a distinct sense of place. This is a design hypothesis rather than evidence of improved conversion. The welcome lasts 3.2 seconds plus a brief reveal, or can be skipped immediately. Short browse transitions last 1 second; the Private Wealth exit lasts 0.9 seconds. Other category tabs and hero paging controls are hidden inside Private Wealth. The dedicated back action returns to the remembered prior category. Keyboard focus is managed while overlays are visible. Reduced-motion settings bypass short transitions and provide a static, user-dismissed welcome. Evaluate skipped transitions, exits before product exposure, time to first product and risk/fee comprehension. Measure first unassisted funded investment and test the effect separately from the layout and AI changes. Avoid interpreting animation engagement as purchase intent.</a:t>
+            </a:r>
+          </a:p>
+        </p:txBody>
+      </p:sp>
+      <p:sp>
+        <p:nvSpPr>
+          <p:cNvPr id="4" name="Slide Number Placeholder 3"/>
+          <p:cNvSpPr>
+            <a:spLocks xmlns:a="http://schemas.openxmlformats.org/drawingml/2006/main" noGrp="1"/>
+          </p:cNvSpPr>
+          <p:nvPr>
+            <p:ph type="sldNum" idx="5"/>
+          </p:nvPr>
+        </p:nvSpPr>
+        <p:spPr/>
+        <p:txBody>
+          <a:bodyPr xmlns:a="http://schemas.openxmlformats.org/drawingml/2006/main"/>
+          <a:lstStyle xmlns:a="http://schemas.openxmlformats.org/drawingml/2006/main"/>
+          <a:p xmlns:a="http://schemas.openxmlformats.org/drawingml/2006/main"/>
+        </p:txBody>
+      </p:sp>
+    </p:spTree>
+  </p:cSld>
+  <p:clrMapOvr>
+    <a:masterClrMapping xmlns:a="http://schemas.openxmlformats.org/drawingml/2006/main"/>
+  </p:clrMapOvr>
+</p:notes>
+</file>
+
 <file path=ppt/slideLayouts/slideLayout1.xml><?xml version="1.0" encoding="utf-8"?>
 <p:sldLayout xmlns:p="http://schemas.openxmlformats.org/presentationml/2006/main" type="title">
   <p:cSld name="Title Slide">
@@ -702,7 +773,7 @@
           <p:cNvPr id="3" name="Title">
             <a:extLst xmlns:a="http://schemas.openxmlformats.org/drawingml/2006/main">
               <a:ext uri="{FF2B5EF4-FFF2-40B4-BE49-F238E27FC236}">
-                <a16:creationId xmlns:a16="http://schemas.microsoft.com/office/drawing/2014/main" id="{C4030177-A12D-4217-B958-EFCFB3B567B8}"/>
+                <a16:creationId xmlns:a16="http://schemas.microsoft.com/office/drawing/2014/main" id="{4415DD71-FC3A-4E82-B3E1-4BAB3322AD6F}"/>
               </a:ext>
             </a:extLst>
           </p:cNvPr>
@@ -931,7 +1002,7 @@
           <p:cNvPr id="2" name="Subtitle">
             <a:extLst xmlns:a="http://schemas.openxmlformats.org/drawingml/2006/main">
               <a:ext uri="{FF2B5EF4-FFF2-40B4-BE49-F238E27FC236}">
-                <a16:creationId xmlns:a16="http://schemas.microsoft.com/office/drawing/2014/main" id="{A829C897-0B09-4977-8570-8962F1B9169D}"/>
+                <a16:creationId xmlns:a16="http://schemas.microsoft.com/office/drawing/2014/main" id="{AF343C79-A591-4655-BC20-4764357494E1}"/>
               </a:ext>
             </a:extLst>
           </p:cNvPr>
@@ -1177,7 +1248,7 @@
           <p:cNvPr id="2" name="Section title">
             <a:extLst xmlns:a="http://schemas.openxmlformats.org/drawingml/2006/main">
               <a:ext uri="{FF2B5EF4-FFF2-40B4-BE49-F238E27FC236}">
-                <a16:creationId xmlns:a16="http://schemas.microsoft.com/office/drawing/2014/main" id="{8A26963E-607C-44DC-AB9B-54B16C0553E7}"/>
+                <a16:creationId xmlns:a16="http://schemas.microsoft.com/office/drawing/2014/main" id="{33B2EC1A-6692-480B-B36B-3760D8E725AB}"/>
               </a:ext>
             </a:extLst>
           </p:cNvPr>
@@ -1423,7 +1494,7 @@
           <p:cNvPr id="3" name="Title">
             <a:extLst xmlns:a="http://schemas.openxmlformats.org/drawingml/2006/main">
               <a:ext uri="{FF2B5EF4-FFF2-40B4-BE49-F238E27FC236}">
-                <a16:creationId xmlns:a16="http://schemas.microsoft.com/office/drawing/2014/main" id="{C4B1DAC6-6D3D-4A72-B53C-EB7BEFD4D3D7}"/>
+                <a16:creationId xmlns:a16="http://schemas.microsoft.com/office/drawing/2014/main" id="{AB62A23B-E4EA-437F-B27D-BD081B6C8EF4}"/>
               </a:ext>
             </a:extLst>
           </p:cNvPr>
@@ -1652,7 +1723,7 @@
           <p:cNvPr id="2" name="Body">
             <a:extLst xmlns:a="http://schemas.openxmlformats.org/drawingml/2006/main">
               <a:ext uri="{FF2B5EF4-FFF2-40B4-BE49-F238E27FC236}">
-                <a16:creationId xmlns:a16="http://schemas.microsoft.com/office/drawing/2014/main" id="{AC17B363-DC06-44F3-8942-2998694D6A69}"/>
+                <a16:creationId xmlns:a16="http://schemas.microsoft.com/office/drawing/2014/main" id="{7F0F3A47-69CF-4FBD-B2BA-661C7040104E}"/>
               </a:ext>
             </a:extLst>
           </p:cNvPr>
@@ -1898,7 +1969,7 @@
           <p:cNvPr id="4" name="Title">
             <a:extLst xmlns:a="http://schemas.openxmlformats.org/drawingml/2006/main">
               <a:ext uri="{FF2B5EF4-FFF2-40B4-BE49-F238E27FC236}">
-                <a16:creationId xmlns:a16="http://schemas.microsoft.com/office/drawing/2014/main" id="{C37F6F6F-2FB2-4360-B11E-A1B7D81E1E06}"/>
+                <a16:creationId xmlns:a16="http://schemas.microsoft.com/office/drawing/2014/main" id="{E8BAFC3D-4A51-41F9-8CB4-7F089617F642}"/>
               </a:ext>
             </a:extLst>
           </p:cNvPr>
@@ -2127,7 +2198,7 @@
           <p:cNvPr id="2" name="Left column">
             <a:extLst xmlns:a="http://schemas.openxmlformats.org/drawingml/2006/main">
               <a:ext uri="{FF2B5EF4-FFF2-40B4-BE49-F238E27FC236}">
-                <a16:creationId xmlns:a16="http://schemas.microsoft.com/office/drawing/2014/main" id="{1B63E573-8A8A-45E1-BB87-EDDE0E732B24}"/>
+                <a16:creationId xmlns:a16="http://schemas.microsoft.com/office/drawing/2014/main" id="{9B4F5FCB-077E-47EF-B7EA-343048CE96CD}"/>
               </a:ext>
             </a:extLst>
           </p:cNvPr>
@@ -2356,7 +2427,7 @@
           <p:cNvPr id="3" name="Right column">
             <a:extLst xmlns:a="http://schemas.openxmlformats.org/drawingml/2006/main">
               <a:ext uri="{FF2B5EF4-FFF2-40B4-BE49-F238E27FC236}">
-                <a16:creationId xmlns:a16="http://schemas.microsoft.com/office/drawing/2014/main" id="{8C6A2318-211F-4C02-9B04-482CB63D219B}"/>
+                <a16:creationId xmlns:a16="http://schemas.microsoft.com/office/drawing/2014/main" id="{F1AD2E8F-9250-401E-A0F2-3C2585AB0FAD}"/>
               </a:ext>
             </a:extLst>
           </p:cNvPr>
@@ -2602,7 +2673,7 @@
           <p:cNvPr id="3" name="Title">
             <a:extLst xmlns:a="http://schemas.openxmlformats.org/drawingml/2006/main">
               <a:ext uri="{FF2B5EF4-FFF2-40B4-BE49-F238E27FC236}">
-                <a16:creationId xmlns:a16="http://schemas.microsoft.com/office/drawing/2014/main" id="{1FF9D47B-212B-48A0-9639-9B01263A353E}"/>
+                <a16:creationId xmlns:a16="http://schemas.microsoft.com/office/drawing/2014/main" id="{03D74E47-1444-43D0-A301-39D60E48DCB8}"/>
               </a:ext>
             </a:extLst>
           </p:cNvPr>
@@ -2831,7 +2902,7 @@
           <p:cNvPr id="2" name="Left column">
             <a:extLst xmlns:a="http://schemas.openxmlformats.org/drawingml/2006/main">
               <a:ext uri="{FF2B5EF4-FFF2-40B4-BE49-F238E27FC236}">
-                <a16:creationId xmlns:a16="http://schemas.microsoft.com/office/drawing/2014/main" id="{7B807D7D-1CED-474F-B889-9A7A27E3CE6F}"/>
+                <a16:creationId xmlns:a16="http://schemas.microsoft.com/office/drawing/2014/main" id="{9D795911-45D5-4126-8979-3D81224E770F}"/>
               </a:ext>
             </a:extLst>
           </p:cNvPr>
@@ -3098,12 +3169,12 @@
   </p:cSld>
   <p:clrMap bg1="lt1" tx1="dk1" bg2="lt2" tx2="dk2" accent1="accent1" accent2="accent2" accent3="accent3" accent4="accent4" accent5="accent5" accent6="accent6" hlink="hlink" folHlink="folHlink"/>
   <p:sldLayoutIdLst>
-    <p:sldLayoutId xmlns:r="http://schemas.openxmlformats.org/officeDocument/2006/relationships" id="2147483649" r:id="Ra582d71aba144fcb"/>
-    <p:sldLayoutId xmlns:r="http://schemas.openxmlformats.org/officeDocument/2006/relationships" id="2147483650" r:id="Rabd84782a1f24132"/>
-    <p:sldLayoutId xmlns:r="http://schemas.openxmlformats.org/officeDocument/2006/relationships" id="2147483651" r:id="Rcf60860ed0b84e0c"/>
-    <p:sldLayoutId xmlns:r="http://schemas.openxmlformats.org/officeDocument/2006/relationships" id="2147483652" r:id="Ra05080989d9a414c"/>
-    <p:sldLayoutId xmlns:r="http://schemas.openxmlformats.org/officeDocument/2006/relationships" id="2147483653" r:id="Rc403fbc62ea843b6"/>
-    <p:sldLayoutId xmlns:r="http://schemas.openxmlformats.org/officeDocument/2006/relationships" id="2147483654" r:id="R67c1c556949245fe"/>
+    <p:sldLayoutId xmlns:r="http://schemas.openxmlformats.org/officeDocument/2006/relationships" id="2147483649" r:id="R80abb8fa7ef04bbe"/>
+    <p:sldLayoutId xmlns:r="http://schemas.openxmlformats.org/officeDocument/2006/relationships" id="2147483650" r:id="Rec0e957237d341f8"/>
+    <p:sldLayoutId xmlns:r="http://schemas.openxmlformats.org/officeDocument/2006/relationships" id="2147483651" r:id="R803a4e9d35664556"/>
+    <p:sldLayoutId xmlns:r="http://schemas.openxmlformats.org/officeDocument/2006/relationships" id="2147483652" r:id="R53f4e0e003024da7"/>
+    <p:sldLayoutId xmlns:r="http://schemas.openxmlformats.org/officeDocument/2006/relationships" id="2147483653" r:id="R3d2ce0cd36c943c2"/>
+    <p:sldLayoutId xmlns:r="http://schemas.openxmlformats.org/officeDocument/2006/relationships" id="2147483654" r:id="Rbb51c3a9d72e448c"/>
   </p:sldLayoutIdLst>
   <p:txStyles>
     <p:titleStyle>
@@ -3654,7 +3725,7 @@
           <p:cNvPr id="9" name="">
             <a:extLst xmlns:a="http://schemas.openxmlformats.org/drawingml/2006/main">
               <a:ext uri="{FF2B5EF4-FFF2-40B4-BE49-F238E27FC236}">
-                <a16:creationId xmlns:a16="http://schemas.microsoft.com/office/drawing/2014/main" id="{B5527C18-79A6-49A5-8C11-220CBA60E6D5}"/>
+                <a16:creationId xmlns:a16="http://schemas.microsoft.com/office/drawing/2014/main" id="{F9279B11-1FB9-455B-AF2E-C0CA94F9D125}"/>
               </a:ext>
             </a:extLst>
           </p:cNvPr>
@@ -3810,7 +3881,7 @@
           <p:cNvPr id="2" name="">
             <a:extLst xmlns:a="http://schemas.openxmlformats.org/drawingml/2006/main">
               <a:ext uri="{FF2B5EF4-FFF2-40B4-BE49-F238E27FC236}">
-                <a16:creationId xmlns:a16="http://schemas.microsoft.com/office/drawing/2014/main" id="{75951965-648A-4E12-97CA-C2A2161AE10C}"/>
+                <a16:creationId xmlns:a16="http://schemas.microsoft.com/office/drawing/2014/main" id="{8BFE8E33-405C-4F33-ACBE-12D68171EF0E}"/>
               </a:ext>
             </a:extLst>
           </p:cNvPr>
@@ -3989,7 +4060,7 @@
           <p:cNvPr id="3" name="">
             <a:extLst xmlns:a="http://schemas.openxmlformats.org/drawingml/2006/main">
               <a:ext uri="{FF2B5EF4-FFF2-40B4-BE49-F238E27FC236}">
-                <a16:creationId xmlns:a16="http://schemas.microsoft.com/office/drawing/2014/main" id="{DFA85032-C5D5-4344-B88E-35A3EDA2FB05}"/>
+                <a16:creationId xmlns:a16="http://schemas.microsoft.com/office/drawing/2014/main" id="{A744D9EB-AD19-4255-8438-2317FF6E6485}"/>
               </a:ext>
             </a:extLst>
           </p:cNvPr>
@@ -4145,7 +4216,7 @@
           <p:cNvPr id="4" name="">
             <a:extLst xmlns:a="http://schemas.openxmlformats.org/drawingml/2006/main">
               <a:ext uri="{FF2B5EF4-FFF2-40B4-BE49-F238E27FC236}">
-                <a16:creationId xmlns:a16="http://schemas.microsoft.com/office/drawing/2014/main" id="{679C3850-8A03-4981-AE9D-F9792AB350FF}"/>
+                <a16:creationId xmlns:a16="http://schemas.microsoft.com/office/drawing/2014/main" id="{27B902D5-2F1C-42F1-8DF2-9A0DF41F397F}"/>
               </a:ext>
             </a:extLst>
           </p:cNvPr>
@@ -4301,7 +4372,7 @@
           <p:cNvPr id="5" name="">
             <a:extLst xmlns:a="http://schemas.openxmlformats.org/drawingml/2006/main">
               <a:ext uri="{FF2B5EF4-FFF2-40B4-BE49-F238E27FC236}">
-                <a16:creationId xmlns:a16="http://schemas.microsoft.com/office/drawing/2014/main" id="{9129846A-1486-4A60-A386-206600C40B6B}"/>
+                <a16:creationId xmlns:a16="http://schemas.microsoft.com/office/drawing/2014/main" id="{DD1E97F0-FBD4-4338-A2DA-85BFF19E9816}"/>
               </a:ext>
             </a:extLst>
           </p:cNvPr>
@@ -4457,7 +4528,7 @@
           <p:cNvPr id="6" name="">
             <a:extLst xmlns:a="http://schemas.openxmlformats.org/drawingml/2006/main">
               <a:ext uri="{FF2B5EF4-FFF2-40B4-BE49-F238E27FC236}">
-                <a16:creationId xmlns:a16="http://schemas.microsoft.com/office/drawing/2014/main" id="{AE9DA23E-BAE4-4B77-ACB8-B0B7DC083E5C}"/>
+                <a16:creationId xmlns:a16="http://schemas.microsoft.com/office/drawing/2014/main" id="{4D04E819-7DE7-4763-9C3C-8D85742329DE}"/>
               </a:ext>
             </a:extLst>
           </p:cNvPr>
@@ -4613,7 +4684,7 @@
           <p:cNvPr id="7" name="">
             <a:extLst xmlns:a="http://schemas.openxmlformats.org/drawingml/2006/main">
               <a:ext uri="{FF2B5EF4-FFF2-40B4-BE49-F238E27FC236}">
-                <a16:creationId xmlns:a16="http://schemas.microsoft.com/office/drawing/2014/main" id="{6453A883-9E26-44CE-BA80-9F7A15AE1EAB}"/>
+                <a16:creationId xmlns:a16="http://schemas.microsoft.com/office/drawing/2014/main" id="{5D1ED9D3-0B7A-40BE-98AE-FCC21C9CC7A5}"/>
               </a:ext>
             </a:extLst>
           </p:cNvPr>
@@ -4769,7 +4840,7 @@
           <p:cNvPr id="8" name="">
             <a:extLst xmlns:a="http://schemas.openxmlformats.org/drawingml/2006/main">
               <a:ext uri="{FF2B5EF4-FFF2-40B4-BE49-F238E27FC236}">
-                <a16:creationId xmlns:a16="http://schemas.microsoft.com/office/drawing/2014/main" id="{58DE404C-F305-42F7-8A2C-9345601789F1}"/>
+                <a16:creationId xmlns:a16="http://schemas.microsoft.com/office/drawing/2014/main" id="{27034AB6-3FEC-4C93-8CC7-1F0D861D49BE}"/>
               </a:ext>
             </a:extLst>
           </p:cNvPr>
@@ -4779,7 +4850,7 @@
           <p:nvPr/>
         </p:nvPicPr>
         <p:blipFill>
-          <a:blip xmlns:r="http://schemas.openxmlformats.org/officeDocument/2006/relationships" xmlns:a="http://schemas.openxmlformats.org/drawingml/2006/main" r:embed="R01a9771a362f4b36"/>
+          <a:blip xmlns:r="http://schemas.openxmlformats.org/officeDocument/2006/relationships" xmlns:a="http://schemas.openxmlformats.org/drawingml/2006/main" r:embed="Rfab6fd9b16ee42ab"/>
           <a:stretch xmlns:a="http://schemas.openxmlformats.org/drawingml/2006/main"/>
         </p:blipFill>
         <p:spPr>
@@ -4795,7 +4866,7 @@
     </p:spTree>
     <p:extLst>
       <p:ext uri="{BB962C8B-B14F-4D97-AF65-F5344CB8AC3E}">
-        <p14:creationId xmlns:p14="http://schemas.microsoft.com/office/powerpoint/2010/main" val="1833769585"/>
+        <p14:creationId xmlns:p14="http://schemas.microsoft.com/office/powerpoint/2010/main" val="619085916"/>
       </p:ext>
     </p:extLst>
   </p:cSld>
@@ -4826,7 +4897,7 @@
           <p:cNvPr id="12" name="">
             <a:extLst xmlns:a="http://schemas.openxmlformats.org/drawingml/2006/main">
               <a:ext uri="{FF2B5EF4-FFF2-40B4-BE49-F238E27FC236}">
-                <a16:creationId xmlns:a16="http://schemas.microsoft.com/office/drawing/2014/main" id="{86E09541-FA27-4E26-8561-932CAF3317A0}"/>
+                <a16:creationId xmlns:a16="http://schemas.microsoft.com/office/drawing/2014/main" id="{C21122AC-037F-44DB-B639-64BEB0FD07F1}"/>
               </a:ext>
             </a:extLst>
           </p:cNvPr>
@@ -4982,7 +5053,7 @@
           <p:cNvPr id="2" name="">
             <a:extLst xmlns:a="http://schemas.openxmlformats.org/drawingml/2006/main">
               <a:ext uri="{FF2B5EF4-FFF2-40B4-BE49-F238E27FC236}">
-                <a16:creationId xmlns:a16="http://schemas.microsoft.com/office/drawing/2014/main" id="{CB0AD907-209E-4E93-B676-1776D6738A12}"/>
+                <a16:creationId xmlns:a16="http://schemas.microsoft.com/office/drawing/2014/main" id="{F16C377A-29C7-4E23-B370-B242404D1FE6}"/>
               </a:ext>
             </a:extLst>
           </p:cNvPr>
@@ -5138,7 +5209,7 @@
           <p:cNvPr id="3" name="">
             <a:extLst xmlns:a="http://schemas.openxmlformats.org/drawingml/2006/main">
               <a:ext uri="{FF2B5EF4-FFF2-40B4-BE49-F238E27FC236}">
-                <a16:creationId xmlns:a16="http://schemas.microsoft.com/office/drawing/2014/main" id="{BCD25FBC-1CD1-46FE-9F7A-D7117FBE0411}"/>
+                <a16:creationId xmlns:a16="http://schemas.microsoft.com/office/drawing/2014/main" id="{618C9BD2-D6AC-4A5B-A5E5-248CE7264028}"/>
               </a:ext>
             </a:extLst>
           </p:cNvPr>
@@ -5148,7 +5219,7 @@
           <p:nvPr/>
         </p:nvPicPr>
         <p:blipFill>
-          <a:blip xmlns:r="http://schemas.openxmlformats.org/officeDocument/2006/relationships" xmlns:a="http://schemas.openxmlformats.org/drawingml/2006/main" r:embed="R6bf1c4f363094407"/>
+          <a:blip xmlns:r="http://schemas.openxmlformats.org/officeDocument/2006/relationships" xmlns:a="http://schemas.openxmlformats.org/drawingml/2006/main" r:embed="R47a4558ae2b444ba"/>
           <a:stretch xmlns:a="http://schemas.openxmlformats.org/drawingml/2006/main"/>
         </p:blipFill>
         <p:spPr>
@@ -5166,7 +5237,7 @@
           <p:cNvPr id="4" name="">
             <a:extLst xmlns:a="http://schemas.openxmlformats.org/drawingml/2006/main">
               <a:ext uri="{FF2B5EF4-FFF2-40B4-BE49-F238E27FC236}">
-                <a16:creationId xmlns:a16="http://schemas.microsoft.com/office/drawing/2014/main" id="{18C2D555-082C-45CC-80DA-6DE33364239B}"/>
+                <a16:creationId xmlns:a16="http://schemas.microsoft.com/office/drawing/2014/main" id="{1016E88E-B17D-4609-9422-8EAE05C41E09}"/>
               </a:ext>
             </a:extLst>
           </p:cNvPr>
@@ -5176,7 +5247,7 @@
           <p:nvPr/>
         </p:nvPicPr>
         <p:blipFill>
-          <a:blip xmlns:r="http://schemas.openxmlformats.org/officeDocument/2006/relationships" xmlns:a="http://schemas.openxmlformats.org/drawingml/2006/main" r:embed="R3b078bd13e9c4330"/>
+          <a:blip xmlns:r="http://schemas.openxmlformats.org/officeDocument/2006/relationships" xmlns:a="http://schemas.openxmlformats.org/drawingml/2006/main" r:embed="Rb88dd8020a384c45"/>
           <a:stretch xmlns:a="http://schemas.openxmlformats.org/drawingml/2006/main"/>
         </p:blipFill>
         <p:spPr>
@@ -5194,7 +5265,7 @@
           <p:cNvPr id="5" name="">
             <a:extLst xmlns:a="http://schemas.openxmlformats.org/drawingml/2006/main">
               <a:ext uri="{FF2B5EF4-FFF2-40B4-BE49-F238E27FC236}">
-                <a16:creationId xmlns:a16="http://schemas.microsoft.com/office/drawing/2014/main" id="{C361484C-1193-492B-92A1-E9CBDD5BF63B}"/>
+                <a16:creationId xmlns:a16="http://schemas.microsoft.com/office/drawing/2014/main" id="{7768C905-6988-4B82-8806-BDC76EB77662}"/>
               </a:ext>
             </a:extLst>
           </p:cNvPr>
@@ -5204,7 +5275,7 @@
           <p:nvPr/>
         </p:nvPicPr>
         <p:blipFill>
-          <a:blip xmlns:r="http://schemas.openxmlformats.org/officeDocument/2006/relationships" xmlns:a="http://schemas.openxmlformats.org/drawingml/2006/main" r:embed="R544a1d28fbd64677"/>
+          <a:blip xmlns:r="http://schemas.openxmlformats.org/officeDocument/2006/relationships" xmlns:a="http://schemas.openxmlformats.org/drawingml/2006/main" r:embed="R15667977bbc140d3"/>
           <a:stretch xmlns:a="http://schemas.openxmlformats.org/drawingml/2006/main"/>
         </p:blipFill>
         <p:spPr>
@@ -5222,7 +5293,7 @@
           <p:cNvPr id="6" name="">
             <a:extLst xmlns:a="http://schemas.openxmlformats.org/drawingml/2006/main">
               <a:ext uri="{FF2B5EF4-FFF2-40B4-BE49-F238E27FC236}">
-                <a16:creationId xmlns:a16="http://schemas.microsoft.com/office/drawing/2014/main" id="{16CC2243-25C5-48B5-A68F-2666423431D7}"/>
+                <a16:creationId xmlns:a16="http://schemas.microsoft.com/office/drawing/2014/main" id="{AB4C6D45-4239-4657-BDA1-113DF15A7953}"/>
               </a:ext>
             </a:extLst>
           </p:cNvPr>
@@ -5378,7 +5449,7 @@
           <p:cNvPr id="7" name="">
             <a:extLst xmlns:a="http://schemas.openxmlformats.org/drawingml/2006/main">
               <a:ext uri="{FF2B5EF4-FFF2-40B4-BE49-F238E27FC236}">
-                <a16:creationId xmlns:a16="http://schemas.microsoft.com/office/drawing/2014/main" id="{1D17FA09-C95A-4BF5-B1FB-E3102D3BA545}"/>
+                <a16:creationId xmlns:a16="http://schemas.microsoft.com/office/drawing/2014/main" id="{87677048-6A2C-4A91-B5DC-42D741B63810}"/>
               </a:ext>
             </a:extLst>
           </p:cNvPr>
@@ -5534,7 +5605,7 @@
           <p:cNvPr id="8" name="">
             <a:extLst xmlns:a="http://schemas.openxmlformats.org/drawingml/2006/main">
               <a:ext uri="{FF2B5EF4-FFF2-40B4-BE49-F238E27FC236}">
-                <a16:creationId xmlns:a16="http://schemas.microsoft.com/office/drawing/2014/main" id="{DBEBE876-C89B-43B9-9B78-A3A93ADC5C77}"/>
+                <a16:creationId xmlns:a16="http://schemas.microsoft.com/office/drawing/2014/main" id="{39B172D7-4416-4E06-A3A6-2F8142C78762}"/>
               </a:ext>
             </a:extLst>
           </p:cNvPr>
@@ -5690,7 +5761,7 @@
           <p:cNvPr id="9" name="">
             <a:extLst xmlns:a="http://schemas.openxmlformats.org/drawingml/2006/main">
               <a:ext uri="{FF2B5EF4-FFF2-40B4-BE49-F238E27FC236}">
-                <a16:creationId xmlns:a16="http://schemas.microsoft.com/office/drawing/2014/main" id="{0A206C36-33A9-4DD3-88C5-CEA5C68F7DD4}"/>
+                <a16:creationId xmlns:a16="http://schemas.microsoft.com/office/drawing/2014/main" id="{2A0B3634-93EE-4E81-A068-EBD673440700}"/>
               </a:ext>
             </a:extLst>
           </p:cNvPr>
@@ -5846,7 +5917,7 @@
           <p:cNvPr id="10" name="">
             <a:extLst xmlns:a="http://schemas.openxmlformats.org/drawingml/2006/main">
               <a:ext uri="{FF2B5EF4-FFF2-40B4-BE49-F238E27FC236}">
-                <a16:creationId xmlns:a16="http://schemas.microsoft.com/office/drawing/2014/main" id="{3894D845-C84F-4845-B424-23D6BC7A18EF}"/>
+                <a16:creationId xmlns:a16="http://schemas.microsoft.com/office/drawing/2014/main" id="{A7229236-27B0-434D-B7DB-0C1E8F6559C6}"/>
               </a:ext>
             </a:extLst>
           </p:cNvPr>
@@ -6002,7 +6073,7 @@
           <p:cNvPr id="11" name="">
             <a:extLst xmlns:a="http://schemas.openxmlformats.org/drawingml/2006/main">
               <a:ext uri="{FF2B5EF4-FFF2-40B4-BE49-F238E27FC236}">
-                <a16:creationId xmlns:a16="http://schemas.microsoft.com/office/drawing/2014/main" id="{C17FF858-B010-4603-9DD8-3A16275EB48A}"/>
+                <a16:creationId xmlns:a16="http://schemas.microsoft.com/office/drawing/2014/main" id="{50A7C98D-30E6-412A-BCD2-C8123F12419D}"/>
               </a:ext>
             </a:extLst>
           </p:cNvPr>
@@ -6156,7 +6227,7 @@
     </p:spTree>
     <p:extLst>
       <p:ext uri="{BB962C8B-B14F-4D97-AF65-F5344CB8AC3E}">
-        <p14:creationId xmlns:p14="http://schemas.microsoft.com/office/powerpoint/2010/main" val="50753927"/>
+        <p14:creationId xmlns:p14="http://schemas.microsoft.com/office/powerpoint/2010/main" val="955642227"/>
       </p:ext>
     </p:extLst>
   </p:cSld>
@@ -6187,7 +6258,7 @@
           <p:cNvPr id="14" name="">
             <a:extLst xmlns:a="http://schemas.openxmlformats.org/drawingml/2006/main">
               <a:ext uri="{FF2B5EF4-FFF2-40B4-BE49-F238E27FC236}">
-                <a16:creationId xmlns:a16="http://schemas.microsoft.com/office/drawing/2014/main" id="{7851105B-3F02-435F-993D-43DBE0A56E69}"/>
+                <a16:creationId xmlns:a16="http://schemas.microsoft.com/office/drawing/2014/main" id="{D2FBCCC2-716B-4403-AAEF-0D19306CD296}"/>
               </a:ext>
             </a:extLst>
           </p:cNvPr>
@@ -6343,7 +6414,7 @@
           <p:cNvPr id="2" name="">
             <a:extLst xmlns:a="http://schemas.openxmlformats.org/drawingml/2006/main">
               <a:ext uri="{FF2B5EF4-FFF2-40B4-BE49-F238E27FC236}">
-                <a16:creationId xmlns:a16="http://schemas.microsoft.com/office/drawing/2014/main" id="{9F4E866B-AC22-413D-9DCB-64061CBD8912}"/>
+                <a16:creationId xmlns:a16="http://schemas.microsoft.com/office/drawing/2014/main" id="{185EDE95-96B7-4DAB-B937-BB7F861CFDC9}"/>
               </a:ext>
             </a:extLst>
           </p:cNvPr>
@@ -6499,7 +6570,7 @@
           <p:cNvPr id="3" name="">
             <a:extLst xmlns:a="http://schemas.openxmlformats.org/drawingml/2006/main">
               <a:ext uri="{FF2B5EF4-FFF2-40B4-BE49-F238E27FC236}">
-                <a16:creationId xmlns:a16="http://schemas.microsoft.com/office/drawing/2014/main" id="{26D0206C-44FD-4BE3-AAE3-4D17685B68D2}"/>
+                <a16:creationId xmlns:a16="http://schemas.microsoft.com/office/drawing/2014/main" id="{D155CB8B-95F0-45B4-8F6C-0DF361093E63}"/>
               </a:ext>
             </a:extLst>
           </p:cNvPr>
@@ -6655,7 +6726,7 @@
           <p:cNvPr id="4" name="">
             <a:extLst xmlns:a="http://schemas.openxmlformats.org/drawingml/2006/main">
               <a:ext uri="{FF2B5EF4-FFF2-40B4-BE49-F238E27FC236}">
-                <a16:creationId xmlns:a16="http://schemas.microsoft.com/office/drawing/2014/main" id="{5E49EABE-27CB-478A-A853-71C8DB7A2C7A}"/>
+                <a16:creationId xmlns:a16="http://schemas.microsoft.com/office/drawing/2014/main" id="{F33DAA9F-CBB5-4CDC-9739-242D076BAFF1}"/>
               </a:ext>
             </a:extLst>
           </p:cNvPr>
@@ -6811,7 +6882,7 @@
           <p:cNvPr id="5" name="">
             <a:extLst xmlns:a="http://schemas.openxmlformats.org/drawingml/2006/main">
               <a:ext uri="{FF2B5EF4-FFF2-40B4-BE49-F238E27FC236}">
-                <a16:creationId xmlns:a16="http://schemas.microsoft.com/office/drawing/2014/main" id="{0417C228-FEE6-4668-ACB8-AB7EB97B70AA}"/>
+                <a16:creationId xmlns:a16="http://schemas.microsoft.com/office/drawing/2014/main" id="{0D1A1211-4B0A-40F2-835E-F1E71260DEC5}"/>
               </a:ext>
             </a:extLst>
           </p:cNvPr>
@@ -6967,7 +7038,7 @@
           <p:cNvPr id="6" name="">
             <a:extLst xmlns:a="http://schemas.openxmlformats.org/drawingml/2006/main">
               <a:ext uri="{FF2B5EF4-FFF2-40B4-BE49-F238E27FC236}">
-                <a16:creationId xmlns:a16="http://schemas.microsoft.com/office/drawing/2014/main" id="{EDB2968A-F67C-4DF3-91DB-F3D2A13454DB}"/>
+                <a16:creationId xmlns:a16="http://schemas.microsoft.com/office/drawing/2014/main" id="{B4282B3D-1B30-4849-9A7B-D1C7651E332D}"/>
               </a:ext>
             </a:extLst>
           </p:cNvPr>
@@ -7123,7 +7194,7 @@
           <p:cNvPr id="7" name="">
             <a:extLst xmlns:a="http://schemas.openxmlformats.org/drawingml/2006/main">
               <a:ext uri="{FF2B5EF4-FFF2-40B4-BE49-F238E27FC236}">
-                <a16:creationId xmlns:a16="http://schemas.microsoft.com/office/drawing/2014/main" id="{0FB50FA1-E8B4-4916-88E5-7336127C1D94}"/>
+                <a16:creationId xmlns:a16="http://schemas.microsoft.com/office/drawing/2014/main" id="{AD6AA975-81D4-4BCC-ADC3-D8776B7DA54C}"/>
               </a:ext>
             </a:extLst>
           </p:cNvPr>
@@ -7279,7 +7350,7 @@
           <p:cNvPr id="8" name="">
             <a:extLst xmlns:a="http://schemas.openxmlformats.org/drawingml/2006/main">
               <a:ext uri="{FF2B5EF4-FFF2-40B4-BE49-F238E27FC236}">
-                <a16:creationId xmlns:a16="http://schemas.microsoft.com/office/drawing/2014/main" id="{780BDDD2-7346-4765-BFAC-7F7384528329}"/>
+                <a16:creationId xmlns:a16="http://schemas.microsoft.com/office/drawing/2014/main" id="{A41E099B-0274-4BAD-95F0-13C06DEEB361}"/>
               </a:ext>
             </a:extLst>
           </p:cNvPr>
@@ -7435,7 +7506,7 @@
           <p:cNvPr id="9" name="">
             <a:extLst xmlns:a="http://schemas.openxmlformats.org/drawingml/2006/main">
               <a:ext uri="{FF2B5EF4-FFF2-40B4-BE49-F238E27FC236}">
-                <a16:creationId xmlns:a16="http://schemas.microsoft.com/office/drawing/2014/main" id="{175FDECE-1DEB-4F8B-83B5-1518E6733C6C}"/>
+                <a16:creationId xmlns:a16="http://schemas.microsoft.com/office/drawing/2014/main" id="{B7729BE1-D3F8-460F-9CBE-CC188CC402E9}"/>
               </a:ext>
             </a:extLst>
           </p:cNvPr>
@@ -7445,7 +7516,7 @@
           <p:nvPr/>
         </p:nvPicPr>
         <p:blipFill>
-          <a:blip xmlns:r="http://schemas.openxmlformats.org/officeDocument/2006/relationships" xmlns:a="http://schemas.openxmlformats.org/drawingml/2006/main" r:embed="R2e2ee73f71304653"/>
+          <a:blip xmlns:r="http://schemas.openxmlformats.org/officeDocument/2006/relationships" xmlns:a="http://schemas.openxmlformats.org/drawingml/2006/main" r:embed="R58f5a039d96d40ba"/>
           <a:stretch xmlns:a="http://schemas.openxmlformats.org/drawingml/2006/main"/>
         </p:blipFill>
         <p:spPr>
@@ -7463,7 +7534,7 @@
           <p:cNvPr id="10" name="">
             <a:extLst xmlns:a="http://schemas.openxmlformats.org/drawingml/2006/main">
               <a:ext uri="{FF2B5EF4-FFF2-40B4-BE49-F238E27FC236}">
-                <a16:creationId xmlns:a16="http://schemas.microsoft.com/office/drawing/2014/main" id="{31F7F3C5-11AD-4741-94FE-5CF87F436C8E}"/>
+                <a16:creationId xmlns:a16="http://schemas.microsoft.com/office/drawing/2014/main" id="{36FBF6EE-168E-4286-B4C8-10DB07FC9E49}"/>
               </a:ext>
             </a:extLst>
           </p:cNvPr>
@@ -7473,7 +7544,7 @@
           <p:nvPr/>
         </p:nvPicPr>
         <p:blipFill>
-          <a:blip xmlns:r="http://schemas.openxmlformats.org/officeDocument/2006/relationships" xmlns:a="http://schemas.openxmlformats.org/drawingml/2006/main" r:embed="R3033347cc16d4fca"/>
+          <a:blip xmlns:r="http://schemas.openxmlformats.org/officeDocument/2006/relationships" xmlns:a="http://schemas.openxmlformats.org/drawingml/2006/main" r:embed="Re426826936864a3d"/>
           <a:stretch xmlns:a="http://schemas.openxmlformats.org/drawingml/2006/main"/>
         </p:blipFill>
         <p:spPr>
@@ -7491,7 +7562,7 @@
           <p:cNvPr id="11" name="">
             <a:extLst xmlns:a="http://schemas.openxmlformats.org/drawingml/2006/main">
               <a:ext uri="{FF2B5EF4-FFF2-40B4-BE49-F238E27FC236}">
-                <a16:creationId xmlns:a16="http://schemas.microsoft.com/office/drawing/2014/main" id="{BF343894-5BBC-4E16-8ED0-E3CA4FF5A25A}"/>
+                <a16:creationId xmlns:a16="http://schemas.microsoft.com/office/drawing/2014/main" id="{77BFB623-6834-4414-830B-449A06292AD9}"/>
               </a:ext>
             </a:extLst>
           </p:cNvPr>
@@ -7647,7 +7718,7 @@
           <p:cNvPr id="12" name="">
             <a:extLst xmlns:a="http://schemas.openxmlformats.org/drawingml/2006/main">
               <a:ext uri="{FF2B5EF4-FFF2-40B4-BE49-F238E27FC236}">
-                <a16:creationId xmlns:a16="http://schemas.microsoft.com/office/drawing/2014/main" id="{B8A0FD78-9153-4821-8001-B239EABB5171}"/>
+                <a16:creationId xmlns:a16="http://schemas.microsoft.com/office/drawing/2014/main" id="{9D588D0E-F368-4F26-BB15-FC6F1E1E0AC9}"/>
               </a:ext>
             </a:extLst>
           </p:cNvPr>
@@ -7803,7 +7874,7 @@
           <p:cNvPr id="13" name="">
             <a:extLst xmlns:a="http://schemas.openxmlformats.org/drawingml/2006/main">
               <a:ext uri="{FF2B5EF4-FFF2-40B4-BE49-F238E27FC236}">
-                <a16:creationId xmlns:a16="http://schemas.microsoft.com/office/drawing/2014/main" id="{D85C4245-FDB3-4ABA-A5AE-A9D7854B967F}"/>
+                <a16:creationId xmlns:a16="http://schemas.microsoft.com/office/drawing/2014/main" id="{C62C6CC3-4058-412B-9FB6-90BFB67B25EA}"/>
               </a:ext>
             </a:extLst>
           </p:cNvPr>
@@ -7957,7 +8028,7 @@
     </p:spTree>
     <p:extLst>
       <p:ext uri="{BB962C8B-B14F-4D97-AF65-F5344CB8AC3E}">
-        <p14:creationId xmlns:p14="http://schemas.microsoft.com/office/powerpoint/2010/main" val="504698080"/>
+        <p14:creationId xmlns:p14="http://schemas.microsoft.com/office/powerpoint/2010/main" val="1416161168"/>
       </p:ext>
     </p:extLst>
   </p:cSld>
@@ -7985,10 +8056,10 @@
       </p:grpSpPr>
       <p:sp>
         <p:nvSpPr>
-          <p:cNvPr id="15" name="">
+          <p:cNvPr id="16" name="">
             <a:extLst xmlns:a="http://schemas.openxmlformats.org/drawingml/2006/main">
               <a:ext uri="{FF2B5EF4-FFF2-40B4-BE49-F238E27FC236}">
-                <a16:creationId xmlns:a16="http://schemas.microsoft.com/office/drawing/2014/main" id="{DC0D66E1-2894-4163-A2CF-07D7481DE4A1}"/>
+                <a16:creationId xmlns:a16="http://schemas.microsoft.com/office/drawing/2014/main" id="{B32FFFC0-28C9-479D-977C-655ABA0C6008}"/>
               </a:ext>
             </a:extLst>
           </p:cNvPr>
@@ -8134,7 +8205,7 @@
                 <a:ea typeface="Arial"/>
                 <a:cs typeface="Arial"/>
               </a:rPr>
-              <a:t>Appendix / The hypothesis and its limits</a:t>
+              <a:t>4 / Supporting research</a:t>
             </a:r>
           </a:p>
         </p:txBody>
@@ -8144,7 +8215,7 @@
           <p:cNvPr id="2" name="">
             <a:extLst xmlns:a="http://schemas.openxmlformats.org/drawingml/2006/main">
               <a:ext uri="{FF2B5EF4-FFF2-40B4-BE49-F238E27FC236}">
-                <a16:creationId xmlns:a16="http://schemas.microsoft.com/office/drawing/2014/main" id="{903560ED-3898-4CD6-B97A-0AB0B165ACE9}"/>
+                <a16:creationId xmlns:a16="http://schemas.microsoft.com/office/drawing/2014/main" id="{4DE859E5-E6F4-43CD-9FAD-2048706DFB45}"/>
               </a:ext>
             </a:extLst>
           </p:cNvPr>
@@ -8156,7 +8227,7 @@
         <p:spPr>
           <a:xfrm xmlns:a="http://schemas.openxmlformats.org/drawingml/2006/main">
             <a:off x="590550" y="742950"/>
-            <a:ext cx="10953750" cy="990600"/>
+            <a:ext cx="10953750" cy="495300"/>
           </a:xfrm>
           <a:prstGeom xmlns:a="http://schemas.openxmlformats.org/drawingml/2006/main" prst="rect">
             <a:avLst/>
@@ -8290,7 +8361,7 @@
                 <a:ea typeface="Arial"/>
                 <a:cs typeface="Arial"/>
               </a:rPr>
-              <a:t>Why this is worth testing</a:t>
+              <a:t>APPENDIX</a:t>
             </a:r>
           </a:p>
         </p:txBody>
@@ -8300,7 +8371,7 @@
           <p:cNvPr id="3" name="">
             <a:extLst xmlns:a="http://schemas.openxmlformats.org/drawingml/2006/main">
               <a:ext uri="{FF2B5EF4-FFF2-40B4-BE49-F238E27FC236}">
-                <a16:creationId xmlns:a16="http://schemas.microsoft.com/office/drawing/2014/main" id="{954B3CC2-6E2A-4117-A03F-3E121467B388}"/>
+                <a16:creationId xmlns:a16="http://schemas.microsoft.com/office/drawing/2014/main" id="{B229B553-F2B1-4A47-8A4B-B68444BA020E}"/>
               </a:ext>
             </a:extLst>
           </p:cNvPr>
@@ -8456,7 +8527,7 @@
           <p:cNvPr id="4" name="">
             <a:extLst xmlns:a="http://schemas.openxmlformats.org/drawingml/2006/main">
               <a:ext uri="{FF2B5EF4-FFF2-40B4-BE49-F238E27FC236}">
-                <a16:creationId xmlns:a16="http://schemas.microsoft.com/office/drawing/2014/main" id="{EB1AE06C-95BD-4DDE-A836-027426BC65E7}"/>
+                <a16:creationId xmlns:a16="http://schemas.microsoft.com/office/drawing/2014/main" id="{9B035657-F314-4DCE-811B-E1E173351207}"/>
               </a:ext>
             </a:extLst>
           </p:cNvPr>
@@ -8612,7 +8683,7 @@
           <p:cNvPr id="5" name="">
             <a:extLst xmlns:a="http://schemas.openxmlformats.org/drawingml/2006/main">
               <a:ext uri="{FF2B5EF4-FFF2-40B4-BE49-F238E27FC236}">
-                <a16:creationId xmlns:a16="http://schemas.microsoft.com/office/drawing/2014/main" id="{8971008B-31B6-404E-B52E-57A351C126E7}"/>
+                <a16:creationId xmlns:a16="http://schemas.microsoft.com/office/drawing/2014/main" id="{4ADAB177-3831-4C8A-850F-8DAB4C5CC646}"/>
               </a:ext>
             </a:extLst>
           </p:cNvPr>
@@ -8768,7 +8839,7 @@
           <p:cNvPr id="6" name="">
             <a:extLst xmlns:a="http://schemas.openxmlformats.org/drawingml/2006/main">
               <a:ext uri="{FF2B5EF4-FFF2-40B4-BE49-F238E27FC236}">
-                <a16:creationId xmlns:a16="http://schemas.microsoft.com/office/drawing/2014/main" id="{20E1E8FB-E915-4D73-B146-15AC10F1BD40}"/>
+                <a16:creationId xmlns:a16="http://schemas.microsoft.com/office/drawing/2014/main" id="{56900482-D6E2-42E6-999F-F98CA1E02D7C}"/>
               </a:ext>
             </a:extLst>
           </p:cNvPr>
@@ -8924,7 +8995,7 @@
           <p:cNvPr id="7" name="">
             <a:extLst xmlns:a="http://schemas.openxmlformats.org/drawingml/2006/main">
               <a:ext uri="{FF2B5EF4-FFF2-40B4-BE49-F238E27FC236}">
-                <a16:creationId xmlns:a16="http://schemas.microsoft.com/office/drawing/2014/main" id="{09398D95-6266-44AB-8F62-477CF2573020}"/>
+                <a16:creationId xmlns:a16="http://schemas.microsoft.com/office/drawing/2014/main" id="{BAC7592A-4BD1-4DB1-BE39-4DB717D95A06}"/>
               </a:ext>
             </a:extLst>
           </p:cNvPr>
@@ -9080,7 +9151,7 @@
           <p:cNvPr id="8" name="">
             <a:extLst xmlns:a="http://schemas.openxmlformats.org/drawingml/2006/main">
               <a:ext uri="{FF2B5EF4-FFF2-40B4-BE49-F238E27FC236}">
-                <a16:creationId xmlns:a16="http://schemas.microsoft.com/office/drawing/2014/main" id="{E778822A-400B-481D-BD0F-7DE0A0FD98EF}"/>
+                <a16:creationId xmlns:a16="http://schemas.microsoft.com/office/drawing/2014/main" id="{4608C79B-5AD5-4D9C-B527-60C32431BB42}"/>
               </a:ext>
             </a:extLst>
           </p:cNvPr>
@@ -9236,7 +9307,7 @@
           <p:cNvPr id="9" name="">
             <a:extLst xmlns:a="http://schemas.openxmlformats.org/drawingml/2006/main">
               <a:ext uri="{FF2B5EF4-FFF2-40B4-BE49-F238E27FC236}">
-                <a16:creationId xmlns:a16="http://schemas.microsoft.com/office/drawing/2014/main" id="{3D24B493-D1E9-43DB-BFB6-C79E7D23DEBB}"/>
+                <a16:creationId xmlns:a16="http://schemas.microsoft.com/office/drawing/2014/main" id="{ED5A0DEF-9C14-4CEE-99F4-6A1E0866E7B1}"/>
               </a:ext>
             </a:extLst>
           </p:cNvPr>
@@ -9392,7 +9463,7 @@
           <p:cNvPr id="10" name="">
             <a:extLst xmlns:a="http://schemas.openxmlformats.org/drawingml/2006/main">
               <a:ext uri="{FF2B5EF4-FFF2-40B4-BE49-F238E27FC236}">
-                <a16:creationId xmlns:a16="http://schemas.microsoft.com/office/drawing/2014/main" id="{BD770A91-9C86-4091-98D1-852EAC147F63}"/>
+                <a16:creationId xmlns:a16="http://schemas.microsoft.com/office/drawing/2014/main" id="{2F0D73B0-44F8-4996-B481-A2B267381511}"/>
               </a:ext>
             </a:extLst>
           </p:cNvPr>
@@ -9548,7 +9619,7 @@
           <p:cNvPr id="11" name="">
             <a:extLst xmlns:a="http://schemas.openxmlformats.org/drawingml/2006/main">
               <a:ext uri="{FF2B5EF4-FFF2-40B4-BE49-F238E27FC236}">
-                <a16:creationId xmlns:a16="http://schemas.microsoft.com/office/drawing/2014/main" id="{C93C81E8-0E2A-4BFB-8089-C899F5B84420}"/>
+                <a16:creationId xmlns:a16="http://schemas.microsoft.com/office/drawing/2014/main" id="{CB1E387C-ED3A-4861-B68D-26C04073D5DD}"/>
               </a:ext>
             </a:extLst>
           </p:cNvPr>
@@ -9704,7 +9775,7 @@
           <p:cNvPr id="12" name="">
             <a:extLst xmlns:a="http://schemas.openxmlformats.org/drawingml/2006/main">
               <a:ext uri="{FF2B5EF4-FFF2-40B4-BE49-F238E27FC236}">
-                <a16:creationId xmlns:a16="http://schemas.microsoft.com/office/drawing/2014/main" id="{C12F5217-13E9-4FDF-8C77-353288EA0BD5}"/>
+                <a16:creationId xmlns:a16="http://schemas.microsoft.com/office/drawing/2014/main" id="{DAE3EB1B-B9B1-42B6-B71E-6BF6346484FC}"/>
               </a:ext>
             </a:extLst>
           </p:cNvPr>
@@ -9849,7 +9920,7 @@
                 <a:latin typeface="Arial"/>
                 <a:ea typeface="Arial"/>
                 <a:cs typeface="Arial"/>
-                <a:hlinkClick xmlns:r="http://schemas.openxmlformats.org/officeDocument/2006/relationships" r:id="Rd1404d81be3042db"/>
+                <a:hlinkClick xmlns:r="http://schemas.openxmlformats.org/officeDocument/2006/relationships" r:id="Rd914416d44194551"/>
               </a:rPr>
               <a:t>Android study: Haverkamp et al.</a:t>
             </a:r>
@@ -9861,7 +9932,7 @@
           <p:cNvPr id="13" name="">
             <a:extLst xmlns:a="http://schemas.openxmlformats.org/drawingml/2006/main">
               <a:ext uri="{FF2B5EF4-FFF2-40B4-BE49-F238E27FC236}">
-                <a16:creationId xmlns:a16="http://schemas.microsoft.com/office/drawing/2014/main" id="{8A27ADA4-D8C7-4AE9-B4FC-9AB56B9FA123}"/>
+                <a16:creationId xmlns:a16="http://schemas.microsoft.com/office/drawing/2014/main" id="{CD9B96E2-3745-40CC-BDA6-D676A78231F4}"/>
               </a:ext>
             </a:extLst>
           </p:cNvPr>
@@ -10006,7 +10077,7 @@
                 <a:latin typeface="Arial"/>
                 <a:ea typeface="Arial"/>
                 <a:cs typeface="Arial"/>
-                <a:hlinkClick xmlns:r="http://schemas.openxmlformats.org/officeDocument/2006/relationships" r:id="R6a443726235e4512"/>
+                <a:hlinkClick xmlns:r="http://schemas.openxmlformats.org/officeDocument/2006/relationships" r:id="R2821b02bea844afa"/>
               </a:rPr>
               <a:t>Choice study: Iyengar &amp; Kamenica</a:t>
             </a:r>
@@ -10018,7 +10089,7 @@
           <p:cNvPr id="14" name="">
             <a:extLst xmlns:a="http://schemas.openxmlformats.org/drawingml/2006/main">
               <a:ext uri="{FF2B5EF4-FFF2-40B4-BE49-F238E27FC236}">
-                <a16:creationId xmlns:a16="http://schemas.microsoft.com/office/drawing/2014/main" id="{49DB28A7-BA35-4EEE-A861-4A2D7B55F88F}"/>
+                <a16:creationId xmlns:a16="http://schemas.microsoft.com/office/drawing/2014/main" id="{F89B1ED2-8AC4-4F73-9338-A18F58A0BD22}"/>
               </a:ext>
             </a:extLst>
           </p:cNvPr>
@@ -10163,9 +10234,165 @@
                 <a:latin typeface="Arial"/>
                 <a:ea typeface="Arial"/>
                 <a:cs typeface="Arial"/>
-                <a:hlinkClick xmlns:r="http://schemas.openxmlformats.org/officeDocument/2006/relationships" r:id="R9abb59e398e94d12"/>
+                <a:hlinkClick xmlns:r="http://schemas.openxmlformats.org/officeDocument/2006/relationships" r:id="Raf688461b3814b27"/>
               </a:rPr>
               <a:t>Motion controls: W3C guidance</a:t>
+            </a:r>
+          </a:p>
+        </p:txBody>
+      </p:sp>
+      <p:sp>
+        <p:nvSpPr>
+          <p:cNvPr id="15" name="">
+            <a:extLst xmlns:a="http://schemas.openxmlformats.org/drawingml/2006/main">
+              <a:ext uri="{FF2B5EF4-FFF2-40B4-BE49-F238E27FC236}">
+                <a16:creationId xmlns:a16="http://schemas.microsoft.com/office/drawing/2014/main" id="{5667CCC5-9FC2-4176-B47F-559F2BC793CE}"/>
+              </a:ext>
+            </a:extLst>
+          </p:cNvPr>
+          <p:cNvSpPr>
+            <a:spLocks xmlns:a="http://schemas.openxmlformats.org/drawingml/2006/main" noGrp="1"/>
+          </p:cNvSpPr>
+          <p:nvPr/>
+        </p:nvSpPr>
+        <p:spPr>
+          <a:xfrm xmlns:a="http://schemas.openxmlformats.org/drawingml/2006/main">
+            <a:off x="590550" y="1323975"/>
+            <a:ext cx="10477500" cy="285750"/>
+          </a:xfrm>
+          <a:prstGeom xmlns:a="http://schemas.openxmlformats.org/drawingml/2006/main" prst="rect">
+            <a:avLst/>
+          </a:prstGeom>
+          <a:noFill xmlns:a="http://schemas.openxmlformats.org/drawingml/2006/main"/>
+          <a:ln xmlns:a="http://schemas.openxmlformats.org/drawingml/2006/main" w="0">
+            <a:noFill/>
+          </a:ln>
+        </p:spPr>
+        <p:txBody>
+          <a:bodyPr xmlns:a="http://schemas.openxmlformats.org/drawingml/2006/main"/>
+          <a:lstStyle xmlns:a="http://schemas.openxmlformats.org/drawingml/2006/main">
+            <a:defPPr>
+              <a:defRPr sz="1800" b="1">
+                <a:solidFill>
+                  <a:srgbClr val="28369F"/>
+                </a:solidFill>
+                <a:latin typeface="Arial"/>
+                <a:ea typeface="Arial"/>
+                <a:cs typeface="Arial"/>
+              </a:defRPr>
+            </a:defPPr>
+            <a:lvl1pPr>
+              <a:defRPr sz="1800" b="1">
+                <a:solidFill>
+                  <a:srgbClr val="28369F"/>
+                </a:solidFill>
+                <a:latin typeface="Arial"/>
+                <a:ea typeface="Arial"/>
+                <a:cs typeface="Arial"/>
+              </a:defRPr>
+            </a:lvl1pPr>
+            <a:lvl2pPr>
+              <a:defRPr sz="1800" b="1">
+                <a:solidFill>
+                  <a:srgbClr val="28369F"/>
+                </a:solidFill>
+                <a:latin typeface="Arial"/>
+                <a:ea typeface="Arial"/>
+                <a:cs typeface="Arial"/>
+              </a:defRPr>
+            </a:lvl2pPr>
+            <a:lvl3pPr>
+              <a:defRPr sz="1800" b="1">
+                <a:solidFill>
+                  <a:srgbClr val="28369F"/>
+                </a:solidFill>
+                <a:latin typeface="Arial"/>
+                <a:ea typeface="Arial"/>
+                <a:cs typeface="Arial"/>
+              </a:defRPr>
+            </a:lvl3pPr>
+            <a:lvl4pPr>
+              <a:defRPr sz="1800" b="1">
+                <a:solidFill>
+                  <a:srgbClr val="28369F"/>
+                </a:solidFill>
+                <a:latin typeface="Arial"/>
+                <a:ea typeface="Arial"/>
+                <a:cs typeface="Arial"/>
+              </a:defRPr>
+            </a:lvl4pPr>
+            <a:lvl5pPr>
+              <a:defRPr sz="1800" b="1">
+                <a:solidFill>
+                  <a:srgbClr val="28369F"/>
+                </a:solidFill>
+                <a:latin typeface="Arial"/>
+                <a:ea typeface="Arial"/>
+                <a:cs typeface="Arial"/>
+              </a:defRPr>
+            </a:lvl5pPr>
+            <a:lvl6pPr>
+              <a:defRPr sz="1800" b="1">
+                <a:solidFill>
+                  <a:srgbClr val="28369F"/>
+                </a:solidFill>
+                <a:latin typeface="Arial"/>
+                <a:ea typeface="Arial"/>
+                <a:cs typeface="Arial"/>
+              </a:defRPr>
+            </a:lvl6pPr>
+            <a:lvl7pPr>
+              <a:defRPr sz="1800" b="1">
+                <a:solidFill>
+                  <a:srgbClr val="28369F"/>
+                </a:solidFill>
+                <a:latin typeface="Arial"/>
+                <a:ea typeface="Arial"/>
+                <a:cs typeface="Arial"/>
+              </a:defRPr>
+            </a:lvl7pPr>
+            <a:lvl8pPr>
+              <a:defRPr sz="1800" b="1">
+                <a:solidFill>
+                  <a:srgbClr val="28369F"/>
+                </a:solidFill>
+                <a:latin typeface="Arial"/>
+                <a:ea typeface="Arial"/>
+                <a:cs typeface="Arial"/>
+              </a:defRPr>
+            </a:lvl8pPr>
+            <a:lvl9pPr>
+              <a:defRPr sz="1800" b="1">
+                <a:solidFill>
+                  <a:srgbClr val="28369F"/>
+                </a:solidFill>
+                <a:latin typeface="Arial"/>
+                <a:ea typeface="Arial"/>
+                <a:cs typeface="Arial"/>
+              </a:defRPr>
+            </a:lvl9pPr>
+          </a:lstStyle>
+          <a:p xmlns:a="http://schemas.openxmlformats.org/drawingml/2006/main">
+            <a:pPr>
+              <a:defRPr sz="1800" b="1">
+                <a:solidFill>
+                  <a:srgbClr val="28369F"/>
+                </a:solidFill>
+                <a:latin typeface="Arial"/>
+                <a:ea typeface="Arial"/>
+                <a:cs typeface="Arial"/>
+              </a:defRPr>
+            </a:pPr>
+            <a:r>
+              <a:rPr sz="1800" b="1">
+                <a:solidFill>
+                  <a:srgbClr val="28369F"/>
+                </a:solidFill>
+                <a:latin typeface="Arial"/>
+                <a:ea typeface="Arial"/>
+                <a:cs typeface="Arial"/>
+              </a:rPr>
+              <a:t>Research and hypothesis</a:t>
             </a:r>
           </a:p>
         </p:txBody>
@@ -10173,7 +10400,1624 @@
     </p:spTree>
     <p:extLst>
       <p:ext uri="{BB962C8B-B14F-4D97-AF65-F5344CB8AC3E}">
-        <p14:creationId xmlns:p14="http://schemas.microsoft.com/office/powerpoint/2010/main" val="1874902756"/>
+        <p14:creationId xmlns:p14="http://schemas.microsoft.com/office/powerpoint/2010/main" val="874204592"/>
+      </p:ext>
+    </p:extLst>
+  </p:cSld>
+</p:sld>
+</file>
+
+<file path=ppt/slides/slide5.xml><?xml version="1.0" encoding="utf-8"?>
+<p:sld xmlns:p="http://schemas.openxmlformats.org/presentationml/2006/main">
+  <p:cSld>
+    <p:bg>
+      <p:bgPr>
+        <a:solidFill xmlns:a="http://schemas.openxmlformats.org/drawingml/2006/main">
+          <a:srgbClr val="F8F8F4"/>
+        </a:solidFill>
+      </p:bgPr>
+    </p:bg>
+    <p:spTree>
+      <p:nvGrpSpPr>
+        <p:cNvPr id="1" name=""/>
+        <p:cNvGrpSpPr/>
+        <p:nvPr/>
+      </p:nvGrpSpPr>
+      <p:grpSpPr>
+        <a:xfrm xmlns:a="http://schemas.openxmlformats.org/drawingml/2006/main"/>
+      </p:grpSpPr>
+      <p:sp>
+        <p:nvSpPr>
+          <p:cNvPr id="12" name="">
+            <a:extLst xmlns:a="http://schemas.openxmlformats.org/drawingml/2006/main">
+              <a:ext uri="{FF2B5EF4-FFF2-40B4-BE49-F238E27FC236}">
+                <a16:creationId xmlns:a16="http://schemas.microsoft.com/office/drawing/2014/main" id="{FF1E9DDF-F65C-4B9A-8B12-3CC8670B6E3D}"/>
+              </a:ext>
+            </a:extLst>
+          </p:cNvPr>
+          <p:cNvSpPr>
+            <a:spLocks xmlns:a="http://schemas.openxmlformats.org/drawingml/2006/main" noGrp="1"/>
+          </p:cNvSpPr>
+          <p:nvPr/>
+        </p:nvSpPr>
+        <p:spPr>
+          <a:xfrm xmlns:a="http://schemas.openxmlformats.org/drawingml/2006/main">
+            <a:off x="590550" y="276225"/>
+            <a:ext cx="10858500" cy="219075"/>
+          </a:xfrm>
+          <a:prstGeom xmlns:a="http://schemas.openxmlformats.org/drawingml/2006/main" prst="rect">
+            <a:avLst/>
+          </a:prstGeom>
+          <a:noFill xmlns:a="http://schemas.openxmlformats.org/drawingml/2006/main"/>
+          <a:ln xmlns:a="http://schemas.openxmlformats.org/drawingml/2006/main" w="0">
+            <a:noFill/>
+          </a:ln>
+        </p:spPr>
+        <p:txBody>
+          <a:bodyPr xmlns:a="http://schemas.openxmlformats.org/drawingml/2006/main"/>
+          <a:lstStyle xmlns:a="http://schemas.openxmlformats.org/drawingml/2006/main">
+            <a:defPPr>
+              <a:defRPr sz="975" b="1">
+                <a:solidFill>
+                  <a:srgbClr val="28369F"/>
+                </a:solidFill>
+                <a:latin typeface="Arial"/>
+                <a:ea typeface="Arial"/>
+                <a:cs typeface="Arial"/>
+              </a:defRPr>
+            </a:defPPr>
+            <a:lvl1pPr>
+              <a:defRPr sz="975" b="1">
+                <a:solidFill>
+                  <a:srgbClr val="28369F"/>
+                </a:solidFill>
+                <a:latin typeface="Arial"/>
+                <a:ea typeface="Arial"/>
+                <a:cs typeface="Arial"/>
+              </a:defRPr>
+            </a:lvl1pPr>
+            <a:lvl2pPr>
+              <a:defRPr sz="975" b="1">
+                <a:solidFill>
+                  <a:srgbClr val="28369F"/>
+                </a:solidFill>
+                <a:latin typeface="Arial"/>
+                <a:ea typeface="Arial"/>
+                <a:cs typeface="Arial"/>
+              </a:defRPr>
+            </a:lvl2pPr>
+            <a:lvl3pPr>
+              <a:defRPr sz="975" b="1">
+                <a:solidFill>
+                  <a:srgbClr val="28369F"/>
+                </a:solidFill>
+                <a:latin typeface="Arial"/>
+                <a:ea typeface="Arial"/>
+                <a:cs typeface="Arial"/>
+              </a:defRPr>
+            </a:lvl3pPr>
+            <a:lvl4pPr>
+              <a:defRPr sz="975" b="1">
+                <a:solidFill>
+                  <a:srgbClr val="28369F"/>
+                </a:solidFill>
+                <a:latin typeface="Arial"/>
+                <a:ea typeface="Arial"/>
+                <a:cs typeface="Arial"/>
+              </a:defRPr>
+            </a:lvl4pPr>
+            <a:lvl5pPr>
+              <a:defRPr sz="975" b="1">
+                <a:solidFill>
+                  <a:srgbClr val="28369F"/>
+                </a:solidFill>
+                <a:latin typeface="Arial"/>
+                <a:ea typeface="Arial"/>
+                <a:cs typeface="Arial"/>
+              </a:defRPr>
+            </a:lvl5pPr>
+            <a:lvl6pPr>
+              <a:defRPr sz="975" b="1">
+                <a:solidFill>
+                  <a:srgbClr val="28369F"/>
+                </a:solidFill>
+                <a:latin typeface="Arial"/>
+                <a:ea typeface="Arial"/>
+                <a:cs typeface="Arial"/>
+              </a:defRPr>
+            </a:lvl6pPr>
+            <a:lvl7pPr>
+              <a:defRPr sz="975" b="1">
+                <a:solidFill>
+                  <a:srgbClr val="28369F"/>
+                </a:solidFill>
+                <a:latin typeface="Arial"/>
+                <a:ea typeface="Arial"/>
+                <a:cs typeface="Arial"/>
+              </a:defRPr>
+            </a:lvl7pPr>
+            <a:lvl8pPr>
+              <a:defRPr sz="975" b="1">
+                <a:solidFill>
+                  <a:srgbClr val="28369F"/>
+                </a:solidFill>
+                <a:latin typeface="Arial"/>
+                <a:ea typeface="Arial"/>
+                <a:cs typeface="Arial"/>
+              </a:defRPr>
+            </a:lvl8pPr>
+            <a:lvl9pPr>
+              <a:defRPr sz="975" b="1">
+                <a:solidFill>
+                  <a:srgbClr val="28369F"/>
+                </a:solidFill>
+                <a:latin typeface="Arial"/>
+                <a:ea typeface="Arial"/>
+                <a:cs typeface="Arial"/>
+              </a:defRPr>
+            </a:lvl9pPr>
+          </a:lstStyle>
+          <a:p xmlns:a="http://schemas.openxmlformats.org/drawingml/2006/main">
+            <a:pPr>
+              <a:defRPr sz="975" b="1">
+                <a:solidFill>
+                  <a:srgbClr val="28369F"/>
+                </a:solidFill>
+                <a:latin typeface="Arial"/>
+                <a:ea typeface="Arial"/>
+                <a:cs typeface="Arial"/>
+              </a:defRPr>
+            </a:pPr>
+            <a:r>
+              <a:rPr sz="975" b="1">
+                <a:solidFill>
+                  <a:srgbClr val="28369F"/>
+                </a:solidFill>
+                <a:latin typeface="Arial"/>
+                <a:ea typeface="Arial"/>
+                <a:cs typeface="Arial"/>
+              </a:rPr>
+              <a:t>5 / Motion and navigation</a:t>
+            </a:r>
+          </a:p>
+        </p:txBody>
+      </p:sp>
+      <p:sp>
+        <p:nvSpPr>
+          <p:cNvPr id="2" name="">
+            <a:extLst xmlns:a="http://schemas.openxmlformats.org/drawingml/2006/main">
+              <a:ext uri="{FF2B5EF4-FFF2-40B4-BE49-F238E27FC236}">
+                <a16:creationId xmlns:a16="http://schemas.microsoft.com/office/drawing/2014/main" id="{36B3F73C-06C9-4CAD-8CF6-917098FEA7C6}"/>
+              </a:ext>
+            </a:extLst>
+          </p:cNvPr>
+          <p:cNvSpPr>
+            <a:spLocks xmlns:a="http://schemas.openxmlformats.org/drawingml/2006/main" noGrp="1"/>
+          </p:cNvSpPr>
+          <p:nvPr/>
+        </p:nvSpPr>
+        <p:spPr>
+          <a:xfrm xmlns:a="http://schemas.openxmlformats.org/drawingml/2006/main">
+            <a:off x="590550" y="742950"/>
+            <a:ext cx="10858500" cy="495300"/>
+          </a:xfrm>
+          <a:prstGeom xmlns:a="http://schemas.openxmlformats.org/drawingml/2006/main" prst="rect">
+            <a:avLst/>
+          </a:prstGeom>
+          <a:noFill xmlns:a="http://schemas.openxmlformats.org/drawingml/2006/main"/>
+          <a:ln xmlns:a="http://schemas.openxmlformats.org/drawingml/2006/main" w="0">
+            <a:noFill/>
+          </a:ln>
+        </p:spPr>
+        <p:txBody>
+          <a:bodyPr xmlns:a="http://schemas.openxmlformats.org/drawingml/2006/main"/>
+          <a:lstStyle xmlns:a="http://schemas.openxmlformats.org/drawingml/2006/main">
+            <a:defPPr>
+              <a:defRPr sz="2850" b="1">
+                <a:solidFill>
+                  <a:srgbClr val="17263E"/>
+                </a:solidFill>
+                <a:latin typeface="Arial"/>
+                <a:ea typeface="Arial"/>
+                <a:cs typeface="Arial"/>
+              </a:defRPr>
+            </a:defPPr>
+            <a:lvl1pPr>
+              <a:defRPr sz="2850" b="1">
+                <a:solidFill>
+                  <a:srgbClr val="17263E"/>
+                </a:solidFill>
+                <a:latin typeface="Arial"/>
+                <a:ea typeface="Arial"/>
+                <a:cs typeface="Arial"/>
+              </a:defRPr>
+            </a:lvl1pPr>
+            <a:lvl2pPr>
+              <a:defRPr sz="2850" b="1">
+                <a:solidFill>
+                  <a:srgbClr val="17263E"/>
+                </a:solidFill>
+                <a:latin typeface="Arial"/>
+                <a:ea typeface="Arial"/>
+                <a:cs typeface="Arial"/>
+              </a:defRPr>
+            </a:lvl2pPr>
+            <a:lvl3pPr>
+              <a:defRPr sz="2850" b="1">
+                <a:solidFill>
+                  <a:srgbClr val="17263E"/>
+                </a:solidFill>
+                <a:latin typeface="Arial"/>
+                <a:ea typeface="Arial"/>
+                <a:cs typeface="Arial"/>
+              </a:defRPr>
+            </a:lvl3pPr>
+            <a:lvl4pPr>
+              <a:defRPr sz="2850" b="1">
+                <a:solidFill>
+                  <a:srgbClr val="17263E"/>
+                </a:solidFill>
+                <a:latin typeface="Arial"/>
+                <a:ea typeface="Arial"/>
+                <a:cs typeface="Arial"/>
+              </a:defRPr>
+            </a:lvl4pPr>
+            <a:lvl5pPr>
+              <a:defRPr sz="2850" b="1">
+                <a:solidFill>
+                  <a:srgbClr val="17263E"/>
+                </a:solidFill>
+                <a:latin typeface="Arial"/>
+                <a:ea typeface="Arial"/>
+                <a:cs typeface="Arial"/>
+              </a:defRPr>
+            </a:lvl5pPr>
+            <a:lvl6pPr>
+              <a:defRPr sz="2850" b="1">
+                <a:solidFill>
+                  <a:srgbClr val="17263E"/>
+                </a:solidFill>
+                <a:latin typeface="Arial"/>
+                <a:ea typeface="Arial"/>
+                <a:cs typeface="Arial"/>
+              </a:defRPr>
+            </a:lvl6pPr>
+            <a:lvl7pPr>
+              <a:defRPr sz="2850" b="1">
+                <a:solidFill>
+                  <a:srgbClr val="17263E"/>
+                </a:solidFill>
+                <a:latin typeface="Arial"/>
+                <a:ea typeface="Arial"/>
+                <a:cs typeface="Arial"/>
+              </a:defRPr>
+            </a:lvl7pPr>
+            <a:lvl8pPr>
+              <a:defRPr sz="2850" b="1">
+                <a:solidFill>
+                  <a:srgbClr val="17263E"/>
+                </a:solidFill>
+                <a:latin typeface="Arial"/>
+                <a:ea typeface="Arial"/>
+                <a:cs typeface="Arial"/>
+              </a:defRPr>
+            </a:lvl8pPr>
+            <a:lvl9pPr>
+              <a:defRPr sz="2850" b="1">
+                <a:solidFill>
+                  <a:srgbClr val="17263E"/>
+                </a:solidFill>
+                <a:latin typeface="Arial"/>
+                <a:ea typeface="Arial"/>
+                <a:cs typeface="Arial"/>
+              </a:defRPr>
+            </a:lvl9pPr>
+          </a:lstStyle>
+          <a:p xmlns:a="http://schemas.openxmlformats.org/drawingml/2006/main">
+            <a:pPr>
+              <a:defRPr sz="2850" b="1">
+                <a:solidFill>
+                  <a:srgbClr val="17263E"/>
+                </a:solidFill>
+                <a:latin typeface="Arial"/>
+                <a:ea typeface="Arial"/>
+                <a:cs typeface="Arial"/>
+              </a:defRPr>
+            </a:pPr>
+            <a:r>
+              <a:rPr sz="2850" b="1">
+                <a:solidFill>
+                  <a:srgbClr val="17263E"/>
+                </a:solidFill>
+                <a:latin typeface="Arial"/>
+                <a:ea typeface="Arial"/>
+                <a:cs typeface="Arial"/>
+              </a:rPr>
+              <a:t>APPENDIX</a:t>
+            </a:r>
+          </a:p>
+        </p:txBody>
+      </p:sp>
+      <p:sp>
+        <p:nvSpPr>
+          <p:cNvPr id="3" name="">
+            <a:extLst xmlns:a="http://schemas.openxmlformats.org/drawingml/2006/main">
+              <a:ext uri="{FF2B5EF4-FFF2-40B4-BE49-F238E27FC236}">
+                <a16:creationId xmlns:a16="http://schemas.microsoft.com/office/drawing/2014/main" id="{C344ACAB-120F-41E3-94AD-36DF78483C19}"/>
+              </a:ext>
+            </a:extLst>
+          </p:cNvPr>
+          <p:cNvSpPr>
+            <a:spLocks xmlns:a="http://schemas.openxmlformats.org/drawingml/2006/main" noGrp="1"/>
+          </p:cNvSpPr>
+          <p:nvPr/>
+        </p:nvSpPr>
+        <p:spPr>
+          <a:xfrm xmlns:a="http://schemas.openxmlformats.org/drawingml/2006/main">
+            <a:off x="590550" y="1323975"/>
+            <a:ext cx="10858500" cy="323850"/>
+          </a:xfrm>
+          <a:prstGeom xmlns:a="http://schemas.openxmlformats.org/drawingml/2006/main" prst="rect">
+            <a:avLst/>
+          </a:prstGeom>
+          <a:noFill xmlns:a="http://schemas.openxmlformats.org/drawingml/2006/main"/>
+          <a:ln xmlns:a="http://schemas.openxmlformats.org/drawingml/2006/main" w="0">
+            <a:noFill/>
+          </a:ln>
+        </p:spPr>
+        <p:txBody>
+          <a:bodyPr xmlns:a="http://schemas.openxmlformats.org/drawingml/2006/main"/>
+          <a:lstStyle xmlns:a="http://schemas.openxmlformats.org/drawingml/2006/main">
+            <a:defPPr>
+              <a:defRPr sz="1800" b="1">
+                <a:solidFill>
+                  <a:srgbClr val="28369F"/>
+                </a:solidFill>
+                <a:latin typeface="Arial"/>
+                <a:ea typeface="Arial"/>
+                <a:cs typeface="Arial"/>
+              </a:defRPr>
+            </a:defPPr>
+            <a:lvl1pPr>
+              <a:defRPr sz="1800" b="1">
+                <a:solidFill>
+                  <a:srgbClr val="28369F"/>
+                </a:solidFill>
+                <a:latin typeface="Arial"/>
+                <a:ea typeface="Arial"/>
+                <a:cs typeface="Arial"/>
+              </a:defRPr>
+            </a:lvl1pPr>
+            <a:lvl2pPr>
+              <a:defRPr sz="1800" b="1">
+                <a:solidFill>
+                  <a:srgbClr val="28369F"/>
+                </a:solidFill>
+                <a:latin typeface="Arial"/>
+                <a:ea typeface="Arial"/>
+                <a:cs typeface="Arial"/>
+              </a:defRPr>
+            </a:lvl2pPr>
+            <a:lvl3pPr>
+              <a:defRPr sz="1800" b="1">
+                <a:solidFill>
+                  <a:srgbClr val="28369F"/>
+                </a:solidFill>
+                <a:latin typeface="Arial"/>
+                <a:ea typeface="Arial"/>
+                <a:cs typeface="Arial"/>
+              </a:defRPr>
+            </a:lvl3pPr>
+            <a:lvl4pPr>
+              <a:defRPr sz="1800" b="1">
+                <a:solidFill>
+                  <a:srgbClr val="28369F"/>
+                </a:solidFill>
+                <a:latin typeface="Arial"/>
+                <a:ea typeface="Arial"/>
+                <a:cs typeface="Arial"/>
+              </a:defRPr>
+            </a:lvl4pPr>
+            <a:lvl5pPr>
+              <a:defRPr sz="1800" b="1">
+                <a:solidFill>
+                  <a:srgbClr val="28369F"/>
+                </a:solidFill>
+                <a:latin typeface="Arial"/>
+                <a:ea typeface="Arial"/>
+                <a:cs typeface="Arial"/>
+              </a:defRPr>
+            </a:lvl5pPr>
+            <a:lvl6pPr>
+              <a:defRPr sz="1800" b="1">
+                <a:solidFill>
+                  <a:srgbClr val="28369F"/>
+                </a:solidFill>
+                <a:latin typeface="Arial"/>
+                <a:ea typeface="Arial"/>
+                <a:cs typeface="Arial"/>
+              </a:defRPr>
+            </a:lvl6pPr>
+            <a:lvl7pPr>
+              <a:defRPr sz="1800" b="1">
+                <a:solidFill>
+                  <a:srgbClr val="28369F"/>
+                </a:solidFill>
+                <a:latin typeface="Arial"/>
+                <a:ea typeface="Arial"/>
+                <a:cs typeface="Arial"/>
+              </a:defRPr>
+            </a:lvl7pPr>
+            <a:lvl8pPr>
+              <a:defRPr sz="1800" b="1">
+                <a:solidFill>
+                  <a:srgbClr val="28369F"/>
+                </a:solidFill>
+                <a:latin typeface="Arial"/>
+                <a:ea typeface="Arial"/>
+                <a:cs typeface="Arial"/>
+              </a:defRPr>
+            </a:lvl8pPr>
+            <a:lvl9pPr>
+              <a:defRPr sz="1800" b="1">
+                <a:solidFill>
+                  <a:srgbClr val="28369F"/>
+                </a:solidFill>
+                <a:latin typeface="Arial"/>
+                <a:ea typeface="Arial"/>
+                <a:cs typeface="Arial"/>
+              </a:defRPr>
+            </a:lvl9pPr>
+          </a:lstStyle>
+          <a:p xmlns:a="http://schemas.openxmlformats.org/drawingml/2006/main">
+            <a:pPr>
+              <a:defRPr sz="1800" b="1">
+                <a:solidFill>
+                  <a:srgbClr val="28369F"/>
+                </a:solidFill>
+                <a:latin typeface="Arial"/>
+                <a:ea typeface="Arial"/>
+                <a:cs typeface="Arial"/>
+              </a:defRPr>
+            </a:pPr>
+            <a:r>
+              <a:rPr sz="1800" b="1">
+                <a:solidFill>
+                  <a:srgbClr val="28369F"/>
+                </a:solidFill>
+                <a:latin typeface="Arial"/>
+                <a:ea typeface="Arial"/>
+                <a:cs typeface="Arial"/>
+              </a:rPr>
+              <a:t>Give each section a clear beginning and end.</a:t>
+            </a:r>
+          </a:p>
+        </p:txBody>
+      </p:sp>
+      <p:sp>
+        <p:nvSpPr>
+          <p:cNvPr id="4" name="">
+            <a:extLst xmlns:a="http://schemas.openxmlformats.org/drawingml/2006/main">
+              <a:ext uri="{FF2B5EF4-FFF2-40B4-BE49-F238E27FC236}">
+                <a16:creationId xmlns:a16="http://schemas.microsoft.com/office/drawing/2014/main" id="{6F1703EA-A213-47C6-AAB7-2604E0F35B44}"/>
+              </a:ext>
+            </a:extLst>
+          </p:cNvPr>
+          <p:cNvSpPr>
+            <a:spLocks xmlns:a="http://schemas.openxmlformats.org/drawingml/2006/main" noGrp="1"/>
+          </p:cNvSpPr>
+          <p:nvPr/>
+        </p:nvSpPr>
+        <p:spPr>
+          <a:xfrm xmlns:a="http://schemas.openxmlformats.org/drawingml/2006/main">
+            <a:off x="590550" y="2028825"/>
+            <a:ext cx="6143625" cy="285750"/>
+          </a:xfrm>
+          <a:prstGeom xmlns:a="http://schemas.openxmlformats.org/drawingml/2006/main" prst="rect">
+            <a:avLst/>
+          </a:prstGeom>
+          <a:noFill xmlns:a="http://schemas.openxmlformats.org/drawingml/2006/main"/>
+          <a:ln xmlns:a="http://schemas.openxmlformats.org/drawingml/2006/main" w="0">
+            <a:noFill/>
+          </a:ln>
+        </p:spPr>
+        <p:txBody>
+          <a:bodyPr xmlns:a="http://schemas.openxmlformats.org/drawingml/2006/main"/>
+          <a:lstStyle xmlns:a="http://schemas.openxmlformats.org/drawingml/2006/main">
+            <a:defPPr>
+              <a:defRPr sz="1725" b="1">
+                <a:solidFill>
+                  <a:srgbClr val="28369F"/>
+                </a:solidFill>
+                <a:latin typeface="Arial"/>
+                <a:ea typeface="Arial"/>
+                <a:cs typeface="Arial"/>
+              </a:defRPr>
+            </a:defPPr>
+            <a:lvl1pPr>
+              <a:defRPr sz="1725" b="1">
+                <a:solidFill>
+                  <a:srgbClr val="28369F"/>
+                </a:solidFill>
+                <a:latin typeface="Arial"/>
+                <a:ea typeface="Arial"/>
+                <a:cs typeface="Arial"/>
+              </a:defRPr>
+            </a:lvl1pPr>
+            <a:lvl2pPr>
+              <a:defRPr sz="1725" b="1">
+                <a:solidFill>
+                  <a:srgbClr val="28369F"/>
+                </a:solidFill>
+                <a:latin typeface="Arial"/>
+                <a:ea typeface="Arial"/>
+                <a:cs typeface="Arial"/>
+              </a:defRPr>
+            </a:lvl2pPr>
+            <a:lvl3pPr>
+              <a:defRPr sz="1725" b="1">
+                <a:solidFill>
+                  <a:srgbClr val="28369F"/>
+                </a:solidFill>
+                <a:latin typeface="Arial"/>
+                <a:ea typeface="Arial"/>
+                <a:cs typeface="Arial"/>
+              </a:defRPr>
+            </a:lvl3pPr>
+            <a:lvl4pPr>
+              <a:defRPr sz="1725" b="1">
+                <a:solidFill>
+                  <a:srgbClr val="28369F"/>
+                </a:solidFill>
+                <a:latin typeface="Arial"/>
+                <a:ea typeface="Arial"/>
+                <a:cs typeface="Arial"/>
+              </a:defRPr>
+            </a:lvl4pPr>
+            <a:lvl5pPr>
+              <a:defRPr sz="1725" b="1">
+                <a:solidFill>
+                  <a:srgbClr val="28369F"/>
+                </a:solidFill>
+                <a:latin typeface="Arial"/>
+                <a:ea typeface="Arial"/>
+                <a:cs typeface="Arial"/>
+              </a:defRPr>
+            </a:lvl5pPr>
+            <a:lvl6pPr>
+              <a:defRPr sz="1725" b="1">
+                <a:solidFill>
+                  <a:srgbClr val="28369F"/>
+                </a:solidFill>
+                <a:latin typeface="Arial"/>
+                <a:ea typeface="Arial"/>
+                <a:cs typeface="Arial"/>
+              </a:defRPr>
+            </a:lvl6pPr>
+            <a:lvl7pPr>
+              <a:defRPr sz="1725" b="1">
+                <a:solidFill>
+                  <a:srgbClr val="28369F"/>
+                </a:solidFill>
+                <a:latin typeface="Arial"/>
+                <a:ea typeface="Arial"/>
+                <a:cs typeface="Arial"/>
+              </a:defRPr>
+            </a:lvl7pPr>
+            <a:lvl8pPr>
+              <a:defRPr sz="1725" b="1">
+                <a:solidFill>
+                  <a:srgbClr val="28369F"/>
+                </a:solidFill>
+                <a:latin typeface="Arial"/>
+                <a:ea typeface="Arial"/>
+                <a:cs typeface="Arial"/>
+              </a:defRPr>
+            </a:lvl8pPr>
+            <a:lvl9pPr>
+              <a:defRPr sz="1725" b="1">
+                <a:solidFill>
+                  <a:srgbClr val="28369F"/>
+                </a:solidFill>
+                <a:latin typeface="Arial"/>
+                <a:ea typeface="Arial"/>
+                <a:cs typeface="Arial"/>
+              </a:defRPr>
+            </a:lvl9pPr>
+          </a:lstStyle>
+          <a:p xmlns:a="http://schemas.openxmlformats.org/drawingml/2006/main">
+            <a:pPr>
+              <a:defRPr sz="1725" b="1">
+                <a:solidFill>
+                  <a:srgbClr val="28369F"/>
+                </a:solidFill>
+                <a:latin typeface="Arial"/>
+                <a:ea typeface="Arial"/>
+                <a:cs typeface="Arial"/>
+              </a:defRPr>
+            </a:pPr>
+            <a:r>
+              <a:rPr sz="1725" b="1">
+                <a:solidFill>
+                  <a:srgbClr val="28369F"/>
+                </a:solidFill>
+                <a:latin typeface="Arial"/>
+                <a:ea typeface="Arial"/>
+                <a:cs typeface="Arial"/>
+              </a:rPr>
+              <a:t>Short transitions for everyday browsing</a:t>
+            </a:r>
+          </a:p>
+        </p:txBody>
+      </p:sp>
+      <p:sp>
+        <p:nvSpPr>
+          <p:cNvPr id="5" name="">
+            <a:extLst xmlns:a="http://schemas.openxmlformats.org/drawingml/2006/main">
+              <a:ext uri="{FF2B5EF4-FFF2-40B4-BE49-F238E27FC236}">
+                <a16:creationId xmlns:a16="http://schemas.microsoft.com/office/drawing/2014/main" id="{161BA935-EAB2-421C-8C3A-5452AD5DD336}"/>
+              </a:ext>
+            </a:extLst>
+          </p:cNvPr>
+          <p:cNvSpPr>
+            <a:spLocks xmlns:a="http://schemas.openxmlformats.org/drawingml/2006/main" noGrp="1"/>
+          </p:cNvSpPr>
+          <p:nvPr/>
+        </p:nvSpPr>
+        <p:spPr>
+          <a:xfrm xmlns:a="http://schemas.openxmlformats.org/drawingml/2006/main">
+            <a:off x="590550" y="2438400"/>
+            <a:ext cx="6143625" cy="866775"/>
+          </a:xfrm>
+          <a:prstGeom xmlns:a="http://schemas.openxmlformats.org/drawingml/2006/main" prst="rect">
+            <a:avLst/>
+          </a:prstGeom>
+          <a:noFill xmlns:a="http://schemas.openxmlformats.org/drawingml/2006/main"/>
+          <a:ln xmlns:a="http://schemas.openxmlformats.org/drawingml/2006/main" w="0">
+            <a:noFill/>
+          </a:ln>
+        </p:spPr>
+        <p:txBody>
+          <a:bodyPr xmlns:a="http://schemas.openxmlformats.org/drawingml/2006/main"/>
+          <a:lstStyle xmlns:a="http://schemas.openxmlformats.org/drawingml/2006/main">
+            <a:defPPr>
+              <a:defRPr sz="1650" b="0">
+                <a:solidFill>
+                  <a:srgbClr val="17263E"/>
+                </a:solidFill>
+                <a:latin typeface="Arial"/>
+                <a:ea typeface="Arial"/>
+                <a:cs typeface="Arial"/>
+              </a:defRPr>
+            </a:defPPr>
+            <a:lvl1pPr>
+              <a:defRPr sz="1650" b="0">
+                <a:solidFill>
+                  <a:srgbClr val="17263E"/>
+                </a:solidFill>
+                <a:latin typeface="Arial"/>
+                <a:ea typeface="Arial"/>
+                <a:cs typeface="Arial"/>
+              </a:defRPr>
+            </a:lvl1pPr>
+            <a:lvl2pPr>
+              <a:defRPr sz="1650" b="0">
+                <a:solidFill>
+                  <a:srgbClr val="17263E"/>
+                </a:solidFill>
+                <a:latin typeface="Arial"/>
+                <a:ea typeface="Arial"/>
+                <a:cs typeface="Arial"/>
+              </a:defRPr>
+            </a:lvl2pPr>
+            <a:lvl3pPr>
+              <a:defRPr sz="1650" b="0">
+                <a:solidFill>
+                  <a:srgbClr val="17263E"/>
+                </a:solidFill>
+                <a:latin typeface="Arial"/>
+                <a:ea typeface="Arial"/>
+                <a:cs typeface="Arial"/>
+              </a:defRPr>
+            </a:lvl3pPr>
+            <a:lvl4pPr>
+              <a:defRPr sz="1650" b="0">
+                <a:solidFill>
+                  <a:srgbClr val="17263E"/>
+                </a:solidFill>
+                <a:latin typeface="Arial"/>
+                <a:ea typeface="Arial"/>
+                <a:cs typeface="Arial"/>
+              </a:defRPr>
+            </a:lvl4pPr>
+            <a:lvl5pPr>
+              <a:defRPr sz="1650" b="0">
+                <a:solidFill>
+                  <a:srgbClr val="17263E"/>
+                </a:solidFill>
+                <a:latin typeface="Arial"/>
+                <a:ea typeface="Arial"/>
+                <a:cs typeface="Arial"/>
+              </a:defRPr>
+            </a:lvl5pPr>
+            <a:lvl6pPr>
+              <a:defRPr sz="1650" b="0">
+                <a:solidFill>
+                  <a:srgbClr val="17263E"/>
+                </a:solidFill>
+                <a:latin typeface="Arial"/>
+                <a:ea typeface="Arial"/>
+                <a:cs typeface="Arial"/>
+              </a:defRPr>
+            </a:lvl6pPr>
+            <a:lvl7pPr>
+              <a:defRPr sz="1650" b="0">
+                <a:solidFill>
+                  <a:srgbClr val="17263E"/>
+                </a:solidFill>
+                <a:latin typeface="Arial"/>
+                <a:ea typeface="Arial"/>
+                <a:cs typeface="Arial"/>
+              </a:defRPr>
+            </a:lvl7pPr>
+            <a:lvl8pPr>
+              <a:defRPr sz="1650" b="0">
+                <a:solidFill>
+                  <a:srgbClr val="17263E"/>
+                </a:solidFill>
+                <a:latin typeface="Arial"/>
+                <a:ea typeface="Arial"/>
+                <a:cs typeface="Arial"/>
+              </a:defRPr>
+            </a:lvl8pPr>
+            <a:lvl9pPr>
+              <a:defRPr sz="1650" b="0">
+                <a:solidFill>
+                  <a:srgbClr val="17263E"/>
+                </a:solidFill>
+                <a:latin typeface="Arial"/>
+                <a:ea typeface="Arial"/>
+                <a:cs typeface="Arial"/>
+              </a:defRPr>
+            </a:lvl9pPr>
+          </a:lstStyle>
+          <a:p xmlns:a="http://schemas.openxmlformats.org/drawingml/2006/main">
+            <a:pPr>
+              <a:defRPr sz="1650" b="0">
+                <a:solidFill>
+                  <a:srgbClr val="17263E"/>
+                </a:solidFill>
+                <a:latin typeface="Arial"/>
+                <a:ea typeface="Arial"/>
+                <a:cs typeface="Arial"/>
+              </a:defRPr>
+            </a:pPr>
+            <a:r>
+              <a:rPr sz="1650" b="0">
+                <a:solidFill>
+                  <a:srgbClr val="17263E"/>
+                </a:solidFill>
+                <a:latin typeface="Arial"/>
+                <a:ea typeface="Arial"/>
+                <a:cs typeface="Arial"/>
+              </a:rPr>
+              <a:t>US stocks and Funds &amp; baskets use a one-second transition to signal a change of context. The content stays one tap away.</a:t>
+            </a:r>
+          </a:p>
+        </p:txBody>
+      </p:sp>
+      <p:sp>
+        <p:nvSpPr>
+          <p:cNvPr id="6" name="">
+            <a:extLst xmlns:a="http://schemas.openxmlformats.org/drawingml/2006/main">
+              <a:ext uri="{FF2B5EF4-FFF2-40B4-BE49-F238E27FC236}">
+                <a16:creationId xmlns:a16="http://schemas.microsoft.com/office/drawing/2014/main" id="{B8D793B4-62B2-487C-B1B4-C659C6A052C1}"/>
+              </a:ext>
+            </a:extLst>
+          </p:cNvPr>
+          <p:cNvSpPr>
+            <a:spLocks xmlns:a="http://schemas.openxmlformats.org/drawingml/2006/main" noGrp="1"/>
+          </p:cNvSpPr>
+          <p:nvPr/>
+        </p:nvSpPr>
+        <p:spPr>
+          <a:xfrm xmlns:a="http://schemas.openxmlformats.org/drawingml/2006/main">
+            <a:off x="590550" y="3533775"/>
+            <a:ext cx="6143625" cy="285750"/>
+          </a:xfrm>
+          <a:prstGeom xmlns:a="http://schemas.openxmlformats.org/drawingml/2006/main" prst="rect">
+            <a:avLst/>
+          </a:prstGeom>
+          <a:noFill xmlns:a="http://schemas.openxmlformats.org/drawingml/2006/main"/>
+          <a:ln xmlns:a="http://schemas.openxmlformats.org/drawingml/2006/main" w="0">
+            <a:noFill/>
+          </a:ln>
+        </p:spPr>
+        <p:txBody>
+          <a:bodyPr xmlns:a="http://schemas.openxmlformats.org/drawingml/2006/main"/>
+          <a:lstStyle xmlns:a="http://schemas.openxmlformats.org/drawingml/2006/main">
+            <a:defPPr>
+              <a:defRPr sz="1725" b="1">
+                <a:solidFill>
+                  <a:srgbClr val="28369F"/>
+                </a:solidFill>
+                <a:latin typeface="Arial"/>
+                <a:ea typeface="Arial"/>
+                <a:cs typeface="Arial"/>
+              </a:defRPr>
+            </a:defPPr>
+            <a:lvl1pPr>
+              <a:defRPr sz="1725" b="1">
+                <a:solidFill>
+                  <a:srgbClr val="28369F"/>
+                </a:solidFill>
+                <a:latin typeface="Arial"/>
+                <a:ea typeface="Arial"/>
+                <a:cs typeface="Arial"/>
+              </a:defRPr>
+            </a:lvl1pPr>
+            <a:lvl2pPr>
+              <a:defRPr sz="1725" b="1">
+                <a:solidFill>
+                  <a:srgbClr val="28369F"/>
+                </a:solidFill>
+                <a:latin typeface="Arial"/>
+                <a:ea typeface="Arial"/>
+                <a:cs typeface="Arial"/>
+              </a:defRPr>
+            </a:lvl2pPr>
+            <a:lvl3pPr>
+              <a:defRPr sz="1725" b="1">
+                <a:solidFill>
+                  <a:srgbClr val="28369F"/>
+                </a:solidFill>
+                <a:latin typeface="Arial"/>
+                <a:ea typeface="Arial"/>
+                <a:cs typeface="Arial"/>
+              </a:defRPr>
+            </a:lvl3pPr>
+            <a:lvl4pPr>
+              <a:defRPr sz="1725" b="1">
+                <a:solidFill>
+                  <a:srgbClr val="28369F"/>
+                </a:solidFill>
+                <a:latin typeface="Arial"/>
+                <a:ea typeface="Arial"/>
+                <a:cs typeface="Arial"/>
+              </a:defRPr>
+            </a:lvl4pPr>
+            <a:lvl5pPr>
+              <a:defRPr sz="1725" b="1">
+                <a:solidFill>
+                  <a:srgbClr val="28369F"/>
+                </a:solidFill>
+                <a:latin typeface="Arial"/>
+                <a:ea typeface="Arial"/>
+                <a:cs typeface="Arial"/>
+              </a:defRPr>
+            </a:lvl5pPr>
+            <a:lvl6pPr>
+              <a:defRPr sz="1725" b="1">
+                <a:solidFill>
+                  <a:srgbClr val="28369F"/>
+                </a:solidFill>
+                <a:latin typeface="Arial"/>
+                <a:ea typeface="Arial"/>
+                <a:cs typeface="Arial"/>
+              </a:defRPr>
+            </a:lvl6pPr>
+            <a:lvl7pPr>
+              <a:defRPr sz="1725" b="1">
+                <a:solidFill>
+                  <a:srgbClr val="28369F"/>
+                </a:solidFill>
+                <a:latin typeface="Arial"/>
+                <a:ea typeface="Arial"/>
+                <a:cs typeface="Arial"/>
+              </a:defRPr>
+            </a:lvl7pPr>
+            <a:lvl8pPr>
+              <a:defRPr sz="1725" b="1">
+                <a:solidFill>
+                  <a:srgbClr val="28369F"/>
+                </a:solidFill>
+                <a:latin typeface="Arial"/>
+                <a:ea typeface="Arial"/>
+                <a:cs typeface="Arial"/>
+              </a:defRPr>
+            </a:lvl8pPr>
+            <a:lvl9pPr>
+              <a:defRPr sz="1725" b="1">
+                <a:solidFill>
+                  <a:srgbClr val="28369F"/>
+                </a:solidFill>
+                <a:latin typeface="Arial"/>
+                <a:ea typeface="Arial"/>
+                <a:cs typeface="Arial"/>
+              </a:defRPr>
+            </a:lvl9pPr>
+          </a:lstStyle>
+          <a:p xmlns:a="http://schemas.openxmlformats.org/drawingml/2006/main">
+            <a:pPr>
+              <a:defRPr sz="1725" b="1">
+                <a:solidFill>
+                  <a:srgbClr val="28369F"/>
+                </a:solidFill>
+                <a:latin typeface="Arial"/>
+                <a:ea typeface="Arial"/>
+                <a:cs typeface="Arial"/>
+              </a:defRPr>
+            </a:pPr>
+            <a:r>
+              <a:rPr sz="1725" b="1">
+                <a:solidFill>
+                  <a:srgbClr val="28369F"/>
+                </a:solidFill>
+                <a:latin typeface="Arial"/>
+                <a:ea typeface="Arial"/>
+                <a:cs typeface="Arial"/>
+              </a:rPr>
+              <a:t>Private Wealth gets its own space</a:t>
+            </a:r>
+          </a:p>
+        </p:txBody>
+      </p:sp>
+      <p:sp>
+        <p:nvSpPr>
+          <p:cNvPr id="7" name="">
+            <a:extLst xmlns:a="http://schemas.openxmlformats.org/drawingml/2006/main">
+              <a:ext uri="{FF2B5EF4-FFF2-40B4-BE49-F238E27FC236}">
+                <a16:creationId xmlns:a16="http://schemas.microsoft.com/office/drawing/2014/main" id="{50B11AC9-328F-44DE-9DF1-0A3BB939547D}"/>
+              </a:ext>
+            </a:extLst>
+          </p:cNvPr>
+          <p:cNvSpPr>
+            <a:spLocks xmlns:a="http://schemas.openxmlformats.org/drawingml/2006/main" noGrp="1"/>
+          </p:cNvSpPr>
+          <p:nvPr/>
+        </p:nvSpPr>
+        <p:spPr>
+          <a:xfrm xmlns:a="http://schemas.openxmlformats.org/drawingml/2006/main">
+            <a:off x="590550" y="3943350"/>
+            <a:ext cx="6143625" cy="1066800"/>
+          </a:xfrm>
+          <a:prstGeom xmlns:a="http://schemas.openxmlformats.org/drawingml/2006/main" prst="rect">
+            <a:avLst/>
+          </a:prstGeom>
+          <a:noFill xmlns:a="http://schemas.openxmlformats.org/drawingml/2006/main"/>
+          <a:ln xmlns:a="http://schemas.openxmlformats.org/drawingml/2006/main" w="0">
+            <a:noFill/>
+          </a:ln>
+        </p:spPr>
+        <p:txBody>
+          <a:bodyPr xmlns:a="http://schemas.openxmlformats.org/drawingml/2006/main"/>
+          <a:lstStyle xmlns:a="http://schemas.openxmlformats.org/drawingml/2006/main">
+            <a:defPPr>
+              <a:defRPr sz="1650" b="0">
+                <a:solidFill>
+                  <a:srgbClr val="17263E"/>
+                </a:solidFill>
+                <a:latin typeface="Arial"/>
+                <a:ea typeface="Arial"/>
+                <a:cs typeface="Arial"/>
+              </a:defRPr>
+            </a:defPPr>
+            <a:lvl1pPr>
+              <a:defRPr sz="1650" b="0">
+                <a:solidFill>
+                  <a:srgbClr val="17263E"/>
+                </a:solidFill>
+                <a:latin typeface="Arial"/>
+                <a:ea typeface="Arial"/>
+                <a:cs typeface="Arial"/>
+              </a:defRPr>
+            </a:lvl1pPr>
+            <a:lvl2pPr>
+              <a:defRPr sz="1650" b="0">
+                <a:solidFill>
+                  <a:srgbClr val="17263E"/>
+                </a:solidFill>
+                <a:latin typeface="Arial"/>
+                <a:ea typeface="Arial"/>
+                <a:cs typeface="Arial"/>
+              </a:defRPr>
+            </a:lvl2pPr>
+            <a:lvl3pPr>
+              <a:defRPr sz="1650" b="0">
+                <a:solidFill>
+                  <a:srgbClr val="17263E"/>
+                </a:solidFill>
+                <a:latin typeface="Arial"/>
+                <a:ea typeface="Arial"/>
+                <a:cs typeface="Arial"/>
+              </a:defRPr>
+            </a:lvl3pPr>
+            <a:lvl4pPr>
+              <a:defRPr sz="1650" b="0">
+                <a:solidFill>
+                  <a:srgbClr val="17263E"/>
+                </a:solidFill>
+                <a:latin typeface="Arial"/>
+                <a:ea typeface="Arial"/>
+                <a:cs typeface="Arial"/>
+              </a:defRPr>
+            </a:lvl4pPr>
+            <a:lvl5pPr>
+              <a:defRPr sz="1650" b="0">
+                <a:solidFill>
+                  <a:srgbClr val="17263E"/>
+                </a:solidFill>
+                <a:latin typeface="Arial"/>
+                <a:ea typeface="Arial"/>
+                <a:cs typeface="Arial"/>
+              </a:defRPr>
+            </a:lvl5pPr>
+            <a:lvl6pPr>
+              <a:defRPr sz="1650" b="0">
+                <a:solidFill>
+                  <a:srgbClr val="17263E"/>
+                </a:solidFill>
+                <a:latin typeface="Arial"/>
+                <a:ea typeface="Arial"/>
+                <a:cs typeface="Arial"/>
+              </a:defRPr>
+            </a:lvl6pPr>
+            <a:lvl7pPr>
+              <a:defRPr sz="1650" b="0">
+                <a:solidFill>
+                  <a:srgbClr val="17263E"/>
+                </a:solidFill>
+                <a:latin typeface="Arial"/>
+                <a:ea typeface="Arial"/>
+                <a:cs typeface="Arial"/>
+              </a:defRPr>
+            </a:lvl7pPr>
+            <a:lvl8pPr>
+              <a:defRPr sz="1650" b="0">
+                <a:solidFill>
+                  <a:srgbClr val="17263E"/>
+                </a:solidFill>
+                <a:latin typeface="Arial"/>
+                <a:ea typeface="Arial"/>
+                <a:cs typeface="Arial"/>
+              </a:defRPr>
+            </a:lvl8pPr>
+            <a:lvl9pPr>
+              <a:defRPr sz="1650" b="0">
+                <a:solidFill>
+                  <a:srgbClr val="17263E"/>
+                </a:solidFill>
+                <a:latin typeface="Arial"/>
+                <a:ea typeface="Arial"/>
+                <a:cs typeface="Arial"/>
+              </a:defRPr>
+            </a:lvl9pPr>
+          </a:lstStyle>
+          <a:p xmlns:a="http://schemas.openxmlformats.org/drawingml/2006/main">
+            <a:pPr>
+              <a:defRPr sz="1650" b="0">
+                <a:solidFill>
+                  <a:srgbClr val="17263E"/>
+                </a:solidFill>
+                <a:latin typeface="Arial"/>
+                <a:ea typeface="Arial"/>
+                <a:cs typeface="Arial"/>
+              </a:defRPr>
+            </a:pPr>
+            <a:r>
+              <a:rPr sz="1650" b="0">
+                <a:solidFill>
+                  <a:srgbClr val="17263E"/>
+                </a:solidFill>
+                <a:latin typeface="Arial"/>
+                <a:ea typeface="Arial"/>
+                <a:cs typeface="Arial"/>
+              </a:rPr>
+              <a:t>The welcome introduces the section. Once inside, the other category tabs are hidden. Back to Exclusives plays a short exit and returns to the previous category.</a:t>
+            </a:r>
+          </a:p>
+        </p:txBody>
+      </p:sp>
+      <p:sp>
+        <p:nvSpPr>
+          <p:cNvPr id="8" name="">
+            <a:extLst xmlns:a="http://schemas.openxmlformats.org/drawingml/2006/main">
+              <a:ext uri="{FF2B5EF4-FFF2-40B4-BE49-F238E27FC236}">
+                <a16:creationId xmlns:a16="http://schemas.microsoft.com/office/drawing/2014/main" id="{E8F62D6F-B2AB-492B-86AD-0CE52451C0C9}"/>
+              </a:ext>
+            </a:extLst>
+          </p:cNvPr>
+          <p:cNvSpPr>
+            <a:spLocks xmlns:a="http://schemas.openxmlformats.org/drawingml/2006/main" noGrp="1"/>
+          </p:cNvSpPr>
+          <p:nvPr/>
+        </p:nvSpPr>
+        <p:spPr>
+          <a:xfrm xmlns:a="http://schemas.openxmlformats.org/drawingml/2006/main">
+            <a:off x="590550" y="5238750"/>
+            <a:ext cx="6143625" cy="285750"/>
+          </a:xfrm>
+          <a:prstGeom xmlns:a="http://schemas.openxmlformats.org/drawingml/2006/main" prst="rect">
+            <a:avLst/>
+          </a:prstGeom>
+          <a:noFill xmlns:a="http://schemas.openxmlformats.org/drawingml/2006/main"/>
+          <a:ln xmlns:a="http://schemas.openxmlformats.org/drawingml/2006/main" w="0">
+            <a:noFill/>
+          </a:ln>
+        </p:spPr>
+        <p:txBody>
+          <a:bodyPr xmlns:a="http://schemas.openxmlformats.org/drawingml/2006/main"/>
+          <a:lstStyle xmlns:a="http://schemas.openxmlformats.org/drawingml/2006/main">
+            <a:defPPr>
+              <a:defRPr sz="1725" b="1">
+                <a:solidFill>
+                  <a:srgbClr val="28369F"/>
+                </a:solidFill>
+                <a:latin typeface="Arial"/>
+                <a:ea typeface="Arial"/>
+                <a:cs typeface="Arial"/>
+              </a:defRPr>
+            </a:defPPr>
+            <a:lvl1pPr>
+              <a:defRPr sz="1725" b="1">
+                <a:solidFill>
+                  <a:srgbClr val="28369F"/>
+                </a:solidFill>
+                <a:latin typeface="Arial"/>
+                <a:ea typeface="Arial"/>
+                <a:cs typeface="Arial"/>
+              </a:defRPr>
+            </a:lvl1pPr>
+            <a:lvl2pPr>
+              <a:defRPr sz="1725" b="1">
+                <a:solidFill>
+                  <a:srgbClr val="28369F"/>
+                </a:solidFill>
+                <a:latin typeface="Arial"/>
+                <a:ea typeface="Arial"/>
+                <a:cs typeface="Arial"/>
+              </a:defRPr>
+            </a:lvl2pPr>
+            <a:lvl3pPr>
+              <a:defRPr sz="1725" b="1">
+                <a:solidFill>
+                  <a:srgbClr val="28369F"/>
+                </a:solidFill>
+                <a:latin typeface="Arial"/>
+                <a:ea typeface="Arial"/>
+                <a:cs typeface="Arial"/>
+              </a:defRPr>
+            </a:lvl3pPr>
+            <a:lvl4pPr>
+              <a:defRPr sz="1725" b="1">
+                <a:solidFill>
+                  <a:srgbClr val="28369F"/>
+                </a:solidFill>
+                <a:latin typeface="Arial"/>
+                <a:ea typeface="Arial"/>
+                <a:cs typeface="Arial"/>
+              </a:defRPr>
+            </a:lvl4pPr>
+            <a:lvl5pPr>
+              <a:defRPr sz="1725" b="1">
+                <a:solidFill>
+                  <a:srgbClr val="28369F"/>
+                </a:solidFill>
+                <a:latin typeface="Arial"/>
+                <a:ea typeface="Arial"/>
+                <a:cs typeface="Arial"/>
+              </a:defRPr>
+            </a:lvl5pPr>
+            <a:lvl6pPr>
+              <a:defRPr sz="1725" b="1">
+                <a:solidFill>
+                  <a:srgbClr val="28369F"/>
+                </a:solidFill>
+                <a:latin typeface="Arial"/>
+                <a:ea typeface="Arial"/>
+                <a:cs typeface="Arial"/>
+              </a:defRPr>
+            </a:lvl6pPr>
+            <a:lvl7pPr>
+              <a:defRPr sz="1725" b="1">
+                <a:solidFill>
+                  <a:srgbClr val="28369F"/>
+                </a:solidFill>
+                <a:latin typeface="Arial"/>
+                <a:ea typeface="Arial"/>
+                <a:cs typeface="Arial"/>
+              </a:defRPr>
+            </a:lvl7pPr>
+            <a:lvl8pPr>
+              <a:defRPr sz="1725" b="1">
+                <a:solidFill>
+                  <a:srgbClr val="28369F"/>
+                </a:solidFill>
+                <a:latin typeface="Arial"/>
+                <a:ea typeface="Arial"/>
+                <a:cs typeface="Arial"/>
+              </a:defRPr>
+            </a:lvl8pPr>
+            <a:lvl9pPr>
+              <a:defRPr sz="1725" b="1">
+                <a:solidFill>
+                  <a:srgbClr val="28369F"/>
+                </a:solidFill>
+                <a:latin typeface="Arial"/>
+                <a:ea typeface="Arial"/>
+                <a:cs typeface="Arial"/>
+              </a:defRPr>
+            </a:lvl9pPr>
+          </a:lstStyle>
+          <a:p xmlns:a="http://schemas.openxmlformats.org/drawingml/2006/main">
+            <a:pPr>
+              <a:defRPr sz="1725" b="1">
+                <a:solidFill>
+                  <a:srgbClr val="28369F"/>
+                </a:solidFill>
+                <a:latin typeface="Arial"/>
+                <a:ea typeface="Arial"/>
+                <a:cs typeface="Arial"/>
+              </a:defRPr>
+            </a:pPr>
+            <a:r>
+              <a:rPr sz="1725" b="1">
+                <a:solidFill>
+                  <a:srgbClr val="28369F"/>
+                </a:solidFill>
+                <a:latin typeface="Arial"/>
+                <a:ea typeface="Arial"/>
+                <a:cs typeface="Arial"/>
+              </a:rPr>
+              <a:t>Motion should not become a barrier</a:t>
+            </a:r>
+          </a:p>
+        </p:txBody>
+      </p:sp>
+      <p:sp>
+        <p:nvSpPr>
+          <p:cNvPr id="9" name="">
+            <a:extLst xmlns:a="http://schemas.openxmlformats.org/drawingml/2006/main">
+              <a:ext uri="{FF2B5EF4-FFF2-40B4-BE49-F238E27FC236}">
+                <a16:creationId xmlns:a16="http://schemas.microsoft.com/office/drawing/2014/main" id="{76E3FA1B-E9BC-4657-8B97-3FA53D9FF65A}"/>
+              </a:ext>
+            </a:extLst>
+          </p:cNvPr>
+          <p:cNvSpPr>
+            <a:spLocks xmlns:a="http://schemas.openxmlformats.org/drawingml/2006/main" noGrp="1"/>
+          </p:cNvSpPr>
+          <p:nvPr/>
+        </p:nvSpPr>
+        <p:spPr>
+          <a:xfrm xmlns:a="http://schemas.openxmlformats.org/drawingml/2006/main">
+            <a:off x="590550" y="5648325"/>
+            <a:ext cx="6143625" cy="895350"/>
+          </a:xfrm>
+          <a:prstGeom xmlns:a="http://schemas.openxmlformats.org/drawingml/2006/main" prst="rect">
+            <a:avLst/>
+          </a:prstGeom>
+          <a:noFill xmlns:a="http://schemas.openxmlformats.org/drawingml/2006/main"/>
+          <a:ln xmlns:a="http://schemas.openxmlformats.org/drawingml/2006/main" w="0">
+            <a:noFill/>
+          </a:ln>
+        </p:spPr>
+        <p:txBody>
+          <a:bodyPr xmlns:a="http://schemas.openxmlformats.org/drawingml/2006/main"/>
+          <a:lstStyle xmlns:a="http://schemas.openxmlformats.org/drawingml/2006/main">
+            <a:defPPr>
+              <a:defRPr sz="1650" b="0">
+                <a:solidFill>
+                  <a:srgbClr val="17263E"/>
+                </a:solidFill>
+                <a:latin typeface="Arial"/>
+                <a:ea typeface="Arial"/>
+                <a:cs typeface="Arial"/>
+              </a:defRPr>
+            </a:defPPr>
+            <a:lvl1pPr>
+              <a:defRPr sz="1650" b="0">
+                <a:solidFill>
+                  <a:srgbClr val="17263E"/>
+                </a:solidFill>
+                <a:latin typeface="Arial"/>
+                <a:ea typeface="Arial"/>
+                <a:cs typeface="Arial"/>
+              </a:defRPr>
+            </a:lvl1pPr>
+            <a:lvl2pPr>
+              <a:defRPr sz="1650" b="0">
+                <a:solidFill>
+                  <a:srgbClr val="17263E"/>
+                </a:solidFill>
+                <a:latin typeface="Arial"/>
+                <a:ea typeface="Arial"/>
+                <a:cs typeface="Arial"/>
+              </a:defRPr>
+            </a:lvl2pPr>
+            <a:lvl3pPr>
+              <a:defRPr sz="1650" b="0">
+                <a:solidFill>
+                  <a:srgbClr val="17263E"/>
+                </a:solidFill>
+                <a:latin typeface="Arial"/>
+                <a:ea typeface="Arial"/>
+                <a:cs typeface="Arial"/>
+              </a:defRPr>
+            </a:lvl3pPr>
+            <a:lvl4pPr>
+              <a:defRPr sz="1650" b="0">
+                <a:solidFill>
+                  <a:srgbClr val="17263E"/>
+                </a:solidFill>
+                <a:latin typeface="Arial"/>
+                <a:ea typeface="Arial"/>
+                <a:cs typeface="Arial"/>
+              </a:defRPr>
+            </a:lvl4pPr>
+            <a:lvl5pPr>
+              <a:defRPr sz="1650" b="0">
+                <a:solidFill>
+                  <a:srgbClr val="17263E"/>
+                </a:solidFill>
+                <a:latin typeface="Arial"/>
+                <a:ea typeface="Arial"/>
+                <a:cs typeface="Arial"/>
+              </a:defRPr>
+            </a:lvl5pPr>
+            <a:lvl6pPr>
+              <a:defRPr sz="1650" b="0">
+                <a:solidFill>
+                  <a:srgbClr val="17263E"/>
+                </a:solidFill>
+                <a:latin typeface="Arial"/>
+                <a:ea typeface="Arial"/>
+                <a:cs typeface="Arial"/>
+              </a:defRPr>
+            </a:lvl6pPr>
+            <a:lvl7pPr>
+              <a:defRPr sz="1650" b="0">
+                <a:solidFill>
+                  <a:srgbClr val="17263E"/>
+                </a:solidFill>
+                <a:latin typeface="Arial"/>
+                <a:ea typeface="Arial"/>
+                <a:cs typeface="Arial"/>
+              </a:defRPr>
+            </a:lvl7pPr>
+            <a:lvl8pPr>
+              <a:defRPr sz="1650" b="0">
+                <a:solidFill>
+                  <a:srgbClr val="17263E"/>
+                </a:solidFill>
+                <a:latin typeface="Arial"/>
+                <a:ea typeface="Arial"/>
+                <a:cs typeface="Arial"/>
+              </a:defRPr>
+            </a:lvl8pPr>
+            <a:lvl9pPr>
+              <a:defRPr sz="1650" b="0">
+                <a:solidFill>
+                  <a:srgbClr val="17263E"/>
+                </a:solidFill>
+                <a:latin typeface="Arial"/>
+                <a:ea typeface="Arial"/>
+                <a:cs typeface="Arial"/>
+              </a:defRPr>
+            </a:lvl9pPr>
+          </a:lstStyle>
+          <a:p xmlns:a="http://schemas.openxmlformats.org/drawingml/2006/main">
+            <a:pPr>
+              <a:defRPr sz="1650" b="0">
+                <a:solidFill>
+                  <a:srgbClr val="17263E"/>
+                </a:solidFill>
+                <a:latin typeface="Arial"/>
+                <a:ea typeface="Arial"/>
+                <a:cs typeface="Arial"/>
+              </a:defRPr>
+            </a:pPr>
+            <a:r>
+              <a:rPr sz="1650" b="0">
+                <a:solidFill>
+                  <a:srgbClr val="17263E"/>
+                </a:solidFill>
+                <a:latin typeface="Arial"/>
+                <a:ea typeface="Arial"/>
+                <a:cs typeface="Arial"/>
+              </a:rPr>
+              <a:t>Skip and Escape work immediately. Reduced-motion settings remove the transitions. Test skips, exits and time to reach a product before keeping the effect.</a:t>
+            </a:r>
+          </a:p>
+        </p:txBody>
+      </p:sp>
+      <p:pic>
+        <p:nvPicPr>
+          <p:cNvPr id="10" name="">
+            <a:extLst xmlns:a="http://schemas.openxmlformats.org/drawingml/2006/main">
+              <a:ext uri="{FF2B5EF4-FFF2-40B4-BE49-F238E27FC236}">
+                <a16:creationId xmlns:a16="http://schemas.microsoft.com/office/drawing/2014/main" id="{D49A2586-57BC-43B4-B800-99781F00AD0F}"/>
+              </a:ext>
+            </a:extLst>
+          </p:cNvPr>
+          <p:cNvPicPr>
+            <a:picLocks xmlns:a="http://schemas.openxmlformats.org/drawingml/2006/main" noChangeAspect="1"/>
+          </p:cNvPicPr>
+          <p:nvPr/>
+        </p:nvPicPr>
+        <p:blipFill>
+          <a:blip xmlns:r="http://schemas.openxmlformats.org/officeDocument/2006/relationships" xmlns:a="http://schemas.openxmlformats.org/drawingml/2006/main" r:embed="R4d85fd219e74425a"/>
+          <a:stretch xmlns:a="http://schemas.openxmlformats.org/drawingml/2006/main"/>
+        </p:blipFill>
+        <p:spPr>
+          <a:xfrm xmlns:a="http://schemas.openxmlformats.org/drawingml/2006/main">
+            <a:off x="8391751" y="1885950"/>
+            <a:ext cx="2095049" cy="4533900"/>
+          </a:xfrm>
+          <a:prstGeom xmlns:a="http://schemas.openxmlformats.org/drawingml/2006/main" prst="rect">
+            <a:avLst/>
+          </a:prstGeom>
+        </p:spPr>
+      </p:pic>
+      <p:sp>
+        <p:nvSpPr>
+          <p:cNvPr id="11" name="">
+            <a:extLst xmlns:a="http://schemas.openxmlformats.org/drawingml/2006/main">
+              <a:ext uri="{FF2B5EF4-FFF2-40B4-BE49-F238E27FC236}">
+                <a16:creationId xmlns:a16="http://schemas.microsoft.com/office/drawing/2014/main" id="{584180D6-B7BD-451B-B129-7F12ADBAA5EB}"/>
+              </a:ext>
+            </a:extLst>
+          </p:cNvPr>
+          <p:cNvSpPr>
+            <a:spLocks xmlns:a="http://schemas.openxmlformats.org/drawingml/2006/main" noGrp="1"/>
+          </p:cNvSpPr>
+          <p:nvPr/>
+        </p:nvSpPr>
+        <p:spPr>
+          <a:xfrm xmlns:a="http://schemas.openxmlformats.org/drawingml/2006/main">
+            <a:off x="8077200" y="6534150"/>
+            <a:ext cx="3238500" cy="190500"/>
+          </a:xfrm>
+          <a:prstGeom xmlns:a="http://schemas.openxmlformats.org/drawingml/2006/main" prst="rect">
+            <a:avLst/>
+          </a:prstGeom>
+          <a:noFill xmlns:a="http://schemas.openxmlformats.org/drawingml/2006/main"/>
+          <a:ln xmlns:a="http://schemas.openxmlformats.org/drawingml/2006/main" w="0">
+            <a:noFill/>
+          </a:ln>
+        </p:spPr>
+        <p:txBody>
+          <a:bodyPr xmlns:a="http://schemas.openxmlformats.org/drawingml/2006/main"/>
+          <a:lstStyle xmlns:a="http://schemas.openxmlformats.org/drawingml/2006/main">
+            <a:defPPr>
+              <a:defRPr sz="900" b="0">
+                <a:solidFill>
+                  <a:srgbClr val="58677E"/>
+                </a:solidFill>
+                <a:latin typeface="Arial"/>
+                <a:ea typeface="Arial"/>
+                <a:cs typeface="Arial"/>
+              </a:defRPr>
+            </a:defPPr>
+            <a:lvl1pPr>
+              <a:defRPr sz="900" b="0">
+                <a:solidFill>
+                  <a:srgbClr val="58677E"/>
+                </a:solidFill>
+                <a:latin typeface="Arial"/>
+                <a:ea typeface="Arial"/>
+                <a:cs typeface="Arial"/>
+              </a:defRPr>
+            </a:lvl1pPr>
+            <a:lvl2pPr>
+              <a:defRPr sz="900" b="0">
+                <a:solidFill>
+                  <a:srgbClr val="58677E"/>
+                </a:solidFill>
+                <a:latin typeface="Arial"/>
+                <a:ea typeface="Arial"/>
+                <a:cs typeface="Arial"/>
+              </a:defRPr>
+            </a:lvl2pPr>
+            <a:lvl3pPr>
+              <a:defRPr sz="900" b="0">
+                <a:solidFill>
+                  <a:srgbClr val="58677E"/>
+                </a:solidFill>
+                <a:latin typeface="Arial"/>
+                <a:ea typeface="Arial"/>
+                <a:cs typeface="Arial"/>
+              </a:defRPr>
+            </a:lvl3pPr>
+            <a:lvl4pPr>
+              <a:defRPr sz="900" b="0">
+                <a:solidFill>
+                  <a:srgbClr val="58677E"/>
+                </a:solidFill>
+                <a:latin typeface="Arial"/>
+                <a:ea typeface="Arial"/>
+                <a:cs typeface="Arial"/>
+              </a:defRPr>
+            </a:lvl4pPr>
+            <a:lvl5pPr>
+              <a:defRPr sz="900" b="0">
+                <a:solidFill>
+                  <a:srgbClr val="58677E"/>
+                </a:solidFill>
+                <a:latin typeface="Arial"/>
+                <a:ea typeface="Arial"/>
+                <a:cs typeface="Arial"/>
+              </a:defRPr>
+            </a:lvl5pPr>
+            <a:lvl6pPr>
+              <a:defRPr sz="900" b="0">
+                <a:solidFill>
+                  <a:srgbClr val="58677E"/>
+                </a:solidFill>
+                <a:latin typeface="Arial"/>
+                <a:ea typeface="Arial"/>
+                <a:cs typeface="Arial"/>
+              </a:defRPr>
+            </a:lvl6pPr>
+            <a:lvl7pPr>
+              <a:defRPr sz="900" b="0">
+                <a:solidFill>
+                  <a:srgbClr val="58677E"/>
+                </a:solidFill>
+                <a:latin typeface="Arial"/>
+                <a:ea typeface="Arial"/>
+                <a:cs typeface="Arial"/>
+              </a:defRPr>
+            </a:lvl7pPr>
+            <a:lvl8pPr>
+              <a:defRPr sz="900" b="0">
+                <a:solidFill>
+                  <a:srgbClr val="58677E"/>
+                </a:solidFill>
+                <a:latin typeface="Arial"/>
+                <a:ea typeface="Arial"/>
+                <a:cs typeface="Arial"/>
+              </a:defRPr>
+            </a:lvl8pPr>
+            <a:lvl9pPr>
+              <a:defRPr sz="900" b="0">
+                <a:solidFill>
+                  <a:srgbClr val="58677E"/>
+                </a:solidFill>
+                <a:latin typeface="Arial"/>
+                <a:ea typeface="Arial"/>
+                <a:cs typeface="Arial"/>
+              </a:defRPr>
+            </a:lvl9pPr>
+          </a:lstStyle>
+          <a:p xmlns:a="http://schemas.openxmlformats.org/drawingml/2006/main">
+            <a:pPr>
+              <a:defRPr sz="900" b="0">
+                <a:solidFill>
+                  <a:srgbClr val="58677E"/>
+                </a:solidFill>
+                <a:latin typeface="Arial"/>
+                <a:ea typeface="Arial"/>
+                <a:cs typeface="Arial"/>
+              </a:defRPr>
+            </a:pPr>
+            <a:r>
+              <a:rPr sz="900" b="0">
+                <a:solidFill>
+                  <a:srgbClr val="58677E"/>
+                </a:solidFill>
+                <a:latin typeface="Arial"/>
+                <a:ea typeface="Arial"/>
+                <a:cs typeface="Arial"/>
+              </a:rPr>
+              <a:t>Private Wealth after the welcome</a:t>
+            </a:r>
+          </a:p>
+        </p:txBody>
+      </p:sp>
+    </p:spTree>
+    <p:extLst>
+      <p:ext uri="{BB962C8B-B14F-4D97-AF65-F5344CB8AC3E}">
+        <p14:creationId xmlns:p14="http://schemas.microsoft.com/office/powerpoint/2010/main" val="1327039326"/>
       </p:ext>
     </p:extLst>
   </p:cSld>

</xml_diff>

<commit_message>
Sharpen product narrative with original shelf evidence and decision support
</commit_message>
<xml_diff>
--- a/deliverables/Ionic-Exclusives-Final.pptx
+++ b/deliverables/Ionic-Exclusives-Final.pptx
@@ -2,17 +2,17 @@
 <file path=ppt/presentation.xml><?xml version="1.0" encoding="utf-8"?>
 <p:presentation xmlns:p="http://schemas.openxmlformats.org/presentationml/2006/main">
   <p:sldMasterIdLst>
-    <p:sldMasterId xmlns:r="http://schemas.openxmlformats.org/officeDocument/2006/relationships" id="2147483648" r:id="Rcfce73f1ac3346e1"/>
+    <p:sldMasterId xmlns:r="http://schemas.openxmlformats.org/officeDocument/2006/relationships" id="2147483648" r:id="Rf34de8df769b4e57"/>
   </p:sldMasterIdLst>
   <p:notesMasterIdLst>
-    <p:notesMasterId xmlns:r="http://schemas.openxmlformats.org/officeDocument/2006/relationships" r:id="R3f87a73d6512434b"/>
+    <p:notesMasterId xmlns:r="http://schemas.openxmlformats.org/officeDocument/2006/relationships" r:id="R07cf0066d8614ceb"/>
   </p:notesMasterIdLst>
   <p:sldIdLst>
-    <p:sldId xmlns:r="http://schemas.openxmlformats.org/officeDocument/2006/relationships" id="256" r:id="R13b39066e4fe4009"/>
-    <p:sldId xmlns:r="http://schemas.openxmlformats.org/officeDocument/2006/relationships" id="257" r:id="Rf2a3b787ec814b99"/>
-    <p:sldId xmlns:r="http://schemas.openxmlformats.org/officeDocument/2006/relationships" id="258" r:id="Rcd463cabe6b24633"/>
-    <p:sldId xmlns:r="http://schemas.openxmlformats.org/officeDocument/2006/relationships" id="259" r:id="R314384c3eb114824"/>
-    <p:sldId xmlns:r="http://schemas.openxmlformats.org/officeDocument/2006/relationships" id="260" r:id="R6930afd21cfe4b52"/>
+    <p:sldId xmlns:r="http://schemas.openxmlformats.org/officeDocument/2006/relationships" id="256" r:id="Rde599e339ea24bf2"/>
+    <p:sldId xmlns:r="http://schemas.openxmlformats.org/officeDocument/2006/relationships" id="257" r:id="R742be0deed0b46f8"/>
+    <p:sldId xmlns:r="http://schemas.openxmlformats.org/officeDocument/2006/relationships" id="258" r:id="R7ba6e2c8f48e447e"/>
+    <p:sldId xmlns:r="http://schemas.openxmlformats.org/officeDocument/2006/relationships" id="259" r:id="R9a24d2cf1b794a48"/>
+    <p:sldId xmlns:r="http://schemas.openxmlformats.org/officeDocument/2006/relationships" id="260" r:id="R937bbf9907d34cbc"/>
   </p:sldIdLst>
   <p:sldSz cx="12192000" cy="6858000"/>
   <p:notesSz cx="6858000" cy="9144000"/>
@@ -446,7 +446,7 @@
           <a:lstStyle xmlns:a="http://schemas.openxmlformats.org/drawingml/2006/main"/>
           <a:p xmlns:a="http://schemas.openxmlformats.org/drawingml/2006/main">
             <a:r>
-              <a:t>The product lead supplied the observation about portfolio imports and assisted purchases. The app captures show the shelf structure. No production conversion baseline or NPS was provided. The screenshot is the captured Imported Portfolio experience inside the shared Android shell. The hypothesis and research limits are on page 4.</a:t>
+              <a:t>Observation supplied by the product lead, not production funnel data. Screenshots are the original Ionic Android captures supplied by the user: WhatsApp Image 2026-10-17 at 00.22.33 (1).jpeg (PMS shelf) and 00.22.33 (2).jpeg (US investing shelf). The captured catalogue orders PMS and NFOs before US investing, then baskets, SIFs and mutual funds. Side-by-side crops show different scroll positions, not a measured distance or drop-off. This is a proposed causal explanation to test; no conversion baseline, NPS or uplift is claimed. Research and limitations remain in Appendix 4.</a:t>
             </a:r>
           </a:p>
         </p:txBody>
@@ -516,7 +516,7 @@
           <a:lstStyle xmlns:a="http://schemas.openxmlformats.org/drawingml/2006/main"/>
           <a:p xmlns:a="http://schemas.openxmlformats.org/drawingml/2006/main">
             <a:r>
-              <a:t>All screenshots are from the working proposal. The category tabs and horizontal hero swipe update each other. Private Wealth has a Flagship badge outside and above its tab, with a slow pulse and reduced-motion support. It contains 9 PMS, 3 AIF and 6 SIF offerings. Each product has a working detail link. Stock rows move at 4 CSS pixels per second in opposite directions, with pause, mouse drag and stationary search/filter results. The 392px frame, header and navigation are shared with Portfolio. Product figures are captured fixtures, not live quotes. The stock footer and mutual fund metadata slot now include a blue-flower AI deep dive action. Their heights are unchanged from the previous version. The Private Wealth screenshot now shows the opening welcome. It automatically continues after 3.2 seconds, with immediate Skip and Explore actions. Interaction stops the timer. Keyboard focus is contained during the introduction and restored on exit. Reduced-motion mode is static. The welcome gives a premium visual treatment; it does not grant eligibility or membership. The underlying catalogue still contains all 18 captured offerings.</a:t>
+              <a:t>Screenshots from the current working proposal. All three categories sit below the hero. US stocks show captured prices and daily moves, a two-stock comparison and product details. Funds show captured performance with period labels; details contain investment facts. Historical returns do not predict future returns. Private Wealth screenshot shows the catalogue after the welcome: 9 PMS, 3 AIF and 6 SIF offerings. Figures are fixtures, not live quotes. Desktop uses a 392px presentation frame; real phones fill the viewport without the frame. The two stock rails move at 14 CSS pixels per second, with pause, drag, automatic resumption and reduced-motion support. Welcome animation belongs in Appendix 5, not as the main evidence of product value.</a:t>
             </a:r>
           </a:p>
         </p:txBody>
@@ -773,7 +773,7 @@
           <p:cNvPr id="3" name="Title">
             <a:extLst xmlns:a="http://schemas.openxmlformats.org/drawingml/2006/main">
               <a:ext uri="{FF2B5EF4-FFF2-40B4-BE49-F238E27FC236}">
-                <a16:creationId xmlns:a16="http://schemas.microsoft.com/office/drawing/2014/main" id="{4415DD71-FC3A-4E82-B3E1-4BAB3322AD6F}"/>
+                <a16:creationId xmlns:a16="http://schemas.microsoft.com/office/drawing/2014/main" id="{8F0D01CB-0093-4BB9-929B-B7C62FE6D99E}"/>
               </a:ext>
             </a:extLst>
           </p:cNvPr>
@@ -1002,7 +1002,7 @@
           <p:cNvPr id="2" name="Subtitle">
             <a:extLst xmlns:a="http://schemas.openxmlformats.org/drawingml/2006/main">
               <a:ext uri="{FF2B5EF4-FFF2-40B4-BE49-F238E27FC236}">
-                <a16:creationId xmlns:a16="http://schemas.microsoft.com/office/drawing/2014/main" id="{AF343C79-A591-4655-BC20-4764357494E1}"/>
+                <a16:creationId xmlns:a16="http://schemas.microsoft.com/office/drawing/2014/main" id="{5A0D8B0E-2D27-46DD-A99E-5F2D05D52DDF}"/>
               </a:ext>
             </a:extLst>
           </p:cNvPr>
@@ -1248,7 +1248,7 @@
           <p:cNvPr id="2" name="Section title">
             <a:extLst xmlns:a="http://schemas.openxmlformats.org/drawingml/2006/main">
               <a:ext uri="{FF2B5EF4-FFF2-40B4-BE49-F238E27FC236}">
-                <a16:creationId xmlns:a16="http://schemas.microsoft.com/office/drawing/2014/main" id="{33B2EC1A-6692-480B-B36B-3760D8E725AB}"/>
+                <a16:creationId xmlns:a16="http://schemas.microsoft.com/office/drawing/2014/main" id="{7FC40C09-6634-4D5D-AC26-E5A716291D8E}"/>
               </a:ext>
             </a:extLst>
           </p:cNvPr>
@@ -1494,7 +1494,7 @@
           <p:cNvPr id="3" name="Title">
             <a:extLst xmlns:a="http://schemas.openxmlformats.org/drawingml/2006/main">
               <a:ext uri="{FF2B5EF4-FFF2-40B4-BE49-F238E27FC236}">
-                <a16:creationId xmlns:a16="http://schemas.microsoft.com/office/drawing/2014/main" id="{AB62A23B-E4EA-437F-B27D-BD081B6C8EF4}"/>
+                <a16:creationId xmlns:a16="http://schemas.microsoft.com/office/drawing/2014/main" id="{F49E45F0-4D83-4AB7-8A55-E3CAA5E41394}"/>
               </a:ext>
             </a:extLst>
           </p:cNvPr>
@@ -1723,7 +1723,7 @@
           <p:cNvPr id="2" name="Body">
             <a:extLst xmlns:a="http://schemas.openxmlformats.org/drawingml/2006/main">
               <a:ext uri="{FF2B5EF4-FFF2-40B4-BE49-F238E27FC236}">
-                <a16:creationId xmlns:a16="http://schemas.microsoft.com/office/drawing/2014/main" id="{7F0F3A47-69CF-4FBD-B2BA-661C7040104E}"/>
+                <a16:creationId xmlns:a16="http://schemas.microsoft.com/office/drawing/2014/main" id="{5C8F0491-CDFD-49FA-B78A-88C4F4530996}"/>
               </a:ext>
             </a:extLst>
           </p:cNvPr>
@@ -1969,7 +1969,7 @@
           <p:cNvPr id="4" name="Title">
             <a:extLst xmlns:a="http://schemas.openxmlformats.org/drawingml/2006/main">
               <a:ext uri="{FF2B5EF4-FFF2-40B4-BE49-F238E27FC236}">
-                <a16:creationId xmlns:a16="http://schemas.microsoft.com/office/drawing/2014/main" id="{E8BAFC3D-4A51-41F9-8CB4-7F089617F642}"/>
+                <a16:creationId xmlns:a16="http://schemas.microsoft.com/office/drawing/2014/main" id="{DAC84D37-4C29-48B0-BF33-7384329D447E}"/>
               </a:ext>
             </a:extLst>
           </p:cNvPr>
@@ -2198,7 +2198,7 @@
           <p:cNvPr id="2" name="Left column">
             <a:extLst xmlns:a="http://schemas.openxmlformats.org/drawingml/2006/main">
               <a:ext uri="{FF2B5EF4-FFF2-40B4-BE49-F238E27FC236}">
-                <a16:creationId xmlns:a16="http://schemas.microsoft.com/office/drawing/2014/main" id="{9B4F5FCB-077E-47EF-B7EA-343048CE96CD}"/>
+                <a16:creationId xmlns:a16="http://schemas.microsoft.com/office/drawing/2014/main" id="{8FDDB21C-E7C3-4A9A-924D-0C2784B6F15F}"/>
               </a:ext>
             </a:extLst>
           </p:cNvPr>
@@ -2427,7 +2427,7 @@
           <p:cNvPr id="3" name="Right column">
             <a:extLst xmlns:a="http://schemas.openxmlformats.org/drawingml/2006/main">
               <a:ext uri="{FF2B5EF4-FFF2-40B4-BE49-F238E27FC236}">
-                <a16:creationId xmlns:a16="http://schemas.microsoft.com/office/drawing/2014/main" id="{F1AD2E8F-9250-401E-A0F2-3C2585AB0FAD}"/>
+                <a16:creationId xmlns:a16="http://schemas.microsoft.com/office/drawing/2014/main" id="{DE23CAA2-10DA-4604-8D18-EE2DE514A2CC}"/>
               </a:ext>
             </a:extLst>
           </p:cNvPr>
@@ -2673,7 +2673,7 @@
           <p:cNvPr id="3" name="Title">
             <a:extLst xmlns:a="http://schemas.openxmlformats.org/drawingml/2006/main">
               <a:ext uri="{FF2B5EF4-FFF2-40B4-BE49-F238E27FC236}">
-                <a16:creationId xmlns:a16="http://schemas.microsoft.com/office/drawing/2014/main" id="{03D74E47-1444-43D0-A301-39D60E48DCB8}"/>
+                <a16:creationId xmlns:a16="http://schemas.microsoft.com/office/drawing/2014/main" id="{03EB757C-27C0-4B89-B211-252BD2DD586C}"/>
               </a:ext>
             </a:extLst>
           </p:cNvPr>
@@ -2902,7 +2902,7 @@
           <p:cNvPr id="2" name="Left column">
             <a:extLst xmlns:a="http://schemas.openxmlformats.org/drawingml/2006/main">
               <a:ext uri="{FF2B5EF4-FFF2-40B4-BE49-F238E27FC236}">
-                <a16:creationId xmlns:a16="http://schemas.microsoft.com/office/drawing/2014/main" id="{9D795911-45D5-4126-8979-3D81224E770F}"/>
+                <a16:creationId xmlns:a16="http://schemas.microsoft.com/office/drawing/2014/main" id="{8BBBAB1A-DF56-46D0-96B4-BF535F70ECA9}"/>
               </a:ext>
             </a:extLst>
           </p:cNvPr>
@@ -3169,12 +3169,12 @@
   </p:cSld>
   <p:clrMap bg1="lt1" tx1="dk1" bg2="lt2" tx2="dk2" accent1="accent1" accent2="accent2" accent3="accent3" accent4="accent4" accent5="accent5" accent6="accent6" hlink="hlink" folHlink="folHlink"/>
   <p:sldLayoutIdLst>
-    <p:sldLayoutId xmlns:r="http://schemas.openxmlformats.org/officeDocument/2006/relationships" id="2147483649" r:id="R80abb8fa7ef04bbe"/>
-    <p:sldLayoutId xmlns:r="http://schemas.openxmlformats.org/officeDocument/2006/relationships" id="2147483650" r:id="Rec0e957237d341f8"/>
-    <p:sldLayoutId xmlns:r="http://schemas.openxmlformats.org/officeDocument/2006/relationships" id="2147483651" r:id="R803a4e9d35664556"/>
-    <p:sldLayoutId xmlns:r="http://schemas.openxmlformats.org/officeDocument/2006/relationships" id="2147483652" r:id="R53f4e0e003024da7"/>
-    <p:sldLayoutId xmlns:r="http://schemas.openxmlformats.org/officeDocument/2006/relationships" id="2147483653" r:id="R3d2ce0cd36c943c2"/>
-    <p:sldLayoutId xmlns:r="http://schemas.openxmlformats.org/officeDocument/2006/relationships" id="2147483654" r:id="Rbb51c3a9d72e448c"/>
+    <p:sldLayoutId xmlns:r="http://schemas.openxmlformats.org/officeDocument/2006/relationships" id="2147483649" r:id="Rd60bd51515254dcd"/>
+    <p:sldLayoutId xmlns:r="http://schemas.openxmlformats.org/officeDocument/2006/relationships" id="2147483650" r:id="Rdbd2fae6ca0b4d89"/>
+    <p:sldLayoutId xmlns:r="http://schemas.openxmlformats.org/officeDocument/2006/relationships" id="2147483651" r:id="Rde628fe551d64a9e"/>
+    <p:sldLayoutId xmlns:r="http://schemas.openxmlformats.org/officeDocument/2006/relationships" id="2147483652" r:id="R70e07d47e5fb4785"/>
+    <p:sldLayoutId xmlns:r="http://schemas.openxmlformats.org/officeDocument/2006/relationships" id="2147483653" r:id="Rb56ea58cbc054e50"/>
+    <p:sldLayoutId xmlns:r="http://schemas.openxmlformats.org/officeDocument/2006/relationships" id="2147483654" r:id="R9ea6d29a86354e62"/>
   </p:sldLayoutIdLst>
   <p:txStyles>
     <p:titleStyle>
@@ -3722,10 +3722,10 @@
       </p:grpSpPr>
       <p:sp>
         <p:nvSpPr>
-          <p:cNvPr id="9" name="">
+          <p:cNvPr id="14" name="">
             <a:extLst xmlns:a="http://schemas.openxmlformats.org/drawingml/2006/main">
               <a:ext uri="{FF2B5EF4-FFF2-40B4-BE49-F238E27FC236}">
-                <a16:creationId xmlns:a16="http://schemas.microsoft.com/office/drawing/2014/main" id="{F9279B11-1FB9-455B-AF2E-C0CA94F9D125}"/>
+                <a16:creationId xmlns:a16="http://schemas.microsoft.com/office/drawing/2014/main" id="{3AFEAE17-463A-4729-BD1A-67B8D7654D02}"/>
               </a:ext>
             </a:extLst>
           </p:cNvPr>
@@ -3881,7 +3881,7 @@
           <p:cNvPr id="2" name="">
             <a:extLst xmlns:a="http://schemas.openxmlformats.org/drawingml/2006/main">
               <a:ext uri="{FF2B5EF4-FFF2-40B4-BE49-F238E27FC236}">
-                <a16:creationId xmlns:a16="http://schemas.microsoft.com/office/drawing/2014/main" id="{8BFE8E33-405C-4F33-ACBE-12D68171EF0E}"/>
+                <a16:creationId xmlns:a16="http://schemas.microsoft.com/office/drawing/2014/main" id="{71F9AACF-7927-4152-9201-4BCD2C3CE236}"/>
               </a:ext>
             </a:extLst>
           </p:cNvPr>
@@ -4027,7 +4027,7 @@
                 <a:ea typeface="Arial"/>
                 <a:cs typeface="Arial"/>
               </a:rPr>
-              <a:t>The portfolio review is useful.</a:t>
+              <a:t>The gap is between browsing</a:t>
             </a:r>
           </a:p>
           <a:p xmlns:a="http://schemas.openxmlformats.org/drawingml/2006/main">
@@ -4050,7 +4050,7 @@
                 <a:ea typeface="Arial"/>
                 <a:cs typeface="Arial"/>
               </a:rPr>
-              <a:t>The first purchase needs a clearer path.</a:t>
+              <a:t>and the first investment.</a:t>
             </a:r>
           </a:p>
         </p:txBody>
@@ -4060,7 +4060,7 @@
           <p:cNvPr id="3" name="">
             <a:extLst xmlns:a="http://schemas.openxmlformats.org/drawingml/2006/main">
               <a:ext uri="{FF2B5EF4-FFF2-40B4-BE49-F238E27FC236}">
-                <a16:creationId xmlns:a16="http://schemas.microsoft.com/office/drawing/2014/main" id="{A744D9EB-AD19-4255-8438-2317FF6E6485}"/>
+                <a16:creationId xmlns:a16="http://schemas.microsoft.com/office/drawing/2014/main" id="{704A5092-2CF1-43A1-A140-3E1EC00AD851}"/>
               </a:ext>
             </a:extLst>
           </p:cNvPr>
@@ -4206,7 +4206,7 @@
                 <a:ea typeface="Arial"/>
                 <a:cs typeface="Arial"/>
               </a:rPr>
-              <a:t>What seems to be happening</a:t>
+              <a:t>What we know</a:t>
             </a:r>
           </a:p>
         </p:txBody>
@@ -4216,7 +4216,7 @@
           <p:cNvPr id="4" name="">
             <a:extLst xmlns:a="http://schemas.openxmlformats.org/drawingml/2006/main">
               <a:ext uri="{FF2B5EF4-FFF2-40B4-BE49-F238E27FC236}">
-                <a16:creationId xmlns:a16="http://schemas.microsoft.com/office/drawing/2014/main" id="{27B902D5-2F1C-42F1-8DF2-9A0DF41F397F}"/>
+                <a16:creationId xmlns:a16="http://schemas.microsoft.com/office/drawing/2014/main" id="{14D6399A-9142-490E-89F3-70AACC8DA1AB}"/>
               </a:ext>
             </a:extLst>
           </p:cNvPr>
@@ -4227,475 +4227,7 @@
         </p:nvSpPr>
         <p:spPr>
           <a:xfrm xmlns:a="http://schemas.openxmlformats.org/drawingml/2006/main">
-            <a:off x="590550" y="2533650"/>
-            <a:ext cx="6000750" cy="876300"/>
-          </a:xfrm>
-          <a:prstGeom xmlns:a="http://schemas.openxmlformats.org/drawingml/2006/main" prst="rect">
-            <a:avLst/>
-          </a:prstGeom>
-          <a:noFill xmlns:a="http://schemas.openxmlformats.org/drawingml/2006/main"/>
-          <a:ln xmlns:a="http://schemas.openxmlformats.org/drawingml/2006/main" w="0">
-            <a:noFill/>
-          </a:ln>
-        </p:spPr>
-        <p:txBody>
-          <a:bodyPr xmlns:a="http://schemas.openxmlformats.org/drawingml/2006/main"/>
-          <a:lstStyle xmlns:a="http://schemas.openxmlformats.org/drawingml/2006/main">
-            <a:defPPr>
-              <a:defRPr sz="1800" b="0">
-                <a:solidFill>
-                  <a:srgbClr val="17263E"/>
-                </a:solidFill>
-                <a:latin typeface="Arial"/>
-                <a:ea typeface="Arial"/>
-                <a:cs typeface="Arial"/>
-              </a:defRPr>
-            </a:defPPr>
-            <a:lvl1pPr>
-              <a:defRPr sz="1800" b="0">
-                <a:solidFill>
-                  <a:srgbClr val="17263E"/>
-                </a:solidFill>
-                <a:latin typeface="Arial"/>
-                <a:ea typeface="Arial"/>
-                <a:cs typeface="Arial"/>
-              </a:defRPr>
-            </a:lvl1pPr>
-            <a:lvl2pPr>
-              <a:defRPr sz="1800" b="0">
-                <a:solidFill>
-                  <a:srgbClr val="17263E"/>
-                </a:solidFill>
-                <a:latin typeface="Arial"/>
-                <a:ea typeface="Arial"/>
-                <a:cs typeface="Arial"/>
-              </a:defRPr>
-            </a:lvl2pPr>
-            <a:lvl3pPr>
-              <a:defRPr sz="1800" b="0">
-                <a:solidFill>
-                  <a:srgbClr val="17263E"/>
-                </a:solidFill>
-                <a:latin typeface="Arial"/>
-                <a:ea typeface="Arial"/>
-                <a:cs typeface="Arial"/>
-              </a:defRPr>
-            </a:lvl3pPr>
-            <a:lvl4pPr>
-              <a:defRPr sz="1800" b="0">
-                <a:solidFill>
-                  <a:srgbClr val="17263E"/>
-                </a:solidFill>
-                <a:latin typeface="Arial"/>
-                <a:ea typeface="Arial"/>
-                <a:cs typeface="Arial"/>
-              </a:defRPr>
-            </a:lvl4pPr>
-            <a:lvl5pPr>
-              <a:defRPr sz="1800" b="0">
-                <a:solidFill>
-                  <a:srgbClr val="17263E"/>
-                </a:solidFill>
-                <a:latin typeface="Arial"/>
-                <a:ea typeface="Arial"/>
-                <a:cs typeface="Arial"/>
-              </a:defRPr>
-            </a:lvl5pPr>
-            <a:lvl6pPr>
-              <a:defRPr sz="1800" b="0">
-                <a:solidFill>
-                  <a:srgbClr val="17263E"/>
-                </a:solidFill>
-                <a:latin typeface="Arial"/>
-                <a:ea typeface="Arial"/>
-                <a:cs typeface="Arial"/>
-              </a:defRPr>
-            </a:lvl6pPr>
-            <a:lvl7pPr>
-              <a:defRPr sz="1800" b="0">
-                <a:solidFill>
-                  <a:srgbClr val="17263E"/>
-                </a:solidFill>
-                <a:latin typeface="Arial"/>
-                <a:ea typeface="Arial"/>
-                <a:cs typeface="Arial"/>
-              </a:defRPr>
-            </a:lvl7pPr>
-            <a:lvl8pPr>
-              <a:defRPr sz="1800" b="0">
-                <a:solidFill>
-                  <a:srgbClr val="17263E"/>
-                </a:solidFill>
-                <a:latin typeface="Arial"/>
-                <a:ea typeface="Arial"/>
-                <a:cs typeface="Arial"/>
-              </a:defRPr>
-            </a:lvl8pPr>
-            <a:lvl9pPr>
-              <a:defRPr sz="1800" b="0">
-                <a:solidFill>
-                  <a:srgbClr val="17263E"/>
-                </a:solidFill>
-                <a:latin typeface="Arial"/>
-                <a:ea typeface="Arial"/>
-                <a:cs typeface="Arial"/>
-              </a:defRPr>
-            </a:lvl9pPr>
-          </a:lstStyle>
-          <a:p xmlns:a="http://schemas.openxmlformats.org/drawingml/2006/main">
-            <a:pPr>
-              <a:defRPr sz="1800" b="0">
-                <a:solidFill>
-                  <a:srgbClr val="17263E"/>
-                </a:solidFill>
-                <a:latin typeface="Arial"/>
-                <a:ea typeface="Arial"/>
-                <a:cs typeface="Arial"/>
-              </a:defRPr>
-            </a:pPr>
-            <a:r>
-              <a:rPr sz="1800" b="0">
-                <a:solidFill>
-                  <a:srgbClr val="17263E"/>
-                </a:solidFill>
-                <a:latin typeface="Arial"/>
-                <a:ea typeface="Arial"/>
-                <a:cs typeface="Arial"/>
-              </a:rPr>
-              <a:t>The product lead reports that people import their holdings for insights, but often need guidance before making their first purchase.</a:t>
-            </a:r>
-          </a:p>
-        </p:txBody>
-      </p:sp>
-      <p:sp>
-        <p:nvSpPr>
-          <p:cNvPr id="5" name="">
-            <a:extLst xmlns:a="http://schemas.openxmlformats.org/drawingml/2006/main">
-              <a:ext uri="{FF2B5EF4-FFF2-40B4-BE49-F238E27FC236}">
-                <a16:creationId xmlns:a16="http://schemas.microsoft.com/office/drawing/2014/main" id="{DD1E97F0-FBD4-4338-A2DA-85BFF19E9816}"/>
-              </a:ext>
-            </a:extLst>
-          </p:cNvPr>
-          <p:cNvSpPr>
-            <a:spLocks xmlns:a="http://schemas.openxmlformats.org/drawingml/2006/main" noGrp="1"/>
-          </p:cNvSpPr>
-          <p:nvPr/>
-        </p:nvSpPr>
-        <p:spPr>
-          <a:xfrm xmlns:a="http://schemas.openxmlformats.org/drawingml/2006/main">
-            <a:off x="590550" y="3590925"/>
-            <a:ext cx="6000750" cy="1190625"/>
-          </a:xfrm>
-          <a:prstGeom xmlns:a="http://schemas.openxmlformats.org/drawingml/2006/main" prst="rect">
-            <a:avLst/>
-          </a:prstGeom>
-          <a:noFill xmlns:a="http://schemas.openxmlformats.org/drawingml/2006/main"/>
-          <a:ln xmlns:a="http://schemas.openxmlformats.org/drawingml/2006/main" w="0">
-            <a:noFill/>
-          </a:ln>
-        </p:spPr>
-        <p:txBody>
-          <a:bodyPr xmlns:a="http://schemas.openxmlformats.org/drawingml/2006/main"/>
-          <a:lstStyle xmlns:a="http://schemas.openxmlformats.org/drawingml/2006/main">
-            <a:defPPr>
-              <a:defRPr sz="1800" b="0">
-                <a:solidFill>
-                  <a:srgbClr val="17263E"/>
-                </a:solidFill>
-                <a:latin typeface="Arial"/>
-                <a:ea typeface="Arial"/>
-                <a:cs typeface="Arial"/>
-              </a:defRPr>
-            </a:defPPr>
-            <a:lvl1pPr>
-              <a:defRPr sz="1800" b="0">
-                <a:solidFill>
-                  <a:srgbClr val="17263E"/>
-                </a:solidFill>
-                <a:latin typeface="Arial"/>
-                <a:ea typeface="Arial"/>
-                <a:cs typeface="Arial"/>
-              </a:defRPr>
-            </a:lvl1pPr>
-            <a:lvl2pPr>
-              <a:defRPr sz="1800" b="0">
-                <a:solidFill>
-                  <a:srgbClr val="17263E"/>
-                </a:solidFill>
-                <a:latin typeface="Arial"/>
-                <a:ea typeface="Arial"/>
-                <a:cs typeface="Arial"/>
-              </a:defRPr>
-            </a:lvl2pPr>
-            <a:lvl3pPr>
-              <a:defRPr sz="1800" b="0">
-                <a:solidFill>
-                  <a:srgbClr val="17263E"/>
-                </a:solidFill>
-                <a:latin typeface="Arial"/>
-                <a:ea typeface="Arial"/>
-                <a:cs typeface="Arial"/>
-              </a:defRPr>
-            </a:lvl3pPr>
-            <a:lvl4pPr>
-              <a:defRPr sz="1800" b="0">
-                <a:solidFill>
-                  <a:srgbClr val="17263E"/>
-                </a:solidFill>
-                <a:latin typeface="Arial"/>
-                <a:ea typeface="Arial"/>
-                <a:cs typeface="Arial"/>
-              </a:defRPr>
-            </a:lvl4pPr>
-            <a:lvl5pPr>
-              <a:defRPr sz="1800" b="0">
-                <a:solidFill>
-                  <a:srgbClr val="17263E"/>
-                </a:solidFill>
-                <a:latin typeface="Arial"/>
-                <a:ea typeface="Arial"/>
-                <a:cs typeface="Arial"/>
-              </a:defRPr>
-            </a:lvl5pPr>
-            <a:lvl6pPr>
-              <a:defRPr sz="1800" b="0">
-                <a:solidFill>
-                  <a:srgbClr val="17263E"/>
-                </a:solidFill>
-                <a:latin typeface="Arial"/>
-                <a:ea typeface="Arial"/>
-                <a:cs typeface="Arial"/>
-              </a:defRPr>
-            </a:lvl6pPr>
-            <a:lvl7pPr>
-              <a:defRPr sz="1800" b="0">
-                <a:solidFill>
-                  <a:srgbClr val="17263E"/>
-                </a:solidFill>
-                <a:latin typeface="Arial"/>
-                <a:ea typeface="Arial"/>
-                <a:cs typeface="Arial"/>
-              </a:defRPr>
-            </a:lvl7pPr>
-            <a:lvl8pPr>
-              <a:defRPr sz="1800" b="0">
-                <a:solidFill>
-                  <a:srgbClr val="17263E"/>
-                </a:solidFill>
-                <a:latin typeface="Arial"/>
-                <a:ea typeface="Arial"/>
-                <a:cs typeface="Arial"/>
-              </a:defRPr>
-            </a:lvl8pPr>
-            <a:lvl9pPr>
-              <a:defRPr sz="1800" b="0">
-                <a:solidFill>
-                  <a:srgbClr val="17263E"/>
-                </a:solidFill>
-                <a:latin typeface="Arial"/>
-                <a:ea typeface="Arial"/>
-                <a:cs typeface="Arial"/>
-              </a:defRPr>
-            </a:lvl9pPr>
-          </a:lstStyle>
-          <a:p xmlns:a="http://schemas.openxmlformats.org/drawingml/2006/main">
-            <a:pPr>
-              <a:defRPr sz="1800" b="0">
-                <a:solidFill>
-                  <a:srgbClr val="17263E"/>
-                </a:solidFill>
-                <a:latin typeface="Arial"/>
-                <a:ea typeface="Arial"/>
-                <a:cs typeface="Arial"/>
-              </a:defRPr>
-            </a:pPr>
-            <a:r>
-              <a:rPr sz="1800" b="0">
-                <a:solidFill>
-                  <a:srgbClr val="17263E"/>
-                </a:solidFill>
-                <a:latin typeface="Arial"/>
-                <a:ea typeface="Arial"/>
-                <a:cs typeface="Arial"/>
-              </a:rPr>
-              <a:t>The existing Exclusives page asks them to browse long product shelves before finding an option with a smaller entry amount. They then still have to work out what to buy and how to begin.</a:t>
-            </a:r>
-          </a:p>
-        </p:txBody>
-      </p:sp>
-      <p:sp>
-        <p:nvSpPr>
-          <p:cNvPr id="6" name="">
-            <a:extLst xmlns:a="http://schemas.openxmlformats.org/drawingml/2006/main">
-              <a:ext uri="{FF2B5EF4-FFF2-40B4-BE49-F238E27FC236}">
-                <a16:creationId xmlns:a16="http://schemas.microsoft.com/office/drawing/2014/main" id="{4D04E819-7DE7-4763-9C3C-8D85742329DE}"/>
-              </a:ext>
-            </a:extLst>
-          </p:cNvPr>
-          <p:cNvSpPr>
-            <a:spLocks xmlns:a="http://schemas.openxmlformats.org/drawingml/2006/main" noGrp="1"/>
-          </p:cNvSpPr>
-          <p:nvPr/>
-        </p:nvSpPr>
-        <p:spPr>
-          <a:xfrm xmlns:a="http://schemas.openxmlformats.org/drawingml/2006/main">
-            <a:off x="590550" y="5143500"/>
-            <a:ext cx="6191250" cy="295275"/>
-          </a:xfrm>
-          <a:prstGeom xmlns:a="http://schemas.openxmlformats.org/drawingml/2006/main" prst="rect">
-            <a:avLst/>
-          </a:prstGeom>
-          <a:noFill xmlns:a="http://schemas.openxmlformats.org/drawingml/2006/main"/>
-          <a:ln xmlns:a="http://schemas.openxmlformats.org/drawingml/2006/main" w="0">
-            <a:noFill/>
-          </a:ln>
-        </p:spPr>
-        <p:txBody>
-          <a:bodyPr xmlns:a="http://schemas.openxmlformats.org/drawingml/2006/main"/>
-          <a:lstStyle xmlns:a="http://schemas.openxmlformats.org/drawingml/2006/main">
-            <a:defPPr>
-              <a:defRPr sz="1725" b="1">
-                <a:solidFill>
-                  <a:srgbClr val="28369F"/>
-                </a:solidFill>
-                <a:latin typeface="Arial"/>
-                <a:ea typeface="Arial"/>
-                <a:cs typeface="Arial"/>
-              </a:defRPr>
-            </a:defPPr>
-            <a:lvl1pPr>
-              <a:defRPr sz="1725" b="1">
-                <a:solidFill>
-                  <a:srgbClr val="28369F"/>
-                </a:solidFill>
-                <a:latin typeface="Arial"/>
-                <a:ea typeface="Arial"/>
-                <a:cs typeface="Arial"/>
-              </a:defRPr>
-            </a:lvl1pPr>
-            <a:lvl2pPr>
-              <a:defRPr sz="1725" b="1">
-                <a:solidFill>
-                  <a:srgbClr val="28369F"/>
-                </a:solidFill>
-                <a:latin typeface="Arial"/>
-                <a:ea typeface="Arial"/>
-                <a:cs typeface="Arial"/>
-              </a:defRPr>
-            </a:lvl2pPr>
-            <a:lvl3pPr>
-              <a:defRPr sz="1725" b="1">
-                <a:solidFill>
-                  <a:srgbClr val="28369F"/>
-                </a:solidFill>
-                <a:latin typeface="Arial"/>
-                <a:ea typeface="Arial"/>
-                <a:cs typeface="Arial"/>
-              </a:defRPr>
-            </a:lvl3pPr>
-            <a:lvl4pPr>
-              <a:defRPr sz="1725" b="1">
-                <a:solidFill>
-                  <a:srgbClr val="28369F"/>
-                </a:solidFill>
-                <a:latin typeface="Arial"/>
-                <a:ea typeface="Arial"/>
-                <a:cs typeface="Arial"/>
-              </a:defRPr>
-            </a:lvl4pPr>
-            <a:lvl5pPr>
-              <a:defRPr sz="1725" b="1">
-                <a:solidFill>
-                  <a:srgbClr val="28369F"/>
-                </a:solidFill>
-                <a:latin typeface="Arial"/>
-                <a:ea typeface="Arial"/>
-                <a:cs typeface="Arial"/>
-              </a:defRPr>
-            </a:lvl5pPr>
-            <a:lvl6pPr>
-              <a:defRPr sz="1725" b="1">
-                <a:solidFill>
-                  <a:srgbClr val="28369F"/>
-                </a:solidFill>
-                <a:latin typeface="Arial"/>
-                <a:ea typeface="Arial"/>
-                <a:cs typeface="Arial"/>
-              </a:defRPr>
-            </a:lvl6pPr>
-            <a:lvl7pPr>
-              <a:defRPr sz="1725" b="1">
-                <a:solidFill>
-                  <a:srgbClr val="28369F"/>
-                </a:solidFill>
-                <a:latin typeface="Arial"/>
-                <a:ea typeface="Arial"/>
-                <a:cs typeface="Arial"/>
-              </a:defRPr>
-            </a:lvl7pPr>
-            <a:lvl8pPr>
-              <a:defRPr sz="1725" b="1">
-                <a:solidFill>
-                  <a:srgbClr val="28369F"/>
-                </a:solidFill>
-                <a:latin typeface="Arial"/>
-                <a:ea typeface="Arial"/>
-                <a:cs typeface="Arial"/>
-              </a:defRPr>
-            </a:lvl8pPr>
-            <a:lvl9pPr>
-              <a:defRPr sz="1725" b="1">
-                <a:solidFill>
-                  <a:srgbClr val="28369F"/>
-                </a:solidFill>
-                <a:latin typeface="Arial"/>
-                <a:ea typeface="Arial"/>
-                <a:cs typeface="Arial"/>
-              </a:defRPr>
-            </a:lvl9pPr>
-          </a:lstStyle>
-          <a:p xmlns:a="http://schemas.openxmlformats.org/drawingml/2006/main">
-            <a:pPr>
-              <a:defRPr sz="1725" b="1">
-                <a:solidFill>
-                  <a:srgbClr val="28369F"/>
-                </a:solidFill>
-                <a:latin typeface="Arial"/>
-                <a:ea typeface="Arial"/>
-                <a:cs typeface="Arial"/>
-              </a:defRPr>
-            </a:pPr>
-            <a:r>
-              <a:rPr sz="1725" b="1">
-                <a:solidFill>
-                  <a:srgbClr val="28369F"/>
-                </a:solidFill>
-                <a:latin typeface="Arial"/>
-                <a:ea typeface="Arial"/>
-                <a:cs typeface="Arial"/>
-              </a:rPr>
-              <a:t>Move the first useful choice up</a:t>
-            </a:r>
-          </a:p>
-        </p:txBody>
-      </p:sp>
-      <p:sp>
-        <p:nvSpPr>
-          <p:cNvPr id="7" name="">
-            <a:extLst xmlns:a="http://schemas.openxmlformats.org/drawingml/2006/main">
-              <a:ext uri="{FF2B5EF4-FFF2-40B4-BE49-F238E27FC236}">
-                <a16:creationId xmlns:a16="http://schemas.microsoft.com/office/drawing/2014/main" id="{5D1ED9D3-0B7A-40BE-98AE-FCC21C9CC7A5}"/>
-              </a:ext>
-            </a:extLst>
-          </p:cNvPr>
-          <p:cNvSpPr>
-            <a:spLocks xmlns:a="http://schemas.openxmlformats.org/drawingml/2006/main" noGrp="1"/>
-          </p:cNvSpPr>
-          <p:nvPr/>
-        </p:nvSpPr>
-        <p:spPr>
-          <a:xfrm xmlns:a="http://schemas.openxmlformats.org/drawingml/2006/main">
-            <a:off x="590550" y="5581650"/>
+            <a:off x="590550" y="2514600"/>
             <a:ext cx="6000750" cy="857250"/>
           </a:xfrm>
           <a:prstGeom xmlns:a="http://schemas.openxmlformats.org/drawingml/2006/main" prst="rect">
@@ -4830,17 +4362,641 @@
                 <a:ea typeface="Arial"/>
                 <a:cs typeface="Arial"/>
               </a:rPr>
-              <a:t>Keep the hero. Put US stocks, funds and Private Wealth just below it, with enough product information to make an initial comparison.</a:t>
+              <a:t>The product lead reports that people import their portfolios for insights, but often need guidance before making their first purchase.</a:t>
+            </a:r>
+          </a:p>
+        </p:txBody>
+      </p:sp>
+      <p:sp>
+        <p:nvSpPr>
+          <p:cNvPr id="5" name="">
+            <a:extLst xmlns:a="http://schemas.openxmlformats.org/drawingml/2006/main">
+              <a:ext uri="{FF2B5EF4-FFF2-40B4-BE49-F238E27FC236}">
+                <a16:creationId xmlns:a16="http://schemas.microsoft.com/office/drawing/2014/main" id="{559F7327-C0C4-4B81-A817-9ADFF0354200}"/>
+              </a:ext>
+            </a:extLst>
+          </p:cNvPr>
+          <p:cNvSpPr>
+            <a:spLocks xmlns:a="http://schemas.openxmlformats.org/drawingml/2006/main" noGrp="1"/>
+          </p:cNvSpPr>
+          <p:nvPr/>
+        </p:nvSpPr>
+        <p:spPr>
+          <a:xfrm xmlns:a="http://schemas.openxmlformats.org/drawingml/2006/main">
+            <a:off x="590550" y="3600450"/>
+            <a:ext cx="6191250" cy="304800"/>
+          </a:xfrm>
+          <a:prstGeom xmlns:a="http://schemas.openxmlformats.org/drawingml/2006/main" prst="rect">
+            <a:avLst/>
+          </a:prstGeom>
+          <a:noFill xmlns:a="http://schemas.openxmlformats.org/drawingml/2006/main"/>
+          <a:ln xmlns:a="http://schemas.openxmlformats.org/drawingml/2006/main" w="0">
+            <a:noFill/>
+          </a:ln>
+        </p:spPr>
+        <p:txBody>
+          <a:bodyPr xmlns:a="http://schemas.openxmlformats.org/drawingml/2006/main"/>
+          <a:lstStyle xmlns:a="http://schemas.openxmlformats.org/drawingml/2006/main">
+            <a:defPPr>
+              <a:defRPr sz="1725" b="1">
+                <a:solidFill>
+                  <a:srgbClr val="28369F"/>
+                </a:solidFill>
+                <a:latin typeface="Arial"/>
+                <a:ea typeface="Arial"/>
+                <a:cs typeface="Arial"/>
+              </a:defRPr>
+            </a:defPPr>
+            <a:lvl1pPr>
+              <a:defRPr sz="1725" b="1">
+                <a:solidFill>
+                  <a:srgbClr val="28369F"/>
+                </a:solidFill>
+                <a:latin typeface="Arial"/>
+                <a:ea typeface="Arial"/>
+                <a:cs typeface="Arial"/>
+              </a:defRPr>
+            </a:lvl1pPr>
+            <a:lvl2pPr>
+              <a:defRPr sz="1725" b="1">
+                <a:solidFill>
+                  <a:srgbClr val="28369F"/>
+                </a:solidFill>
+                <a:latin typeface="Arial"/>
+                <a:ea typeface="Arial"/>
+                <a:cs typeface="Arial"/>
+              </a:defRPr>
+            </a:lvl2pPr>
+            <a:lvl3pPr>
+              <a:defRPr sz="1725" b="1">
+                <a:solidFill>
+                  <a:srgbClr val="28369F"/>
+                </a:solidFill>
+                <a:latin typeface="Arial"/>
+                <a:ea typeface="Arial"/>
+                <a:cs typeface="Arial"/>
+              </a:defRPr>
+            </a:lvl3pPr>
+            <a:lvl4pPr>
+              <a:defRPr sz="1725" b="1">
+                <a:solidFill>
+                  <a:srgbClr val="28369F"/>
+                </a:solidFill>
+                <a:latin typeface="Arial"/>
+                <a:ea typeface="Arial"/>
+                <a:cs typeface="Arial"/>
+              </a:defRPr>
+            </a:lvl4pPr>
+            <a:lvl5pPr>
+              <a:defRPr sz="1725" b="1">
+                <a:solidFill>
+                  <a:srgbClr val="28369F"/>
+                </a:solidFill>
+                <a:latin typeface="Arial"/>
+                <a:ea typeface="Arial"/>
+                <a:cs typeface="Arial"/>
+              </a:defRPr>
+            </a:lvl5pPr>
+            <a:lvl6pPr>
+              <a:defRPr sz="1725" b="1">
+                <a:solidFill>
+                  <a:srgbClr val="28369F"/>
+                </a:solidFill>
+                <a:latin typeface="Arial"/>
+                <a:ea typeface="Arial"/>
+                <a:cs typeface="Arial"/>
+              </a:defRPr>
+            </a:lvl6pPr>
+            <a:lvl7pPr>
+              <a:defRPr sz="1725" b="1">
+                <a:solidFill>
+                  <a:srgbClr val="28369F"/>
+                </a:solidFill>
+                <a:latin typeface="Arial"/>
+                <a:ea typeface="Arial"/>
+                <a:cs typeface="Arial"/>
+              </a:defRPr>
+            </a:lvl7pPr>
+            <a:lvl8pPr>
+              <a:defRPr sz="1725" b="1">
+                <a:solidFill>
+                  <a:srgbClr val="28369F"/>
+                </a:solidFill>
+                <a:latin typeface="Arial"/>
+                <a:ea typeface="Arial"/>
+                <a:cs typeface="Arial"/>
+              </a:defRPr>
+            </a:lvl8pPr>
+            <a:lvl9pPr>
+              <a:defRPr sz="1725" b="1">
+                <a:solidFill>
+                  <a:srgbClr val="28369F"/>
+                </a:solidFill>
+                <a:latin typeface="Arial"/>
+                <a:ea typeface="Arial"/>
+                <a:cs typeface="Arial"/>
+              </a:defRPr>
+            </a:lvl9pPr>
+          </a:lstStyle>
+          <a:p xmlns:a="http://schemas.openxmlformats.org/drawingml/2006/main">
+            <a:pPr>
+              <a:defRPr sz="1725" b="1">
+                <a:solidFill>
+                  <a:srgbClr val="28369F"/>
+                </a:solidFill>
+                <a:latin typeface="Arial"/>
+                <a:ea typeface="Arial"/>
+                <a:cs typeface="Arial"/>
+              </a:defRPr>
+            </a:pPr>
+            <a:r>
+              <a:rPr sz="1725" b="1">
+                <a:solidFill>
+                  <a:srgbClr val="28369F"/>
+                </a:solidFill>
+                <a:latin typeface="Arial"/>
+                <a:ea typeface="Arial"/>
+                <a:cs typeface="Arial"/>
+              </a:rPr>
+              <a:t>What the screens suggest</a:t>
+            </a:r>
+          </a:p>
+        </p:txBody>
+      </p:sp>
+      <p:sp>
+        <p:nvSpPr>
+          <p:cNvPr id="6" name="">
+            <a:extLst xmlns:a="http://schemas.openxmlformats.org/drawingml/2006/main">
+              <a:ext uri="{FF2B5EF4-FFF2-40B4-BE49-F238E27FC236}">
+                <a16:creationId xmlns:a16="http://schemas.microsoft.com/office/drawing/2014/main" id="{2F6AC76A-1B3D-46C9-BF93-173A9870238F}"/>
+              </a:ext>
+            </a:extLst>
+          </p:cNvPr>
+          <p:cNvSpPr>
+            <a:spLocks xmlns:a="http://schemas.openxmlformats.org/drawingml/2006/main" noGrp="1"/>
+          </p:cNvSpPr>
+          <p:nvPr/>
+        </p:nvSpPr>
+        <p:spPr>
+          <a:xfrm xmlns:a="http://schemas.openxmlformats.org/drawingml/2006/main">
+            <a:off x="590550" y="4019550"/>
+            <a:ext cx="6000750" cy="1000125"/>
+          </a:xfrm>
+          <a:prstGeom xmlns:a="http://schemas.openxmlformats.org/drawingml/2006/main" prst="rect">
+            <a:avLst/>
+          </a:prstGeom>
+          <a:noFill xmlns:a="http://schemas.openxmlformats.org/drawingml/2006/main"/>
+          <a:ln xmlns:a="http://schemas.openxmlformats.org/drawingml/2006/main" w="0">
+            <a:noFill/>
+          </a:ln>
+        </p:spPr>
+        <p:txBody>
+          <a:bodyPr xmlns:a="http://schemas.openxmlformats.org/drawingml/2006/main"/>
+          <a:lstStyle xmlns:a="http://schemas.openxmlformats.org/drawingml/2006/main">
+            <a:defPPr>
+              <a:defRPr sz="1725" b="0">
+                <a:solidFill>
+                  <a:srgbClr val="17263E"/>
+                </a:solidFill>
+                <a:latin typeface="Arial"/>
+                <a:ea typeface="Arial"/>
+                <a:cs typeface="Arial"/>
+              </a:defRPr>
+            </a:defPPr>
+            <a:lvl1pPr>
+              <a:defRPr sz="1725" b="0">
+                <a:solidFill>
+                  <a:srgbClr val="17263E"/>
+                </a:solidFill>
+                <a:latin typeface="Arial"/>
+                <a:ea typeface="Arial"/>
+                <a:cs typeface="Arial"/>
+              </a:defRPr>
+            </a:lvl1pPr>
+            <a:lvl2pPr>
+              <a:defRPr sz="1725" b="0">
+                <a:solidFill>
+                  <a:srgbClr val="17263E"/>
+                </a:solidFill>
+                <a:latin typeface="Arial"/>
+                <a:ea typeface="Arial"/>
+                <a:cs typeface="Arial"/>
+              </a:defRPr>
+            </a:lvl2pPr>
+            <a:lvl3pPr>
+              <a:defRPr sz="1725" b="0">
+                <a:solidFill>
+                  <a:srgbClr val="17263E"/>
+                </a:solidFill>
+                <a:latin typeface="Arial"/>
+                <a:ea typeface="Arial"/>
+                <a:cs typeface="Arial"/>
+              </a:defRPr>
+            </a:lvl3pPr>
+            <a:lvl4pPr>
+              <a:defRPr sz="1725" b="0">
+                <a:solidFill>
+                  <a:srgbClr val="17263E"/>
+                </a:solidFill>
+                <a:latin typeface="Arial"/>
+                <a:ea typeface="Arial"/>
+                <a:cs typeface="Arial"/>
+              </a:defRPr>
+            </a:lvl4pPr>
+            <a:lvl5pPr>
+              <a:defRPr sz="1725" b="0">
+                <a:solidFill>
+                  <a:srgbClr val="17263E"/>
+                </a:solidFill>
+                <a:latin typeface="Arial"/>
+                <a:ea typeface="Arial"/>
+                <a:cs typeface="Arial"/>
+              </a:defRPr>
+            </a:lvl5pPr>
+            <a:lvl6pPr>
+              <a:defRPr sz="1725" b="0">
+                <a:solidFill>
+                  <a:srgbClr val="17263E"/>
+                </a:solidFill>
+                <a:latin typeface="Arial"/>
+                <a:ea typeface="Arial"/>
+                <a:cs typeface="Arial"/>
+              </a:defRPr>
+            </a:lvl6pPr>
+            <a:lvl7pPr>
+              <a:defRPr sz="1725" b="0">
+                <a:solidFill>
+                  <a:srgbClr val="17263E"/>
+                </a:solidFill>
+                <a:latin typeface="Arial"/>
+                <a:ea typeface="Arial"/>
+                <a:cs typeface="Arial"/>
+              </a:defRPr>
+            </a:lvl7pPr>
+            <a:lvl8pPr>
+              <a:defRPr sz="1725" b="0">
+                <a:solidFill>
+                  <a:srgbClr val="17263E"/>
+                </a:solidFill>
+                <a:latin typeface="Arial"/>
+                <a:ea typeface="Arial"/>
+                <a:cs typeface="Arial"/>
+              </a:defRPr>
+            </a:lvl8pPr>
+            <a:lvl9pPr>
+              <a:defRPr sz="1725" b="0">
+                <a:solidFill>
+                  <a:srgbClr val="17263E"/>
+                </a:solidFill>
+                <a:latin typeface="Arial"/>
+                <a:ea typeface="Arial"/>
+                <a:cs typeface="Arial"/>
+              </a:defRPr>
+            </a:lvl9pPr>
+          </a:lstStyle>
+          <a:p xmlns:a="http://schemas.openxmlformats.org/drawingml/2006/main">
+            <a:pPr>
+              <a:defRPr sz="1725" b="0">
+                <a:solidFill>
+                  <a:srgbClr val="17263E"/>
+                </a:solidFill>
+                <a:latin typeface="Arial"/>
+                <a:ea typeface="Arial"/>
+                <a:cs typeface="Arial"/>
+              </a:defRPr>
+            </a:pPr>
+            <a:r>
+              <a:rPr sz="1725" b="0">
+                <a:solidFill>
+                  <a:srgbClr val="17263E"/>
+                </a:solidFill>
+                <a:latin typeface="Arial"/>
+                <a:ea typeface="Arial"/>
+                <a:cs typeface="Arial"/>
+              </a:rPr>
+              <a:t>Exclusives presents long product shelves. US investing and mutual funds appear later, so users have to keep browsing to find a smaller entry option.</a:t>
+            </a:r>
+          </a:p>
+        </p:txBody>
+      </p:sp>
+      <p:sp>
+        <p:nvSpPr>
+          <p:cNvPr id="7" name="">
+            <a:extLst xmlns:a="http://schemas.openxmlformats.org/drawingml/2006/main">
+              <a:ext uri="{FF2B5EF4-FFF2-40B4-BE49-F238E27FC236}">
+                <a16:creationId xmlns:a16="http://schemas.microsoft.com/office/drawing/2014/main" id="{399C1B99-F3E9-4A1D-A11C-698FA45CD276}"/>
+              </a:ext>
+            </a:extLst>
+          </p:cNvPr>
+          <p:cNvSpPr>
+            <a:spLocks xmlns:a="http://schemas.openxmlformats.org/drawingml/2006/main" noGrp="1"/>
+          </p:cNvSpPr>
+          <p:nvPr/>
+        </p:nvSpPr>
+        <p:spPr>
+          <a:xfrm xmlns:a="http://schemas.openxmlformats.org/drawingml/2006/main">
+            <a:off x="590550" y="5257800"/>
+            <a:ext cx="6191250" cy="285750"/>
+          </a:xfrm>
+          <a:prstGeom xmlns:a="http://schemas.openxmlformats.org/drawingml/2006/main" prst="rect">
+            <a:avLst/>
+          </a:prstGeom>
+          <a:noFill xmlns:a="http://schemas.openxmlformats.org/drawingml/2006/main"/>
+          <a:ln xmlns:a="http://schemas.openxmlformats.org/drawingml/2006/main" w="0">
+            <a:noFill/>
+          </a:ln>
+        </p:spPr>
+        <p:txBody>
+          <a:bodyPr xmlns:a="http://schemas.openxmlformats.org/drawingml/2006/main"/>
+          <a:lstStyle xmlns:a="http://schemas.openxmlformats.org/drawingml/2006/main">
+            <a:defPPr>
+              <a:defRPr sz="1725" b="1">
+                <a:solidFill>
+                  <a:srgbClr val="28369F"/>
+                </a:solidFill>
+                <a:latin typeface="Arial"/>
+                <a:ea typeface="Arial"/>
+                <a:cs typeface="Arial"/>
+              </a:defRPr>
+            </a:defPPr>
+            <a:lvl1pPr>
+              <a:defRPr sz="1725" b="1">
+                <a:solidFill>
+                  <a:srgbClr val="28369F"/>
+                </a:solidFill>
+                <a:latin typeface="Arial"/>
+                <a:ea typeface="Arial"/>
+                <a:cs typeface="Arial"/>
+              </a:defRPr>
+            </a:lvl1pPr>
+            <a:lvl2pPr>
+              <a:defRPr sz="1725" b="1">
+                <a:solidFill>
+                  <a:srgbClr val="28369F"/>
+                </a:solidFill>
+                <a:latin typeface="Arial"/>
+                <a:ea typeface="Arial"/>
+                <a:cs typeface="Arial"/>
+              </a:defRPr>
+            </a:lvl2pPr>
+            <a:lvl3pPr>
+              <a:defRPr sz="1725" b="1">
+                <a:solidFill>
+                  <a:srgbClr val="28369F"/>
+                </a:solidFill>
+                <a:latin typeface="Arial"/>
+                <a:ea typeface="Arial"/>
+                <a:cs typeface="Arial"/>
+              </a:defRPr>
+            </a:lvl3pPr>
+            <a:lvl4pPr>
+              <a:defRPr sz="1725" b="1">
+                <a:solidFill>
+                  <a:srgbClr val="28369F"/>
+                </a:solidFill>
+                <a:latin typeface="Arial"/>
+                <a:ea typeface="Arial"/>
+                <a:cs typeface="Arial"/>
+              </a:defRPr>
+            </a:lvl4pPr>
+            <a:lvl5pPr>
+              <a:defRPr sz="1725" b="1">
+                <a:solidFill>
+                  <a:srgbClr val="28369F"/>
+                </a:solidFill>
+                <a:latin typeface="Arial"/>
+                <a:ea typeface="Arial"/>
+                <a:cs typeface="Arial"/>
+              </a:defRPr>
+            </a:lvl5pPr>
+            <a:lvl6pPr>
+              <a:defRPr sz="1725" b="1">
+                <a:solidFill>
+                  <a:srgbClr val="28369F"/>
+                </a:solidFill>
+                <a:latin typeface="Arial"/>
+                <a:ea typeface="Arial"/>
+                <a:cs typeface="Arial"/>
+              </a:defRPr>
+            </a:lvl6pPr>
+            <a:lvl7pPr>
+              <a:defRPr sz="1725" b="1">
+                <a:solidFill>
+                  <a:srgbClr val="28369F"/>
+                </a:solidFill>
+                <a:latin typeface="Arial"/>
+                <a:ea typeface="Arial"/>
+                <a:cs typeface="Arial"/>
+              </a:defRPr>
+            </a:lvl7pPr>
+            <a:lvl8pPr>
+              <a:defRPr sz="1725" b="1">
+                <a:solidFill>
+                  <a:srgbClr val="28369F"/>
+                </a:solidFill>
+                <a:latin typeface="Arial"/>
+                <a:ea typeface="Arial"/>
+                <a:cs typeface="Arial"/>
+              </a:defRPr>
+            </a:lvl8pPr>
+            <a:lvl9pPr>
+              <a:defRPr sz="1725" b="1">
+                <a:solidFill>
+                  <a:srgbClr val="28369F"/>
+                </a:solidFill>
+                <a:latin typeface="Arial"/>
+                <a:ea typeface="Arial"/>
+                <a:cs typeface="Arial"/>
+              </a:defRPr>
+            </a:lvl9pPr>
+          </a:lstStyle>
+          <a:p xmlns:a="http://schemas.openxmlformats.org/drawingml/2006/main">
+            <a:pPr>
+              <a:defRPr sz="1725" b="1">
+                <a:solidFill>
+                  <a:srgbClr val="28369F"/>
+                </a:solidFill>
+                <a:latin typeface="Arial"/>
+                <a:ea typeface="Arial"/>
+                <a:cs typeface="Arial"/>
+              </a:defRPr>
+            </a:pPr>
+            <a:r>
+              <a:rPr sz="1725" b="1">
+                <a:solidFill>
+                  <a:srgbClr val="28369F"/>
+                </a:solidFill>
+                <a:latin typeface="Arial"/>
+                <a:ea typeface="Arial"/>
+                <a:cs typeface="Arial"/>
+              </a:rPr>
+              <a:t>The hypothesis</a:t>
+            </a:r>
+          </a:p>
+        </p:txBody>
+      </p:sp>
+      <p:sp>
+        <p:nvSpPr>
+          <p:cNvPr id="8" name="">
+            <a:extLst xmlns:a="http://schemas.openxmlformats.org/drawingml/2006/main">
+              <a:ext uri="{FF2B5EF4-FFF2-40B4-BE49-F238E27FC236}">
+                <a16:creationId xmlns:a16="http://schemas.microsoft.com/office/drawing/2014/main" id="{8B293548-EA46-43C7-B973-E7B0ADF826CB}"/>
+              </a:ext>
+            </a:extLst>
+          </p:cNvPr>
+          <p:cNvSpPr>
+            <a:spLocks xmlns:a="http://schemas.openxmlformats.org/drawingml/2006/main" noGrp="1"/>
+          </p:cNvSpPr>
+          <p:nvPr/>
+        </p:nvSpPr>
+        <p:spPr>
+          <a:xfrm xmlns:a="http://schemas.openxmlformats.org/drawingml/2006/main">
+            <a:off x="590550" y="5657850"/>
+            <a:ext cx="6000750" cy="952500"/>
+          </a:xfrm>
+          <a:prstGeom xmlns:a="http://schemas.openxmlformats.org/drawingml/2006/main" prst="rect">
+            <a:avLst/>
+          </a:prstGeom>
+          <a:noFill xmlns:a="http://schemas.openxmlformats.org/drawingml/2006/main"/>
+          <a:ln xmlns:a="http://schemas.openxmlformats.org/drawingml/2006/main" w="0">
+            <a:noFill/>
+          </a:ln>
+        </p:spPr>
+        <p:txBody>
+          <a:bodyPr xmlns:a="http://schemas.openxmlformats.org/drawingml/2006/main"/>
+          <a:lstStyle xmlns:a="http://schemas.openxmlformats.org/drawingml/2006/main">
+            <a:defPPr>
+              <a:defRPr sz="1650" b="0">
+                <a:solidFill>
+                  <a:srgbClr val="17263E"/>
+                </a:solidFill>
+                <a:latin typeface="Arial"/>
+                <a:ea typeface="Arial"/>
+                <a:cs typeface="Arial"/>
+              </a:defRPr>
+            </a:defPPr>
+            <a:lvl1pPr>
+              <a:defRPr sz="1650" b="0">
+                <a:solidFill>
+                  <a:srgbClr val="17263E"/>
+                </a:solidFill>
+                <a:latin typeface="Arial"/>
+                <a:ea typeface="Arial"/>
+                <a:cs typeface="Arial"/>
+              </a:defRPr>
+            </a:lvl1pPr>
+            <a:lvl2pPr>
+              <a:defRPr sz="1650" b="0">
+                <a:solidFill>
+                  <a:srgbClr val="17263E"/>
+                </a:solidFill>
+                <a:latin typeface="Arial"/>
+                <a:ea typeface="Arial"/>
+                <a:cs typeface="Arial"/>
+              </a:defRPr>
+            </a:lvl2pPr>
+            <a:lvl3pPr>
+              <a:defRPr sz="1650" b="0">
+                <a:solidFill>
+                  <a:srgbClr val="17263E"/>
+                </a:solidFill>
+                <a:latin typeface="Arial"/>
+                <a:ea typeface="Arial"/>
+                <a:cs typeface="Arial"/>
+              </a:defRPr>
+            </a:lvl3pPr>
+            <a:lvl4pPr>
+              <a:defRPr sz="1650" b="0">
+                <a:solidFill>
+                  <a:srgbClr val="17263E"/>
+                </a:solidFill>
+                <a:latin typeface="Arial"/>
+                <a:ea typeface="Arial"/>
+                <a:cs typeface="Arial"/>
+              </a:defRPr>
+            </a:lvl4pPr>
+            <a:lvl5pPr>
+              <a:defRPr sz="1650" b="0">
+                <a:solidFill>
+                  <a:srgbClr val="17263E"/>
+                </a:solidFill>
+                <a:latin typeface="Arial"/>
+                <a:ea typeface="Arial"/>
+                <a:cs typeface="Arial"/>
+              </a:defRPr>
+            </a:lvl5pPr>
+            <a:lvl6pPr>
+              <a:defRPr sz="1650" b="0">
+                <a:solidFill>
+                  <a:srgbClr val="17263E"/>
+                </a:solidFill>
+                <a:latin typeface="Arial"/>
+                <a:ea typeface="Arial"/>
+                <a:cs typeface="Arial"/>
+              </a:defRPr>
+            </a:lvl6pPr>
+            <a:lvl7pPr>
+              <a:defRPr sz="1650" b="0">
+                <a:solidFill>
+                  <a:srgbClr val="17263E"/>
+                </a:solidFill>
+                <a:latin typeface="Arial"/>
+                <a:ea typeface="Arial"/>
+                <a:cs typeface="Arial"/>
+              </a:defRPr>
+            </a:lvl7pPr>
+            <a:lvl8pPr>
+              <a:defRPr sz="1650" b="0">
+                <a:solidFill>
+                  <a:srgbClr val="17263E"/>
+                </a:solidFill>
+                <a:latin typeface="Arial"/>
+                <a:ea typeface="Arial"/>
+                <a:cs typeface="Arial"/>
+              </a:defRPr>
+            </a:lvl8pPr>
+            <a:lvl9pPr>
+              <a:defRPr sz="1650" b="0">
+                <a:solidFill>
+                  <a:srgbClr val="17263E"/>
+                </a:solidFill>
+                <a:latin typeface="Arial"/>
+                <a:ea typeface="Arial"/>
+                <a:cs typeface="Arial"/>
+              </a:defRPr>
+            </a:lvl9pPr>
+          </a:lstStyle>
+          <a:p xmlns:a="http://schemas.openxmlformats.org/drawingml/2006/main">
+            <a:pPr>
+              <a:defRPr sz="1650" b="0">
+                <a:solidFill>
+                  <a:srgbClr val="17263E"/>
+                </a:solidFill>
+                <a:latin typeface="Arial"/>
+                <a:ea typeface="Arial"/>
+                <a:cs typeface="Arial"/>
+              </a:defRPr>
+            </a:pPr>
+            <a:r>
+              <a:rPr sz="1650" b="0">
+                <a:solidFill>
+                  <a:srgbClr val="17263E"/>
+                </a:solidFill>
+                <a:latin typeface="Arial"/>
+                <a:ea typeface="Arial"/>
+                <a:cs typeface="Arial"/>
+              </a:rPr>
+              <a:t>Bring accessible products forward, with comparable facts and clear next steps. More users may then make a first investment without assisted guidance.</a:t>
             </a:r>
           </a:p>
         </p:txBody>
       </p:sp>
       <p:pic>
         <p:nvPicPr>
-          <p:cNvPr id="8" name="">
+          <p:cNvPr id="9" name="">
             <a:extLst xmlns:a="http://schemas.openxmlformats.org/drawingml/2006/main">
               <a:ext uri="{FF2B5EF4-FFF2-40B4-BE49-F238E27FC236}">
-                <a16:creationId xmlns:a16="http://schemas.microsoft.com/office/drawing/2014/main" id="{27034AB6-3FEC-4C93-8CC7-1F0D861D49BE}"/>
+                <a16:creationId xmlns:a16="http://schemas.microsoft.com/office/drawing/2014/main" id="{FDD82FFB-15DC-4173-B0D9-33BA15D4B337}"/>
               </a:ext>
             </a:extLst>
           </p:cNvPr>
@@ -4850,23 +5006,519 @@
           <p:nvPr/>
         </p:nvPicPr>
         <p:blipFill>
-          <a:blip xmlns:r="http://schemas.openxmlformats.org/officeDocument/2006/relationships" xmlns:a="http://schemas.openxmlformats.org/drawingml/2006/main" r:embed="Rfab6fd9b16ee42ab"/>
+          <a:blip xmlns:r="http://schemas.openxmlformats.org/officeDocument/2006/relationships" xmlns:a="http://schemas.openxmlformats.org/drawingml/2006/main" r:embed="Rb75e1b94ca934072"/>
           <a:stretch xmlns:a="http://schemas.openxmlformats.org/drawingml/2006/main"/>
         </p:blipFill>
         <p:spPr>
           <a:xfrm xmlns:a="http://schemas.openxmlformats.org/drawingml/2006/main">
-            <a:off x="8305800" y="1745796"/>
-            <a:ext cx="1933575" cy="4537982"/>
+            <a:off x="7419975" y="1994326"/>
+            <a:ext cx="1714500" cy="3717073"/>
           </a:xfrm>
           <a:prstGeom xmlns:a="http://schemas.openxmlformats.org/drawingml/2006/main" prst="rect">
             <a:avLst/>
           </a:prstGeom>
         </p:spPr>
       </p:pic>
+      <p:pic>
+        <p:nvPicPr>
+          <p:cNvPr id="10" name="">
+            <a:extLst xmlns:a="http://schemas.openxmlformats.org/drawingml/2006/main">
+              <a:ext uri="{FF2B5EF4-FFF2-40B4-BE49-F238E27FC236}">
+                <a16:creationId xmlns:a16="http://schemas.microsoft.com/office/drawing/2014/main" id="{F47C3E6B-66C4-44AA-B7B0-764B3B4849FC}"/>
+              </a:ext>
+            </a:extLst>
+          </p:cNvPr>
+          <p:cNvPicPr>
+            <a:picLocks xmlns:a="http://schemas.openxmlformats.org/drawingml/2006/main" noChangeAspect="1"/>
+          </p:cNvPicPr>
+          <p:nvPr/>
+        </p:nvPicPr>
+        <p:blipFill>
+          <a:blip xmlns:r="http://schemas.openxmlformats.org/officeDocument/2006/relationships" xmlns:a="http://schemas.openxmlformats.org/drawingml/2006/main" r:embed="Rd852c926e53c430a"/>
+          <a:stretch xmlns:a="http://schemas.openxmlformats.org/drawingml/2006/main"/>
+        </p:blipFill>
+        <p:spPr>
+          <a:xfrm xmlns:a="http://schemas.openxmlformats.org/drawingml/2006/main">
+            <a:off x="9839325" y="1994326"/>
+            <a:ext cx="1714500" cy="3717073"/>
+          </a:xfrm>
+          <a:prstGeom xmlns:a="http://schemas.openxmlformats.org/drawingml/2006/main" prst="rect">
+            <a:avLst/>
+          </a:prstGeom>
+        </p:spPr>
+      </p:pic>
+      <p:sp>
+        <p:nvSpPr>
+          <p:cNvPr id="11" name="">
+            <a:extLst xmlns:a="http://schemas.openxmlformats.org/drawingml/2006/main">
+              <a:ext uri="{FF2B5EF4-FFF2-40B4-BE49-F238E27FC236}">
+                <a16:creationId xmlns:a16="http://schemas.microsoft.com/office/drawing/2014/main" id="{F212BA24-FF81-4A3F-BDE8-E162E7AE35A7}"/>
+              </a:ext>
+            </a:extLst>
+          </p:cNvPr>
+          <p:cNvSpPr>
+            <a:spLocks xmlns:a="http://schemas.openxmlformats.org/drawingml/2006/main" noGrp="1"/>
+          </p:cNvSpPr>
+          <p:nvPr/>
+        </p:nvSpPr>
+        <p:spPr>
+          <a:xfrm xmlns:a="http://schemas.openxmlformats.org/drawingml/2006/main">
+            <a:off x="7419975" y="5886450"/>
+            <a:ext cx="1809750" cy="247650"/>
+          </a:xfrm>
+          <a:prstGeom xmlns:a="http://schemas.openxmlformats.org/drawingml/2006/main" prst="rect">
+            <a:avLst/>
+          </a:prstGeom>
+          <a:noFill xmlns:a="http://schemas.openxmlformats.org/drawingml/2006/main"/>
+          <a:ln xmlns:a="http://schemas.openxmlformats.org/drawingml/2006/main" w="0">
+            <a:noFill/>
+          </a:ln>
+        </p:spPr>
+        <p:txBody>
+          <a:bodyPr xmlns:a="http://schemas.openxmlformats.org/drawingml/2006/main"/>
+          <a:lstStyle xmlns:a="http://schemas.openxmlformats.org/drawingml/2006/main">
+            <a:defPPr>
+              <a:defRPr sz="1350" b="1">
+                <a:solidFill>
+                  <a:srgbClr val="28369F"/>
+                </a:solidFill>
+                <a:latin typeface="Arial"/>
+                <a:ea typeface="Arial"/>
+                <a:cs typeface="Arial"/>
+              </a:defRPr>
+            </a:defPPr>
+            <a:lvl1pPr>
+              <a:defRPr sz="1350" b="1">
+                <a:solidFill>
+                  <a:srgbClr val="28369F"/>
+                </a:solidFill>
+                <a:latin typeface="Arial"/>
+                <a:ea typeface="Arial"/>
+                <a:cs typeface="Arial"/>
+              </a:defRPr>
+            </a:lvl1pPr>
+            <a:lvl2pPr>
+              <a:defRPr sz="1350" b="1">
+                <a:solidFill>
+                  <a:srgbClr val="28369F"/>
+                </a:solidFill>
+                <a:latin typeface="Arial"/>
+                <a:ea typeface="Arial"/>
+                <a:cs typeface="Arial"/>
+              </a:defRPr>
+            </a:lvl2pPr>
+            <a:lvl3pPr>
+              <a:defRPr sz="1350" b="1">
+                <a:solidFill>
+                  <a:srgbClr val="28369F"/>
+                </a:solidFill>
+                <a:latin typeface="Arial"/>
+                <a:ea typeface="Arial"/>
+                <a:cs typeface="Arial"/>
+              </a:defRPr>
+            </a:lvl3pPr>
+            <a:lvl4pPr>
+              <a:defRPr sz="1350" b="1">
+                <a:solidFill>
+                  <a:srgbClr val="28369F"/>
+                </a:solidFill>
+                <a:latin typeface="Arial"/>
+                <a:ea typeface="Arial"/>
+                <a:cs typeface="Arial"/>
+              </a:defRPr>
+            </a:lvl4pPr>
+            <a:lvl5pPr>
+              <a:defRPr sz="1350" b="1">
+                <a:solidFill>
+                  <a:srgbClr val="28369F"/>
+                </a:solidFill>
+                <a:latin typeface="Arial"/>
+                <a:ea typeface="Arial"/>
+                <a:cs typeface="Arial"/>
+              </a:defRPr>
+            </a:lvl5pPr>
+            <a:lvl6pPr>
+              <a:defRPr sz="1350" b="1">
+                <a:solidFill>
+                  <a:srgbClr val="28369F"/>
+                </a:solidFill>
+                <a:latin typeface="Arial"/>
+                <a:ea typeface="Arial"/>
+                <a:cs typeface="Arial"/>
+              </a:defRPr>
+            </a:lvl6pPr>
+            <a:lvl7pPr>
+              <a:defRPr sz="1350" b="1">
+                <a:solidFill>
+                  <a:srgbClr val="28369F"/>
+                </a:solidFill>
+                <a:latin typeface="Arial"/>
+                <a:ea typeface="Arial"/>
+                <a:cs typeface="Arial"/>
+              </a:defRPr>
+            </a:lvl7pPr>
+            <a:lvl8pPr>
+              <a:defRPr sz="1350" b="1">
+                <a:solidFill>
+                  <a:srgbClr val="28369F"/>
+                </a:solidFill>
+                <a:latin typeface="Arial"/>
+                <a:ea typeface="Arial"/>
+                <a:cs typeface="Arial"/>
+              </a:defRPr>
+            </a:lvl8pPr>
+            <a:lvl9pPr>
+              <a:defRPr sz="1350" b="1">
+                <a:solidFill>
+                  <a:srgbClr val="28369F"/>
+                </a:solidFill>
+                <a:latin typeface="Arial"/>
+                <a:ea typeface="Arial"/>
+                <a:cs typeface="Arial"/>
+              </a:defRPr>
+            </a:lvl9pPr>
+          </a:lstStyle>
+          <a:p xmlns:a="http://schemas.openxmlformats.org/drawingml/2006/main">
+            <a:pPr>
+              <a:defRPr sz="1350" b="1">
+                <a:solidFill>
+                  <a:srgbClr val="28369F"/>
+                </a:solidFill>
+                <a:latin typeface="Arial"/>
+                <a:ea typeface="Arial"/>
+                <a:cs typeface="Arial"/>
+              </a:defRPr>
+            </a:pPr>
+            <a:r>
+              <a:rPr sz="1350" b="1">
+                <a:solidFill>
+                  <a:srgbClr val="28369F"/>
+                </a:solidFill>
+                <a:latin typeface="Arial"/>
+                <a:ea typeface="Arial"/>
+                <a:cs typeface="Arial"/>
+              </a:rPr>
+              <a:t>PMS shelf</a:t>
+            </a:r>
+          </a:p>
+        </p:txBody>
+      </p:sp>
+      <p:sp>
+        <p:nvSpPr>
+          <p:cNvPr id="12" name="">
+            <a:extLst xmlns:a="http://schemas.openxmlformats.org/drawingml/2006/main">
+              <a:ext uri="{FF2B5EF4-FFF2-40B4-BE49-F238E27FC236}">
+                <a16:creationId xmlns:a16="http://schemas.microsoft.com/office/drawing/2014/main" id="{F47CACF0-24D6-4B29-91C6-B392F32F8D84}"/>
+              </a:ext>
+            </a:extLst>
+          </p:cNvPr>
+          <p:cNvSpPr>
+            <a:spLocks xmlns:a="http://schemas.openxmlformats.org/drawingml/2006/main" noGrp="1"/>
+          </p:cNvSpPr>
+          <p:nvPr/>
+        </p:nvSpPr>
+        <p:spPr>
+          <a:xfrm xmlns:a="http://schemas.openxmlformats.org/drawingml/2006/main">
+            <a:off x="9839325" y="5886450"/>
+            <a:ext cx="1905000" cy="247650"/>
+          </a:xfrm>
+          <a:prstGeom xmlns:a="http://schemas.openxmlformats.org/drawingml/2006/main" prst="rect">
+            <a:avLst/>
+          </a:prstGeom>
+          <a:noFill xmlns:a="http://schemas.openxmlformats.org/drawingml/2006/main"/>
+          <a:ln xmlns:a="http://schemas.openxmlformats.org/drawingml/2006/main" w="0">
+            <a:noFill/>
+          </a:ln>
+        </p:spPr>
+        <p:txBody>
+          <a:bodyPr xmlns:a="http://schemas.openxmlformats.org/drawingml/2006/main"/>
+          <a:lstStyle xmlns:a="http://schemas.openxmlformats.org/drawingml/2006/main">
+            <a:defPPr>
+              <a:defRPr sz="1350" b="1">
+                <a:solidFill>
+                  <a:srgbClr val="28369F"/>
+                </a:solidFill>
+                <a:latin typeface="Arial"/>
+                <a:ea typeface="Arial"/>
+                <a:cs typeface="Arial"/>
+              </a:defRPr>
+            </a:defPPr>
+            <a:lvl1pPr>
+              <a:defRPr sz="1350" b="1">
+                <a:solidFill>
+                  <a:srgbClr val="28369F"/>
+                </a:solidFill>
+                <a:latin typeface="Arial"/>
+                <a:ea typeface="Arial"/>
+                <a:cs typeface="Arial"/>
+              </a:defRPr>
+            </a:lvl1pPr>
+            <a:lvl2pPr>
+              <a:defRPr sz="1350" b="1">
+                <a:solidFill>
+                  <a:srgbClr val="28369F"/>
+                </a:solidFill>
+                <a:latin typeface="Arial"/>
+                <a:ea typeface="Arial"/>
+                <a:cs typeface="Arial"/>
+              </a:defRPr>
+            </a:lvl2pPr>
+            <a:lvl3pPr>
+              <a:defRPr sz="1350" b="1">
+                <a:solidFill>
+                  <a:srgbClr val="28369F"/>
+                </a:solidFill>
+                <a:latin typeface="Arial"/>
+                <a:ea typeface="Arial"/>
+                <a:cs typeface="Arial"/>
+              </a:defRPr>
+            </a:lvl3pPr>
+            <a:lvl4pPr>
+              <a:defRPr sz="1350" b="1">
+                <a:solidFill>
+                  <a:srgbClr val="28369F"/>
+                </a:solidFill>
+                <a:latin typeface="Arial"/>
+                <a:ea typeface="Arial"/>
+                <a:cs typeface="Arial"/>
+              </a:defRPr>
+            </a:lvl4pPr>
+            <a:lvl5pPr>
+              <a:defRPr sz="1350" b="1">
+                <a:solidFill>
+                  <a:srgbClr val="28369F"/>
+                </a:solidFill>
+                <a:latin typeface="Arial"/>
+                <a:ea typeface="Arial"/>
+                <a:cs typeface="Arial"/>
+              </a:defRPr>
+            </a:lvl5pPr>
+            <a:lvl6pPr>
+              <a:defRPr sz="1350" b="1">
+                <a:solidFill>
+                  <a:srgbClr val="28369F"/>
+                </a:solidFill>
+                <a:latin typeface="Arial"/>
+                <a:ea typeface="Arial"/>
+                <a:cs typeface="Arial"/>
+              </a:defRPr>
+            </a:lvl6pPr>
+            <a:lvl7pPr>
+              <a:defRPr sz="1350" b="1">
+                <a:solidFill>
+                  <a:srgbClr val="28369F"/>
+                </a:solidFill>
+                <a:latin typeface="Arial"/>
+                <a:ea typeface="Arial"/>
+                <a:cs typeface="Arial"/>
+              </a:defRPr>
+            </a:lvl7pPr>
+            <a:lvl8pPr>
+              <a:defRPr sz="1350" b="1">
+                <a:solidFill>
+                  <a:srgbClr val="28369F"/>
+                </a:solidFill>
+                <a:latin typeface="Arial"/>
+                <a:ea typeface="Arial"/>
+                <a:cs typeface="Arial"/>
+              </a:defRPr>
+            </a:lvl8pPr>
+            <a:lvl9pPr>
+              <a:defRPr sz="1350" b="1">
+                <a:solidFill>
+                  <a:srgbClr val="28369F"/>
+                </a:solidFill>
+                <a:latin typeface="Arial"/>
+                <a:ea typeface="Arial"/>
+                <a:cs typeface="Arial"/>
+              </a:defRPr>
+            </a:lvl9pPr>
+          </a:lstStyle>
+          <a:p xmlns:a="http://schemas.openxmlformats.org/drawingml/2006/main">
+            <a:pPr>
+              <a:defRPr sz="1350" b="1">
+                <a:solidFill>
+                  <a:srgbClr val="28369F"/>
+                </a:solidFill>
+                <a:latin typeface="Arial"/>
+                <a:ea typeface="Arial"/>
+                <a:cs typeface="Arial"/>
+              </a:defRPr>
+            </a:pPr>
+            <a:r>
+              <a:rPr sz="1350" b="1">
+                <a:solidFill>
+                  <a:srgbClr val="28369F"/>
+                </a:solidFill>
+                <a:latin typeface="Arial"/>
+                <a:ea typeface="Arial"/>
+                <a:cs typeface="Arial"/>
+              </a:rPr>
+              <a:t>US investing, later</a:t>
+            </a:r>
+          </a:p>
+        </p:txBody>
+      </p:sp>
+      <p:sp>
+        <p:nvSpPr>
+          <p:cNvPr id="13" name="">
+            <a:extLst xmlns:a="http://schemas.openxmlformats.org/drawingml/2006/main">
+              <a:ext uri="{FF2B5EF4-FFF2-40B4-BE49-F238E27FC236}">
+                <a16:creationId xmlns:a16="http://schemas.microsoft.com/office/drawing/2014/main" id="{D7086C1F-4014-4A84-8CD2-3BC9B710A83A}"/>
+              </a:ext>
+            </a:extLst>
+          </p:cNvPr>
+          <p:cNvSpPr>
+            <a:spLocks xmlns:a="http://schemas.openxmlformats.org/drawingml/2006/main" noGrp="1"/>
+          </p:cNvSpPr>
+          <p:nvPr/>
+        </p:nvSpPr>
+        <p:spPr>
+          <a:xfrm xmlns:a="http://schemas.openxmlformats.org/drawingml/2006/main">
+            <a:off x="7419975" y="6276975"/>
+            <a:ext cx="4286250" cy="381000"/>
+          </a:xfrm>
+          <a:prstGeom xmlns:a="http://schemas.openxmlformats.org/drawingml/2006/main" prst="rect">
+            <a:avLst/>
+          </a:prstGeom>
+          <a:noFill xmlns:a="http://schemas.openxmlformats.org/drawingml/2006/main"/>
+          <a:ln xmlns:a="http://schemas.openxmlformats.org/drawingml/2006/main" w="0">
+            <a:noFill/>
+          </a:ln>
+        </p:spPr>
+        <p:txBody>
+          <a:bodyPr xmlns:a="http://schemas.openxmlformats.org/drawingml/2006/main"/>
+          <a:lstStyle xmlns:a="http://schemas.openxmlformats.org/drawingml/2006/main">
+            <a:defPPr>
+              <a:defRPr sz="1050" b="0">
+                <a:solidFill>
+                  <a:srgbClr val="58677E"/>
+                </a:solidFill>
+                <a:latin typeface="Arial"/>
+                <a:ea typeface="Arial"/>
+                <a:cs typeface="Arial"/>
+              </a:defRPr>
+            </a:defPPr>
+            <a:lvl1pPr>
+              <a:defRPr sz="1050" b="0">
+                <a:solidFill>
+                  <a:srgbClr val="58677E"/>
+                </a:solidFill>
+                <a:latin typeface="Arial"/>
+                <a:ea typeface="Arial"/>
+                <a:cs typeface="Arial"/>
+              </a:defRPr>
+            </a:lvl1pPr>
+            <a:lvl2pPr>
+              <a:defRPr sz="1050" b="0">
+                <a:solidFill>
+                  <a:srgbClr val="58677E"/>
+                </a:solidFill>
+                <a:latin typeface="Arial"/>
+                <a:ea typeface="Arial"/>
+                <a:cs typeface="Arial"/>
+              </a:defRPr>
+            </a:lvl2pPr>
+            <a:lvl3pPr>
+              <a:defRPr sz="1050" b="0">
+                <a:solidFill>
+                  <a:srgbClr val="58677E"/>
+                </a:solidFill>
+                <a:latin typeface="Arial"/>
+                <a:ea typeface="Arial"/>
+                <a:cs typeface="Arial"/>
+              </a:defRPr>
+            </a:lvl3pPr>
+            <a:lvl4pPr>
+              <a:defRPr sz="1050" b="0">
+                <a:solidFill>
+                  <a:srgbClr val="58677E"/>
+                </a:solidFill>
+                <a:latin typeface="Arial"/>
+                <a:ea typeface="Arial"/>
+                <a:cs typeface="Arial"/>
+              </a:defRPr>
+            </a:lvl4pPr>
+            <a:lvl5pPr>
+              <a:defRPr sz="1050" b="0">
+                <a:solidFill>
+                  <a:srgbClr val="58677E"/>
+                </a:solidFill>
+                <a:latin typeface="Arial"/>
+                <a:ea typeface="Arial"/>
+                <a:cs typeface="Arial"/>
+              </a:defRPr>
+            </a:lvl5pPr>
+            <a:lvl6pPr>
+              <a:defRPr sz="1050" b="0">
+                <a:solidFill>
+                  <a:srgbClr val="58677E"/>
+                </a:solidFill>
+                <a:latin typeface="Arial"/>
+                <a:ea typeface="Arial"/>
+                <a:cs typeface="Arial"/>
+              </a:defRPr>
+            </a:lvl6pPr>
+            <a:lvl7pPr>
+              <a:defRPr sz="1050" b="0">
+                <a:solidFill>
+                  <a:srgbClr val="58677E"/>
+                </a:solidFill>
+                <a:latin typeface="Arial"/>
+                <a:ea typeface="Arial"/>
+                <a:cs typeface="Arial"/>
+              </a:defRPr>
+            </a:lvl7pPr>
+            <a:lvl8pPr>
+              <a:defRPr sz="1050" b="0">
+                <a:solidFill>
+                  <a:srgbClr val="58677E"/>
+                </a:solidFill>
+                <a:latin typeface="Arial"/>
+                <a:ea typeface="Arial"/>
+                <a:cs typeface="Arial"/>
+              </a:defRPr>
+            </a:lvl8pPr>
+            <a:lvl9pPr>
+              <a:defRPr sz="1050" b="0">
+                <a:solidFill>
+                  <a:srgbClr val="58677E"/>
+                </a:solidFill>
+                <a:latin typeface="Arial"/>
+                <a:ea typeface="Arial"/>
+                <a:cs typeface="Arial"/>
+              </a:defRPr>
+            </a:lvl9pPr>
+          </a:lstStyle>
+          <a:p xmlns:a="http://schemas.openxmlformats.org/drawingml/2006/main">
+            <a:pPr>
+              <a:defRPr sz="1050" b="0">
+                <a:solidFill>
+                  <a:srgbClr val="58677E"/>
+                </a:solidFill>
+                <a:latin typeface="Arial"/>
+                <a:ea typeface="Arial"/>
+                <a:cs typeface="Arial"/>
+              </a:defRPr>
+            </a:pPr>
+            <a:r>
+              <a:rPr sz="1050" b="0">
+                <a:solidFill>
+                  <a:srgbClr val="58677E"/>
+                </a:solidFill>
+                <a:latin typeface="Arial"/>
+                <a:ea typeface="Arial"/>
+                <a:cs typeface="Arial"/>
+              </a:rPr>
+              <a:t>Original app captures. Scroll drop-off has not been measured.</a:t>
+            </a:r>
+          </a:p>
+        </p:txBody>
+      </p:sp>
     </p:spTree>
     <p:extLst>
       <p:ext uri="{BB962C8B-B14F-4D97-AF65-F5344CB8AC3E}">
-        <p14:creationId xmlns:p14="http://schemas.microsoft.com/office/powerpoint/2010/main" val="619085916"/>
+        <p14:creationId xmlns:p14="http://schemas.microsoft.com/office/powerpoint/2010/main" val="766107474"/>
       </p:ext>
     </p:extLst>
   </p:cSld>
@@ -4897,7 +5549,7 @@
           <p:cNvPr id="12" name="">
             <a:extLst xmlns:a="http://schemas.openxmlformats.org/drawingml/2006/main">
               <a:ext uri="{FF2B5EF4-FFF2-40B4-BE49-F238E27FC236}">
-                <a16:creationId xmlns:a16="http://schemas.microsoft.com/office/drawing/2014/main" id="{C21122AC-037F-44DB-B639-64BEB0FD07F1}"/>
+                <a16:creationId xmlns:a16="http://schemas.microsoft.com/office/drawing/2014/main" id="{61D76DE8-3324-4134-97D8-D2142EA80294}"/>
               </a:ext>
             </a:extLst>
           </p:cNvPr>
@@ -5053,7 +5705,7 @@
           <p:cNvPr id="2" name="">
             <a:extLst xmlns:a="http://schemas.openxmlformats.org/drawingml/2006/main">
               <a:ext uri="{FF2B5EF4-FFF2-40B4-BE49-F238E27FC236}">
-                <a16:creationId xmlns:a16="http://schemas.microsoft.com/office/drawing/2014/main" id="{F16C377A-29C7-4E23-B370-B242404D1FE6}"/>
+                <a16:creationId xmlns:a16="http://schemas.microsoft.com/office/drawing/2014/main" id="{3A5762D3-A7CC-4057-8D11-359322AB24B9}"/>
               </a:ext>
             </a:extLst>
           </p:cNvPr>
@@ -5209,7 +5861,7 @@
           <p:cNvPr id="3" name="">
             <a:extLst xmlns:a="http://schemas.openxmlformats.org/drawingml/2006/main">
               <a:ext uri="{FF2B5EF4-FFF2-40B4-BE49-F238E27FC236}">
-                <a16:creationId xmlns:a16="http://schemas.microsoft.com/office/drawing/2014/main" id="{618C9BD2-D6AC-4A5B-A5E5-248CE7264028}"/>
+                <a16:creationId xmlns:a16="http://schemas.microsoft.com/office/drawing/2014/main" id="{69AB8053-9415-4973-87C9-EF085EC741C2}"/>
               </a:ext>
             </a:extLst>
           </p:cNvPr>
@@ -5219,13 +5871,13 @@
           <p:nvPr/>
         </p:nvPicPr>
         <p:blipFill>
-          <a:blip xmlns:r="http://schemas.openxmlformats.org/officeDocument/2006/relationships" xmlns:a="http://schemas.openxmlformats.org/drawingml/2006/main" r:embed="R47a4558ae2b444ba"/>
+          <a:blip xmlns:r="http://schemas.openxmlformats.org/officeDocument/2006/relationships" xmlns:a="http://schemas.openxmlformats.org/drawingml/2006/main" r:embed="Rd2f45ab177fb426e"/>
           <a:stretch xmlns:a="http://schemas.openxmlformats.org/drawingml/2006/main"/>
         </p:blipFill>
         <p:spPr>
           <a:xfrm xmlns:a="http://schemas.openxmlformats.org/drawingml/2006/main">
-            <a:off x="971685" y="1685925"/>
-            <a:ext cx="1628504" cy="3524250"/>
+            <a:off x="1033483" y="1685925"/>
+            <a:ext cx="1504908" cy="3524250"/>
           </a:xfrm>
           <a:prstGeom xmlns:a="http://schemas.openxmlformats.org/drawingml/2006/main" prst="rect">
             <a:avLst/>
@@ -5237,7 +5889,7 @@
           <p:cNvPr id="4" name="">
             <a:extLst xmlns:a="http://schemas.openxmlformats.org/drawingml/2006/main">
               <a:ext uri="{FF2B5EF4-FFF2-40B4-BE49-F238E27FC236}">
-                <a16:creationId xmlns:a16="http://schemas.microsoft.com/office/drawing/2014/main" id="{1016E88E-B17D-4609-9422-8EAE05C41E09}"/>
+                <a16:creationId xmlns:a16="http://schemas.microsoft.com/office/drawing/2014/main" id="{FF445D8E-6F8E-47BA-A40B-D53CAB3B5D7D}"/>
               </a:ext>
             </a:extLst>
           </p:cNvPr>
@@ -5247,13 +5899,13 @@
           <p:nvPr/>
         </p:nvPicPr>
         <p:blipFill>
-          <a:blip xmlns:r="http://schemas.openxmlformats.org/officeDocument/2006/relationships" xmlns:a="http://schemas.openxmlformats.org/drawingml/2006/main" r:embed="Rb88dd8020a384c45"/>
+          <a:blip xmlns:r="http://schemas.openxmlformats.org/officeDocument/2006/relationships" xmlns:a="http://schemas.openxmlformats.org/drawingml/2006/main" r:embed="R7e9e23ab731a4bf0"/>
           <a:stretch xmlns:a="http://schemas.openxmlformats.org/drawingml/2006/main"/>
         </p:blipFill>
         <p:spPr>
           <a:xfrm xmlns:a="http://schemas.openxmlformats.org/drawingml/2006/main">
-            <a:off x="5096010" y="1685925"/>
-            <a:ext cx="1628504" cy="3524250"/>
+            <a:off x="5157808" y="1685925"/>
+            <a:ext cx="1504908" cy="3524250"/>
           </a:xfrm>
           <a:prstGeom xmlns:a="http://schemas.openxmlformats.org/drawingml/2006/main" prst="rect">
             <a:avLst/>
@@ -5265,7 +5917,7 @@
           <p:cNvPr id="5" name="">
             <a:extLst xmlns:a="http://schemas.openxmlformats.org/drawingml/2006/main">
               <a:ext uri="{FF2B5EF4-FFF2-40B4-BE49-F238E27FC236}">
-                <a16:creationId xmlns:a16="http://schemas.microsoft.com/office/drawing/2014/main" id="{7768C905-6988-4B82-8806-BDC76EB77662}"/>
+                <a16:creationId xmlns:a16="http://schemas.microsoft.com/office/drawing/2014/main" id="{4EFEE3A6-E3B9-4E4D-A81D-155F86A9296E}"/>
               </a:ext>
             </a:extLst>
           </p:cNvPr>
@@ -5275,13 +5927,13 @@
           <p:nvPr/>
         </p:nvPicPr>
         <p:blipFill>
-          <a:blip xmlns:r="http://schemas.openxmlformats.org/officeDocument/2006/relationships" xmlns:a="http://schemas.openxmlformats.org/drawingml/2006/main" r:embed="R15667977bbc140d3"/>
+          <a:blip xmlns:r="http://schemas.openxmlformats.org/officeDocument/2006/relationships" xmlns:a="http://schemas.openxmlformats.org/drawingml/2006/main" r:embed="Rcdece9af19614c8e"/>
           <a:stretch xmlns:a="http://schemas.openxmlformats.org/drawingml/2006/main"/>
         </p:blipFill>
         <p:spPr>
           <a:xfrm xmlns:a="http://schemas.openxmlformats.org/drawingml/2006/main">
-            <a:off x="9238652" y="1685925"/>
-            <a:ext cx="1591871" cy="3524250"/>
+            <a:off x="9282133" y="1685925"/>
+            <a:ext cx="1504908" cy="3524250"/>
           </a:xfrm>
           <a:prstGeom xmlns:a="http://schemas.openxmlformats.org/drawingml/2006/main" prst="rect">
             <a:avLst/>
@@ -5293,7 +5945,7 @@
           <p:cNvPr id="6" name="">
             <a:extLst xmlns:a="http://schemas.openxmlformats.org/drawingml/2006/main">
               <a:ext uri="{FF2B5EF4-FFF2-40B4-BE49-F238E27FC236}">
-                <a16:creationId xmlns:a16="http://schemas.microsoft.com/office/drawing/2014/main" id="{AB4C6D45-4239-4657-BDA1-113DF15A7953}"/>
+                <a16:creationId xmlns:a16="http://schemas.microsoft.com/office/drawing/2014/main" id="{08ED8078-069C-4B0A-AC12-9EA94A3149C6}"/>
               </a:ext>
             </a:extLst>
           </p:cNvPr>
@@ -5449,7 +6101,7 @@
           <p:cNvPr id="7" name="">
             <a:extLst xmlns:a="http://schemas.openxmlformats.org/drawingml/2006/main">
               <a:ext uri="{FF2B5EF4-FFF2-40B4-BE49-F238E27FC236}">
-                <a16:creationId xmlns:a16="http://schemas.microsoft.com/office/drawing/2014/main" id="{87677048-6A2C-4A91-B5DC-42D741B63810}"/>
+                <a16:creationId xmlns:a16="http://schemas.microsoft.com/office/drawing/2014/main" id="{97720A20-0A40-458D-9A3C-E4E95C03C804}"/>
               </a:ext>
             </a:extLst>
           </p:cNvPr>
@@ -5595,7 +6247,7 @@
                 <a:ea typeface="Arial"/>
                 <a:cs typeface="Arial"/>
               </a:rPr>
-              <a:t>See the share price, compare companies, or open the blue flower for a deeper explanation.</a:t>
+              <a:t>Scan share prices and daily moves. Compare two companies, then open details or the AI explanation.</a:t>
             </a:r>
           </a:p>
         </p:txBody>
@@ -5605,7 +6257,7 @@
           <p:cNvPr id="8" name="">
             <a:extLst xmlns:a="http://schemas.openxmlformats.org/drawingml/2006/main">
               <a:ext uri="{FF2B5EF4-FFF2-40B4-BE49-F238E27FC236}">
-                <a16:creationId xmlns:a16="http://schemas.microsoft.com/office/drawing/2014/main" id="{39B172D7-4416-4E06-A3A6-2F8142C78762}"/>
+                <a16:creationId xmlns:a16="http://schemas.microsoft.com/office/drawing/2014/main" id="{362196D2-8430-4897-94E8-65BA0B8AB084}"/>
               </a:ext>
             </a:extLst>
           </p:cNvPr>
@@ -5761,7 +6413,7 @@
           <p:cNvPr id="9" name="">
             <a:extLst xmlns:a="http://schemas.openxmlformats.org/drawingml/2006/main">
               <a:ext uri="{FF2B5EF4-FFF2-40B4-BE49-F238E27FC236}">
-                <a16:creationId xmlns:a16="http://schemas.microsoft.com/office/drawing/2014/main" id="{2A0B3634-93EE-4E81-A068-EBD673440700}"/>
+                <a16:creationId xmlns:a16="http://schemas.microsoft.com/office/drawing/2014/main" id="{202AB696-7717-4BB4-8A98-167DE303C926}"/>
               </a:ext>
             </a:extLst>
           </p:cNvPr>
@@ -5907,7 +6559,7 @@
                 <a:ea typeface="Arial"/>
                 <a:cs typeface="Arial"/>
               </a:rPr>
-              <a:t>Browse funds and baskets. Open the blue flower for the fund’s appeal, risks and approach.</a:t>
+              <a:t>See the fund, category and labelled return period. Open details for the minimum, costs and risks.</a:t>
             </a:r>
           </a:p>
         </p:txBody>
@@ -5917,7 +6569,7 @@
           <p:cNvPr id="10" name="">
             <a:extLst xmlns:a="http://schemas.openxmlformats.org/drawingml/2006/main">
               <a:ext uri="{FF2B5EF4-FFF2-40B4-BE49-F238E27FC236}">
-                <a16:creationId xmlns:a16="http://schemas.microsoft.com/office/drawing/2014/main" id="{A7229236-27B0-434D-B7DB-0C1E8F6559C6}"/>
+                <a16:creationId xmlns:a16="http://schemas.microsoft.com/office/drawing/2014/main" id="{DE83D981-4BBC-46F3-A5E6-B90756678EDC}"/>
               </a:ext>
             </a:extLst>
           </p:cNvPr>
@@ -6073,7 +6725,7 @@
           <p:cNvPr id="11" name="">
             <a:extLst xmlns:a="http://schemas.openxmlformats.org/drawingml/2006/main">
               <a:ext uri="{FF2B5EF4-FFF2-40B4-BE49-F238E27FC236}">
-                <a16:creationId xmlns:a16="http://schemas.microsoft.com/office/drawing/2014/main" id="{50A7C98D-30E6-412A-BCD2-C8123F12419D}"/>
+                <a16:creationId xmlns:a16="http://schemas.microsoft.com/office/drawing/2014/main" id="{763892FE-D136-4741-8155-1FCFABBE9AE4}"/>
               </a:ext>
             </a:extLst>
           </p:cNvPr>
@@ -6219,7 +6871,7 @@
                 <a:ea typeface="Arial"/>
                 <a:cs typeface="Arial"/>
               </a:rPr>
-              <a:t>Private Wealth opens with a short, skippable welcome. The catalogue then shows all 18 PMS, AIF and SIF offerings.</a:t>
+              <a:t>Browse all 18 PMS, AIF and SIF offerings in one catalogue, with minimums and working detail links.</a:t>
             </a:r>
           </a:p>
         </p:txBody>
@@ -6227,7 +6879,7 @@
     </p:spTree>
     <p:extLst>
       <p:ext uri="{BB962C8B-B14F-4D97-AF65-F5344CB8AC3E}">
-        <p14:creationId xmlns:p14="http://schemas.microsoft.com/office/powerpoint/2010/main" val="955642227"/>
+        <p14:creationId xmlns:p14="http://schemas.microsoft.com/office/powerpoint/2010/main" val="1285272463"/>
       </p:ext>
     </p:extLst>
   </p:cSld>
@@ -6258,7 +6910,7 @@
           <p:cNvPr id="14" name="">
             <a:extLst xmlns:a="http://schemas.openxmlformats.org/drawingml/2006/main">
               <a:ext uri="{FF2B5EF4-FFF2-40B4-BE49-F238E27FC236}">
-                <a16:creationId xmlns:a16="http://schemas.microsoft.com/office/drawing/2014/main" id="{D2FBCCC2-716B-4403-AAEF-0D19306CD296}"/>
+                <a16:creationId xmlns:a16="http://schemas.microsoft.com/office/drawing/2014/main" id="{1BA51A39-3FDE-4261-917A-C4AE5C38B810}"/>
               </a:ext>
             </a:extLst>
           </p:cNvPr>
@@ -6404,7 +7056,7 @@
                 <a:ea typeface="Arial"/>
                 <a:cs typeface="Arial"/>
               </a:rPr>
-              <a:t>3 / AI support, at the point of doubt</a:t>
+              <a:t>3 / Help users resolve doubt before investing</a:t>
             </a:r>
           </a:p>
         </p:txBody>
@@ -6414,7 +7066,7 @@
           <p:cNvPr id="2" name="">
             <a:extLst xmlns:a="http://schemas.openxmlformats.org/drawingml/2006/main">
               <a:ext uri="{FF2B5EF4-FFF2-40B4-BE49-F238E27FC236}">
-                <a16:creationId xmlns:a16="http://schemas.microsoft.com/office/drawing/2014/main" id="{185EDE95-96B7-4DAB-B937-BB7F861CFDC9}"/>
+                <a16:creationId xmlns:a16="http://schemas.microsoft.com/office/drawing/2014/main" id="{10C6F29E-AD5A-4D77-BCD1-798B589C0148}"/>
               </a:ext>
             </a:extLst>
           </p:cNvPr>
@@ -6560,7 +7212,7 @@
                 <a:ea typeface="Arial"/>
                 <a:cs typeface="Arial"/>
               </a:rPr>
-              <a:t>Help users understand the investment.</a:t>
+              <a:t>Answer the questions that interrupt a purchase.</a:t>
             </a:r>
           </a:p>
         </p:txBody>
@@ -6570,7 +7222,7 @@
           <p:cNvPr id="3" name="">
             <a:extLst xmlns:a="http://schemas.openxmlformats.org/drawingml/2006/main">
               <a:ext uri="{FF2B5EF4-FFF2-40B4-BE49-F238E27FC236}">
-                <a16:creationId xmlns:a16="http://schemas.microsoft.com/office/drawing/2014/main" id="{D155CB8B-95F0-45B4-8F6C-0DF361093E63}"/>
+                <a16:creationId xmlns:a16="http://schemas.microsoft.com/office/drawing/2014/main" id="{FD97800E-870B-4F9A-80DF-6DF712B8E93A}"/>
               </a:ext>
             </a:extLst>
           </p:cNvPr>
@@ -6716,7 +7368,7 @@
                 <a:ea typeface="Arial"/>
                 <a:cs typeface="Arial"/>
               </a:rPr>
-              <a:t>Explain the upside and downside</a:t>
+              <a:t>What does this company actually do?</a:t>
             </a:r>
           </a:p>
         </p:txBody>
@@ -6726,7 +7378,7 @@
           <p:cNvPr id="4" name="">
             <a:extLst xmlns:a="http://schemas.openxmlformats.org/drawingml/2006/main">
               <a:ext uri="{FF2B5EF4-FFF2-40B4-BE49-F238E27FC236}">
-                <a16:creationId xmlns:a16="http://schemas.microsoft.com/office/drawing/2014/main" id="{F33DAA9F-CBB5-4CDC-9739-242D076BAFF1}"/>
+                <a16:creationId xmlns:a16="http://schemas.microsoft.com/office/drawing/2014/main" id="{75C6D820-F814-40D5-AFFE-51E2A0316EF1}"/>
               </a:ext>
             </a:extLst>
           </p:cNvPr>
@@ -6872,7 +7524,7 @@
                 <a:ea typeface="Arial"/>
                 <a:cs typeface="Arial"/>
               </a:rPr>
-              <a:t>Explain the business, what makes it interesting and what could go wrong. Let users switch between Overview, Strengths, Risks and Vision.</a:t>
+              <a:t>Explain the business and its main strengths in plain English. Link the company's stated plans to its filing so users can check the source.</a:t>
             </a:r>
           </a:p>
         </p:txBody>
@@ -6882,7 +7534,7 @@
           <p:cNvPr id="5" name="">
             <a:extLst xmlns:a="http://schemas.openxmlformats.org/drawingml/2006/main">
               <a:ext uri="{FF2B5EF4-FFF2-40B4-BE49-F238E27FC236}">
-                <a16:creationId xmlns:a16="http://schemas.microsoft.com/office/drawing/2014/main" id="{0D1A1211-4B0A-40F2-835E-F1E71260DEC5}"/>
+                <a16:creationId xmlns:a16="http://schemas.microsoft.com/office/drawing/2014/main" id="{6918F6AF-5C4F-4A50-A94B-D12CC004D94E}"/>
               </a:ext>
             </a:extLst>
           </p:cNvPr>
@@ -7028,7 +7680,7 @@
                 <a:ea typeface="Arial"/>
                 <a:cs typeface="Arial"/>
               </a:rPr>
-              <a:t>Make the company’s direction clear</a:t>
+              <a:t>What could go wrong?</a:t>
             </a:r>
           </a:p>
         </p:txBody>
@@ -7038,7 +7690,7 @@
           <p:cNvPr id="6" name="">
             <a:extLst xmlns:a="http://schemas.openxmlformats.org/drawingml/2006/main">
               <a:ext uri="{FF2B5EF4-FFF2-40B4-BE49-F238E27FC236}">
-                <a16:creationId xmlns:a16="http://schemas.microsoft.com/office/drawing/2014/main" id="{B4282B3D-1B30-4849-9A7B-D1C7651E332D}"/>
+                <a16:creationId xmlns:a16="http://schemas.microsoft.com/office/drawing/2014/main" id="{1F641B54-1190-49DD-80DB-B7EEC526B942}"/>
               </a:ext>
             </a:extLst>
           </p:cNvPr>
@@ -7184,7 +7836,7 @@
                 <a:ea typeface="Arial"/>
                 <a:cs typeface="Arial"/>
               </a:rPr>
-              <a:t>Summarise the company’s stated direction and link to its filing. Separate those plans from any claim about the future share price.</a:t>
+              <a:t>Show risks alongside the appeal. For funds, explain the mandate and exposure. Company plans and past returns are not promises.</a:t>
             </a:r>
           </a:p>
         </p:txBody>
@@ -7194,7 +7846,7 @@
           <p:cNvPr id="7" name="">
             <a:extLst xmlns:a="http://schemas.openxmlformats.org/drawingml/2006/main">
               <a:ext uri="{FF2B5EF4-FFF2-40B4-BE49-F238E27FC236}">
-                <a16:creationId xmlns:a16="http://schemas.microsoft.com/office/drawing/2014/main" id="{AD6AA975-81D4-4BCC-ADC3-D8776B7DA54C}"/>
+                <a16:creationId xmlns:a16="http://schemas.microsoft.com/office/drawing/2014/main" id="{06A8A882-BD8D-4E08-99B6-70156E6A06D7}"/>
               </a:ext>
             </a:extLst>
           </p:cNvPr>
@@ -7340,7 +7992,7 @@
                 <a:ea typeface="Arial"/>
                 <a:cs typeface="Arial"/>
               </a:rPr>
-              <a:t>Help the user decide what to check next</a:t>
+              <a:t>What should I check before proceeding?</a:t>
             </a:r>
           </a:p>
         </p:txBody>
@@ -7350,7 +8002,7 @@
           <p:cNvPr id="8" name="">
             <a:extLst xmlns:a="http://schemas.openxmlformats.org/drawingml/2006/main">
               <a:ext uri="{FF2B5EF4-FFF2-40B4-BE49-F238E27FC236}">
-                <a16:creationId xmlns:a16="http://schemas.microsoft.com/office/drawing/2014/main" id="{A41E099B-0274-4BAD-95F0-13C06DEEB361}"/>
+                <a16:creationId xmlns:a16="http://schemas.microsoft.com/office/drawing/2014/main" id="{07C621E1-E62F-48DF-BB2A-607ED304B4A3}"/>
               </a:ext>
             </a:extLst>
           </p:cNvPr>
@@ -7496,7 +8148,7 @@
                 <a:ea typeface="Arial"/>
                 <a:cs typeface="Arial"/>
               </a:rPr>
-              <a:t>Fund deep dives explain the mandate, exposure and costs. For US stocks, call out funding and FX needs. Link back to the product details before the next step.</a:t>
+              <a:t>Explain fees and, for US stocks, funding and FX needs. Return users to product details to continue. Success means an informed first investment, not more AI opens.</a:t>
             </a:r>
           </a:p>
         </p:txBody>
@@ -7506,7 +8158,7 @@
           <p:cNvPr id="9" name="">
             <a:extLst xmlns:a="http://schemas.openxmlformats.org/drawingml/2006/main">
               <a:ext uri="{FF2B5EF4-FFF2-40B4-BE49-F238E27FC236}">
-                <a16:creationId xmlns:a16="http://schemas.microsoft.com/office/drawing/2014/main" id="{B7729BE1-D3F8-460F-9CBE-CC188CC402E9}"/>
+                <a16:creationId xmlns:a16="http://schemas.microsoft.com/office/drawing/2014/main" id="{1C6FA715-BEDB-456F-9554-B6F8E36A863F}"/>
               </a:ext>
             </a:extLst>
           </p:cNvPr>
@@ -7516,7 +8168,7 @@
           <p:nvPr/>
         </p:nvPicPr>
         <p:blipFill>
-          <a:blip xmlns:r="http://schemas.openxmlformats.org/officeDocument/2006/relationships" xmlns:a="http://schemas.openxmlformats.org/drawingml/2006/main" r:embed="R58f5a039d96d40ba"/>
+          <a:blip xmlns:r="http://schemas.openxmlformats.org/officeDocument/2006/relationships" xmlns:a="http://schemas.openxmlformats.org/drawingml/2006/main" r:embed="R10e7c120506b4ad8"/>
           <a:stretch xmlns:a="http://schemas.openxmlformats.org/drawingml/2006/main"/>
         </p:blipFill>
         <p:spPr>
@@ -7534,7 +8186,7 @@
           <p:cNvPr id="10" name="">
             <a:extLst xmlns:a="http://schemas.openxmlformats.org/drawingml/2006/main">
               <a:ext uri="{FF2B5EF4-FFF2-40B4-BE49-F238E27FC236}">
-                <a16:creationId xmlns:a16="http://schemas.microsoft.com/office/drawing/2014/main" id="{36FBF6EE-168E-4286-B4C8-10DB07FC9E49}"/>
+                <a16:creationId xmlns:a16="http://schemas.microsoft.com/office/drawing/2014/main" id="{07FE6A20-097C-4975-8807-3D2FF83A9D71}"/>
               </a:ext>
             </a:extLst>
           </p:cNvPr>
@@ -7544,7 +8196,7 @@
           <p:nvPr/>
         </p:nvPicPr>
         <p:blipFill>
-          <a:blip xmlns:r="http://schemas.openxmlformats.org/officeDocument/2006/relationships" xmlns:a="http://schemas.openxmlformats.org/drawingml/2006/main" r:embed="Re426826936864a3d"/>
+          <a:blip xmlns:r="http://schemas.openxmlformats.org/officeDocument/2006/relationships" xmlns:a="http://schemas.openxmlformats.org/drawingml/2006/main" r:embed="R547e308f201d4c50"/>
           <a:stretch xmlns:a="http://schemas.openxmlformats.org/drawingml/2006/main"/>
         </p:blipFill>
         <p:spPr>
@@ -7562,7 +8214,7 @@
           <p:cNvPr id="11" name="">
             <a:extLst xmlns:a="http://schemas.openxmlformats.org/drawingml/2006/main">
               <a:ext uri="{FF2B5EF4-FFF2-40B4-BE49-F238E27FC236}">
-                <a16:creationId xmlns:a16="http://schemas.microsoft.com/office/drawing/2014/main" id="{77BFB623-6834-4414-830B-449A06292AD9}"/>
+                <a16:creationId xmlns:a16="http://schemas.microsoft.com/office/drawing/2014/main" id="{4BA0CD93-E658-4ED3-9F21-4D3827188928}"/>
               </a:ext>
             </a:extLst>
           </p:cNvPr>
@@ -7718,7 +8370,7 @@
           <p:cNvPr id="12" name="">
             <a:extLst xmlns:a="http://schemas.openxmlformats.org/drawingml/2006/main">
               <a:ext uri="{FF2B5EF4-FFF2-40B4-BE49-F238E27FC236}">
-                <a16:creationId xmlns:a16="http://schemas.microsoft.com/office/drawing/2014/main" id="{9D588D0E-F368-4F26-BB15-FC6F1E1E0AC9}"/>
+                <a16:creationId xmlns:a16="http://schemas.microsoft.com/office/drawing/2014/main" id="{6547FCDD-04BD-49F4-BCCC-8D5F800115C9}"/>
               </a:ext>
             </a:extLst>
           </p:cNvPr>
@@ -7874,7 +8526,7 @@
           <p:cNvPr id="13" name="">
             <a:extLst xmlns:a="http://schemas.openxmlformats.org/drawingml/2006/main">
               <a:ext uri="{FF2B5EF4-FFF2-40B4-BE49-F238E27FC236}">
-                <a16:creationId xmlns:a16="http://schemas.microsoft.com/office/drawing/2014/main" id="{C62C6CC3-4058-412B-9FB6-90BFB67B25EA}"/>
+                <a16:creationId xmlns:a16="http://schemas.microsoft.com/office/drawing/2014/main" id="{029A6C85-F68C-4620-ABAE-4036A07FC493}"/>
               </a:ext>
             </a:extLst>
           </p:cNvPr>
@@ -8028,7 +8680,7 @@
     </p:spTree>
     <p:extLst>
       <p:ext uri="{BB962C8B-B14F-4D97-AF65-F5344CB8AC3E}">
-        <p14:creationId xmlns:p14="http://schemas.microsoft.com/office/powerpoint/2010/main" val="1416161168"/>
+        <p14:creationId xmlns:p14="http://schemas.microsoft.com/office/powerpoint/2010/main" val="1319694430"/>
       </p:ext>
     </p:extLst>
   </p:cSld>
@@ -8059,7 +8711,7 @@
           <p:cNvPr id="16" name="">
             <a:extLst xmlns:a="http://schemas.openxmlformats.org/drawingml/2006/main">
               <a:ext uri="{FF2B5EF4-FFF2-40B4-BE49-F238E27FC236}">
-                <a16:creationId xmlns:a16="http://schemas.microsoft.com/office/drawing/2014/main" id="{B32FFFC0-28C9-479D-977C-655ABA0C6008}"/>
+                <a16:creationId xmlns:a16="http://schemas.microsoft.com/office/drawing/2014/main" id="{447A75C7-2551-47BE-8158-01FE05AF4BEB}"/>
               </a:ext>
             </a:extLst>
           </p:cNvPr>
@@ -8215,7 +8867,7 @@
           <p:cNvPr id="2" name="">
             <a:extLst xmlns:a="http://schemas.openxmlformats.org/drawingml/2006/main">
               <a:ext uri="{FF2B5EF4-FFF2-40B4-BE49-F238E27FC236}">
-                <a16:creationId xmlns:a16="http://schemas.microsoft.com/office/drawing/2014/main" id="{4DE859E5-E6F4-43CD-9FAD-2048706DFB45}"/>
+                <a16:creationId xmlns:a16="http://schemas.microsoft.com/office/drawing/2014/main" id="{4B3A90B1-B20E-4732-A630-AD6D878806F9}"/>
               </a:ext>
             </a:extLst>
           </p:cNvPr>
@@ -8371,7 +9023,7 @@
           <p:cNvPr id="3" name="">
             <a:extLst xmlns:a="http://schemas.openxmlformats.org/drawingml/2006/main">
               <a:ext uri="{FF2B5EF4-FFF2-40B4-BE49-F238E27FC236}">
-                <a16:creationId xmlns:a16="http://schemas.microsoft.com/office/drawing/2014/main" id="{B229B553-F2B1-4A47-8A4B-B68444BA020E}"/>
+                <a16:creationId xmlns:a16="http://schemas.microsoft.com/office/drawing/2014/main" id="{CFEE1913-1881-4F12-AD31-218ED82145D2}"/>
               </a:ext>
             </a:extLst>
           </p:cNvPr>
@@ -8527,7 +9179,7 @@
           <p:cNvPr id="4" name="">
             <a:extLst xmlns:a="http://schemas.openxmlformats.org/drawingml/2006/main">
               <a:ext uri="{FF2B5EF4-FFF2-40B4-BE49-F238E27FC236}">
-                <a16:creationId xmlns:a16="http://schemas.microsoft.com/office/drawing/2014/main" id="{9B035657-F314-4DCE-811B-E1E173351207}"/>
+                <a16:creationId xmlns:a16="http://schemas.microsoft.com/office/drawing/2014/main" id="{A2E62A4C-2F82-4454-B4B5-F0A80775CF88}"/>
               </a:ext>
             </a:extLst>
           </p:cNvPr>
@@ -8683,7 +9335,7 @@
           <p:cNvPr id="5" name="">
             <a:extLst xmlns:a="http://schemas.openxmlformats.org/drawingml/2006/main">
               <a:ext uri="{FF2B5EF4-FFF2-40B4-BE49-F238E27FC236}">
-                <a16:creationId xmlns:a16="http://schemas.microsoft.com/office/drawing/2014/main" id="{4ADAB177-3831-4C8A-850F-8DAB4C5CC646}"/>
+                <a16:creationId xmlns:a16="http://schemas.microsoft.com/office/drawing/2014/main" id="{3D17EF0B-18C6-4ED3-B6D0-AC160C72C52F}"/>
               </a:ext>
             </a:extLst>
           </p:cNvPr>
@@ -8839,7 +9491,7 @@
           <p:cNvPr id="6" name="">
             <a:extLst xmlns:a="http://schemas.openxmlformats.org/drawingml/2006/main">
               <a:ext uri="{FF2B5EF4-FFF2-40B4-BE49-F238E27FC236}">
-                <a16:creationId xmlns:a16="http://schemas.microsoft.com/office/drawing/2014/main" id="{56900482-D6E2-42E6-999F-F98CA1E02D7C}"/>
+                <a16:creationId xmlns:a16="http://schemas.microsoft.com/office/drawing/2014/main" id="{026B4A45-6073-4BD9-9749-C2384AD99CD0}"/>
               </a:ext>
             </a:extLst>
           </p:cNvPr>
@@ -8995,7 +9647,7 @@
           <p:cNvPr id="7" name="">
             <a:extLst xmlns:a="http://schemas.openxmlformats.org/drawingml/2006/main">
               <a:ext uri="{FF2B5EF4-FFF2-40B4-BE49-F238E27FC236}">
-                <a16:creationId xmlns:a16="http://schemas.microsoft.com/office/drawing/2014/main" id="{BAC7592A-4BD1-4DB1-BE39-4DB717D95A06}"/>
+                <a16:creationId xmlns:a16="http://schemas.microsoft.com/office/drawing/2014/main" id="{163FF95C-23BB-4774-868A-70E7BCB849FC}"/>
               </a:ext>
             </a:extLst>
           </p:cNvPr>
@@ -9151,7 +9803,7 @@
           <p:cNvPr id="8" name="">
             <a:extLst xmlns:a="http://schemas.openxmlformats.org/drawingml/2006/main">
               <a:ext uri="{FF2B5EF4-FFF2-40B4-BE49-F238E27FC236}">
-                <a16:creationId xmlns:a16="http://schemas.microsoft.com/office/drawing/2014/main" id="{4608C79B-5AD5-4D9C-B527-60C32431BB42}"/>
+                <a16:creationId xmlns:a16="http://schemas.microsoft.com/office/drawing/2014/main" id="{824D954A-7AB2-4BFE-BA7E-490BCD3D11F4}"/>
               </a:ext>
             </a:extLst>
           </p:cNvPr>
@@ -9307,7 +9959,7 @@
           <p:cNvPr id="9" name="">
             <a:extLst xmlns:a="http://schemas.openxmlformats.org/drawingml/2006/main">
               <a:ext uri="{FF2B5EF4-FFF2-40B4-BE49-F238E27FC236}">
-                <a16:creationId xmlns:a16="http://schemas.microsoft.com/office/drawing/2014/main" id="{ED5A0DEF-9C14-4CEE-99F4-6A1E0866E7B1}"/>
+                <a16:creationId xmlns:a16="http://schemas.microsoft.com/office/drawing/2014/main" id="{F8515B6C-1D57-41D7-B7A0-B27879F556BD}"/>
               </a:ext>
             </a:extLst>
           </p:cNvPr>
@@ -9463,7 +10115,7 @@
           <p:cNvPr id="10" name="">
             <a:extLst xmlns:a="http://schemas.openxmlformats.org/drawingml/2006/main">
               <a:ext uri="{FF2B5EF4-FFF2-40B4-BE49-F238E27FC236}">
-                <a16:creationId xmlns:a16="http://schemas.microsoft.com/office/drawing/2014/main" id="{2F0D73B0-44F8-4996-B481-A2B267381511}"/>
+                <a16:creationId xmlns:a16="http://schemas.microsoft.com/office/drawing/2014/main" id="{C9226C9F-CFEE-4357-BB47-606FC95A764B}"/>
               </a:ext>
             </a:extLst>
           </p:cNvPr>
@@ -9619,7 +10271,7 @@
           <p:cNvPr id="11" name="">
             <a:extLst xmlns:a="http://schemas.openxmlformats.org/drawingml/2006/main">
               <a:ext uri="{FF2B5EF4-FFF2-40B4-BE49-F238E27FC236}">
-                <a16:creationId xmlns:a16="http://schemas.microsoft.com/office/drawing/2014/main" id="{CB1E387C-ED3A-4861-B68D-26C04073D5DD}"/>
+                <a16:creationId xmlns:a16="http://schemas.microsoft.com/office/drawing/2014/main" id="{2283BE05-BB71-489F-9F23-9AAB65EB3F31}"/>
               </a:ext>
             </a:extLst>
           </p:cNvPr>
@@ -9775,7 +10427,7 @@
           <p:cNvPr id="12" name="">
             <a:extLst xmlns:a="http://schemas.openxmlformats.org/drawingml/2006/main">
               <a:ext uri="{FF2B5EF4-FFF2-40B4-BE49-F238E27FC236}">
-                <a16:creationId xmlns:a16="http://schemas.microsoft.com/office/drawing/2014/main" id="{DAE3EB1B-B9B1-42B6-B71E-6BF6346484FC}"/>
+                <a16:creationId xmlns:a16="http://schemas.microsoft.com/office/drawing/2014/main" id="{ED647636-57A9-46D9-BB1B-B640EEFD805D}"/>
               </a:ext>
             </a:extLst>
           </p:cNvPr>
@@ -9920,7 +10572,7 @@
                 <a:latin typeface="Arial"/>
                 <a:ea typeface="Arial"/>
                 <a:cs typeface="Arial"/>
-                <a:hlinkClick xmlns:r="http://schemas.openxmlformats.org/officeDocument/2006/relationships" r:id="Rd914416d44194551"/>
+                <a:hlinkClick xmlns:r="http://schemas.openxmlformats.org/officeDocument/2006/relationships" r:id="Rd973f5da87c64ba4"/>
               </a:rPr>
               <a:t>Android study: Haverkamp et al.</a:t>
             </a:r>
@@ -9932,7 +10584,7 @@
           <p:cNvPr id="13" name="">
             <a:extLst xmlns:a="http://schemas.openxmlformats.org/drawingml/2006/main">
               <a:ext uri="{FF2B5EF4-FFF2-40B4-BE49-F238E27FC236}">
-                <a16:creationId xmlns:a16="http://schemas.microsoft.com/office/drawing/2014/main" id="{CD9B96E2-3745-40CC-BDA6-D676A78231F4}"/>
+                <a16:creationId xmlns:a16="http://schemas.microsoft.com/office/drawing/2014/main" id="{9B061FA3-9ECA-4983-83B0-D974D3E98411}"/>
               </a:ext>
             </a:extLst>
           </p:cNvPr>
@@ -10077,7 +10729,7 @@
                 <a:latin typeface="Arial"/>
                 <a:ea typeface="Arial"/>
                 <a:cs typeface="Arial"/>
-                <a:hlinkClick xmlns:r="http://schemas.openxmlformats.org/officeDocument/2006/relationships" r:id="R2821b02bea844afa"/>
+                <a:hlinkClick xmlns:r="http://schemas.openxmlformats.org/officeDocument/2006/relationships" r:id="Rcc9da90cdebe4b97"/>
               </a:rPr>
               <a:t>Choice study: Iyengar &amp; Kamenica</a:t>
             </a:r>
@@ -10089,7 +10741,7 @@
           <p:cNvPr id="14" name="">
             <a:extLst xmlns:a="http://schemas.openxmlformats.org/drawingml/2006/main">
               <a:ext uri="{FF2B5EF4-FFF2-40B4-BE49-F238E27FC236}">
-                <a16:creationId xmlns:a16="http://schemas.microsoft.com/office/drawing/2014/main" id="{F89B1ED2-8AC4-4F73-9338-A18F58A0BD22}"/>
+                <a16:creationId xmlns:a16="http://schemas.microsoft.com/office/drawing/2014/main" id="{7FDCB3BE-8532-410D-ADC2-5AD40A01657C}"/>
               </a:ext>
             </a:extLst>
           </p:cNvPr>
@@ -10234,7 +10886,7 @@
                 <a:latin typeface="Arial"/>
                 <a:ea typeface="Arial"/>
                 <a:cs typeface="Arial"/>
-                <a:hlinkClick xmlns:r="http://schemas.openxmlformats.org/officeDocument/2006/relationships" r:id="Raf688461b3814b27"/>
+                <a:hlinkClick xmlns:r="http://schemas.openxmlformats.org/officeDocument/2006/relationships" r:id="Rc0470a0bba444531"/>
               </a:rPr>
               <a:t>Motion controls: W3C guidance</a:t>
             </a:r>
@@ -10246,7 +10898,7 @@
           <p:cNvPr id="15" name="">
             <a:extLst xmlns:a="http://schemas.openxmlformats.org/drawingml/2006/main">
               <a:ext uri="{FF2B5EF4-FFF2-40B4-BE49-F238E27FC236}">
-                <a16:creationId xmlns:a16="http://schemas.microsoft.com/office/drawing/2014/main" id="{5667CCC5-9FC2-4176-B47F-559F2BC793CE}"/>
+                <a16:creationId xmlns:a16="http://schemas.microsoft.com/office/drawing/2014/main" id="{66CAD7F3-5FF1-4ED9-BE41-804FABBA09E8}"/>
               </a:ext>
             </a:extLst>
           </p:cNvPr>
@@ -10400,7 +11052,7 @@
     </p:spTree>
     <p:extLst>
       <p:ext uri="{BB962C8B-B14F-4D97-AF65-F5344CB8AC3E}">
-        <p14:creationId xmlns:p14="http://schemas.microsoft.com/office/powerpoint/2010/main" val="874204592"/>
+        <p14:creationId xmlns:p14="http://schemas.microsoft.com/office/powerpoint/2010/main" val="946098292"/>
       </p:ext>
     </p:extLst>
   </p:cSld>
@@ -10431,7 +11083,7 @@
           <p:cNvPr id="12" name="">
             <a:extLst xmlns:a="http://schemas.openxmlformats.org/drawingml/2006/main">
               <a:ext uri="{FF2B5EF4-FFF2-40B4-BE49-F238E27FC236}">
-                <a16:creationId xmlns:a16="http://schemas.microsoft.com/office/drawing/2014/main" id="{FF1E9DDF-F65C-4B9A-8B12-3CC8670B6E3D}"/>
+                <a16:creationId xmlns:a16="http://schemas.microsoft.com/office/drawing/2014/main" id="{21A1F8F5-A305-4F05-98A3-8A41C17A1769}"/>
               </a:ext>
             </a:extLst>
           </p:cNvPr>
@@ -10587,7 +11239,7 @@
           <p:cNvPr id="2" name="">
             <a:extLst xmlns:a="http://schemas.openxmlformats.org/drawingml/2006/main">
               <a:ext uri="{FF2B5EF4-FFF2-40B4-BE49-F238E27FC236}">
-                <a16:creationId xmlns:a16="http://schemas.microsoft.com/office/drawing/2014/main" id="{36B3F73C-06C9-4CAD-8CF6-917098FEA7C6}"/>
+                <a16:creationId xmlns:a16="http://schemas.microsoft.com/office/drawing/2014/main" id="{70D0674B-288E-4989-B6FE-8F7EF8555E6A}"/>
               </a:ext>
             </a:extLst>
           </p:cNvPr>
@@ -10743,7 +11395,7 @@
           <p:cNvPr id="3" name="">
             <a:extLst xmlns:a="http://schemas.openxmlformats.org/drawingml/2006/main">
               <a:ext uri="{FF2B5EF4-FFF2-40B4-BE49-F238E27FC236}">
-                <a16:creationId xmlns:a16="http://schemas.microsoft.com/office/drawing/2014/main" id="{C344ACAB-120F-41E3-94AD-36DF78483C19}"/>
+                <a16:creationId xmlns:a16="http://schemas.microsoft.com/office/drawing/2014/main" id="{214688CE-D15B-4252-BAAE-7B486B0C61EE}"/>
               </a:ext>
             </a:extLst>
           </p:cNvPr>
@@ -10899,7 +11551,7 @@
           <p:cNvPr id="4" name="">
             <a:extLst xmlns:a="http://schemas.openxmlformats.org/drawingml/2006/main">
               <a:ext uri="{FF2B5EF4-FFF2-40B4-BE49-F238E27FC236}">
-                <a16:creationId xmlns:a16="http://schemas.microsoft.com/office/drawing/2014/main" id="{6F1703EA-A213-47C6-AAB7-2604E0F35B44}"/>
+                <a16:creationId xmlns:a16="http://schemas.microsoft.com/office/drawing/2014/main" id="{F4BC9FDD-6E5D-481B-B05C-405F6F46C8B3}"/>
               </a:ext>
             </a:extLst>
           </p:cNvPr>
@@ -11055,7 +11707,7 @@
           <p:cNvPr id="5" name="">
             <a:extLst xmlns:a="http://schemas.openxmlformats.org/drawingml/2006/main">
               <a:ext uri="{FF2B5EF4-FFF2-40B4-BE49-F238E27FC236}">
-                <a16:creationId xmlns:a16="http://schemas.microsoft.com/office/drawing/2014/main" id="{161BA935-EAB2-421C-8C3A-5452AD5DD336}"/>
+                <a16:creationId xmlns:a16="http://schemas.microsoft.com/office/drawing/2014/main" id="{B48C762B-C9B7-4430-8E61-5C481E97BEA2}"/>
               </a:ext>
             </a:extLst>
           </p:cNvPr>
@@ -11211,7 +11863,7 @@
           <p:cNvPr id="6" name="">
             <a:extLst xmlns:a="http://schemas.openxmlformats.org/drawingml/2006/main">
               <a:ext uri="{FF2B5EF4-FFF2-40B4-BE49-F238E27FC236}">
-                <a16:creationId xmlns:a16="http://schemas.microsoft.com/office/drawing/2014/main" id="{B8D793B4-62B2-487C-B1B4-C659C6A052C1}"/>
+                <a16:creationId xmlns:a16="http://schemas.microsoft.com/office/drawing/2014/main" id="{091E9CB3-ED59-4233-AC75-F9F9D671CBAA}"/>
               </a:ext>
             </a:extLst>
           </p:cNvPr>
@@ -11367,7 +12019,7 @@
           <p:cNvPr id="7" name="">
             <a:extLst xmlns:a="http://schemas.openxmlformats.org/drawingml/2006/main">
               <a:ext uri="{FF2B5EF4-FFF2-40B4-BE49-F238E27FC236}">
-                <a16:creationId xmlns:a16="http://schemas.microsoft.com/office/drawing/2014/main" id="{50B11AC9-328F-44DE-9DF1-0A3BB939547D}"/>
+                <a16:creationId xmlns:a16="http://schemas.microsoft.com/office/drawing/2014/main" id="{73A4B9C2-4936-4241-9B89-C04BE33F2404}"/>
               </a:ext>
             </a:extLst>
           </p:cNvPr>
@@ -11523,7 +12175,7 @@
           <p:cNvPr id="8" name="">
             <a:extLst xmlns:a="http://schemas.openxmlformats.org/drawingml/2006/main">
               <a:ext uri="{FF2B5EF4-FFF2-40B4-BE49-F238E27FC236}">
-                <a16:creationId xmlns:a16="http://schemas.microsoft.com/office/drawing/2014/main" id="{E8F62D6F-B2AB-492B-86AD-0CE52451C0C9}"/>
+                <a16:creationId xmlns:a16="http://schemas.microsoft.com/office/drawing/2014/main" id="{FA89C21D-2774-4761-A7CF-DDCCBAC58327}"/>
               </a:ext>
             </a:extLst>
           </p:cNvPr>
@@ -11679,7 +12331,7 @@
           <p:cNvPr id="9" name="">
             <a:extLst xmlns:a="http://schemas.openxmlformats.org/drawingml/2006/main">
               <a:ext uri="{FF2B5EF4-FFF2-40B4-BE49-F238E27FC236}">
-                <a16:creationId xmlns:a16="http://schemas.microsoft.com/office/drawing/2014/main" id="{76E3FA1B-E9BC-4657-8B97-3FA53D9FF65A}"/>
+                <a16:creationId xmlns:a16="http://schemas.microsoft.com/office/drawing/2014/main" id="{D5272F30-19A4-4391-AFAD-12743E0C0A70}"/>
               </a:ext>
             </a:extLst>
           </p:cNvPr>
@@ -11835,7 +12487,7 @@
           <p:cNvPr id="10" name="">
             <a:extLst xmlns:a="http://schemas.openxmlformats.org/drawingml/2006/main">
               <a:ext uri="{FF2B5EF4-FFF2-40B4-BE49-F238E27FC236}">
-                <a16:creationId xmlns:a16="http://schemas.microsoft.com/office/drawing/2014/main" id="{D49A2586-57BC-43B4-B800-99781F00AD0F}"/>
+                <a16:creationId xmlns:a16="http://schemas.microsoft.com/office/drawing/2014/main" id="{3FF5155E-F2D0-4DEF-85EB-7B7D75435473}"/>
               </a:ext>
             </a:extLst>
           </p:cNvPr>
@@ -11845,7 +12497,7 @@
           <p:nvPr/>
         </p:nvPicPr>
         <p:blipFill>
-          <a:blip xmlns:r="http://schemas.openxmlformats.org/officeDocument/2006/relationships" xmlns:a="http://schemas.openxmlformats.org/drawingml/2006/main" r:embed="R4d85fd219e74425a"/>
+          <a:blip xmlns:r="http://schemas.openxmlformats.org/officeDocument/2006/relationships" xmlns:a="http://schemas.openxmlformats.org/drawingml/2006/main" r:embed="Rdc47dd80d33a46e9"/>
           <a:stretch xmlns:a="http://schemas.openxmlformats.org/drawingml/2006/main"/>
         </p:blipFill>
         <p:spPr>
@@ -11863,7 +12515,7 @@
           <p:cNvPr id="11" name="">
             <a:extLst xmlns:a="http://schemas.openxmlformats.org/drawingml/2006/main">
               <a:ext uri="{FF2B5EF4-FFF2-40B4-BE49-F238E27FC236}">
-                <a16:creationId xmlns:a16="http://schemas.microsoft.com/office/drawing/2014/main" id="{584180D6-B7BD-451B-B129-7F12ADBAA5EB}"/>
+                <a16:creationId xmlns:a16="http://schemas.microsoft.com/office/drawing/2014/main" id="{28102F1B-E843-443B-ACAC-A295B99D4DCF}"/>
               </a:ext>
             </a:extLst>
           </p:cNvPr>
@@ -12017,7 +12669,7 @@
     </p:spTree>
     <p:extLst>
       <p:ext uri="{BB962C8B-B14F-4D97-AF65-F5344CB8AC3E}">
-        <p14:creationId xmlns:p14="http://schemas.microsoft.com/office/powerpoint/2010/main" val="1327039326"/>
+        <p14:creationId xmlns:p14="http://schemas.microsoft.com/office/powerpoint/2010/main" val="2056576791"/>
       </p:ext>
     </p:extLst>
   </p:cSld>

</xml_diff>

<commit_message>
Display full research URLs in appendix
</commit_message>
<xml_diff>
--- a/deliverables/Ionic-Exclusives-Final.pptx
+++ b/deliverables/Ionic-Exclusives-Final.pptx
@@ -2,17 +2,17 @@
 <file path=ppt/presentation.xml><?xml version="1.0" encoding="utf-8"?>
 <p:presentation xmlns:p="http://schemas.openxmlformats.org/presentationml/2006/main">
   <p:sldMasterIdLst>
-    <p:sldMasterId xmlns:r="http://schemas.openxmlformats.org/officeDocument/2006/relationships" id="2147483648" r:id="Rf34de8df769b4e57"/>
+    <p:sldMasterId xmlns:r="http://schemas.openxmlformats.org/officeDocument/2006/relationships" id="2147483648" r:id="R201289346bf6490e"/>
   </p:sldMasterIdLst>
   <p:notesMasterIdLst>
-    <p:notesMasterId xmlns:r="http://schemas.openxmlformats.org/officeDocument/2006/relationships" r:id="R07cf0066d8614ceb"/>
+    <p:notesMasterId xmlns:r="http://schemas.openxmlformats.org/officeDocument/2006/relationships" r:id="R860f6577569b4723"/>
   </p:notesMasterIdLst>
   <p:sldIdLst>
-    <p:sldId xmlns:r="http://schemas.openxmlformats.org/officeDocument/2006/relationships" id="256" r:id="Rde599e339ea24bf2"/>
-    <p:sldId xmlns:r="http://schemas.openxmlformats.org/officeDocument/2006/relationships" id="257" r:id="R742be0deed0b46f8"/>
-    <p:sldId xmlns:r="http://schemas.openxmlformats.org/officeDocument/2006/relationships" id="258" r:id="R7ba6e2c8f48e447e"/>
-    <p:sldId xmlns:r="http://schemas.openxmlformats.org/officeDocument/2006/relationships" id="259" r:id="R9a24d2cf1b794a48"/>
-    <p:sldId xmlns:r="http://schemas.openxmlformats.org/officeDocument/2006/relationships" id="260" r:id="R937bbf9907d34cbc"/>
+    <p:sldId xmlns:r="http://schemas.openxmlformats.org/officeDocument/2006/relationships" id="256" r:id="R3d0095d382494982"/>
+    <p:sldId xmlns:r="http://schemas.openxmlformats.org/officeDocument/2006/relationships" id="257" r:id="R78d75236b14b49c9"/>
+    <p:sldId xmlns:r="http://schemas.openxmlformats.org/officeDocument/2006/relationships" id="258" r:id="Rdb4a2fafadcc4158"/>
+    <p:sldId xmlns:r="http://schemas.openxmlformats.org/officeDocument/2006/relationships" id="259" r:id="R0ead2bcf96184638"/>
+    <p:sldId xmlns:r="http://schemas.openxmlformats.org/officeDocument/2006/relationships" id="260" r:id="R91e9ec1a2b9f437a"/>
   </p:sldIdLst>
   <p:sldSz cx="12192000" cy="6858000"/>
   <p:notesSz cx="6858000" cy="9144000"/>
@@ -773,7 +773,7 @@
           <p:cNvPr id="3" name="Title">
             <a:extLst xmlns:a="http://schemas.openxmlformats.org/drawingml/2006/main">
               <a:ext uri="{FF2B5EF4-FFF2-40B4-BE49-F238E27FC236}">
-                <a16:creationId xmlns:a16="http://schemas.microsoft.com/office/drawing/2014/main" id="{8F0D01CB-0093-4BB9-929B-B7C62FE6D99E}"/>
+                <a16:creationId xmlns:a16="http://schemas.microsoft.com/office/drawing/2014/main" id="{F52D427F-CC84-4E72-AFB8-652385C8FB31}"/>
               </a:ext>
             </a:extLst>
           </p:cNvPr>
@@ -1002,7 +1002,7 @@
           <p:cNvPr id="2" name="Subtitle">
             <a:extLst xmlns:a="http://schemas.openxmlformats.org/drawingml/2006/main">
               <a:ext uri="{FF2B5EF4-FFF2-40B4-BE49-F238E27FC236}">
-                <a16:creationId xmlns:a16="http://schemas.microsoft.com/office/drawing/2014/main" id="{5A0D8B0E-2D27-46DD-A99E-5F2D05D52DDF}"/>
+                <a16:creationId xmlns:a16="http://schemas.microsoft.com/office/drawing/2014/main" id="{27ED7114-B77F-4E94-BD35-971820AF6BC0}"/>
               </a:ext>
             </a:extLst>
           </p:cNvPr>
@@ -1248,7 +1248,7 @@
           <p:cNvPr id="2" name="Section title">
             <a:extLst xmlns:a="http://schemas.openxmlformats.org/drawingml/2006/main">
               <a:ext uri="{FF2B5EF4-FFF2-40B4-BE49-F238E27FC236}">
-                <a16:creationId xmlns:a16="http://schemas.microsoft.com/office/drawing/2014/main" id="{7FC40C09-6634-4D5D-AC26-E5A716291D8E}"/>
+                <a16:creationId xmlns:a16="http://schemas.microsoft.com/office/drawing/2014/main" id="{A52D0EBD-FCE8-4EB3-88C3-1B5D9B5A9DED}"/>
               </a:ext>
             </a:extLst>
           </p:cNvPr>
@@ -1494,7 +1494,7 @@
           <p:cNvPr id="3" name="Title">
             <a:extLst xmlns:a="http://schemas.openxmlformats.org/drawingml/2006/main">
               <a:ext uri="{FF2B5EF4-FFF2-40B4-BE49-F238E27FC236}">
-                <a16:creationId xmlns:a16="http://schemas.microsoft.com/office/drawing/2014/main" id="{F49E45F0-4D83-4AB7-8A55-E3CAA5E41394}"/>
+                <a16:creationId xmlns:a16="http://schemas.microsoft.com/office/drawing/2014/main" id="{D0F4BDA8-CB25-49BE-AA9C-74522C2FA1DB}"/>
               </a:ext>
             </a:extLst>
           </p:cNvPr>
@@ -1723,7 +1723,7 @@
           <p:cNvPr id="2" name="Body">
             <a:extLst xmlns:a="http://schemas.openxmlformats.org/drawingml/2006/main">
               <a:ext uri="{FF2B5EF4-FFF2-40B4-BE49-F238E27FC236}">
-                <a16:creationId xmlns:a16="http://schemas.microsoft.com/office/drawing/2014/main" id="{5C8F0491-CDFD-49FA-B78A-88C4F4530996}"/>
+                <a16:creationId xmlns:a16="http://schemas.microsoft.com/office/drawing/2014/main" id="{9E1049CE-42E1-40CB-84B9-E0E4497972EE}"/>
               </a:ext>
             </a:extLst>
           </p:cNvPr>
@@ -1969,7 +1969,7 @@
           <p:cNvPr id="4" name="Title">
             <a:extLst xmlns:a="http://schemas.openxmlformats.org/drawingml/2006/main">
               <a:ext uri="{FF2B5EF4-FFF2-40B4-BE49-F238E27FC236}">
-                <a16:creationId xmlns:a16="http://schemas.microsoft.com/office/drawing/2014/main" id="{DAC84D37-4C29-48B0-BF33-7384329D447E}"/>
+                <a16:creationId xmlns:a16="http://schemas.microsoft.com/office/drawing/2014/main" id="{005332FD-AB4A-45D9-B99B-B28CCC1385DE}"/>
               </a:ext>
             </a:extLst>
           </p:cNvPr>
@@ -2198,7 +2198,7 @@
           <p:cNvPr id="2" name="Left column">
             <a:extLst xmlns:a="http://schemas.openxmlformats.org/drawingml/2006/main">
               <a:ext uri="{FF2B5EF4-FFF2-40B4-BE49-F238E27FC236}">
-                <a16:creationId xmlns:a16="http://schemas.microsoft.com/office/drawing/2014/main" id="{8FDDB21C-E7C3-4A9A-924D-0C2784B6F15F}"/>
+                <a16:creationId xmlns:a16="http://schemas.microsoft.com/office/drawing/2014/main" id="{4EA36572-E0AB-4FDE-A1B3-B98AAF508A65}"/>
               </a:ext>
             </a:extLst>
           </p:cNvPr>
@@ -2427,7 +2427,7 @@
           <p:cNvPr id="3" name="Right column">
             <a:extLst xmlns:a="http://schemas.openxmlformats.org/drawingml/2006/main">
               <a:ext uri="{FF2B5EF4-FFF2-40B4-BE49-F238E27FC236}">
-                <a16:creationId xmlns:a16="http://schemas.microsoft.com/office/drawing/2014/main" id="{DE23CAA2-10DA-4604-8D18-EE2DE514A2CC}"/>
+                <a16:creationId xmlns:a16="http://schemas.microsoft.com/office/drawing/2014/main" id="{19796285-B852-4BCF-8506-9C4A3EDF5685}"/>
               </a:ext>
             </a:extLst>
           </p:cNvPr>
@@ -2673,7 +2673,7 @@
           <p:cNvPr id="3" name="Title">
             <a:extLst xmlns:a="http://schemas.openxmlformats.org/drawingml/2006/main">
               <a:ext uri="{FF2B5EF4-FFF2-40B4-BE49-F238E27FC236}">
-                <a16:creationId xmlns:a16="http://schemas.microsoft.com/office/drawing/2014/main" id="{03EB757C-27C0-4B89-B211-252BD2DD586C}"/>
+                <a16:creationId xmlns:a16="http://schemas.microsoft.com/office/drawing/2014/main" id="{10BE00BA-CA69-4D7E-8FCA-44E3C8DE38CF}"/>
               </a:ext>
             </a:extLst>
           </p:cNvPr>
@@ -2902,7 +2902,7 @@
           <p:cNvPr id="2" name="Left column">
             <a:extLst xmlns:a="http://schemas.openxmlformats.org/drawingml/2006/main">
               <a:ext uri="{FF2B5EF4-FFF2-40B4-BE49-F238E27FC236}">
-                <a16:creationId xmlns:a16="http://schemas.microsoft.com/office/drawing/2014/main" id="{8BBBAB1A-DF56-46D0-96B4-BF535F70ECA9}"/>
+                <a16:creationId xmlns:a16="http://schemas.microsoft.com/office/drawing/2014/main" id="{13C98469-37B4-491B-B0D9-04B20D207D24}"/>
               </a:ext>
             </a:extLst>
           </p:cNvPr>
@@ -3169,12 +3169,12 @@
   </p:cSld>
   <p:clrMap bg1="lt1" tx1="dk1" bg2="lt2" tx2="dk2" accent1="accent1" accent2="accent2" accent3="accent3" accent4="accent4" accent5="accent5" accent6="accent6" hlink="hlink" folHlink="folHlink"/>
   <p:sldLayoutIdLst>
-    <p:sldLayoutId xmlns:r="http://schemas.openxmlformats.org/officeDocument/2006/relationships" id="2147483649" r:id="Rd60bd51515254dcd"/>
-    <p:sldLayoutId xmlns:r="http://schemas.openxmlformats.org/officeDocument/2006/relationships" id="2147483650" r:id="Rdbd2fae6ca0b4d89"/>
-    <p:sldLayoutId xmlns:r="http://schemas.openxmlformats.org/officeDocument/2006/relationships" id="2147483651" r:id="Rde628fe551d64a9e"/>
-    <p:sldLayoutId xmlns:r="http://schemas.openxmlformats.org/officeDocument/2006/relationships" id="2147483652" r:id="R70e07d47e5fb4785"/>
-    <p:sldLayoutId xmlns:r="http://schemas.openxmlformats.org/officeDocument/2006/relationships" id="2147483653" r:id="Rb56ea58cbc054e50"/>
-    <p:sldLayoutId xmlns:r="http://schemas.openxmlformats.org/officeDocument/2006/relationships" id="2147483654" r:id="R9ea6d29a86354e62"/>
+    <p:sldLayoutId xmlns:r="http://schemas.openxmlformats.org/officeDocument/2006/relationships" id="2147483649" r:id="R73b09d17c1194232"/>
+    <p:sldLayoutId xmlns:r="http://schemas.openxmlformats.org/officeDocument/2006/relationships" id="2147483650" r:id="Rc299312bccd2419d"/>
+    <p:sldLayoutId xmlns:r="http://schemas.openxmlformats.org/officeDocument/2006/relationships" id="2147483651" r:id="R35c259416a03423a"/>
+    <p:sldLayoutId xmlns:r="http://schemas.openxmlformats.org/officeDocument/2006/relationships" id="2147483652" r:id="R5391c1bf19eb41ad"/>
+    <p:sldLayoutId xmlns:r="http://schemas.openxmlformats.org/officeDocument/2006/relationships" id="2147483653" r:id="R1bc92ab7d80c4026"/>
+    <p:sldLayoutId xmlns:r="http://schemas.openxmlformats.org/officeDocument/2006/relationships" id="2147483654" r:id="R63a62c3ee4ce4512"/>
   </p:sldLayoutIdLst>
   <p:txStyles>
     <p:titleStyle>
@@ -3725,7 +3725,7 @@
           <p:cNvPr id="14" name="">
             <a:extLst xmlns:a="http://schemas.openxmlformats.org/drawingml/2006/main">
               <a:ext uri="{FF2B5EF4-FFF2-40B4-BE49-F238E27FC236}">
-                <a16:creationId xmlns:a16="http://schemas.microsoft.com/office/drawing/2014/main" id="{3AFEAE17-463A-4729-BD1A-67B8D7654D02}"/>
+                <a16:creationId xmlns:a16="http://schemas.microsoft.com/office/drawing/2014/main" id="{34588747-060C-4F86-87A2-0B4BDB1C939B}"/>
               </a:ext>
             </a:extLst>
           </p:cNvPr>
@@ -3881,7 +3881,7 @@
           <p:cNvPr id="2" name="">
             <a:extLst xmlns:a="http://schemas.openxmlformats.org/drawingml/2006/main">
               <a:ext uri="{FF2B5EF4-FFF2-40B4-BE49-F238E27FC236}">
-                <a16:creationId xmlns:a16="http://schemas.microsoft.com/office/drawing/2014/main" id="{71F9AACF-7927-4152-9201-4BCD2C3CE236}"/>
+                <a16:creationId xmlns:a16="http://schemas.microsoft.com/office/drawing/2014/main" id="{D23CF085-34D3-43B1-8E9A-FC9948D5AAF2}"/>
               </a:ext>
             </a:extLst>
           </p:cNvPr>
@@ -4060,7 +4060,7 @@
           <p:cNvPr id="3" name="">
             <a:extLst xmlns:a="http://schemas.openxmlformats.org/drawingml/2006/main">
               <a:ext uri="{FF2B5EF4-FFF2-40B4-BE49-F238E27FC236}">
-                <a16:creationId xmlns:a16="http://schemas.microsoft.com/office/drawing/2014/main" id="{704A5092-2CF1-43A1-A140-3E1EC00AD851}"/>
+                <a16:creationId xmlns:a16="http://schemas.microsoft.com/office/drawing/2014/main" id="{98A21C99-0610-40E3-98F4-C99F5486CF81}"/>
               </a:ext>
             </a:extLst>
           </p:cNvPr>
@@ -4216,7 +4216,7 @@
           <p:cNvPr id="4" name="">
             <a:extLst xmlns:a="http://schemas.openxmlformats.org/drawingml/2006/main">
               <a:ext uri="{FF2B5EF4-FFF2-40B4-BE49-F238E27FC236}">
-                <a16:creationId xmlns:a16="http://schemas.microsoft.com/office/drawing/2014/main" id="{14D6399A-9142-490E-89F3-70AACC8DA1AB}"/>
+                <a16:creationId xmlns:a16="http://schemas.microsoft.com/office/drawing/2014/main" id="{839C5F1A-3289-416E-B1D9-DEFBE906EF21}"/>
               </a:ext>
             </a:extLst>
           </p:cNvPr>
@@ -4372,7 +4372,7 @@
           <p:cNvPr id="5" name="">
             <a:extLst xmlns:a="http://schemas.openxmlformats.org/drawingml/2006/main">
               <a:ext uri="{FF2B5EF4-FFF2-40B4-BE49-F238E27FC236}">
-                <a16:creationId xmlns:a16="http://schemas.microsoft.com/office/drawing/2014/main" id="{559F7327-C0C4-4B81-A817-9ADFF0354200}"/>
+                <a16:creationId xmlns:a16="http://schemas.microsoft.com/office/drawing/2014/main" id="{483C6611-18C3-4B7A-AB38-0240C47FE705}"/>
               </a:ext>
             </a:extLst>
           </p:cNvPr>
@@ -4528,7 +4528,7 @@
           <p:cNvPr id="6" name="">
             <a:extLst xmlns:a="http://schemas.openxmlformats.org/drawingml/2006/main">
               <a:ext uri="{FF2B5EF4-FFF2-40B4-BE49-F238E27FC236}">
-                <a16:creationId xmlns:a16="http://schemas.microsoft.com/office/drawing/2014/main" id="{2F6AC76A-1B3D-46C9-BF93-173A9870238F}"/>
+                <a16:creationId xmlns:a16="http://schemas.microsoft.com/office/drawing/2014/main" id="{4E133326-C490-4D3B-9FF5-27A99DAE3D5D}"/>
               </a:ext>
             </a:extLst>
           </p:cNvPr>
@@ -4684,7 +4684,7 @@
           <p:cNvPr id="7" name="">
             <a:extLst xmlns:a="http://schemas.openxmlformats.org/drawingml/2006/main">
               <a:ext uri="{FF2B5EF4-FFF2-40B4-BE49-F238E27FC236}">
-                <a16:creationId xmlns:a16="http://schemas.microsoft.com/office/drawing/2014/main" id="{399C1B99-F3E9-4A1D-A11C-698FA45CD276}"/>
+                <a16:creationId xmlns:a16="http://schemas.microsoft.com/office/drawing/2014/main" id="{D98A39C9-24CD-42F2-80FF-BCEEC32EA12A}"/>
               </a:ext>
             </a:extLst>
           </p:cNvPr>
@@ -4840,7 +4840,7 @@
           <p:cNvPr id="8" name="">
             <a:extLst xmlns:a="http://schemas.openxmlformats.org/drawingml/2006/main">
               <a:ext uri="{FF2B5EF4-FFF2-40B4-BE49-F238E27FC236}">
-                <a16:creationId xmlns:a16="http://schemas.microsoft.com/office/drawing/2014/main" id="{8B293548-EA46-43C7-B973-E7B0ADF826CB}"/>
+                <a16:creationId xmlns:a16="http://schemas.microsoft.com/office/drawing/2014/main" id="{28DFCFC6-8F69-4F70-8A68-32A25867D899}"/>
               </a:ext>
             </a:extLst>
           </p:cNvPr>
@@ -4996,7 +4996,7 @@
           <p:cNvPr id="9" name="">
             <a:extLst xmlns:a="http://schemas.openxmlformats.org/drawingml/2006/main">
               <a:ext uri="{FF2B5EF4-FFF2-40B4-BE49-F238E27FC236}">
-                <a16:creationId xmlns:a16="http://schemas.microsoft.com/office/drawing/2014/main" id="{FDD82FFB-15DC-4173-B0D9-33BA15D4B337}"/>
+                <a16:creationId xmlns:a16="http://schemas.microsoft.com/office/drawing/2014/main" id="{A8751DC0-C72F-4C00-AD8F-C6EA6C4A3BE6}"/>
               </a:ext>
             </a:extLst>
           </p:cNvPr>
@@ -5006,7 +5006,7 @@
           <p:nvPr/>
         </p:nvPicPr>
         <p:blipFill>
-          <a:blip xmlns:r="http://schemas.openxmlformats.org/officeDocument/2006/relationships" xmlns:a="http://schemas.openxmlformats.org/drawingml/2006/main" r:embed="Rb75e1b94ca934072"/>
+          <a:blip xmlns:r="http://schemas.openxmlformats.org/officeDocument/2006/relationships" xmlns:a="http://schemas.openxmlformats.org/drawingml/2006/main" r:embed="R2ebf50a5d3ea40d1"/>
           <a:stretch xmlns:a="http://schemas.openxmlformats.org/drawingml/2006/main"/>
         </p:blipFill>
         <p:spPr>
@@ -5024,7 +5024,7 @@
           <p:cNvPr id="10" name="">
             <a:extLst xmlns:a="http://schemas.openxmlformats.org/drawingml/2006/main">
               <a:ext uri="{FF2B5EF4-FFF2-40B4-BE49-F238E27FC236}">
-                <a16:creationId xmlns:a16="http://schemas.microsoft.com/office/drawing/2014/main" id="{F47C3E6B-66C4-44AA-B7B0-764B3B4849FC}"/>
+                <a16:creationId xmlns:a16="http://schemas.microsoft.com/office/drawing/2014/main" id="{9DD73811-6CF2-473C-9FD4-85F181B867EB}"/>
               </a:ext>
             </a:extLst>
           </p:cNvPr>
@@ -5034,7 +5034,7 @@
           <p:nvPr/>
         </p:nvPicPr>
         <p:blipFill>
-          <a:blip xmlns:r="http://schemas.openxmlformats.org/officeDocument/2006/relationships" xmlns:a="http://schemas.openxmlformats.org/drawingml/2006/main" r:embed="Rd852c926e53c430a"/>
+          <a:blip xmlns:r="http://schemas.openxmlformats.org/officeDocument/2006/relationships" xmlns:a="http://schemas.openxmlformats.org/drawingml/2006/main" r:embed="Rd0566dfefb684659"/>
           <a:stretch xmlns:a="http://schemas.openxmlformats.org/drawingml/2006/main"/>
         </p:blipFill>
         <p:spPr>
@@ -5052,7 +5052,7 @@
           <p:cNvPr id="11" name="">
             <a:extLst xmlns:a="http://schemas.openxmlformats.org/drawingml/2006/main">
               <a:ext uri="{FF2B5EF4-FFF2-40B4-BE49-F238E27FC236}">
-                <a16:creationId xmlns:a16="http://schemas.microsoft.com/office/drawing/2014/main" id="{F212BA24-FF81-4A3F-BDE8-E162E7AE35A7}"/>
+                <a16:creationId xmlns:a16="http://schemas.microsoft.com/office/drawing/2014/main" id="{F74342C8-FDF4-40CA-B835-4657F9708C6A}"/>
               </a:ext>
             </a:extLst>
           </p:cNvPr>
@@ -5208,7 +5208,7 @@
           <p:cNvPr id="12" name="">
             <a:extLst xmlns:a="http://schemas.openxmlformats.org/drawingml/2006/main">
               <a:ext uri="{FF2B5EF4-FFF2-40B4-BE49-F238E27FC236}">
-                <a16:creationId xmlns:a16="http://schemas.microsoft.com/office/drawing/2014/main" id="{F47CACF0-24D6-4B29-91C6-B392F32F8D84}"/>
+                <a16:creationId xmlns:a16="http://schemas.microsoft.com/office/drawing/2014/main" id="{18A8B207-A903-4E78-A900-83C8C35EDF9B}"/>
               </a:ext>
             </a:extLst>
           </p:cNvPr>
@@ -5364,7 +5364,7 @@
           <p:cNvPr id="13" name="">
             <a:extLst xmlns:a="http://schemas.openxmlformats.org/drawingml/2006/main">
               <a:ext uri="{FF2B5EF4-FFF2-40B4-BE49-F238E27FC236}">
-                <a16:creationId xmlns:a16="http://schemas.microsoft.com/office/drawing/2014/main" id="{D7086C1F-4014-4A84-8CD2-3BC9B710A83A}"/>
+                <a16:creationId xmlns:a16="http://schemas.microsoft.com/office/drawing/2014/main" id="{6A9065E2-726D-44FB-9ED1-D3D48F090800}"/>
               </a:ext>
             </a:extLst>
           </p:cNvPr>
@@ -5518,7 +5518,7 @@
     </p:spTree>
     <p:extLst>
       <p:ext uri="{BB962C8B-B14F-4D97-AF65-F5344CB8AC3E}">
-        <p14:creationId xmlns:p14="http://schemas.microsoft.com/office/powerpoint/2010/main" val="766107474"/>
+        <p14:creationId xmlns:p14="http://schemas.microsoft.com/office/powerpoint/2010/main" val="792939116"/>
       </p:ext>
     </p:extLst>
   </p:cSld>
@@ -5549,7 +5549,7 @@
           <p:cNvPr id="12" name="">
             <a:extLst xmlns:a="http://schemas.openxmlformats.org/drawingml/2006/main">
               <a:ext uri="{FF2B5EF4-FFF2-40B4-BE49-F238E27FC236}">
-                <a16:creationId xmlns:a16="http://schemas.microsoft.com/office/drawing/2014/main" id="{61D76DE8-3324-4134-97D8-D2142EA80294}"/>
+                <a16:creationId xmlns:a16="http://schemas.microsoft.com/office/drawing/2014/main" id="{5C170876-E3B2-40F1-873A-0FFCE25441B0}"/>
               </a:ext>
             </a:extLst>
           </p:cNvPr>
@@ -5705,7 +5705,7 @@
           <p:cNvPr id="2" name="">
             <a:extLst xmlns:a="http://schemas.openxmlformats.org/drawingml/2006/main">
               <a:ext uri="{FF2B5EF4-FFF2-40B4-BE49-F238E27FC236}">
-                <a16:creationId xmlns:a16="http://schemas.microsoft.com/office/drawing/2014/main" id="{3A5762D3-A7CC-4057-8D11-359322AB24B9}"/>
+                <a16:creationId xmlns:a16="http://schemas.microsoft.com/office/drawing/2014/main" id="{44343C00-91F7-4611-B9A2-5C9CEFED8E38}"/>
               </a:ext>
             </a:extLst>
           </p:cNvPr>
@@ -5861,7 +5861,7 @@
           <p:cNvPr id="3" name="">
             <a:extLst xmlns:a="http://schemas.openxmlformats.org/drawingml/2006/main">
               <a:ext uri="{FF2B5EF4-FFF2-40B4-BE49-F238E27FC236}">
-                <a16:creationId xmlns:a16="http://schemas.microsoft.com/office/drawing/2014/main" id="{69AB8053-9415-4973-87C9-EF085EC741C2}"/>
+                <a16:creationId xmlns:a16="http://schemas.microsoft.com/office/drawing/2014/main" id="{6F1CFE25-0D55-4B39-B0AC-A28F10D689E4}"/>
               </a:ext>
             </a:extLst>
           </p:cNvPr>
@@ -5871,7 +5871,7 @@
           <p:nvPr/>
         </p:nvPicPr>
         <p:blipFill>
-          <a:blip xmlns:r="http://schemas.openxmlformats.org/officeDocument/2006/relationships" xmlns:a="http://schemas.openxmlformats.org/drawingml/2006/main" r:embed="Rd2f45ab177fb426e"/>
+          <a:blip xmlns:r="http://schemas.openxmlformats.org/officeDocument/2006/relationships" xmlns:a="http://schemas.openxmlformats.org/drawingml/2006/main" r:embed="R6a04413b82bd47a2"/>
           <a:stretch xmlns:a="http://schemas.openxmlformats.org/drawingml/2006/main"/>
         </p:blipFill>
         <p:spPr>
@@ -5889,7 +5889,7 @@
           <p:cNvPr id="4" name="">
             <a:extLst xmlns:a="http://schemas.openxmlformats.org/drawingml/2006/main">
               <a:ext uri="{FF2B5EF4-FFF2-40B4-BE49-F238E27FC236}">
-                <a16:creationId xmlns:a16="http://schemas.microsoft.com/office/drawing/2014/main" id="{FF445D8E-6F8E-47BA-A40B-D53CAB3B5D7D}"/>
+                <a16:creationId xmlns:a16="http://schemas.microsoft.com/office/drawing/2014/main" id="{13E5923D-AAA6-4550-BA75-53BEA55533E6}"/>
               </a:ext>
             </a:extLst>
           </p:cNvPr>
@@ -5899,7 +5899,7 @@
           <p:nvPr/>
         </p:nvPicPr>
         <p:blipFill>
-          <a:blip xmlns:r="http://schemas.openxmlformats.org/officeDocument/2006/relationships" xmlns:a="http://schemas.openxmlformats.org/drawingml/2006/main" r:embed="R7e9e23ab731a4bf0"/>
+          <a:blip xmlns:r="http://schemas.openxmlformats.org/officeDocument/2006/relationships" xmlns:a="http://schemas.openxmlformats.org/drawingml/2006/main" r:embed="Rd86003c4141c42be"/>
           <a:stretch xmlns:a="http://schemas.openxmlformats.org/drawingml/2006/main"/>
         </p:blipFill>
         <p:spPr>
@@ -5917,7 +5917,7 @@
           <p:cNvPr id="5" name="">
             <a:extLst xmlns:a="http://schemas.openxmlformats.org/drawingml/2006/main">
               <a:ext uri="{FF2B5EF4-FFF2-40B4-BE49-F238E27FC236}">
-                <a16:creationId xmlns:a16="http://schemas.microsoft.com/office/drawing/2014/main" id="{4EFEE3A6-E3B9-4E4D-A81D-155F86A9296E}"/>
+                <a16:creationId xmlns:a16="http://schemas.microsoft.com/office/drawing/2014/main" id="{CC2A9B05-7DE3-406F-B139-58576E3C0A3B}"/>
               </a:ext>
             </a:extLst>
           </p:cNvPr>
@@ -5927,7 +5927,7 @@
           <p:nvPr/>
         </p:nvPicPr>
         <p:blipFill>
-          <a:blip xmlns:r="http://schemas.openxmlformats.org/officeDocument/2006/relationships" xmlns:a="http://schemas.openxmlformats.org/drawingml/2006/main" r:embed="Rcdece9af19614c8e"/>
+          <a:blip xmlns:r="http://schemas.openxmlformats.org/officeDocument/2006/relationships" xmlns:a="http://schemas.openxmlformats.org/drawingml/2006/main" r:embed="R4b846e0b63914687"/>
           <a:stretch xmlns:a="http://schemas.openxmlformats.org/drawingml/2006/main"/>
         </p:blipFill>
         <p:spPr>
@@ -5945,7 +5945,7 @@
           <p:cNvPr id="6" name="">
             <a:extLst xmlns:a="http://schemas.openxmlformats.org/drawingml/2006/main">
               <a:ext uri="{FF2B5EF4-FFF2-40B4-BE49-F238E27FC236}">
-                <a16:creationId xmlns:a16="http://schemas.microsoft.com/office/drawing/2014/main" id="{08ED8078-069C-4B0A-AC12-9EA94A3149C6}"/>
+                <a16:creationId xmlns:a16="http://schemas.microsoft.com/office/drawing/2014/main" id="{EF748054-1A61-4BFE-A2D7-3507348C7EF7}"/>
               </a:ext>
             </a:extLst>
           </p:cNvPr>
@@ -6101,7 +6101,7 @@
           <p:cNvPr id="7" name="">
             <a:extLst xmlns:a="http://schemas.openxmlformats.org/drawingml/2006/main">
               <a:ext uri="{FF2B5EF4-FFF2-40B4-BE49-F238E27FC236}">
-                <a16:creationId xmlns:a16="http://schemas.microsoft.com/office/drawing/2014/main" id="{97720A20-0A40-458D-9A3C-E4E95C03C804}"/>
+                <a16:creationId xmlns:a16="http://schemas.microsoft.com/office/drawing/2014/main" id="{1EEDA8A5-E00C-413A-B379-0DB7DC5F133B}"/>
               </a:ext>
             </a:extLst>
           </p:cNvPr>
@@ -6257,7 +6257,7 @@
           <p:cNvPr id="8" name="">
             <a:extLst xmlns:a="http://schemas.openxmlformats.org/drawingml/2006/main">
               <a:ext uri="{FF2B5EF4-FFF2-40B4-BE49-F238E27FC236}">
-                <a16:creationId xmlns:a16="http://schemas.microsoft.com/office/drawing/2014/main" id="{362196D2-8430-4897-94E8-65BA0B8AB084}"/>
+                <a16:creationId xmlns:a16="http://schemas.microsoft.com/office/drawing/2014/main" id="{184590FA-726C-49B1-9888-4F5A1C5A6E48}"/>
               </a:ext>
             </a:extLst>
           </p:cNvPr>
@@ -6413,7 +6413,7 @@
           <p:cNvPr id="9" name="">
             <a:extLst xmlns:a="http://schemas.openxmlformats.org/drawingml/2006/main">
               <a:ext uri="{FF2B5EF4-FFF2-40B4-BE49-F238E27FC236}">
-                <a16:creationId xmlns:a16="http://schemas.microsoft.com/office/drawing/2014/main" id="{202AB696-7717-4BB4-8A98-167DE303C926}"/>
+                <a16:creationId xmlns:a16="http://schemas.microsoft.com/office/drawing/2014/main" id="{55385766-6399-4BFB-B3F5-57EDF2C653A4}"/>
               </a:ext>
             </a:extLst>
           </p:cNvPr>
@@ -6569,7 +6569,7 @@
           <p:cNvPr id="10" name="">
             <a:extLst xmlns:a="http://schemas.openxmlformats.org/drawingml/2006/main">
               <a:ext uri="{FF2B5EF4-FFF2-40B4-BE49-F238E27FC236}">
-                <a16:creationId xmlns:a16="http://schemas.microsoft.com/office/drawing/2014/main" id="{DE83D981-4BBC-46F3-A5E6-B90756678EDC}"/>
+                <a16:creationId xmlns:a16="http://schemas.microsoft.com/office/drawing/2014/main" id="{9D6E8C8F-6400-410F-8D5E-B689EC9D6243}"/>
               </a:ext>
             </a:extLst>
           </p:cNvPr>
@@ -6725,7 +6725,7 @@
           <p:cNvPr id="11" name="">
             <a:extLst xmlns:a="http://schemas.openxmlformats.org/drawingml/2006/main">
               <a:ext uri="{FF2B5EF4-FFF2-40B4-BE49-F238E27FC236}">
-                <a16:creationId xmlns:a16="http://schemas.microsoft.com/office/drawing/2014/main" id="{763892FE-D136-4741-8155-1FCFABBE9AE4}"/>
+                <a16:creationId xmlns:a16="http://schemas.microsoft.com/office/drawing/2014/main" id="{E418DEC9-B6D1-4D40-87F4-4ACEAC4B18CE}"/>
               </a:ext>
             </a:extLst>
           </p:cNvPr>
@@ -6879,7 +6879,7 @@
     </p:spTree>
     <p:extLst>
       <p:ext uri="{BB962C8B-B14F-4D97-AF65-F5344CB8AC3E}">
-        <p14:creationId xmlns:p14="http://schemas.microsoft.com/office/powerpoint/2010/main" val="1285272463"/>
+        <p14:creationId xmlns:p14="http://schemas.microsoft.com/office/powerpoint/2010/main" val="755773128"/>
       </p:ext>
     </p:extLst>
   </p:cSld>
@@ -6910,7 +6910,7 @@
           <p:cNvPr id="14" name="">
             <a:extLst xmlns:a="http://schemas.openxmlformats.org/drawingml/2006/main">
               <a:ext uri="{FF2B5EF4-FFF2-40B4-BE49-F238E27FC236}">
-                <a16:creationId xmlns:a16="http://schemas.microsoft.com/office/drawing/2014/main" id="{1BA51A39-3FDE-4261-917A-C4AE5C38B810}"/>
+                <a16:creationId xmlns:a16="http://schemas.microsoft.com/office/drawing/2014/main" id="{701087F5-1877-44D0-A614-2AF6F03CD724}"/>
               </a:ext>
             </a:extLst>
           </p:cNvPr>
@@ -7066,7 +7066,7 @@
           <p:cNvPr id="2" name="">
             <a:extLst xmlns:a="http://schemas.openxmlformats.org/drawingml/2006/main">
               <a:ext uri="{FF2B5EF4-FFF2-40B4-BE49-F238E27FC236}">
-                <a16:creationId xmlns:a16="http://schemas.microsoft.com/office/drawing/2014/main" id="{10C6F29E-AD5A-4D77-BCD1-798B589C0148}"/>
+                <a16:creationId xmlns:a16="http://schemas.microsoft.com/office/drawing/2014/main" id="{D629E88F-2F88-40E0-8147-69FFFAAB0EC4}"/>
               </a:ext>
             </a:extLst>
           </p:cNvPr>
@@ -7222,7 +7222,7 @@
           <p:cNvPr id="3" name="">
             <a:extLst xmlns:a="http://schemas.openxmlformats.org/drawingml/2006/main">
               <a:ext uri="{FF2B5EF4-FFF2-40B4-BE49-F238E27FC236}">
-                <a16:creationId xmlns:a16="http://schemas.microsoft.com/office/drawing/2014/main" id="{FD97800E-870B-4F9A-80DF-6DF712B8E93A}"/>
+                <a16:creationId xmlns:a16="http://schemas.microsoft.com/office/drawing/2014/main" id="{3B171407-609F-4982-9509-AC938684F2DA}"/>
               </a:ext>
             </a:extLst>
           </p:cNvPr>
@@ -7378,7 +7378,7 @@
           <p:cNvPr id="4" name="">
             <a:extLst xmlns:a="http://schemas.openxmlformats.org/drawingml/2006/main">
               <a:ext uri="{FF2B5EF4-FFF2-40B4-BE49-F238E27FC236}">
-                <a16:creationId xmlns:a16="http://schemas.microsoft.com/office/drawing/2014/main" id="{75C6D820-F814-40D5-AFFE-51E2A0316EF1}"/>
+                <a16:creationId xmlns:a16="http://schemas.microsoft.com/office/drawing/2014/main" id="{B10CADE0-6AAF-4708-ADD4-FEEF23DB2D6C}"/>
               </a:ext>
             </a:extLst>
           </p:cNvPr>
@@ -7534,7 +7534,7 @@
           <p:cNvPr id="5" name="">
             <a:extLst xmlns:a="http://schemas.openxmlformats.org/drawingml/2006/main">
               <a:ext uri="{FF2B5EF4-FFF2-40B4-BE49-F238E27FC236}">
-                <a16:creationId xmlns:a16="http://schemas.microsoft.com/office/drawing/2014/main" id="{6918F6AF-5C4F-4A50-A94B-D12CC004D94E}"/>
+                <a16:creationId xmlns:a16="http://schemas.microsoft.com/office/drawing/2014/main" id="{8A384F04-0ADA-431C-8E7B-32E1FAAD44FF}"/>
               </a:ext>
             </a:extLst>
           </p:cNvPr>
@@ -7690,7 +7690,7 @@
           <p:cNvPr id="6" name="">
             <a:extLst xmlns:a="http://schemas.openxmlformats.org/drawingml/2006/main">
               <a:ext uri="{FF2B5EF4-FFF2-40B4-BE49-F238E27FC236}">
-                <a16:creationId xmlns:a16="http://schemas.microsoft.com/office/drawing/2014/main" id="{1F641B54-1190-49DD-80DB-B7EEC526B942}"/>
+                <a16:creationId xmlns:a16="http://schemas.microsoft.com/office/drawing/2014/main" id="{28B033F7-0977-4C20-95F0-E396D341C55A}"/>
               </a:ext>
             </a:extLst>
           </p:cNvPr>
@@ -7846,7 +7846,7 @@
           <p:cNvPr id="7" name="">
             <a:extLst xmlns:a="http://schemas.openxmlformats.org/drawingml/2006/main">
               <a:ext uri="{FF2B5EF4-FFF2-40B4-BE49-F238E27FC236}">
-                <a16:creationId xmlns:a16="http://schemas.microsoft.com/office/drawing/2014/main" id="{06A8A882-BD8D-4E08-99B6-70156E6A06D7}"/>
+                <a16:creationId xmlns:a16="http://schemas.microsoft.com/office/drawing/2014/main" id="{E982B868-A5F7-452C-83B5-4BAF4336195B}"/>
               </a:ext>
             </a:extLst>
           </p:cNvPr>
@@ -8002,7 +8002,7 @@
           <p:cNvPr id="8" name="">
             <a:extLst xmlns:a="http://schemas.openxmlformats.org/drawingml/2006/main">
               <a:ext uri="{FF2B5EF4-FFF2-40B4-BE49-F238E27FC236}">
-                <a16:creationId xmlns:a16="http://schemas.microsoft.com/office/drawing/2014/main" id="{07C621E1-E62F-48DF-BB2A-607ED304B4A3}"/>
+                <a16:creationId xmlns:a16="http://schemas.microsoft.com/office/drawing/2014/main" id="{61D5BD53-4C13-4CF5-96BF-06C1919A760B}"/>
               </a:ext>
             </a:extLst>
           </p:cNvPr>
@@ -8158,7 +8158,7 @@
           <p:cNvPr id="9" name="">
             <a:extLst xmlns:a="http://schemas.openxmlformats.org/drawingml/2006/main">
               <a:ext uri="{FF2B5EF4-FFF2-40B4-BE49-F238E27FC236}">
-                <a16:creationId xmlns:a16="http://schemas.microsoft.com/office/drawing/2014/main" id="{1C6FA715-BEDB-456F-9554-B6F8E36A863F}"/>
+                <a16:creationId xmlns:a16="http://schemas.microsoft.com/office/drawing/2014/main" id="{BCCBD68E-06CD-416A-BAC3-FA5E0FC777EF}"/>
               </a:ext>
             </a:extLst>
           </p:cNvPr>
@@ -8168,7 +8168,7 @@
           <p:nvPr/>
         </p:nvPicPr>
         <p:blipFill>
-          <a:blip xmlns:r="http://schemas.openxmlformats.org/officeDocument/2006/relationships" xmlns:a="http://schemas.openxmlformats.org/drawingml/2006/main" r:embed="R10e7c120506b4ad8"/>
+          <a:blip xmlns:r="http://schemas.openxmlformats.org/officeDocument/2006/relationships" xmlns:a="http://schemas.openxmlformats.org/drawingml/2006/main" r:embed="R22184aab4b0e4c6a"/>
           <a:stretch xmlns:a="http://schemas.openxmlformats.org/drawingml/2006/main"/>
         </p:blipFill>
         <p:spPr>
@@ -8186,7 +8186,7 @@
           <p:cNvPr id="10" name="">
             <a:extLst xmlns:a="http://schemas.openxmlformats.org/drawingml/2006/main">
               <a:ext uri="{FF2B5EF4-FFF2-40B4-BE49-F238E27FC236}">
-                <a16:creationId xmlns:a16="http://schemas.microsoft.com/office/drawing/2014/main" id="{07FE6A20-097C-4975-8807-3D2FF83A9D71}"/>
+                <a16:creationId xmlns:a16="http://schemas.microsoft.com/office/drawing/2014/main" id="{C7105ABF-0260-423A-BC84-7602B39F052A}"/>
               </a:ext>
             </a:extLst>
           </p:cNvPr>
@@ -8196,7 +8196,7 @@
           <p:nvPr/>
         </p:nvPicPr>
         <p:blipFill>
-          <a:blip xmlns:r="http://schemas.openxmlformats.org/officeDocument/2006/relationships" xmlns:a="http://schemas.openxmlformats.org/drawingml/2006/main" r:embed="R547e308f201d4c50"/>
+          <a:blip xmlns:r="http://schemas.openxmlformats.org/officeDocument/2006/relationships" xmlns:a="http://schemas.openxmlformats.org/drawingml/2006/main" r:embed="R879499ea0e9546e1"/>
           <a:stretch xmlns:a="http://schemas.openxmlformats.org/drawingml/2006/main"/>
         </p:blipFill>
         <p:spPr>
@@ -8214,7 +8214,7 @@
           <p:cNvPr id="11" name="">
             <a:extLst xmlns:a="http://schemas.openxmlformats.org/drawingml/2006/main">
               <a:ext uri="{FF2B5EF4-FFF2-40B4-BE49-F238E27FC236}">
-                <a16:creationId xmlns:a16="http://schemas.microsoft.com/office/drawing/2014/main" id="{4BA0CD93-E658-4ED3-9F21-4D3827188928}"/>
+                <a16:creationId xmlns:a16="http://schemas.microsoft.com/office/drawing/2014/main" id="{2C887A12-66CB-43D2-BD2A-CF68BC01CB48}"/>
               </a:ext>
             </a:extLst>
           </p:cNvPr>
@@ -8370,7 +8370,7 @@
           <p:cNvPr id="12" name="">
             <a:extLst xmlns:a="http://schemas.openxmlformats.org/drawingml/2006/main">
               <a:ext uri="{FF2B5EF4-FFF2-40B4-BE49-F238E27FC236}">
-                <a16:creationId xmlns:a16="http://schemas.microsoft.com/office/drawing/2014/main" id="{6547FCDD-04BD-49F4-BCCC-8D5F800115C9}"/>
+                <a16:creationId xmlns:a16="http://schemas.microsoft.com/office/drawing/2014/main" id="{C4804DC4-B950-4842-AE95-ED386FD06833}"/>
               </a:ext>
             </a:extLst>
           </p:cNvPr>
@@ -8526,7 +8526,7 @@
           <p:cNvPr id="13" name="">
             <a:extLst xmlns:a="http://schemas.openxmlformats.org/drawingml/2006/main">
               <a:ext uri="{FF2B5EF4-FFF2-40B4-BE49-F238E27FC236}">
-                <a16:creationId xmlns:a16="http://schemas.microsoft.com/office/drawing/2014/main" id="{029A6C85-F68C-4620-ABAE-4036A07FC493}"/>
+                <a16:creationId xmlns:a16="http://schemas.microsoft.com/office/drawing/2014/main" id="{4EF9ABF1-834C-4467-A754-6EA048250818}"/>
               </a:ext>
             </a:extLst>
           </p:cNvPr>
@@ -8680,7 +8680,7 @@
     </p:spTree>
     <p:extLst>
       <p:ext uri="{BB962C8B-B14F-4D97-AF65-F5344CB8AC3E}">
-        <p14:creationId xmlns:p14="http://schemas.microsoft.com/office/powerpoint/2010/main" val="1319694430"/>
+        <p14:creationId xmlns:p14="http://schemas.microsoft.com/office/powerpoint/2010/main" val="1570819775"/>
       </p:ext>
     </p:extLst>
   </p:cSld>
@@ -8711,7 +8711,7 @@
           <p:cNvPr id="16" name="">
             <a:extLst xmlns:a="http://schemas.openxmlformats.org/drawingml/2006/main">
               <a:ext uri="{FF2B5EF4-FFF2-40B4-BE49-F238E27FC236}">
-                <a16:creationId xmlns:a16="http://schemas.microsoft.com/office/drawing/2014/main" id="{447A75C7-2551-47BE-8158-01FE05AF4BEB}"/>
+                <a16:creationId xmlns:a16="http://schemas.microsoft.com/office/drawing/2014/main" id="{59D999A4-2009-4DB4-BCCC-7C9DD0916B02}"/>
               </a:ext>
             </a:extLst>
           </p:cNvPr>
@@ -8867,7 +8867,7 @@
           <p:cNvPr id="2" name="">
             <a:extLst xmlns:a="http://schemas.openxmlformats.org/drawingml/2006/main">
               <a:ext uri="{FF2B5EF4-FFF2-40B4-BE49-F238E27FC236}">
-                <a16:creationId xmlns:a16="http://schemas.microsoft.com/office/drawing/2014/main" id="{4B3A90B1-B20E-4732-A630-AD6D878806F9}"/>
+                <a16:creationId xmlns:a16="http://schemas.microsoft.com/office/drawing/2014/main" id="{AE4ECB7E-CFE5-434F-A6F1-8143EFF67043}"/>
               </a:ext>
             </a:extLst>
           </p:cNvPr>
@@ -9023,7 +9023,7 @@
           <p:cNvPr id="3" name="">
             <a:extLst xmlns:a="http://schemas.openxmlformats.org/drawingml/2006/main">
               <a:ext uri="{FF2B5EF4-FFF2-40B4-BE49-F238E27FC236}">
-                <a16:creationId xmlns:a16="http://schemas.microsoft.com/office/drawing/2014/main" id="{CFEE1913-1881-4F12-AD31-218ED82145D2}"/>
+                <a16:creationId xmlns:a16="http://schemas.microsoft.com/office/drawing/2014/main" id="{FE32A6EB-951E-493E-A9C9-8EBB91F24CFD}"/>
               </a:ext>
             </a:extLst>
           </p:cNvPr>
@@ -9179,7 +9179,7 @@
           <p:cNvPr id="4" name="">
             <a:extLst xmlns:a="http://schemas.openxmlformats.org/drawingml/2006/main">
               <a:ext uri="{FF2B5EF4-FFF2-40B4-BE49-F238E27FC236}">
-                <a16:creationId xmlns:a16="http://schemas.microsoft.com/office/drawing/2014/main" id="{A2E62A4C-2F82-4454-B4B5-F0A80775CF88}"/>
+                <a16:creationId xmlns:a16="http://schemas.microsoft.com/office/drawing/2014/main" id="{219A3C19-B2D8-47A8-9405-487BFBBF3B77}"/>
               </a:ext>
             </a:extLst>
           </p:cNvPr>
@@ -9335,7 +9335,7 @@
           <p:cNvPr id="5" name="">
             <a:extLst xmlns:a="http://schemas.openxmlformats.org/drawingml/2006/main">
               <a:ext uri="{FF2B5EF4-FFF2-40B4-BE49-F238E27FC236}">
-                <a16:creationId xmlns:a16="http://schemas.microsoft.com/office/drawing/2014/main" id="{3D17EF0B-18C6-4ED3-B6D0-AC160C72C52F}"/>
+                <a16:creationId xmlns:a16="http://schemas.microsoft.com/office/drawing/2014/main" id="{70D7CE41-E154-4727-A0E8-F50D8DFFEC3E}"/>
               </a:ext>
             </a:extLst>
           </p:cNvPr>
@@ -9491,7 +9491,7 @@
           <p:cNvPr id="6" name="">
             <a:extLst xmlns:a="http://schemas.openxmlformats.org/drawingml/2006/main">
               <a:ext uri="{FF2B5EF4-FFF2-40B4-BE49-F238E27FC236}">
-                <a16:creationId xmlns:a16="http://schemas.microsoft.com/office/drawing/2014/main" id="{026B4A45-6073-4BD9-9749-C2384AD99CD0}"/>
+                <a16:creationId xmlns:a16="http://schemas.microsoft.com/office/drawing/2014/main" id="{CFCE37AD-F699-49E4-92E5-8118A48285BE}"/>
               </a:ext>
             </a:extLst>
           </p:cNvPr>
@@ -9647,7 +9647,7 @@
           <p:cNvPr id="7" name="">
             <a:extLst xmlns:a="http://schemas.openxmlformats.org/drawingml/2006/main">
               <a:ext uri="{FF2B5EF4-FFF2-40B4-BE49-F238E27FC236}">
-                <a16:creationId xmlns:a16="http://schemas.microsoft.com/office/drawing/2014/main" id="{163FF95C-23BB-4774-868A-70E7BCB849FC}"/>
+                <a16:creationId xmlns:a16="http://schemas.microsoft.com/office/drawing/2014/main" id="{C9E4E48F-42B4-404A-929D-EFCA9D4A3ED6}"/>
               </a:ext>
             </a:extLst>
           </p:cNvPr>
@@ -9803,7 +9803,7 @@
           <p:cNvPr id="8" name="">
             <a:extLst xmlns:a="http://schemas.openxmlformats.org/drawingml/2006/main">
               <a:ext uri="{FF2B5EF4-FFF2-40B4-BE49-F238E27FC236}">
-                <a16:creationId xmlns:a16="http://schemas.microsoft.com/office/drawing/2014/main" id="{824D954A-7AB2-4BFE-BA7E-490BCD3D11F4}"/>
+                <a16:creationId xmlns:a16="http://schemas.microsoft.com/office/drawing/2014/main" id="{0F4D9737-E4D4-432E-9CA2-6E0A98BBE1A6}"/>
               </a:ext>
             </a:extLst>
           </p:cNvPr>
@@ -9959,7 +9959,7 @@
           <p:cNvPr id="9" name="">
             <a:extLst xmlns:a="http://schemas.openxmlformats.org/drawingml/2006/main">
               <a:ext uri="{FF2B5EF4-FFF2-40B4-BE49-F238E27FC236}">
-                <a16:creationId xmlns:a16="http://schemas.microsoft.com/office/drawing/2014/main" id="{F8515B6C-1D57-41D7-B7A0-B27879F556BD}"/>
+                <a16:creationId xmlns:a16="http://schemas.microsoft.com/office/drawing/2014/main" id="{36DD9B65-600D-446D-B92B-E1D7BDD82E9B}"/>
               </a:ext>
             </a:extLst>
           </p:cNvPr>
@@ -10115,7 +10115,7 @@
           <p:cNvPr id="10" name="">
             <a:extLst xmlns:a="http://schemas.openxmlformats.org/drawingml/2006/main">
               <a:ext uri="{FF2B5EF4-FFF2-40B4-BE49-F238E27FC236}">
-                <a16:creationId xmlns:a16="http://schemas.microsoft.com/office/drawing/2014/main" id="{C9226C9F-CFEE-4357-BB47-606FC95A764B}"/>
+                <a16:creationId xmlns:a16="http://schemas.microsoft.com/office/drawing/2014/main" id="{1B1447EF-513C-429F-BE89-7086F8D15A14}"/>
               </a:ext>
             </a:extLst>
           </p:cNvPr>
@@ -10126,7 +10126,7 @@
         </p:nvSpPr>
         <p:spPr>
           <a:xfrm xmlns:a="http://schemas.openxmlformats.org/drawingml/2006/main">
-            <a:off x="590550" y="5476875"/>
+            <a:off x="590550" y="5381625"/>
             <a:ext cx="10906125" cy="285750"/>
           </a:xfrm>
           <a:prstGeom xmlns:a="http://schemas.openxmlformats.org/drawingml/2006/main" prst="rect">
@@ -10271,7 +10271,7 @@
           <p:cNvPr id="11" name="">
             <a:extLst xmlns:a="http://schemas.openxmlformats.org/drawingml/2006/main">
               <a:ext uri="{FF2B5EF4-FFF2-40B4-BE49-F238E27FC236}">
-                <a16:creationId xmlns:a16="http://schemas.microsoft.com/office/drawing/2014/main" id="{2283BE05-BB71-489F-9F23-9AAB65EB3F31}"/>
+                <a16:creationId xmlns:a16="http://schemas.microsoft.com/office/drawing/2014/main" id="{6470C890-ADA5-4E35-8E53-9D138A9D71EF}"/>
               </a:ext>
             </a:extLst>
           </p:cNvPr>
@@ -10282,8 +10282,8 @@
         </p:nvSpPr>
         <p:spPr>
           <a:xfrm xmlns:a="http://schemas.openxmlformats.org/drawingml/2006/main">
-            <a:off x="590550" y="5867400"/>
-            <a:ext cx="10906125" cy="609600"/>
+            <a:off x="590550" y="5743575"/>
+            <a:ext cx="10906125" cy="409575"/>
           </a:xfrm>
           <a:prstGeom xmlns:a="http://schemas.openxmlformats.org/drawingml/2006/main" prst="rect">
             <a:avLst/>
@@ -10297,7 +10297,7 @@
           <a:bodyPr xmlns:a="http://schemas.openxmlformats.org/drawingml/2006/main"/>
           <a:lstStyle xmlns:a="http://schemas.openxmlformats.org/drawingml/2006/main">
             <a:defPPr>
-              <a:defRPr sz="1500" b="0">
+              <a:defRPr sz="1275" b="0">
                 <a:solidFill>
                   <a:srgbClr val="17263E"/>
                 </a:solidFill>
@@ -10307,7 +10307,7 @@
               </a:defRPr>
             </a:defPPr>
             <a:lvl1pPr>
-              <a:defRPr sz="1500" b="0">
+              <a:defRPr sz="1275" b="0">
                 <a:solidFill>
                   <a:srgbClr val="17263E"/>
                 </a:solidFill>
@@ -10317,7 +10317,7 @@
               </a:defRPr>
             </a:lvl1pPr>
             <a:lvl2pPr>
-              <a:defRPr sz="1500" b="0">
+              <a:defRPr sz="1275" b="0">
                 <a:solidFill>
                   <a:srgbClr val="17263E"/>
                 </a:solidFill>
@@ -10327,7 +10327,7 @@
               </a:defRPr>
             </a:lvl2pPr>
             <a:lvl3pPr>
-              <a:defRPr sz="1500" b="0">
+              <a:defRPr sz="1275" b="0">
                 <a:solidFill>
                   <a:srgbClr val="17263E"/>
                 </a:solidFill>
@@ -10337,7 +10337,7 @@
               </a:defRPr>
             </a:lvl3pPr>
             <a:lvl4pPr>
-              <a:defRPr sz="1500" b="0">
+              <a:defRPr sz="1275" b="0">
                 <a:solidFill>
                   <a:srgbClr val="17263E"/>
                 </a:solidFill>
@@ -10347,7 +10347,7 @@
               </a:defRPr>
             </a:lvl4pPr>
             <a:lvl5pPr>
-              <a:defRPr sz="1500" b="0">
+              <a:defRPr sz="1275" b="0">
                 <a:solidFill>
                   <a:srgbClr val="17263E"/>
                 </a:solidFill>
@@ -10357,7 +10357,7 @@
               </a:defRPr>
             </a:lvl5pPr>
             <a:lvl6pPr>
-              <a:defRPr sz="1500" b="0">
+              <a:defRPr sz="1275" b="0">
                 <a:solidFill>
                   <a:srgbClr val="17263E"/>
                 </a:solidFill>
@@ -10367,7 +10367,7 @@
               </a:defRPr>
             </a:lvl6pPr>
             <a:lvl7pPr>
-              <a:defRPr sz="1500" b="0">
+              <a:defRPr sz="1275" b="0">
                 <a:solidFill>
                   <a:srgbClr val="17263E"/>
                 </a:solidFill>
@@ -10377,7 +10377,7 @@
               </a:defRPr>
             </a:lvl7pPr>
             <a:lvl8pPr>
-              <a:defRPr sz="1500" b="0">
+              <a:defRPr sz="1275" b="0">
                 <a:solidFill>
                   <a:srgbClr val="17263E"/>
                 </a:solidFill>
@@ -10387,7 +10387,7 @@
               </a:defRPr>
             </a:lvl8pPr>
             <a:lvl9pPr>
-              <a:defRPr sz="1500" b="0">
+              <a:defRPr sz="1275" b="0">
                 <a:solidFill>
                   <a:srgbClr val="17263E"/>
                 </a:solidFill>
@@ -10399,7 +10399,7 @@
           </a:lstStyle>
           <a:p xmlns:a="http://schemas.openxmlformats.org/drawingml/2006/main">
             <a:pPr>
-              <a:defRPr sz="1500" b="0">
+              <a:defRPr sz="1275" b="0">
                 <a:solidFill>
                   <a:srgbClr val="17263E"/>
                 </a:solidFill>
@@ -10409,7 +10409,7 @@
               </a:defRPr>
             </a:pPr>
             <a:r>
-              <a:rPr sz="1500" b="0">
+              <a:rPr sz="1275" b="0">
                 <a:solidFill>
                   <a:srgbClr val="17263E"/>
                 </a:solidFill>
@@ -10427,7 +10427,7 @@
           <p:cNvPr id="12" name="">
             <a:extLst xmlns:a="http://schemas.openxmlformats.org/drawingml/2006/main">
               <a:ext uri="{FF2B5EF4-FFF2-40B4-BE49-F238E27FC236}">
-                <a16:creationId xmlns:a16="http://schemas.microsoft.com/office/drawing/2014/main" id="{ED647636-57A9-46D9-BB1B-B640EEFD805D}"/>
+                <a16:creationId xmlns:a16="http://schemas.microsoft.com/office/drawing/2014/main" id="{17B3CC58-DDEA-4CC2-9189-C64EE2616DA9}"/>
               </a:ext>
             </a:extLst>
           </p:cNvPr>
@@ -10438,8 +10438,8 @@
         </p:nvSpPr>
         <p:spPr>
           <a:xfrm xmlns:a="http://schemas.openxmlformats.org/drawingml/2006/main">
-            <a:off x="590550" y="6572250"/>
-            <a:ext cx="3600450" cy="190500"/>
+            <a:off x="590550" y="6219825"/>
+            <a:ext cx="10953750" cy="190500"/>
           </a:xfrm>
           <a:prstGeom xmlns:a="http://schemas.openxmlformats.org/drawingml/2006/main" prst="rect">
             <a:avLst/>
@@ -10453,7 +10453,7 @@
           <a:bodyPr xmlns:a="http://schemas.openxmlformats.org/drawingml/2006/main"/>
           <a:lstStyle xmlns:a="http://schemas.openxmlformats.org/drawingml/2006/main">
             <a:defPPr>
-              <a:defRPr sz="900" b="0">
+              <a:defRPr sz="975" b="0">
                 <a:solidFill>
                   <a:srgbClr val="28369F"/>
                 </a:solidFill>
@@ -10463,7 +10463,7 @@
               </a:defRPr>
             </a:defPPr>
             <a:lvl1pPr>
-              <a:defRPr sz="900" b="0">
+              <a:defRPr sz="975" b="0">
                 <a:solidFill>
                   <a:srgbClr val="28369F"/>
                 </a:solidFill>
@@ -10473,7 +10473,7 @@
               </a:defRPr>
             </a:lvl1pPr>
             <a:lvl2pPr>
-              <a:defRPr sz="900" b="0">
+              <a:defRPr sz="975" b="0">
                 <a:solidFill>
                   <a:srgbClr val="28369F"/>
                 </a:solidFill>
@@ -10483,7 +10483,7 @@
               </a:defRPr>
             </a:lvl2pPr>
             <a:lvl3pPr>
-              <a:defRPr sz="900" b="0">
+              <a:defRPr sz="975" b="0">
                 <a:solidFill>
                   <a:srgbClr val="28369F"/>
                 </a:solidFill>
@@ -10493,7 +10493,7 @@
               </a:defRPr>
             </a:lvl3pPr>
             <a:lvl4pPr>
-              <a:defRPr sz="900" b="0">
+              <a:defRPr sz="975" b="0">
                 <a:solidFill>
                   <a:srgbClr val="28369F"/>
                 </a:solidFill>
@@ -10503,7 +10503,7 @@
               </a:defRPr>
             </a:lvl4pPr>
             <a:lvl5pPr>
-              <a:defRPr sz="900" b="0">
+              <a:defRPr sz="975" b="0">
                 <a:solidFill>
                   <a:srgbClr val="28369F"/>
                 </a:solidFill>
@@ -10513,7 +10513,7 @@
               </a:defRPr>
             </a:lvl5pPr>
             <a:lvl6pPr>
-              <a:defRPr sz="900" b="0">
+              <a:defRPr sz="975" b="0">
                 <a:solidFill>
                   <a:srgbClr val="28369F"/>
                 </a:solidFill>
@@ -10523,7 +10523,7 @@
               </a:defRPr>
             </a:lvl6pPr>
             <a:lvl7pPr>
-              <a:defRPr sz="900" b="0">
+              <a:defRPr sz="975" b="0">
                 <a:solidFill>
                   <a:srgbClr val="28369F"/>
                 </a:solidFill>
@@ -10533,7 +10533,7 @@
               </a:defRPr>
             </a:lvl7pPr>
             <a:lvl8pPr>
-              <a:defRPr sz="900" b="0">
+              <a:defRPr sz="975" b="0">
                 <a:solidFill>
                   <a:srgbClr val="28369F"/>
                 </a:solidFill>
@@ -10543,7 +10543,7 @@
               </a:defRPr>
             </a:lvl8pPr>
             <a:lvl9pPr>
-              <a:defRPr sz="900" b="0">
+              <a:defRPr sz="975" b="0">
                 <a:solidFill>
                   <a:srgbClr val="28369F"/>
                 </a:solidFill>
@@ -10555,7 +10555,7 @@
           </a:lstStyle>
           <a:p xmlns:a="http://schemas.openxmlformats.org/drawingml/2006/main">
             <a:pPr>
-              <a:defRPr sz="900" b="0">
+              <a:defRPr sz="975" b="0">
                 <a:solidFill>
                   <a:srgbClr val="28369F"/>
                 </a:solidFill>
@@ -10565,16 +10565,16 @@
               </a:defRPr>
             </a:pPr>
             <a:r>
-              <a:rPr sz="900" b="0">
-                <a:solidFill>
-                  <a:srgbClr val="28369F"/>
-                </a:solidFill>
-                <a:latin typeface="Arial"/>
-                <a:ea typeface="Arial"/>
-                <a:cs typeface="Arial"/>
-                <a:hlinkClick xmlns:r="http://schemas.openxmlformats.org/officeDocument/2006/relationships" r:id="Rd973f5da87c64ba4"/>
+              <a:rPr sz="975" b="0">
+                <a:solidFill>
+                  <a:srgbClr val="28369F"/>
+                </a:solidFill>
+                <a:latin typeface="Arial"/>
+                <a:ea typeface="Arial"/>
+                <a:cs typeface="Arial"/>
+                <a:hlinkClick xmlns:r="http://schemas.openxmlformats.org/officeDocument/2006/relationships" r:id="R49fa4cb56cfe45e1"/>
               </a:rPr>
-              <a:t>Android study: Haverkamp et al.</a:t>
+              <a:t>Android reading study: https://doi.org/10.1007/s11145-022-10328-9</a:t>
             </a:r>
           </a:p>
         </p:txBody>
@@ -10584,7 +10584,7 @@
           <p:cNvPr id="13" name="">
             <a:extLst xmlns:a="http://schemas.openxmlformats.org/drawingml/2006/main">
               <a:ext uri="{FF2B5EF4-FFF2-40B4-BE49-F238E27FC236}">
-                <a16:creationId xmlns:a16="http://schemas.microsoft.com/office/drawing/2014/main" id="{9B061FA3-9ECA-4983-83B0-D974D3E98411}"/>
+                <a16:creationId xmlns:a16="http://schemas.microsoft.com/office/drawing/2014/main" id="{22D7FAEF-0DFD-4D12-B6F7-E5903DC4E576}"/>
               </a:ext>
             </a:extLst>
           </p:cNvPr>
@@ -10595,8 +10595,8 @@
         </p:nvSpPr>
         <p:spPr>
           <a:xfrm xmlns:a="http://schemas.openxmlformats.org/drawingml/2006/main">
-            <a:off x="4305300" y="6572250"/>
-            <a:ext cx="3600450" cy="190500"/>
+            <a:off x="590550" y="6419850"/>
+            <a:ext cx="10953750" cy="190500"/>
           </a:xfrm>
           <a:prstGeom xmlns:a="http://schemas.openxmlformats.org/drawingml/2006/main" prst="rect">
             <a:avLst/>
@@ -10610,7 +10610,7 @@
           <a:bodyPr xmlns:a="http://schemas.openxmlformats.org/drawingml/2006/main"/>
           <a:lstStyle xmlns:a="http://schemas.openxmlformats.org/drawingml/2006/main">
             <a:defPPr>
-              <a:defRPr sz="900" b="0">
+              <a:defRPr sz="975" b="0">
                 <a:solidFill>
                   <a:srgbClr val="28369F"/>
                 </a:solidFill>
@@ -10620,7 +10620,7 @@
               </a:defRPr>
             </a:defPPr>
             <a:lvl1pPr>
-              <a:defRPr sz="900" b="0">
+              <a:defRPr sz="975" b="0">
                 <a:solidFill>
                   <a:srgbClr val="28369F"/>
                 </a:solidFill>
@@ -10630,7 +10630,7 @@
               </a:defRPr>
             </a:lvl1pPr>
             <a:lvl2pPr>
-              <a:defRPr sz="900" b="0">
+              <a:defRPr sz="975" b="0">
                 <a:solidFill>
                   <a:srgbClr val="28369F"/>
                 </a:solidFill>
@@ -10640,7 +10640,7 @@
               </a:defRPr>
             </a:lvl2pPr>
             <a:lvl3pPr>
-              <a:defRPr sz="900" b="0">
+              <a:defRPr sz="975" b="0">
                 <a:solidFill>
                   <a:srgbClr val="28369F"/>
                 </a:solidFill>
@@ -10650,7 +10650,7 @@
               </a:defRPr>
             </a:lvl3pPr>
             <a:lvl4pPr>
-              <a:defRPr sz="900" b="0">
+              <a:defRPr sz="975" b="0">
                 <a:solidFill>
                   <a:srgbClr val="28369F"/>
                 </a:solidFill>
@@ -10660,7 +10660,7 @@
               </a:defRPr>
             </a:lvl4pPr>
             <a:lvl5pPr>
-              <a:defRPr sz="900" b="0">
+              <a:defRPr sz="975" b="0">
                 <a:solidFill>
                   <a:srgbClr val="28369F"/>
                 </a:solidFill>
@@ -10670,7 +10670,7 @@
               </a:defRPr>
             </a:lvl5pPr>
             <a:lvl6pPr>
-              <a:defRPr sz="900" b="0">
+              <a:defRPr sz="975" b="0">
                 <a:solidFill>
                   <a:srgbClr val="28369F"/>
                 </a:solidFill>
@@ -10680,7 +10680,7 @@
               </a:defRPr>
             </a:lvl6pPr>
             <a:lvl7pPr>
-              <a:defRPr sz="900" b="0">
+              <a:defRPr sz="975" b="0">
                 <a:solidFill>
                   <a:srgbClr val="28369F"/>
                 </a:solidFill>
@@ -10690,7 +10690,7 @@
               </a:defRPr>
             </a:lvl7pPr>
             <a:lvl8pPr>
-              <a:defRPr sz="900" b="0">
+              <a:defRPr sz="975" b="0">
                 <a:solidFill>
                   <a:srgbClr val="28369F"/>
                 </a:solidFill>
@@ -10700,7 +10700,7 @@
               </a:defRPr>
             </a:lvl8pPr>
             <a:lvl9pPr>
-              <a:defRPr sz="900" b="0">
+              <a:defRPr sz="975" b="0">
                 <a:solidFill>
                   <a:srgbClr val="28369F"/>
                 </a:solidFill>
@@ -10712,7 +10712,7 @@
           </a:lstStyle>
           <a:p xmlns:a="http://schemas.openxmlformats.org/drawingml/2006/main">
             <a:pPr>
-              <a:defRPr sz="900" b="0">
+              <a:defRPr sz="975" b="0">
                 <a:solidFill>
                   <a:srgbClr val="28369F"/>
                 </a:solidFill>
@@ -10722,16 +10722,16 @@
               </a:defRPr>
             </a:pPr>
             <a:r>
-              <a:rPr sz="900" b="0">
-                <a:solidFill>
-                  <a:srgbClr val="28369F"/>
-                </a:solidFill>
-                <a:latin typeface="Arial"/>
-                <a:ea typeface="Arial"/>
-                <a:cs typeface="Arial"/>
-                <a:hlinkClick xmlns:r="http://schemas.openxmlformats.org/officeDocument/2006/relationships" r:id="Rcc9da90cdebe4b97"/>
+              <a:rPr sz="975" b="0">
+                <a:solidFill>
+                  <a:srgbClr val="28369F"/>
+                </a:solidFill>
+                <a:latin typeface="Arial"/>
+                <a:ea typeface="Arial"/>
+                <a:cs typeface="Arial"/>
+                <a:hlinkClick xmlns:r="http://schemas.openxmlformats.org/officeDocument/2006/relationships" r:id="R217c5748a6f14b18"/>
               </a:rPr>
-              <a:t>Choice study: Iyengar &amp; Kamenica</a:t>
+              <a:t>Investment choice study: https://business.columbia.edu/sites/default/files-efs/pubfiles/4519/simplicitySeeking.pdf</a:t>
             </a:r>
           </a:p>
         </p:txBody>
@@ -10741,7 +10741,7 @@
           <p:cNvPr id="14" name="">
             <a:extLst xmlns:a="http://schemas.openxmlformats.org/drawingml/2006/main">
               <a:ext uri="{FF2B5EF4-FFF2-40B4-BE49-F238E27FC236}">
-                <a16:creationId xmlns:a16="http://schemas.microsoft.com/office/drawing/2014/main" id="{7FDCB3BE-8532-410D-ADC2-5AD40A01657C}"/>
+                <a16:creationId xmlns:a16="http://schemas.microsoft.com/office/drawing/2014/main" id="{5090AE19-ABAD-4F53-8609-DC6D1375A12D}"/>
               </a:ext>
             </a:extLst>
           </p:cNvPr>
@@ -10752,8 +10752,8 @@
         </p:nvSpPr>
         <p:spPr>
           <a:xfrm xmlns:a="http://schemas.openxmlformats.org/drawingml/2006/main">
-            <a:off x="8020050" y="6572250"/>
-            <a:ext cx="3600450" cy="190500"/>
+            <a:off x="590550" y="6619875"/>
+            <a:ext cx="10953750" cy="190500"/>
           </a:xfrm>
           <a:prstGeom xmlns:a="http://schemas.openxmlformats.org/drawingml/2006/main" prst="rect">
             <a:avLst/>
@@ -10767,7 +10767,7 @@
           <a:bodyPr xmlns:a="http://schemas.openxmlformats.org/drawingml/2006/main"/>
           <a:lstStyle xmlns:a="http://schemas.openxmlformats.org/drawingml/2006/main">
             <a:defPPr>
-              <a:defRPr sz="900" b="0">
+              <a:defRPr sz="975" b="0">
                 <a:solidFill>
                   <a:srgbClr val="28369F"/>
                 </a:solidFill>
@@ -10777,7 +10777,7 @@
               </a:defRPr>
             </a:defPPr>
             <a:lvl1pPr>
-              <a:defRPr sz="900" b="0">
+              <a:defRPr sz="975" b="0">
                 <a:solidFill>
                   <a:srgbClr val="28369F"/>
                 </a:solidFill>
@@ -10787,7 +10787,7 @@
               </a:defRPr>
             </a:lvl1pPr>
             <a:lvl2pPr>
-              <a:defRPr sz="900" b="0">
+              <a:defRPr sz="975" b="0">
                 <a:solidFill>
                   <a:srgbClr val="28369F"/>
                 </a:solidFill>
@@ -10797,7 +10797,7 @@
               </a:defRPr>
             </a:lvl2pPr>
             <a:lvl3pPr>
-              <a:defRPr sz="900" b="0">
+              <a:defRPr sz="975" b="0">
                 <a:solidFill>
                   <a:srgbClr val="28369F"/>
                 </a:solidFill>
@@ -10807,7 +10807,7 @@
               </a:defRPr>
             </a:lvl3pPr>
             <a:lvl4pPr>
-              <a:defRPr sz="900" b="0">
+              <a:defRPr sz="975" b="0">
                 <a:solidFill>
                   <a:srgbClr val="28369F"/>
                 </a:solidFill>
@@ -10817,7 +10817,7 @@
               </a:defRPr>
             </a:lvl4pPr>
             <a:lvl5pPr>
-              <a:defRPr sz="900" b="0">
+              <a:defRPr sz="975" b="0">
                 <a:solidFill>
                   <a:srgbClr val="28369F"/>
                 </a:solidFill>
@@ -10827,7 +10827,7 @@
               </a:defRPr>
             </a:lvl5pPr>
             <a:lvl6pPr>
-              <a:defRPr sz="900" b="0">
+              <a:defRPr sz="975" b="0">
                 <a:solidFill>
                   <a:srgbClr val="28369F"/>
                 </a:solidFill>
@@ -10837,7 +10837,7 @@
               </a:defRPr>
             </a:lvl6pPr>
             <a:lvl7pPr>
-              <a:defRPr sz="900" b="0">
+              <a:defRPr sz="975" b="0">
                 <a:solidFill>
                   <a:srgbClr val="28369F"/>
                 </a:solidFill>
@@ -10847,7 +10847,7 @@
               </a:defRPr>
             </a:lvl7pPr>
             <a:lvl8pPr>
-              <a:defRPr sz="900" b="0">
+              <a:defRPr sz="975" b="0">
                 <a:solidFill>
                   <a:srgbClr val="28369F"/>
                 </a:solidFill>
@@ -10857,7 +10857,7 @@
               </a:defRPr>
             </a:lvl8pPr>
             <a:lvl9pPr>
-              <a:defRPr sz="900" b="0">
+              <a:defRPr sz="975" b="0">
                 <a:solidFill>
                   <a:srgbClr val="28369F"/>
                 </a:solidFill>
@@ -10869,7 +10869,7 @@
           </a:lstStyle>
           <a:p xmlns:a="http://schemas.openxmlformats.org/drawingml/2006/main">
             <a:pPr>
-              <a:defRPr sz="900" b="0">
+              <a:defRPr sz="975" b="0">
                 <a:solidFill>
                   <a:srgbClr val="28369F"/>
                 </a:solidFill>
@@ -10879,16 +10879,16 @@
               </a:defRPr>
             </a:pPr>
             <a:r>
-              <a:rPr sz="900" b="0">
-                <a:solidFill>
-                  <a:srgbClr val="28369F"/>
-                </a:solidFill>
-                <a:latin typeface="Arial"/>
-                <a:ea typeface="Arial"/>
-                <a:cs typeface="Arial"/>
-                <a:hlinkClick xmlns:r="http://schemas.openxmlformats.org/officeDocument/2006/relationships" r:id="Rc0470a0bba444531"/>
+              <a:rPr sz="975" b="0">
+                <a:solidFill>
+                  <a:srgbClr val="28369F"/>
+                </a:solidFill>
+                <a:latin typeface="Arial"/>
+                <a:ea typeface="Arial"/>
+                <a:cs typeface="Arial"/>
+                <a:hlinkClick xmlns:r="http://schemas.openxmlformats.org/officeDocument/2006/relationships" r:id="Rf053a230241e4eb8"/>
               </a:rPr>
-              <a:t>Motion controls: W3C guidance</a:t>
+              <a:t>Motion guidance (W3C): https://www.w3.org/WAI/tutorials/carousels/</a:t>
             </a:r>
           </a:p>
         </p:txBody>
@@ -10898,7 +10898,7 @@
           <p:cNvPr id="15" name="">
             <a:extLst xmlns:a="http://schemas.openxmlformats.org/drawingml/2006/main">
               <a:ext uri="{FF2B5EF4-FFF2-40B4-BE49-F238E27FC236}">
-                <a16:creationId xmlns:a16="http://schemas.microsoft.com/office/drawing/2014/main" id="{66CAD7F3-5FF1-4ED9-BE41-804FABBA09E8}"/>
+                <a16:creationId xmlns:a16="http://schemas.microsoft.com/office/drawing/2014/main" id="{9E1ACC30-BE6D-453D-9F04-A2BBE3F3CAD5}"/>
               </a:ext>
             </a:extLst>
           </p:cNvPr>
@@ -11052,7 +11052,7 @@
     </p:spTree>
     <p:extLst>
       <p:ext uri="{BB962C8B-B14F-4D97-AF65-F5344CB8AC3E}">
-        <p14:creationId xmlns:p14="http://schemas.microsoft.com/office/powerpoint/2010/main" val="946098292"/>
+        <p14:creationId xmlns:p14="http://schemas.microsoft.com/office/powerpoint/2010/main" val="1510888276"/>
       </p:ext>
     </p:extLst>
   </p:cSld>
@@ -11083,7 +11083,7 @@
           <p:cNvPr id="12" name="">
             <a:extLst xmlns:a="http://schemas.openxmlformats.org/drawingml/2006/main">
               <a:ext uri="{FF2B5EF4-FFF2-40B4-BE49-F238E27FC236}">
-                <a16:creationId xmlns:a16="http://schemas.microsoft.com/office/drawing/2014/main" id="{21A1F8F5-A305-4F05-98A3-8A41C17A1769}"/>
+                <a16:creationId xmlns:a16="http://schemas.microsoft.com/office/drawing/2014/main" id="{CF71AA33-0969-46AF-85F6-2754C3358857}"/>
               </a:ext>
             </a:extLst>
           </p:cNvPr>
@@ -11239,7 +11239,7 @@
           <p:cNvPr id="2" name="">
             <a:extLst xmlns:a="http://schemas.openxmlformats.org/drawingml/2006/main">
               <a:ext uri="{FF2B5EF4-FFF2-40B4-BE49-F238E27FC236}">
-                <a16:creationId xmlns:a16="http://schemas.microsoft.com/office/drawing/2014/main" id="{70D0674B-288E-4989-B6FE-8F7EF8555E6A}"/>
+                <a16:creationId xmlns:a16="http://schemas.microsoft.com/office/drawing/2014/main" id="{E0A825FD-77C8-4496-ABD4-7DAA571D6551}"/>
               </a:ext>
             </a:extLst>
           </p:cNvPr>
@@ -11395,7 +11395,7 @@
           <p:cNvPr id="3" name="">
             <a:extLst xmlns:a="http://schemas.openxmlformats.org/drawingml/2006/main">
               <a:ext uri="{FF2B5EF4-FFF2-40B4-BE49-F238E27FC236}">
-                <a16:creationId xmlns:a16="http://schemas.microsoft.com/office/drawing/2014/main" id="{214688CE-D15B-4252-BAAE-7B486B0C61EE}"/>
+                <a16:creationId xmlns:a16="http://schemas.microsoft.com/office/drawing/2014/main" id="{F18D90EE-FBCB-4A21-BC45-846B17ECCD78}"/>
               </a:ext>
             </a:extLst>
           </p:cNvPr>
@@ -11551,7 +11551,7 @@
           <p:cNvPr id="4" name="">
             <a:extLst xmlns:a="http://schemas.openxmlformats.org/drawingml/2006/main">
               <a:ext uri="{FF2B5EF4-FFF2-40B4-BE49-F238E27FC236}">
-                <a16:creationId xmlns:a16="http://schemas.microsoft.com/office/drawing/2014/main" id="{F4BC9FDD-6E5D-481B-B05C-405F6F46C8B3}"/>
+                <a16:creationId xmlns:a16="http://schemas.microsoft.com/office/drawing/2014/main" id="{2FF56F35-2AAB-40C7-AA96-EFE14E76E8CF}"/>
               </a:ext>
             </a:extLst>
           </p:cNvPr>
@@ -11707,7 +11707,7 @@
           <p:cNvPr id="5" name="">
             <a:extLst xmlns:a="http://schemas.openxmlformats.org/drawingml/2006/main">
               <a:ext uri="{FF2B5EF4-FFF2-40B4-BE49-F238E27FC236}">
-                <a16:creationId xmlns:a16="http://schemas.microsoft.com/office/drawing/2014/main" id="{B48C762B-C9B7-4430-8E61-5C481E97BEA2}"/>
+                <a16:creationId xmlns:a16="http://schemas.microsoft.com/office/drawing/2014/main" id="{1D4573A0-DAC5-43E5-9576-3AEE015C4E37}"/>
               </a:ext>
             </a:extLst>
           </p:cNvPr>
@@ -11863,7 +11863,7 @@
           <p:cNvPr id="6" name="">
             <a:extLst xmlns:a="http://schemas.openxmlformats.org/drawingml/2006/main">
               <a:ext uri="{FF2B5EF4-FFF2-40B4-BE49-F238E27FC236}">
-                <a16:creationId xmlns:a16="http://schemas.microsoft.com/office/drawing/2014/main" id="{091E9CB3-ED59-4233-AC75-F9F9D671CBAA}"/>
+                <a16:creationId xmlns:a16="http://schemas.microsoft.com/office/drawing/2014/main" id="{FBBBD857-CFAC-46ED-9C17-4DA80C9B0E60}"/>
               </a:ext>
             </a:extLst>
           </p:cNvPr>
@@ -12019,7 +12019,7 @@
           <p:cNvPr id="7" name="">
             <a:extLst xmlns:a="http://schemas.openxmlformats.org/drawingml/2006/main">
               <a:ext uri="{FF2B5EF4-FFF2-40B4-BE49-F238E27FC236}">
-                <a16:creationId xmlns:a16="http://schemas.microsoft.com/office/drawing/2014/main" id="{73A4B9C2-4936-4241-9B89-C04BE33F2404}"/>
+                <a16:creationId xmlns:a16="http://schemas.microsoft.com/office/drawing/2014/main" id="{06CB85B3-212D-4F32-89C9-A4D21E95D436}"/>
               </a:ext>
             </a:extLst>
           </p:cNvPr>
@@ -12175,7 +12175,7 @@
           <p:cNvPr id="8" name="">
             <a:extLst xmlns:a="http://schemas.openxmlformats.org/drawingml/2006/main">
               <a:ext uri="{FF2B5EF4-FFF2-40B4-BE49-F238E27FC236}">
-                <a16:creationId xmlns:a16="http://schemas.microsoft.com/office/drawing/2014/main" id="{FA89C21D-2774-4761-A7CF-DDCCBAC58327}"/>
+                <a16:creationId xmlns:a16="http://schemas.microsoft.com/office/drawing/2014/main" id="{2474746D-09D6-4772-8C82-593A55EFEFD6}"/>
               </a:ext>
             </a:extLst>
           </p:cNvPr>
@@ -12331,7 +12331,7 @@
           <p:cNvPr id="9" name="">
             <a:extLst xmlns:a="http://schemas.openxmlformats.org/drawingml/2006/main">
               <a:ext uri="{FF2B5EF4-FFF2-40B4-BE49-F238E27FC236}">
-                <a16:creationId xmlns:a16="http://schemas.microsoft.com/office/drawing/2014/main" id="{D5272F30-19A4-4391-AFAD-12743E0C0A70}"/>
+                <a16:creationId xmlns:a16="http://schemas.microsoft.com/office/drawing/2014/main" id="{FE04F1EE-5D66-43F7-92BB-34C51AC0F308}"/>
               </a:ext>
             </a:extLst>
           </p:cNvPr>
@@ -12487,7 +12487,7 @@
           <p:cNvPr id="10" name="">
             <a:extLst xmlns:a="http://schemas.openxmlformats.org/drawingml/2006/main">
               <a:ext uri="{FF2B5EF4-FFF2-40B4-BE49-F238E27FC236}">
-                <a16:creationId xmlns:a16="http://schemas.microsoft.com/office/drawing/2014/main" id="{3FF5155E-F2D0-4DEF-85EB-7B7D75435473}"/>
+                <a16:creationId xmlns:a16="http://schemas.microsoft.com/office/drawing/2014/main" id="{81E93CBA-704D-4EDD-B2F3-E6A6E712F1CC}"/>
               </a:ext>
             </a:extLst>
           </p:cNvPr>
@@ -12497,7 +12497,7 @@
           <p:nvPr/>
         </p:nvPicPr>
         <p:blipFill>
-          <a:blip xmlns:r="http://schemas.openxmlformats.org/officeDocument/2006/relationships" xmlns:a="http://schemas.openxmlformats.org/drawingml/2006/main" r:embed="Rdc47dd80d33a46e9"/>
+          <a:blip xmlns:r="http://schemas.openxmlformats.org/officeDocument/2006/relationships" xmlns:a="http://schemas.openxmlformats.org/drawingml/2006/main" r:embed="Rdcaf765d1f844c9f"/>
           <a:stretch xmlns:a="http://schemas.openxmlformats.org/drawingml/2006/main"/>
         </p:blipFill>
         <p:spPr>
@@ -12515,7 +12515,7 @@
           <p:cNvPr id="11" name="">
             <a:extLst xmlns:a="http://schemas.openxmlformats.org/drawingml/2006/main">
               <a:ext uri="{FF2B5EF4-FFF2-40B4-BE49-F238E27FC236}">
-                <a16:creationId xmlns:a16="http://schemas.microsoft.com/office/drawing/2014/main" id="{28102F1B-E843-443B-ACAC-A295B99D4DCF}"/>
+                <a16:creationId xmlns:a16="http://schemas.microsoft.com/office/drawing/2014/main" id="{1E6699DA-F0A0-4FFE-899F-0C2AD0364C16}"/>
               </a:ext>
             </a:extLst>
           </p:cNvPr>
@@ -12669,7 +12669,7 @@
     </p:spTree>
     <p:extLst>
       <p:ext uri="{BB962C8B-B14F-4D97-AF65-F5344CB8AC3E}">
-        <p14:creationId xmlns:p14="http://schemas.microsoft.com/office/powerpoint/2010/main" val="2056576791"/>
+        <p14:creationId xmlns:p14="http://schemas.microsoft.com/office/powerpoint/2010/main" val="1735483072"/>
       </p:ext>
     </p:extLst>
   </p:cSld>

</xml_diff>

<commit_message>
Align deck with highlighted managed portfolios catalogue
</commit_message>
<xml_diff>
--- a/deliverables/Ionic-Exclusives-Final.pptx
+++ b/deliverables/Ionic-Exclusives-Final.pptx
@@ -2,17 +2,17 @@
 <file path=ppt/presentation.xml><?xml version="1.0" encoding="utf-8"?>
 <p:presentation xmlns:p="http://schemas.openxmlformats.org/presentationml/2006/main">
   <p:sldMasterIdLst>
-    <p:sldMasterId xmlns:r="http://schemas.openxmlformats.org/officeDocument/2006/relationships" id="2147483648" r:id="R201289346bf6490e"/>
+    <p:sldMasterId xmlns:r="http://schemas.openxmlformats.org/officeDocument/2006/relationships" id="2147483648" r:id="R4063b06ed80d4cc0"/>
   </p:sldMasterIdLst>
   <p:notesMasterIdLst>
-    <p:notesMasterId xmlns:r="http://schemas.openxmlformats.org/officeDocument/2006/relationships" r:id="R860f6577569b4723"/>
+    <p:notesMasterId xmlns:r="http://schemas.openxmlformats.org/officeDocument/2006/relationships" r:id="Rc5a906d625804e54"/>
   </p:notesMasterIdLst>
   <p:sldIdLst>
-    <p:sldId xmlns:r="http://schemas.openxmlformats.org/officeDocument/2006/relationships" id="256" r:id="R3d0095d382494982"/>
-    <p:sldId xmlns:r="http://schemas.openxmlformats.org/officeDocument/2006/relationships" id="257" r:id="R78d75236b14b49c9"/>
-    <p:sldId xmlns:r="http://schemas.openxmlformats.org/officeDocument/2006/relationships" id="258" r:id="Rdb4a2fafadcc4158"/>
-    <p:sldId xmlns:r="http://schemas.openxmlformats.org/officeDocument/2006/relationships" id="259" r:id="R0ead2bcf96184638"/>
-    <p:sldId xmlns:r="http://schemas.openxmlformats.org/officeDocument/2006/relationships" id="260" r:id="R91e9ec1a2b9f437a"/>
+    <p:sldId xmlns:r="http://schemas.openxmlformats.org/officeDocument/2006/relationships" id="256" r:id="Rc211c3f0f8de474b"/>
+    <p:sldId xmlns:r="http://schemas.openxmlformats.org/officeDocument/2006/relationships" id="257" r:id="R2e14e39e6e384ad5"/>
+    <p:sldId xmlns:r="http://schemas.openxmlformats.org/officeDocument/2006/relationships" id="258" r:id="Re06b4fe892a94216"/>
+    <p:sldId xmlns:r="http://schemas.openxmlformats.org/officeDocument/2006/relationships" id="259" r:id="Rf458067f4770462b"/>
+    <p:sldId xmlns:r="http://schemas.openxmlformats.org/officeDocument/2006/relationships" id="260" r:id="R28a1ce5f0f114dcd"/>
   </p:sldIdLst>
   <p:sldSz cx="12192000" cy="6858000"/>
   <p:notesSz cx="6858000" cy="9144000"/>
@@ -516,7 +516,7 @@
           <a:lstStyle xmlns:a="http://schemas.openxmlformats.org/drawingml/2006/main"/>
           <a:p xmlns:a="http://schemas.openxmlformats.org/drawingml/2006/main">
             <a:r>
-              <a:t>Screenshots from the current working proposal. All three categories sit below the hero. US stocks show captured prices and daily moves, a two-stock comparison and product details. Funds show captured performance with period labels; details contain investment facts. Historical returns do not predict future returns. Private Wealth screenshot shows the catalogue after the welcome: 9 PMS, 3 AIF and 6 SIF offerings. Figures are fixtures, not live quotes. Desktop uses a 392px presentation frame; real phones fill the viewport without the frame. The two stock rails move at 14 CSS pixels per second, with pause, drag, automatic resumption and reduced-motion support. Welcome animation belongs in Appendix 5, not as the main evidence of product value.</a:t>
+              <a:t>Screenshots from the current working proposal. All three categories sit below the hero. US stocks show captured prices and daily moves, a two-stock comparison and product details. Funds show captured performance with period labels; details contain investment facts. Historical returns do not predict future returns. Private Wealth screenshot shows the catalogue after the welcome: 9 PMS, 3 AIF and 6 SIF offerings. Figures are fixtures, not live quotes. Desktop uses a 392px presentation frame; real phones fill the viewport without the frame. The two stock rails move at 14 CSS pixels per second, with pause, drag, automatic resumption and reduced-motion support. Welcome animation belongs in Appendix 5, not as the main evidence of product value. Updated to match the current mock: three equal-size icon tabs make Mutual funds, Managed portfolios and Stock basket easier to find. Managed portfolios has a stronger blue outline and contains BlackRock Smart Beta, All Weather, The Global Asset Allocation and Commodity &amp; Energy, with individual detail views. The screenshot shows the selected Managed portfolios tab and its first offering. Minimums, returns and risks are captured historical fixtures. This category remains inside Funds &amp; baskets.</a:t>
             </a:r>
           </a:p>
         </p:txBody>
@@ -773,7 +773,7 @@
           <p:cNvPr id="3" name="Title">
             <a:extLst xmlns:a="http://schemas.openxmlformats.org/drawingml/2006/main">
               <a:ext uri="{FF2B5EF4-FFF2-40B4-BE49-F238E27FC236}">
-                <a16:creationId xmlns:a16="http://schemas.microsoft.com/office/drawing/2014/main" id="{F52D427F-CC84-4E72-AFB8-652385C8FB31}"/>
+                <a16:creationId xmlns:a16="http://schemas.microsoft.com/office/drawing/2014/main" id="{47200CD7-36C0-452C-9837-16AA4B80DC62}"/>
               </a:ext>
             </a:extLst>
           </p:cNvPr>
@@ -1002,7 +1002,7 @@
           <p:cNvPr id="2" name="Subtitle">
             <a:extLst xmlns:a="http://schemas.openxmlformats.org/drawingml/2006/main">
               <a:ext uri="{FF2B5EF4-FFF2-40B4-BE49-F238E27FC236}">
-                <a16:creationId xmlns:a16="http://schemas.microsoft.com/office/drawing/2014/main" id="{27ED7114-B77F-4E94-BD35-971820AF6BC0}"/>
+                <a16:creationId xmlns:a16="http://schemas.microsoft.com/office/drawing/2014/main" id="{1692A420-EABA-4090-8819-572A8C4E289F}"/>
               </a:ext>
             </a:extLst>
           </p:cNvPr>
@@ -1248,7 +1248,7 @@
           <p:cNvPr id="2" name="Section title">
             <a:extLst xmlns:a="http://schemas.openxmlformats.org/drawingml/2006/main">
               <a:ext uri="{FF2B5EF4-FFF2-40B4-BE49-F238E27FC236}">
-                <a16:creationId xmlns:a16="http://schemas.microsoft.com/office/drawing/2014/main" id="{A52D0EBD-FCE8-4EB3-88C3-1B5D9B5A9DED}"/>
+                <a16:creationId xmlns:a16="http://schemas.microsoft.com/office/drawing/2014/main" id="{56B64813-1A38-4083-B7FE-53C91654DA52}"/>
               </a:ext>
             </a:extLst>
           </p:cNvPr>
@@ -1494,7 +1494,7 @@
           <p:cNvPr id="3" name="Title">
             <a:extLst xmlns:a="http://schemas.openxmlformats.org/drawingml/2006/main">
               <a:ext uri="{FF2B5EF4-FFF2-40B4-BE49-F238E27FC236}">
-                <a16:creationId xmlns:a16="http://schemas.microsoft.com/office/drawing/2014/main" id="{D0F4BDA8-CB25-49BE-AA9C-74522C2FA1DB}"/>
+                <a16:creationId xmlns:a16="http://schemas.microsoft.com/office/drawing/2014/main" id="{3CCD2840-F31E-46FD-972A-44216C940A20}"/>
               </a:ext>
             </a:extLst>
           </p:cNvPr>
@@ -1723,7 +1723,7 @@
           <p:cNvPr id="2" name="Body">
             <a:extLst xmlns:a="http://schemas.openxmlformats.org/drawingml/2006/main">
               <a:ext uri="{FF2B5EF4-FFF2-40B4-BE49-F238E27FC236}">
-                <a16:creationId xmlns:a16="http://schemas.microsoft.com/office/drawing/2014/main" id="{9E1049CE-42E1-40CB-84B9-E0E4497972EE}"/>
+                <a16:creationId xmlns:a16="http://schemas.microsoft.com/office/drawing/2014/main" id="{A4BD1098-1D18-4AF5-8F66-C65158B6CDE0}"/>
               </a:ext>
             </a:extLst>
           </p:cNvPr>
@@ -1969,7 +1969,7 @@
           <p:cNvPr id="4" name="Title">
             <a:extLst xmlns:a="http://schemas.openxmlformats.org/drawingml/2006/main">
               <a:ext uri="{FF2B5EF4-FFF2-40B4-BE49-F238E27FC236}">
-                <a16:creationId xmlns:a16="http://schemas.microsoft.com/office/drawing/2014/main" id="{005332FD-AB4A-45D9-B99B-B28CCC1385DE}"/>
+                <a16:creationId xmlns:a16="http://schemas.microsoft.com/office/drawing/2014/main" id="{354BADEC-119A-49FD-AAA5-DE455CA73108}"/>
               </a:ext>
             </a:extLst>
           </p:cNvPr>
@@ -2198,7 +2198,7 @@
           <p:cNvPr id="2" name="Left column">
             <a:extLst xmlns:a="http://schemas.openxmlformats.org/drawingml/2006/main">
               <a:ext uri="{FF2B5EF4-FFF2-40B4-BE49-F238E27FC236}">
-                <a16:creationId xmlns:a16="http://schemas.microsoft.com/office/drawing/2014/main" id="{4EA36572-E0AB-4FDE-A1B3-B98AAF508A65}"/>
+                <a16:creationId xmlns:a16="http://schemas.microsoft.com/office/drawing/2014/main" id="{306353DE-735B-4DAB-81B3-7C127345F4C9}"/>
               </a:ext>
             </a:extLst>
           </p:cNvPr>
@@ -2427,7 +2427,7 @@
           <p:cNvPr id="3" name="Right column">
             <a:extLst xmlns:a="http://schemas.openxmlformats.org/drawingml/2006/main">
               <a:ext uri="{FF2B5EF4-FFF2-40B4-BE49-F238E27FC236}">
-                <a16:creationId xmlns:a16="http://schemas.microsoft.com/office/drawing/2014/main" id="{19796285-B852-4BCF-8506-9C4A3EDF5685}"/>
+                <a16:creationId xmlns:a16="http://schemas.microsoft.com/office/drawing/2014/main" id="{75B705F6-4175-410E-A43D-FC1EACCB41C6}"/>
               </a:ext>
             </a:extLst>
           </p:cNvPr>
@@ -2673,7 +2673,7 @@
           <p:cNvPr id="3" name="Title">
             <a:extLst xmlns:a="http://schemas.openxmlformats.org/drawingml/2006/main">
               <a:ext uri="{FF2B5EF4-FFF2-40B4-BE49-F238E27FC236}">
-                <a16:creationId xmlns:a16="http://schemas.microsoft.com/office/drawing/2014/main" id="{10BE00BA-CA69-4D7E-8FCA-44E3C8DE38CF}"/>
+                <a16:creationId xmlns:a16="http://schemas.microsoft.com/office/drawing/2014/main" id="{B3FFE70F-C83E-40F5-97D9-A38F43021F00}"/>
               </a:ext>
             </a:extLst>
           </p:cNvPr>
@@ -2902,7 +2902,7 @@
           <p:cNvPr id="2" name="Left column">
             <a:extLst xmlns:a="http://schemas.openxmlformats.org/drawingml/2006/main">
               <a:ext uri="{FF2B5EF4-FFF2-40B4-BE49-F238E27FC236}">
-                <a16:creationId xmlns:a16="http://schemas.microsoft.com/office/drawing/2014/main" id="{13C98469-37B4-491B-B0D9-04B20D207D24}"/>
+                <a16:creationId xmlns:a16="http://schemas.microsoft.com/office/drawing/2014/main" id="{0C218260-83DF-42DB-BD90-C97CE4EAB6C7}"/>
               </a:ext>
             </a:extLst>
           </p:cNvPr>
@@ -3169,12 +3169,12 @@
   </p:cSld>
   <p:clrMap bg1="lt1" tx1="dk1" bg2="lt2" tx2="dk2" accent1="accent1" accent2="accent2" accent3="accent3" accent4="accent4" accent5="accent5" accent6="accent6" hlink="hlink" folHlink="folHlink"/>
   <p:sldLayoutIdLst>
-    <p:sldLayoutId xmlns:r="http://schemas.openxmlformats.org/officeDocument/2006/relationships" id="2147483649" r:id="R73b09d17c1194232"/>
-    <p:sldLayoutId xmlns:r="http://schemas.openxmlformats.org/officeDocument/2006/relationships" id="2147483650" r:id="Rc299312bccd2419d"/>
-    <p:sldLayoutId xmlns:r="http://schemas.openxmlformats.org/officeDocument/2006/relationships" id="2147483651" r:id="R35c259416a03423a"/>
-    <p:sldLayoutId xmlns:r="http://schemas.openxmlformats.org/officeDocument/2006/relationships" id="2147483652" r:id="R5391c1bf19eb41ad"/>
-    <p:sldLayoutId xmlns:r="http://schemas.openxmlformats.org/officeDocument/2006/relationships" id="2147483653" r:id="R1bc92ab7d80c4026"/>
-    <p:sldLayoutId xmlns:r="http://schemas.openxmlformats.org/officeDocument/2006/relationships" id="2147483654" r:id="R63a62c3ee4ce4512"/>
+    <p:sldLayoutId xmlns:r="http://schemas.openxmlformats.org/officeDocument/2006/relationships" id="2147483649" r:id="R83828ee896644cdb"/>
+    <p:sldLayoutId xmlns:r="http://schemas.openxmlformats.org/officeDocument/2006/relationships" id="2147483650" r:id="Ra87d26bfdedc4e92"/>
+    <p:sldLayoutId xmlns:r="http://schemas.openxmlformats.org/officeDocument/2006/relationships" id="2147483651" r:id="Re418c177ca6c4ed0"/>
+    <p:sldLayoutId xmlns:r="http://schemas.openxmlformats.org/officeDocument/2006/relationships" id="2147483652" r:id="R659bcde6c95841ed"/>
+    <p:sldLayoutId xmlns:r="http://schemas.openxmlformats.org/officeDocument/2006/relationships" id="2147483653" r:id="R5c6f0b7073c54395"/>
+    <p:sldLayoutId xmlns:r="http://schemas.openxmlformats.org/officeDocument/2006/relationships" id="2147483654" r:id="Ref46c688e3d94219"/>
   </p:sldLayoutIdLst>
   <p:txStyles>
     <p:titleStyle>
@@ -3725,7 +3725,7 @@
           <p:cNvPr id="14" name="">
             <a:extLst xmlns:a="http://schemas.openxmlformats.org/drawingml/2006/main">
               <a:ext uri="{FF2B5EF4-FFF2-40B4-BE49-F238E27FC236}">
-                <a16:creationId xmlns:a16="http://schemas.microsoft.com/office/drawing/2014/main" id="{34588747-060C-4F86-87A2-0B4BDB1C939B}"/>
+                <a16:creationId xmlns:a16="http://schemas.microsoft.com/office/drawing/2014/main" id="{6ADD73FF-5350-4FCA-BA40-1B8294DC3471}"/>
               </a:ext>
             </a:extLst>
           </p:cNvPr>
@@ -3881,7 +3881,7 @@
           <p:cNvPr id="2" name="">
             <a:extLst xmlns:a="http://schemas.openxmlformats.org/drawingml/2006/main">
               <a:ext uri="{FF2B5EF4-FFF2-40B4-BE49-F238E27FC236}">
-                <a16:creationId xmlns:a16="http://schemas.microsoft.com/office/drawing/2014/main" id="{D23CF085-34D3-43B1-8E9A-FC9948D5AAF2}"/>
+                <a16:creationId xmlns:a16="http://schemas.microsoft.com/office/drawing/2014/main" id="{BB9AE912-1562-4403-9B13-2980316B789A}"/>
               </a:ext>
             </a:extLst>
           </p:cNvPr>
@@ -4060,7 +4060,7 @@
           <p:cNvPr id="3" name="">
             <a:extLst xmlns:a="http://schemas.openxmlformats.org/drawingml/2006/main">
               <a:ext uri="{FF2B5EF4-FFF2-40B4-BE49-F238E27FC236}">
-                <a16:creationId xmlns:a16="http://schemas.microsoft.com/office/drawing/2014/main" id="{98A21C99-0610-40E3-98F4-C99F5486CF81}"/>
+                <a16:creationId xmlns:a16="http://schemas.microsoft.com/office/drawing/2014/main" id="{8A8F2357-A964-43F2-9715-A25373615952}"/>
               </a:ext>
             </a:extLst>
           </p:cNvPr>
@@ -4216,7 +4216,7 @@
           <p:cNvPr id="4" name="">
             <a:extLst xmlns:a="http://schemas.openxmlformats.org/drawingml/2006/main">
               <a:ext uri="{FF2B5EF4-FFF2-40B4-BE49-F238E27FC236}">
-                <a16:creationId xmlns:a16="http://schemas.microsoft.com/office/drawing/2014/main" id="{839C5F1A-3289-416E-B1D9-DEFBE906EF21}"/>
+                <a16:creationId xmlns:a16="http://schemas.microsoft.com/office/drawing/2014/main" id="{E0614015-52A5-488C-B2F6-40E919B5D936}"/>
               </a:ext>
             </a:extLst>
           </p:cNvPr>
@@ -4372,7 +4372,7 @@
           <p:cNvPr id="5" name="">
             <a:extLst xmlns:a="http://schemas.openxmlformats.org/drawingml/2006/main">
               <a:ext uri="{FF2B5EF4-FFF2-40B4-BE49-F238E27FC236}">
-                <a16:creationId xmlns:a16="http://schemas.microsoft.com/office/drawing/2014/main" id="{483C6611-18C3-4B7A-AB38-0240C47FE705}"/>
+                <a16:creationId xmlns:a16="http://schemas.microsoft.com/office/drawing/2014/main" id="{35E56AD0-46CA-4846-9269-870F68E2266C}"/>
               </a:ext>
             </a:extLst>
           </p:cNvPr>
@@ -4528,7 +4528,7 @@
           <p:cNvPr id="6" name="">
             <a:extLst xmlns:a="http://schemas.openxmlformats.org/drawingml/2006/main">
               <a:ext uri="{FF2B5EF4-FFF2-40B4-BE49-F238E27FC236}">
-                <a16:creationId xmlns:a16="http://schemas.microsoft.com/office/drawing/2014/main" id="{4E133326-C490-4D3B-9FF5-27A99DAE3D5D}"/>
+                <a16:creationId xmlns:a16="http://schemas.microsoft.com/office/drawing/2014/main" id="{23418CD6-295B-4E07-B2BB-849394921F24}"/>
               </a:ext>
             </a:extLst>
           </p:cNvPr>
@@ -4684,7 +4684,7 @@
           <p:cNvPr id="7" name="">
             <a:extLst xmlns:a="http://schemas.openxmlformats.org/drawingml/2006/main">
               <a:ext uri="{FF2B5EF4-FFF2-40B4-BE49-F238E27FC236}">
-                <a16:creationId xmlns:a16="http://schemas.microsoft.com/office/drawing/2014/main" id="{D98A39C9-24CD-42F2-80FF-BCEEC32EA12A}"/>
+                <a16:creationId xmlns:a16="http://schemas.microsoft.com/office/drawing/2014/main" id="{1498A28C-895A-4D67-9501-BA618F5BB23D}"/>
               </a:ext>
             </a:extLst>
           </p:cNvPr>
@@ -4840,7 +4840,7 @@
           <p:cNvPr id="8" name="">
             <a:extLst xmlns:a="http://schemas.openxmlformats.org/drawingml/2006/main">
               <a:ext uri="{FF2B5EF4-FFF2-40B4-BE49-F238E27FC236}">
-                <a16:creationId xmlns:a16="http://schemas.microsoft.com/office/drawing/2014/main" id="{28DFCFC6-8F69-4F70-8A68-32A25867D899}"/>
+                <a16:creationId xmlns:a16="http://schemas.microsoft.com/office/drawing/2014/main" id="{08B7A427-57A6-4BA6-AE90-81598B162009}"/>
               </a:ext>
             </a:extLst>
           </p:cNvPr>
@@ -4996,7 +4996,7 @@
           <p:cNvPr id="9" name="">
             <a:extLst xmlns:a="http://schemas.openxmlformats.org/drawingml/2006/main">
               <a:ext uri="{FF2B5EF4-FFF2-40B4-BE49-F238E27FC236}">
-                <a16:creationId xmlns:a16="http://schemas.microsoft.com/office/drawing/2014/main" id="{A8751DC0-C72F-4C00-AD8F-C6EA6C4A3BE6}"/>
+                <a16:creationId xmlns:a16="http://schemas.microsoft.com/office/drawing/2014/main" id="{804C91F3-32B7-433D-A266-60000398E21E}"/>
               </a:ext>
             </a:extLst>
           </p:cNvPr>
@@ -5006,7 +5006,7 @@
           <p:nvPr/>
         </p:nvPicPr>
         <p:blipFill>
-          <a:blip xmlns:r="http://schemas.openxmlformats.org/officeDocument/2006/relationships" xmlns:a="http://schemas.openxmlformats.org/drawingml/2006/main" r:embed="R2ebf50a5d3ea40d1"/>
+          <a:blip xmlns:r="http://schemas.openxmlformats.org/officeDocument/2006/relationships" xmlns:a="http://schemas.openxmlformats.org/drawingml/2006/main" r:embed="R4d25b16af7884978"/>
           <a:stretch xmlns:a="http://schemas.openxmlformats.org/drawingml/2006/main"/>
         </p:blipFill>
         <p:spPr>
@@ -5024,7 +5024,7 @@
           <p:cNvPr id="10" name="">
             <a:extLst xmlns:a="http://schemas.openxmlformats.org/drawingml/2006/main">
               <a:ext uri="{FF2B5EF4-FFF2-40B4-BE49-F238E27FC236}">
-                <a16:creationId xmlns:a16="http://schemas.microsoft.com/office/drawing/2014/main" id="{9DD73811-6CF2-473C-9FD4-85F181B867EB}"/>
+                <a16:creationId xmlns:a16="http://schemas.microsoft.com/office/drawing/2014/main" id="{E8A6DDE8-2926-4570-A443-AF790B6292ED}"/>
               </a:ext>
             </a:extLst>
           </p:cNvPr>
@@ -5034,7 +5034,7 @@
           <p:nvPr/>
         </p:nvPicPr>
         <p:blipFill>
-          <a:blip xmlns:r="http://schemas.openxmlformats.org/officeDocument/2006/relationships" xmlns:a="http://schemas.openxmlformats.org/drawingml/2006/main" r:embed="Rd0566dfefb684659"/>
+          <a:blip xmlns:r="http://schemas.openxmlformats.org/officeDocument/2006/relationships" xmlns:a="http://schemas.openxmlformats.org/drawingml/2006/main" r:embed="Rf38db60c800644e0"/>
           <a:stretch xmlns:a="http://schemas.openxmlformats.org/drawingml/2006/main"/>
         </p:blipFill>
         <p:spPr>
@@ -5052,7 +5052,7 @@
           <p:cNvPr id="11" name="">
             <a:extLst xmlns:a="http://schemas.openxmlformats.org/drawingml/2006/main">
               <a:ext uri="{FF2B5EF4-FFF2-40B4-BE49-F238E27FC236}">
-                <a16:creationId xmlns:a16="http://schemas.microsoft.com/office/drawing/2014/main" id="{F74342C8-FDF4-40CA-B835-4657F9708C6A}"/>
+                <a16:creationId xmlns:a16="http://schemas.microsoft.com/office/drawing/2014/main" id="{5577B0BD-D574-4A64-8BF4-995A6CAB0196}"/>
               </a:ext>
             </a:extLst>
           </p:cNvPr>
@@ -5208,7 +5208,7 @@
           <p:cNvPr id="12" name="">
             <a:extLst xmlns:a="http://schemas.openxmlformats.org/drawingml/2006/main">
               <a:ext uri="{FF2B5EF4-FFF2-40B4-BE49-F238E27FC236}">
-                <a16:creationId xmlns:a16="http://schemas.microsoft.com/office/drawing/2014/main" id="{18A8B207-A903-4E78-A900-83C8C35EDF9B}"/>
+                <a16:creationId xmlns:a16="http://schemas.microsoft.com/office/drawing/2014/main" id="{7B726EB1-952F-40FE-BA90-E300C85F3664}"/>
               </a:ext>
             </a:extLst>
           </p:cNvPr>
@@ -5364,7 +5364,7 @@
           <p:cNvPr id="13" name="">
             <a:extLst xmlns:a="http://schemas.openxmlformats.org/drawingml/2006/main">
               <a:ext uri="{FF2B5EF4-FFF2-40B4-BE49-F238E27FC236}">
-                <a16:creationId xmlns:a16="http://schemas.microsoft.com/office/drawing/2014/main" id="{6A9065E2-726D-44FB-9ED1-D3D48F090800}"/>
+                <a16:creationId xmlns:a16="http://schemas.microsoft.com/office/drawing/2014/main" id="{0FE1B6AD-7EDE-48F5-99C5-64D32A74AB09}"/>
               </a:ext>
             </a:extLst>
           </p:cNvPr>
@@ -5518,7 +5518,7 @@
     </p:spTree>
     <p:extLst>
       <p:ext uri="{BB962C8B-B14F-4D97-AF65-F5344CB8AC3E}">
-        <p14:creationId xmlns:p14="http://schemas.microsoft.com/office/powerpoint/2010/main" val="792939116"/>
+        <p14:creationId xmlns:p14="http://schemas.microsoft.com/office/powerpoint/2010/main" val="508237428"/>
       </p:ext>
     </p:extLst>
   </p:cSld>
@@ -5549,7 +5549,7 @@
           <p:cNvPr id="12" name="">
             <a:extLst xmlns:a="http://schemas.openxmlformats.org/drawingml/2006/main">
               <a:ext uri="{FF2B5EF4-FFF2-40B4-BE49-F238E27FC236}">
-                <a16:creationId xmlns:a16="http://schemas.microsoft.com/office/drawing/2014/main" id="{5C170876-E3B2-40F1-873A-0FFCE25441B0}"/>
+                <a16:creationId xmlns:a16="http://schemas.microsoft.com/office/drawing/2014/main" id="{902B4EDF-A9EB-4389-A3A4-65C15AA53C62}"/>
               </a:ext>
             </a:extLst>
           </p:cNvPr>
@@ -5705,7 +5705,7 @@
           <p:cNvPr id="2" name="">
             <a:extLst xmlns:a="http://schemas.openxmlformats.org/drawingml/2006/main">
               <a:ext uri="{FF2B5EF4-FFF2-40B4-BE49-F238E27FC236}">
-                <a16:creationId xmlns:a16="http://schemas.microsoft.com/office/drawing/2014/main" id="{44343C00-91F7-4611-B9A2-5C9CEFED8E38}"/>
+                <a16:creationId xmlns:a16="http://schemas.microsoft.com/office/drawing/2014/main" id="{F0F11AD0-B015-474E-8EAB-E0CEBF35E9EE}"/>
               </a:ext>
             </a:extLst>
           </p:cNvPr>
@@ -5861,7 +5861,7 @@
           <p:cNvPr id="3" name="">
             <a:extLst xmlns:a="http://schemas.openxmlformats.org/drawingml/2006/main">
               <a:ext uri="{FF2B5EF4-FFF2-40B4-BE49-F238E27FC236}">
-                <a16:creationId xmlns:a16="http://schemas.microsoft.com/office/drawing/2014/main" id="{6F1CFE25-0D55-4B39-B0AC-A28F10D689E4}"/>
+                <a16:creationId xmlns:a16="http://schemas.microsoft.com/office/drawing/2014/main" id="{075E705F-E309-4523-B090-0C17349F7B5A}"/>
               </a:ext>
             </a:extLst>
           </p:cNvPr>
@@ -5871,7 +5871,7 @@
           <p:nvPr/>
         </p:nvPicPr>
         <p:blipFill>
-          <a:blip xmlns:r="http://schemas.openxmlformats.org/officeDocument/2006/relationships" xmlns:a="http://schemas.openxmlformats.org/drawingml/2006/main" r:embed="R6a04413b82bd47a2"/>
+          <a:blip xmlns:r="http://schemas.openxmlformats.org/officeDocument/2006/relationships" xmlns:a="http://schemas.openxmlformats.org/drawingml/2006/main" r:embed="R7276f6e9da864224"/>
           <a:stretch xmlns:a="http://schemas.openxmlformats.org/drawingml/2006/main"/>
         </p:blipFill>
         <p:spPr>
@@ -5889,7 +5889,7 @@
           <p:cNvPr id="4" name="">
             <a:extLst xmlns:a="http://schemas.openxmlformats.org/drawingml/2006/main">
               <a:ext uri="{FF2B5EF4-FFF2-40B4-BE49-F238E27FC236}">
-                <a16:creationId xmlns:a16="http://schemas.microsoft.com/office/drawing/2014/main" id="{13E5923D-AAA6-4550-BA75-53BEA55533E6}"/>
+                <a16:creationId xmlns:a16="http://schemas.microsoft.com/office/drawing/2014/main" id="{8418C095-F85A-4325-81D9-A3C17FEA65C8}"/>
               </a:ext>
             </a:extLst>
           </p:cNvPr>
@@ -5899,7 +5899,7 @@
           <p:nvPr/>
         </p:nvPicPr>
         <p:blipFill>
-          <a:blip xmlns:r="http://schemas.openxmlformats.org/officeDocument/2006/relationships" xmlns:a="http://schemas.openxmlformats.org/drawingml/2006/main" r:embed="Rd86003c4141c42be"/>
+          <a:blip xmlns:r="http://schemas.openxmlformats.org/officeDocument/2006/relationships" xmlns:a="http://schemas.openxmlformats.org/drawingml/2006/main" r:embed="Rb2de2ffe565b4ca6"/>
           <a:stretch xmlns:a="http://schemas.openxmlformats.org/drawingml/2006/main"/>
         </p:blipFill>
         <p:spPr>
@@ -5917,7 +5917,7 @@
           <p:cNvPr id="5" name="">
             <a:extLst xmlns:a="http://schemas.openxmlformats.org/drawingml/2006/main">
               <a:ext uri="{FF2B5EF4-FFF2-40B4-BE49-F238E27FC236}">
-                <a16:creationId xmlns:a16="http://schemas.microsoft.com/office/drawing/2014/main" id="{CC2A9B05-7DE3-406F-B139-58576E3C0A3B}"/>
+                <a16:creationId xmlns:a16="http://schemas.microsoft.com/office/drawing/2014/main" id="{39AB6A4B-B2C7-43B5-8889-A54F5A530AAA}"/>
               </a:ext>
             </a:extLst>
           </p:cNvPr>
@@ -5927,7 +5927,7 @@
           <p:nvPr/>
         </p:nvPicPr>
         <p:blipFill>
-          <a:blip xmlns:r="http://schemas.openxmlformats.org/officeDocument/2006/relationships" xmlns:a="http://schemas.openxmlformats.org/drawingml/2006/main" r:embed="R4b846e0b63914687"/>
+          <a:blip xmlns:r="http://schemas.openxmlformats.org/officeDocument/2006/relationships" xmlns:a="http://schemas.openxmlformats.org/drawingml/2006/main" r:embed="R3be90dfccabf4299"/>
           <a:stretch xmlns:a="http://schemas.openxmlformats.org/drawingml/2006/main"/>
         </p:blipFill>
         <p:spPr>
@@ -5945,7 +5945,7 @@
           <p:cNvPr id="6" name="">
             <a:extLst xmlns:a="http://schemas.openxmlformats.org/drawingml/2006/main">
               <a:ext uri="{FF2B5EF4-FFF2-40B4-BE49-F238E27FC236}">
-                <a16:creationId xmlns:a16="http://schemas.microsoft.com/office/drawing/2014/main" id="{EF748054-1A61-4BFE-A2D7-3507348C7EF7}"/>
+                <a16:creationId xmlns:a16="http://schemas.microsoft.com/office/drawing/2014/main" id="{E5D73BD9-528F-4CDD-B0F1-4AB0F90C0693}"/>
               </a:ext>
             </a:extLst>
           </p:cNvPr>
@@ -6101,7 +6101,7 @@
           <p:cNvPr id="7" name="">
             <a:extLst xmlns:a="http://schemas.openxmlformats.org/drawingml/2006/main">
               <a:ext uri="{FF2B5EF4-FFF2-40B4-BE49-F238E27FC236}">
-                <a16:creationId xmlns:a16="http://schemas.microsoft.com/office/drawing/2014/main" id="{1EEDA8A5-E00C-413A-B379-0DB7DC5F133B}"/>
+                <a16:creationId xmlns:a16="http://schemas.microsoft.com/office/drawing/2014/main" id="{D9F1DF6E-8C1C-48B8-AF5D-42EACE7E8751}"/>
               </a:ext>
             </a:extLst>
           </p:cNvPr>
@@ -6257,7 +6257,7 @@
           <p:cNvPr id="8" name="">
             <a:extLst xmlns:a="http://schemas.openxmlformats.org/drawingml/2006/main">
               <a:ext uri="{FF2B5EF4-FFF2-40B4-BE49-F238E27FC236}">
-                <a16:creationId xmlns:a16="http://schemas.microsoft.com/office/drawing/2014/main" id="{184590FA-726C-49B1-9888-4F5A1C5A6E48}"/>
+                <a16:creationId xmlns:a16="http://schemas.microsoft.com/office/drawing/2014/main" id="{4EA2B80F-2D81-4E18-91DE-8ABDFA241ACA}"/>
               </a:ext>
             </a:extLst>
           </p:cNvPr>
@@ -6413,7 +6413,7 @@
           <p:cNvPr id="9" name="">
             <a:extLst xmlns:a="http://schemas.openxmlformats.org/drawingml/2006/main">
               <a:ext uri="{FF2B5EF4-FFF2-40B4-BE49-F238E27FC236}">
-                <a16:creationId xmlns:a16="http://schemas.microsoft.com/office/drawing/2014/main" id="{55385766-6399-4BFB-B3F5-57EDF2C653A4}"/>
+                <a16:creationId xmlns:a16="http://schemas.microsoft.com/office/drawing/2014/main" id="{3EECD59C-57F4-473A-B74D-9F20D2BC4940}"/>
               </a:ext>
             </a:extLst>
           </p:cNvPr>
@@ -6559,7 +6559,7 @@
                 <a:ea typeface="Arial"/>
                 <a:cs typeface="Arial"/>
               </a:rPr>
-              <a:t>See the fund, category and labelled return period. Open details for the minimum, costs and risks.</a:t>
+              <a:t>Choose funds, managed portfolios or a stock basket. The highlighted portfolio tab brings BlackRock, All Weather and more together.</a:t>
             </a:r>
           </a:p>
         </p:txBody>
@@ -6569,7 +6569,7 @@
           <p:cNvPr id="10" name="">
             <a:extLst xmlns:a="http://schemas.openxmlformats.org/drawingml/2006/main">
               <a:ext uri="{FF2B5EF4-FFF2-40B4-BE49-F238E27FC236}">
-                <a16:creationId xmlns:a16="http://schemas.microsoft.com/office/drawing/2014/main" id="{9D6E8C8F-6400-410F-8D5E-B689EC9D6243}"/>
+                <a16:creationId xmlns:a16="http://schemas.microsoft.com/office/drawing/2014/main" id="{9BE7A2EA-77CD-412F-8CFD-99880B768AA2}"/>
               </a:ext>
             </a:extLst>
           </p:cNvPr>
@@ -6725,7 +6725,7 @@
           <p:cNvPr id="11" name="">
             <a:extLst xmlns:a="http://schemas.openxmlformats.org/drawingml/2006/main">
               <a:ext uri="{FF2B5EF4-FFF2-40B4-BE49-F238E27FC236}">
-                <a16:creationId xmlns:a16="http://schemas.microsoft.com/office/drawing/2014/main" id="{E418DEC9-B6D1-4D40-87F4-4ACEAC4B18CE}"/>
+                <a16:creationId xmlns:a16="http://schemas.microsoft.com/office/drawing/2014/main" id="{3E0DA25B-0AA4-48AE-8344-F2B271A912D5}"/>
               </a:ext>
             </a:extLst>
           </p:cNvPr>
@@ -6879,7 +6879,7 @@
     </p:spTree>
     <p:extLst>
       <p:ext uri="{BB962C8B-B14F-4D97-AF65-F5344CB8AC3E}">
-        <p14:creationId xmlns:p14="http://schemas.microsoft.com/office/powerpoint/2010/main" val="755773128"/>
+        <p14:creationId xmlns:p14="http://schemas.microsoft.com/office/powerpoint/2010/main" val="1288538014"/>
       </p:ext>
     </p:extLst>
   </p:cSld>
@@ -6910,7 +6910,7 @@
           <p:cNvPr id="14" name="">
             <a:extLst xmlns:a="http://schemas.openxmlformats.org/drawingml/2006/main">
               <a:ext uri="{FF2B5EF4-FFF2-40B4-BE49-F238E27FC236}">
-                <a16:creationId xmlns:a16="http://schemas.microsoft.com/office/drawing/2014/main" id="{701087F5-1877-44D0-A614-2AF6F03CD724}"/>
+                <a16:creationId xmlns:a16="http://schemas.microsoft.com/office/drawing/2014/main" id="{1C5DA953-3C47-4BC5-886C-71436501922B}"/>
               </a:ext>
             </a:extLst>
           </p:cNvPr>
@@ -7066,7 +7066,7 @@
           <p:cNvPr id="2" name="">
             <a:extLst xmlns:a="http://schemas.openxmlformats.org/drawingml/2006/main">
               <a:ext uri="{FF2B5EF4-FFF2-40B4-BE49-F238E27FC236}">
-                <a16:creationId xmlns:a16="http://schemas.microsoft.com/office/drawing/2014/main" id="{D629E88F-2F88-40E0-8147-69FFFAAB0EC4}"/>
+                <a16:creationId xmlns:a16="http://schemas.microsoft.com/office/drawing/2014/main" id="{8E4C0AC9-3926-429D-A204-CD34D785E5D5}"/>
               </a:ext>
             </a:extLst>
           </p:cNvPr>
@@ -7222,7 +7222,7 @@
           <p:cNvPr id="3" name="">
             <a:extLst xmlns:a="http://schemas.openxmlformats.org/drawingml/2006/main">
               <a:ext uri="{FF2B5EF4-FFF2-40B4-BE49-F238E27FC236}">
-                <a16:creationId xmlns:a16="http://schemas.microsoft.com/office/drawing/2014/main" id="{3B171407-609F-4982-9509-AC938684F2DA}"/>
+                <a16:creationId xmlns:a16="http://schemas.microsoft.com/office/drawing/2014/main" id="{5E39CD17-C583-448F-9EE8-3F4243C9A31E}"/>
               </a:ext>
             </a:extLst>
           </p:cNvPr>
@@ -7378,7 +7378,7 @@
           <p:cNvPr id="4" name="">
             <a:extLst xmlns:a="http://schemas.openxmlformats.org/drawingml/2006/main">
               <a:ext uri="{FF2B5EF4-FFF2-40B4-BE49-F238E27FC236}">
-                <a16:creationId xmlns:a16="http://schemas.microsoft.com/office/drawing/2014/main" id="{B10CADE0-6AAF-4708-ADD4-FEEF23DB2D6C}"/>
+                <a16:creationId xmlns:a16="http://schemas.microsoft.com/office/drawing/2014/main" id="{E217E323-9714-4F41-9718-2FAD8F603E9F}"/>
               </a:ext>
             </a:extLst>
           </p:cNvPr>
@@ -7534,7 +7534,7 @@
           <p:cNvPr id="5" name="">
             <a:extLst xmlns:a="http://schemas.openxmlformats.org/drawingml/2006/main">
               <a:ext uri="{FF2B5EF4-FFF2-40B4-BE49-F238E27FC236}">
-                <a16:creationId xmlns:a16="http://schemas.microsoft.com/office/drawing/2014/main" id="{8A384F04-0ADA-431C-8E7B-32E1FAAD44FF}"/>
+                <a16:creationId xmlns:a16="http://schemas.microsoft.com/office/drawing/2014/main" id="{AA29AED2-A08F-4659-A10B-F589A409F6A3}"/>
               </a:ext>
             </a:extLst>
           </p:cNvPr>
@@ -7690,7 +7690,7 @@
           <p:cNvPr id="6" name="">
             <a:extLst xmlns:a="http://schemas.openxmlformats.org/drawingml/2006/main">
               <a:ext uri="{FF2B5EF4-FFF2-40B4-BE49-F238E27FC236}">
-                <a16:creationId xmlns:a16="http://schemas.microsoft.com/office/drawing/2014/main" id="{28B033F7-0977-4C20-95F0-E396D341C55A}"/>
+                <a16:creationId xmlns:a16="http://schemas.microsoft.com/office/drawing/2014/main" id="{F690D0DC-C3E7-48E6-A3CC-2114D5EA73BC}"/>
               </a:ext>
             </a:extLst>
           </p:cNvPr>
@@ -7846,7 +7846,7 @@
           <p:cNvPr id="7" name="">
             <a:extLst xmlns:a="http://schemas.openxmlformats.org/drawingml/2006/main">
               <a:ext uri="{FF2B5EF4-FFF2-40B4-BE49-F238E27FC236}">
-                <a16:creationId xmlns:a16="http://schemas.microsoft.com/office/drawing/2014/main" id="{E982B868-A5F7-452C-83B5-4BAF4336195B}"/>
+                <a16:creationId xmlns:a16="http://schemas.microsoft.com/office/drawing/2014/main" id="{DDF53F9E-1C56-4699-8228-AC897D4098A2}"/>
               </a:ext>
             </a:extLst>
           </p:cNvPr>
@@ -8002,7 +8002,7 @@
           <p:cNvPr id="8" name="">
             <a:extLst xmlns:a="http://schemas.openxmlformats.org/drawingml/2006/main">
               <a:ext uri="{FF2B5EF4-FFF2-40B4-BE49-F238E27FC236}">
-                <a16:creationId xmlns:a16="http://schemas.microsoft.com/office/drawing/2014/main" id="{61D5BD53-4C13-4CF5-96BF-06C1919A760B}"/>
+                <a16:creationId xmlns:a16="http://schemas.microsoft.com/office/drawing/2014/main" id="{B2161BD6-6C36-4259-8E76-C170C248C4FB}"/>
               </a:ext>
             </a:extLst>
           </p:cNvPr>
@@ -8158,7 +8158,7 @@
           <p:cNvPr id="9" name="">
             <a:extLst xmlns:a="http://schemas.openxmlformats.org/drawingml/2006/main">
               <a:ext uri="{FF2B5EF4-FFF2-40B4-BE49-F238E27FC236}">
-                <a16:creationId xmlns:a16="http://schemas.microsoft.com/office/drawing/2014/main" id="{BCCBD68E-06CD-416A-BAC3-FA5E0FC777EF}"/>
+                <a16:creationId xmlns:a16="http://schemas.microsoft.com/office/drawing/2014/main" id="{837B7221-4AE7-4027-A1A1-1B8DDD832F1F}"/>
               </a:ext>
             </a:extLst>
           </p:cNvPr>
@@ -8168,7 +8168,7 @@
           <p:nvPr/>
         </p:nvPicPr>
         <p:blipFill>
-          <a:blip xmlns:r="http://schemas.openxmlformats.org/officeDocument/2006/relationships" xmlns:a="http://schemas.openxmlformats.org/drawingml/2006/main" r:embed="R22184aab4b0e4c6a"/>
+          <a:blip xmlns:r="http://schemas.openxmlformats.org/officeDocument/2006/relationships" xmlns:a="http://schemas.openxmlformats.org/drawingml/2006/main" r:embed="R8ca834f578ef44ed"/>
           <a:stretch xmlns:a="http://schemas.openxmlformats.org/drawingml/2006/main"/>
         </p:blipFill>
         <p:spPr>
@@ -8186,7 +8186,7 @@
           <p:cNvPr id="10" name="">
             <a:extLst xmlns:a="http://schemas.openxmlformats.org/drawingml/2006/main">
               <a:ext uri="{FF2B5EF4-FFF2-40B4-BE49-F238E27FC236}">
-                <a16:creationId xmlns:a16="http://schemas.microsoft.com/office/drawing/2014/main" id="{C7105ABF-0260-423A-BC84-7602B39F052A}"/>
+                <a16:creationId xmlns:a16="http://schemas.microsoft.com/office/drawing/2014/main" id="{1FEF9FAA-6DDD-41E6-A44C-32EAC338C038}"/>
               </a:ext>
             </a:extLst>
           </p:cNvPr>
@@ -8196,7 +8196,7 @@
           <p:nvPr/>
         </p:nvPicPr>
         <p:blipFill>
-          <a:blip xmlns:r="http://schemas.openxmlformats.org/officeDocument/2006/relationships" xmlns:a="http://schemas.openxmlformats.org/drawingml/2006/main" r:embed="R879499ea0e9546e1"/>
+          <a:blip xmlns:r="http://schemas.openxmlformats.org/officeDocument/2006/relationships" xmlns:a="http://schemas.openxmlformats.org/drawingml/2006/main" r:embed="R5d30310a9e2843c0"/>
           <a:stretch xmlns:a="http://schemas.openxmlformats.org/drawingml/2006/main"/>
         </p:blipFill>
         <p:spPr>
@@ -8214,7 +8214,7 @@
           <p:cNvPr id="11" name="">
             <a:extLst xmlns:a="http://schemas.openxmlformats.org/drawingml/2006/main">
               <a:ext uri="{FF2B5EF4-FFF2-40B4-BE49-F238E27FC236}">
-                <a16:creationId xmlns:a16="http://schemas.microsoft.com/office/drawing/2014/main" id="{2C887A12-66CB-43D2-BD2A-CF68BC01CB48}"/>
+                <a16:creationId xmlns:a16="http://schemas.microsoft.com/office/drawing/2014/main" id="{FE2DF644-42F5-40F1-8A4E-DD928F26E549}"/>
               </a:ext>
             </a:extLst>
           </p:cNvPr>
@@ -8370,7 +8370,7 @@
           <p:cNvPr id="12" name="">
             <a:extLst xmlns:a="http://schemas.openxmlformats.org/drawingml/2006/main">
               <a:ext uri="{FF2B5EF4-FFF2-40B4-BE49-F238E27FC236}">
-                <a16:creationId xmlns:a16="http://schemas.microsoft.com/office/drawing/2014/main" id="{C4804DC4-B950-4842-AE95-ED386FD06833}"/>
+                <a16:creationId xmlns:a16="http://schemas.microsoft.com/office/drawing/2014/main" id="{4DA27A1F-A4D6-4EC3-8FC1-35426F767E8C}"/>
               </a:ext>
             </a:extLst>
           </p:cNvPr>
@@ -8526,7 +8526,7 @@
           <p:cNvPr id="13" name="">
             <a:extLst xmlns:a="http://schemas.openxmlformats.org/drawingml/2006/main">
               <a:ext uri="{FF2B5EF4-FFF2-40B4-BE49-F238E27FC236}">
-                <a16:creationId xmlns:a16="http://schemas.microsoft.com/office/drawing/2014/main" id="{4EF9ABF1-834C-4467-A754-6EA048250818}"/>
+                <a16:creationId xmlns:a16="http://schemas.microsoft.com/office/drawing/2014/main" id="{02D3A312-1AD4-4BC6-8C28-87A8E40F514C}"/>
               </a:ext>
             </a:extLst>
           </p:cNvPr>
@@ -8680,7 +8680,7 @@
     </p:spTree>
     <p:extLst>
       <p:ext uri="{BB962C8B-B14F-4D97-AF65-F5344CB8AC3E}">
-        <p14:creationId xmlns:p14="http://schemas.microsoft.com/office/powerpoint/2010/main" val="1570819775"/>
+        <p14:creationId xmlns:p14="http://schemas.microsoft.com/office/powerpoint/2010/main" val="1379873280"/>
       </p:ext>
     </p:extLst>
   </p:cSld>
@@ -8711,7 +8711,7 @@
           <p:cNvPr id="16" name="">
             <a:extLst xmlns:a="http://schemas.openxmlformats.org/drawingml/2006/main">
               <a:ext uri="{FF2B5EF4-FFF2-40B4-BE49-F238E27FC236}">
-                <a16:creationId xmlns:a16="http://schemas.microsoft.com/office/drawing/2014/main" id="{59D999A4-2009-4DB4-BCCC-7C9DD0916B02}"/>
+                <a16:creationId xmlns:a16="http://schemas.microsoft.com/office/drawing/2014/main" id="{44073CB0-6ACE-4F21-A5DE-5619393DC7CA}"/>
               </a:ext>
             </a:extLst>
           </p:cNvPr>
@@ -8867,7 +8867,7 @@
           <p:cNvPr id="2" name="">
             <a:extLst xmlns:a="http://schemas.openxmlformats.org/drawingml/2006/main">
               <a:ext uri="{FF2B5EF4-FFF2-40B4-BE49-F238E27FC236}">
-                <a16:creationId xmlns:a16="http://schemas.microsoft.com/office/drawing/2014/main" id="{AE4ECB7E-CFE5-434F-A6F1-8143EFF67043}"/>
+                <a16:creationId xmlns:a16="http://schemas.microsoft.com/office/drawing/2014/main" id="{5B646C74-4EAB-4DA5-BE03-717FD7ED2655}"/>
               </a:ext>
             </a:extLst>
           </p:cNvPr>
@@ -9023,7 +9023,7 @@
           <p:cNvPr id="3" name="">
             <a:extLst xmlns:a="http://schemas.openxmlformats.org/drawingml/2006/main">
               <a:ext uri="{FF2B5EF4-FFF2-40B4-BE49-F238E27FC236}">
-                <a16:creationId xmlns:a16="http://schemas.microsoft.com/office/drawing/2014/main" id="{FE32A6EB-951E-493E-A9C9-8EBB91F24CFD}"/>
+                <a16:creationId xmlns:a16="http://schemas.microsoft.com/office/drawing/2014/main" id="{69DACB24-F626-48D3-8C1B-A207B0A117B4}"/>
               </a:ext>
             </a:extLst>
           </p:cNvPr>
@@ -9179,7 +9179,7 @@
           <p:cNvPr id="4" name="">
             <a:extLst xmlns:a="http://schemas.openxmlformats.org/drawingml/2006/main">
               <a:ext uri="{FF2B5EF4-FFF2-40B4-BE49-F238E27FC236}">
-                <a16:creationId xmlns:a16="http://schemas.microsoft.com/office/drawing/2014/main" id="{219A3C19-B2D8-47A8-9405-487BFBBF3B77}"/>
+                <a16:creationId xmlns:a16="http://schemas.microsoft.com/office/drawing/2014/main" id="{34285CED-6C24-4375-B6B4-76463D033BA0}"/>
               </a:ext>
             </a:extLst>
           </p:cNvPr>
@@ -9335,7 +9335,7 @@
           <p:cNvPr id="5" name="">
             <a:extLst xmlns:a="http://schemas.openxmlformats.org/drawingml/2006/main">
               <a:ext uri="{FF2B5EF4-FFF2-40B4-BE49-F238E27FC236}">
-                <a16:creationId xmlns:a16="http://schemas.microsoft.com/office/drawing/2014/main" id="{70D7CE41-E154-4727-A0E8-F50D8DFFEC3E}"/>
+                <a16:creationId xmlns:a16="http://schemas.microsoft.com/office/drawing/2014/main" id="{53D95FF7-38CF-4E8E-849D-A7FF3A3713DF}"/>
               </a:ext>
             </a:extLst>
           </p:cNvPr>
@@ -9491,7 +9491,7 @@
           <p:cNvPr id="6" name="">
             <a:extLst xmlns:a="http://schemas.openxmlformats.org/drawingml/2006/main">
               <a:ext uri="{FF2B5EF4-FFF2-40B4-BE49-F238E27FC236}">
-                <a16:creationId xmlns:a16="http://schemas.microsoft.com/office/drawing/2014/main" id="{CFCE37AD-F699-49E4-92E5-8118A48285BE}"/>
+                <a16:creationId xmlns:a16="http://schemas.microsoft.com/office/drawing/2014/main" id="{02B615F3-1753-4BC9-AE84-15F29E153FC4}"/>
               </a:ext>
             </a:extLst>
           </p:cNvPr>
@@ -9647,7 +9647,7 @@
           <p:cNvPr id="7" name="">
             <a:extLst xmlns:a="http://schemas.openxmlformats.org/drawingml/2006/main">
               <a:ext uri="{FF2B5EF4-FFF2-40B4-BE49-F238E27FC236}">
-                <a16:creationId xmlns:a16="http://schemas.microsoft.com/office/drawing/2014/main" id="{C9E4E48F-42B4-404A-929D-EFCA9D4A3ED6}"/>
+                <a16:creationId xmlns:a16="http://schemas.microsoft.com/office/drawing/2014/main" id="{2E912449-2102-4F67-BFF9-AD126673455B}"/>
               </a:ext>
             </a:extLst>
           </p:cNvPr>
@@ -9803,7 +9803,7 @@
           <p:cNvPr id="8" name="">
             <a:extLst xmlns:a="http://schemas.openxmlformats.org/drawingml/2006/main">
               <a:ext uri="{FF2B5EF4-FFF2-40B4-BE49-F238E27FC236}">
-                <a16:creationId xmlns:a16="http://schemas.microsoft.com/office/drawing/2014/main" id="{0F4D9737-E4D4-432E-9CA2-6E0A98BBE1A6}"/>
+                <a16:creationId xmlns:a16="http://schemas.microsoft.com/office/drawing/2014/main" id="{982C3062-9A2A-4291-A853-85422E13D7A0}"/>
               </a:ext>
             </a:extLst>
           </p:cNvPr>
@@ -9959,7 +9959,7 @@
           <p:cNvPr id="9" name="">
             <a:extLst xmlns:a="http://schemas.openxmlformats.org/drawingml/2006/main">
               <a:ext uri="{FF2B5EF4-FFF2-40B4-BE49-F238E27FC236}">
-                <a16:creationId xmlns:a16="http://schemas.microsoft.com/office/drawing/2014/main" id="{36DD9B65-600D-446D-B92B-E1D7BDD82E9B}"/>
+                <a16:creationId xmlns:a16="http://schemas.microsoft.com/office/drawing/2014/main" id="{85FC28B9-7AD4-46F9-AF51-4C4D5EBFD415}"/>
               </a:ext>
             </a:extLst>
           </p:cNvPr>
@@ -10115,7 +10115,7 @@
           <p:cNvPr id="10" name="">
             <a:extLst xmlns:a="http://schemas.openxmlformats.org/drawingml/2006/main">
               <a:ext uri="{FF2B5EF4-FFF2-40B4-BE49-F238E27FC236}">
-                <a16:creationId xmlns:a16="http://schemas.microsoft.com/office/drawing/2014/main" id="{1B1447EF-513C-429F-BE89-7086F8D15A14}"/>
+                <a16:creationId xmlns:a16="http://schemas.microsoft.com/office/drawing/2014/main" id="{81DF938A-AAB8-45D7-844C-6DE3CFC1C6C8}"/>
               </a:ext>
             </a:extLst>
           </p:cNvPr>
@@ -10271,7 +10271,7 @@
           <p:cNvPr id="11" name="">
             <a:extLst xmlns:a="http://schemas.openxmlformats.org/drawingml/2006/main">
               <a:ext uri="{FF2B5EF4-FFF2-40B4-BE49-F238E27FC236}">
-                <a16:creationId xmlns:a16="http://schemas.microsoft.com/office/drawing/2014/main" id="{6470C890-ADA5-4E35-8E53-9D138A9D71EF}"/>
+                <a16:creationId xmlns:a16="http://schemas.microsoft.com/office/drawing/2014/main" id="{0ACFABF7-F571-47D4-956D-E3731DD7FBEB}"/>
               </a:ext>
             </a:extLst>
           </p:cNvPr>
@@ -10427,7 +10427,7 @@
           <p:cNvPr id="12" name="">
             <a:extLst xmlns:a="http://schemas.openxmlformats.org/drawingml/2006/main">
               <a:ext uri="{FF2B5EF4-FFF2-40B4-BE49-F238E27FC236}">
-                <a16:creationId xmlns:a16="http://schemas.microsoft.com/office/drawing/2014/main" id="{17B3CC58-DDEA-4CC2-9189-C64EE2616DA9}"/>
+                <a16:creationId xmlns:a16="http://schemas.microsoft.com/office/drawing/2014/main" id="{6E624DC0-B0C8-4CDB-A4A6-9E0E307E13ED}"/>
               </a:ext>
             </a:extLst>
           </p:cNvPr>
@@ -10572,7 +10572,7 @@
                 <a:latin typeface="Arial"/>
                 <a:ea typeface="Arial"/>
                 <a:cs typeface="Arial"/>
-                <a:hlinkClick xmlns:r="http://schemas.openxmlformats.org/officeDocument/2006/relationships" r:id="R49fa4cb56cfe45e1"/>
+                <a:hlinkClick xmlns:r="http://schemas.openxmlformats.org/officeDocument/2006/relationships" r:id="Rc960d4e8106f4de4"/>
               </a:rPr>
               <a:t>Android reading study: https://doi.org/10.1007/s11145-022-10328-9</a:t>
             </a:r>
@@ -10584,7 +10584,7 @@
           <p:cNvPr id="13" name="">
             <a:extLst xmlns:a="http://schemas.openxmlformats.org/drawingml/2006/main">
               <a:ext uri="{FF2B5EF4-FFF2-40B4-BE49-F238E27FC236}">
-                <a16:creationId xmlns:a16="http://schemas.microsoft.com/office/drawing/2014/main" id="{22D7FAEF-0DFD-4D12-B6F7-E5903DC4E576}"/>
+                <a16:creationId xmlns:a16="http://schemas.microsoft.com/office/drawing/2014/main" id="{A0D24A36-95CD-428C-8F43-09902FCB5AB7}"/>
               </a:ext>
             </a:extLst>
           </p:cNvPr>
@@ -10729,7 +10729,7 @@
                 <a:latin typeface="Arial"/>
                 <a:ea typeface="Arial"/>
                 <a:cs typeface="Arial"/>
-                <a:hlinkClick xmlns:r="http://schemas.openxmlformats.org/officeDocument/2006/relationships" r:id="R217c5748a6f14b18"/>
+                <a:hlinkClick xmlns:r="http://schemas.openxmlformats.org/officeDocument/2006/relationships" r:id="R7aaf611a64054eac"/>
               </a:rPr>
               <a:t>Investment choice study: https://business.columbia.edu/sites/default/files-efs/pubfiles/4519/simplicitySeeking.pdf</a:t>
             </a:r>
@@ -10741,7 +10741,7 @@
           <p:cNvPr id="14" name="">
             <a:extLst xmlns:a="http://schemas.openxmlformats.org/drawingml/2006/main">
               <a:ext uri="{FF2B5EF4-FFF2-40B4-BE49-F238E27FC236}">
-                <a16:creationId xmlns:a16="http://schemas.microsoft.com/office/drawing/2014/main" id="{5090AE19-ABAD-4F53-8609-DC6D1375A12D}"/>
+                <a16:creationId xmlns:a16="http://schemas.microsoft.com/office/drawing/2014/main" id="{72F3B01D-86A3-4B60-B224-9059DB193F68}"/>
               </a:ext>
             </a:extLst>
           </p:cNvPr>
@@ -10886,7 +10886,7 @@
                 <a:latin typeface="Arial"/>
                 <a:ea typeface="Arial"/>
                 <a:cs typeface="Arial"/>
-                <a:hlinkClick xmlns:r="http://schemas.openxmlformats.org/officeDocument/2006/relationships" r:id="Rf053a230241e4eb8"/>
+                <a:hlinkClick xmlns:r="http://schemas.openxmlformats.org/officeDocument/2006/relationships" r:id="R7ff8f91af1ef49d1"/>
               </a:rPr>
               <a:t>Motion guidance (W3C): https://www.w3.org/WAI/tutorials/carousels/</a:t>
             </a:r>
@@ -10898,7 +10898,7 @@
           <p:cNvPr id="15" name="">
             <a:extLst xmlns:a="http://schemas.openxmlformats.org/drawingml/2006/main">
               <a:ext uri="{FF2B5EF4-FFF2-40B4-BE49-F238E27FC236}">
-                <a16:creationId xmlns:a16="http://schemas.microsoft.com/office/drawing/2014/main" id="{9E1ACC30-BE6D-453D-9F04-A2BBE3F3CAD5}"/>
+                <a16:creationId xmlns:a16="http://schemas.microsoft.com/office/drawing/2014/main" id="{E7629AB7-A0AD-4A81-8D8E-B966E84FF085}"/>
               </a:ext>
             </a:extLst>
           </p:cNvPr>
@@ -11052,7 +11052,7 @@
     </p:spTree>
     <p:extLst>
       <p:ext uri="{BB962C8B-B14F-4D97-AF65-F5344CB8AC3E}">
-        <p14:creationId xmlns:p14="http://schemas.microsoft.com/office/powerpoint/2010/main" val="1510888276"/>
+        <p14:creationId xmlns:p14="http://schemas.microsoft.com/office/powerpoint/2010/main" val="1527683211"/>
       </p:ext>
     </p:extLst>
   </p:cSld>
@@ -11083,7 +11083,7 @@
           <p:cNvPr id="12" name="">
             <a:extLst xmlns:a="http://schemas.openxmlformats.org/drawingml/2006/main">
               <a:ext uri="{FF2B5EF4-FFF2-40B4-BE49-F238E27FC236}">
-                <a16:creationId xmlns:a16="http://schemas.microsoft.com/office/drawing/2014/main" id="{CF71AA33-0969-46AF-85F6-2754C3358857}"/>
+                <a16:creationId xmlns:a16="http://schemas.microsoft.com/office/drawing/2014/main" id="{5004C470-20C9-4079-859E-4BD239743C74}"/>
               </a:ext>
             </a:extLst>
           </p:cNvPr>
@@ -11239,7 +11239,7 @@
           <p:cNvPr id="2" name="">
             <a:extLst xmlns:a="http://schemas.openxmlformats.org/drawingml/2006/main">
               <a:ext uri="{FF2B5EF4-FFF2-40B4-BE49-F238E27FC236}">
-                <a16:creationId xmlns:a16="http://schemas.microsoft.com/office/drawing/2014/main" id="{E0A825FD-77C8-4496-ABD4-7DAA571D6551}"/>
+                <a16:creationId xmlns:a16="http://schemas.microsoft.com/office/drawing/2014/main" id="{7E599213-9077-4C2D-80C1-CD77CF30C7F8}"/>
               </a:ext>
             </a:extLst>
           </p:cNvPr>
@@ -11395,7 +11395,7 @@
           <p:cNvPr id="3" name="">
             <a:extLst xmlns:a="http://schemas.openxmlformats.org/drawingml/2006/main">
               <a:ext uri="{FF2B5EF4-FFF2-40B4-BE49-F238E27FC236}">
-                <a16:creationId xmlns:a16="http://schemas.microsoft.com/office/drawing/2014/main" id="{F18D90EE-FBCB-4A21-BC45-846B17ECCD78}"/>
+                <a16:creationId xmlns:a16="http://schemas.microsoft.com/office/drawing/2014/main" id="{91AC0873-D6D2-4D12-834D-BD0861D7BFB4}"/>
               </a:ext>
             </a:extLst>
           </p:cNvPr>
@@ -11551,7 +11551,7 @@
           <p:cNvPr id="4" name="">
             <a:extLst xmlns:a="http://schemas.openxmlformats.org/drawingml/2006/main">
               <a:ext uri="{FF2B5EF4-FFF2-40B4-BE49-F238E27FC236}">
-                <a16:creationId xmlns:a16="http://schemas.microsoft.com/office/drawing/2014/main" id="{2FF56F35-2AAB-40C7-AA96-EFE14E76E8CF}"/>
+                <a16:creationId xmlns:a16="http://schemas.microsoft.com/office/drawing/2014/main" id="{811D3FDA-C3DB-4E69-8F52-AF0A0F47509B}"/>
               </a:ext>
             </a:extLst>
           </p:cNvPr>
@@ -11707,7 +11707,7 @@
           <p:cNvPr id="5" name="">
             <a:extLst xmlns:a="http://schemas.openxmlformats.org/drawingml/2006/main">
               <a:ext uri="{FF2B5EF4-FFF2-40B4-BE49-F238E27FC236}">
-                <a16:creationId xmlns:a16="http://schemas.microsoft.com/office/drawing/2014/main" id="{1D4573A0-DAC5-43E5-9576-3AEE015C4E37}"/>
+                <a16:creationId xmlns:a16="http://schemas.microsoft.com/office/drawing/2014/main" id="{4E6A462B-15FB-485A-A447-1893B291FB10}"/>
               </a:ext>
             </a:extLst>
           </p:cNvPr>
@@ -11863,7 +11863,7 @@
           <p:cNvPr id="6" name="">
             <a:extLst xmlns:a="http://schemas.openxmlformats.org/drawingml/2006/main">
               <a:ext uri="{FF2B5EF4-FFF2-40B4-BE49-F238E27FC236}">
-                <a16:creationId xmlns:a16="http://schemas.microsoft.com/office/drawing/2014/main" id="{FBBBD857-CFAC-46ED-9C17-4DA80C9B0E60}"/>
+                <a16:creationId xmlns:a16="http://schemas.microsoft.com/office/drawing/2014/main" id="{37C21BA5-84BD-493A-A472-23D423DC4810}"/>
               </a:ext>
             </a:extLst>
           </p:cNvPr>
@@ -12019,7 +12019,7 @@
           <p:cNvPr id="7" name="">
             <a:extLst xmlns:a="http://schemas.openxmlformats.org/drawingml/2006/main">
               <a:ext uri="{FF2B5EF4-FFF2-40B4-BE49-F238E27FC236}">
-                <a16:creationId xmlns:a16="http://schemas.microsoft.com/office/drawing/2014/main" id="{06CB85B3-212D-4F32-89C9-A4D21E95D436}"/>
+                <a16:creationId xmlns:a16="http://schemas.microsoft.com/office/drawing/2014/main" id="{52305F81-CA2A-49BB-A2F6-E7CB0C3D6764}"/>
               </a:ext>
             </a:extLst>
           </p:cNvPr>
@@ -12175,7 +12175,7 @@
           <p:cNvPr id="8" name="">
             <a:extLst xmlns:a="http://schemas.openxmlformats.org/drawingml/2006/main">
               <a:ext uri="{FF2B5EF4-FFF2-40B4-BE49-F238E27FC236}">
-                <a16:creationId xmlns:a16="http://schemas.microsoft.com/office/drawing/2014/main" id="{2474746D-09D6-4772-8C82-593A55EFEFD6}"/>
+                <a16:creationId xmlns:a16="http://schemas.microsoft.com/office/drawing/2014/main" id="{E0D1F36C-94DF-4363-B572-8C7398D15364}"/>
               </a:ext>
             </a:extLst>
           </p:cNvPr>
@@ -12331,7 +12331,7 @@
           <p:cNvPr id="9" name="">
             <a:extLst xmlns:a="http://schemas.openxmlformats.org/drawingml/2006/main">
               <a:ext uri="{FF2B5EF4-FFF2-40B4-BE49-F238E27FC236}">
-                <a16:creationId xmlns:a16="http://schemas.microsoft.com/office/drawing/2014/main" id="{FE04F1EE-5D66-43F7-92BB-34C51AC0F308}"/>
+                <a16:creationId xmlns:a16="http://schemas.microsoft.com/office/drawing/2014/main" id="{9459C715-2EE2-4556-9C05-E8C540D2148C}"/>
               </a:ext>
             </a:extLst>
           </p:cNvPr>
@@ -12487,7 +12487,7 @@
           <p:cNvPr id="10" name="">
             <a:extLst xmlns:a="http://schemas.openxmlformats.org/drawingml/2006/main">
               <a:ext uri="{FF2B5EF4-FFF2-40B4-BE49-F238E27FC236}">
-                <a16:creationId xmlns:a16="http://schemas.microsoft.com/office/drawing/2014/main" id="{81E93CBA-704D-4EDD-B2F3-E6A6E712F1CC}"/>
+                <a16:creationId xmlns:a16="http://schemas.microsoft.com/office/drawing/2014/main" id="{27D5C411-95A3-4D4A-BB05-B964E0A456EB}"/>
               </a:ext>
             </a:extLst>
           </p:cNvPr>
@@ -12497,7 +12497,7 @@
           <p:nvPr/>
         </p:nvPicPr>
         <p:blipFill>
-          <a:blip xmlns:r="http://schemas.openxmlformats.org/officeDocument/2006/relationships" xmlns:a="http://schemas.openxmlformats.org/drawingml/2006/main" r:embed="Rdcaf765d1f844c9f"/>
+          <a:blip xmlns:r="http://schemas.openxmlformats.org/officeDocument/2006/relationships" xmlns:a="http://schemas.openxmlformats.org/drawingml/2006/main" r:embed="R3a2810cd5d214457"/>
           <a:stretch xmlns:a="http://schemas.openxmlformats.org/drawingml/2006/main"/>
         </p:blipFill>
         <p:spPr>
@@ -12515,7 +12515,7 @@
           <p:cNvPr id="11" name="">
             <a:extLst xmlns:a="http://schemas.openxmlformats.org/drawingml/2006/main">
               <a:ext uri="{FF2B5EF4-FFF2-40B4-BE49-F238E27FC236}">
-                <a16:creationId xmlns:a16="http://schemas.microsoft.com/office/drawing/2014/main" id="{1E6699DA-F0A0-4FFE-899F-0C2AD0364C16}"/>
+                <a16:creationId xmlns:a16="http://schemas.microsoft.com/office/drawing/2014/main" id="{1E46E69C-ED57-4389-93EC-909CA4DC9EE3}"/>
               </a:ext>
             </a:extLst>
           </p:cNvPr>
@@ -12669,7 +12669,7 @@
     </p:spTree>
     <p:extLst>
       <p:ext uri="{BB962C8B-B14F-4D97-AF65-F5344CB8AC3E}">
-        <p14:creationId xmlns:p14="http://schemas.microsoft.com/office/powerpoint/2010/main" val="1735483072"/>
+        <p14:creationId xmlns:p14="http://schemas.microsoft.com/office/powerpoint/2010/main" val="1903973615"/>
       </p:ext>
     </p:extLst>
   </p:cSld>

</xml_diff>